<commit_message>
docs(slides): deck v4 - schematic line-icon tiles instead of emoji
Co-Authored-By: Claude Fable 5 <noreply@anthropic.com>
Claude-Session: https://claude.ai/code/session_01Gs4wvsmdiVbeWdpfy8uDk7
</commit_message>
<xml_diff>
--- a/slides/wanthat-presentation.pptx
+++ b/slides/wanthat-presentation.pptx
@@ -5767,20 +5767,40 @@
           </a:fontRef>
         </p:style>
         <p:txBody>
-          <a:bodyPr rtlCol="0" anchor="ctr" wrap="square" lIns="9144" rIns="9144" tIns="9144" bIns="9144"/>
+          <a:bodyPr rtlCol="0" anchor="ctr" wrap="square" lIns="146304" rIns="146304" tIns="109728" bIns="109728"/>
           <a:lstStyle/>
           <a:p>
             <a:pPr algn="ctr"/>
-            <a:r>
-              <a:rPr sz="1700"/>
-              <a:t>💬</a:t>
-            </a:r>
-          </a:p>
-        </p:txBody>
-      </p:sp>
-      <p:sp>
-        <p:nvSpPr>
-          <p:cNvPr id="8" name="TextBox 7"/>
+          </a:p>
+        </p:txBody>
+      </p:sp>
+      <p:pic>
+        <p:nvPicPr>
+          <p:cNvPr id="8" name="Picture 7" descr="chat.png"/>
+          <p:cNvPicPr>
+            <a:picLocks noChangeAspect="1"/>
+          </p:cNvPicPr>
+          <p:nvPr/>
+        </p:nvPicPr>
+        <p:blipFill>
+          <a:blip r:embed="rId2"/>
+          <a:stretch>
+            <a:fillRect/>
+          </a:stretch>
+        </p:blipFill>
+        <p:spPr>
+          <a:xfrm>
+            <a:off x="935248" y="3404128"/>
+            <a:ext cx="342351" cy="342351"/>
+          </a:xfrm>
+          <a:prstGeom prst="rect">
+            <a:avLst/>
+          </a:prstGeom>
+        </p:spPr>
+      </p:pic>
+      <p:sp>
+        <p:nvSpPr>
+          <p:cNvPr id="9" name="TextBox 8"/>
           <p:cNvSpPr txBox="1"/>
           <p:nvPr/>
         </p:nvSpPr>
@@ -5814,7 +5834,7 @@
       </p:sp>
       <p:sp>
         <p:nvSpPr>
-          <p:cNvPr id="9" name="TextBox 8"/>
+          <p:cNvPr id="10" name="TextBox 9"/>
           <p:cNvSpPr txBox="1"/>
           <p:nvPr/>
         </p:nvSpPr>
@@ -5853,7 +5873,7 @@
       </p:sp>
       <p:sp>
         <p:nvSpPr>
-          <p:cNvPr id="10" name="Rounded Rectangle 9"/>
+          <p:cNvPr id="11" name="Rounded Rectangle 10"/>
           <p:cNvSpPr/>
           <p:nvPr/>
         </p:nvSpPr>
@@ -5901,7 +5921,7 @@
       </p:sp>
       <p:sp>
         <p:nvSpPr>
-          <p:cNvPr id="11" name="Rounded Rectangle 10"/>
+          <p:cNvPr id="12" name="Rounded Rectangle 11"/>
           <p:cNvSpPr/>
           <p:nvPr/>
         </p:nvSpPr>
@@ -5940,20 +5960,40 @@
           </a:fontRef>
         </p:style>
         <p:txBody>
-          <a:bodyPr rtlCol="0" anchor="ctr" wrap="square" lIns="9144" rIns="9144" tIns="9144" bIns="9144"/>
+          <a:bodyPr rtlCol="0" anchor="ctr" wrap="square" lIns="146304" rIns="146304" tIns="109728" bIns="109728"/>
           <a:lstStyle/>
           <a:p>
             <a:pPr algn="ctr"/>
-            <a:r>
-              <a:rPr sz="1700"/>
-              <a:t>🍪</a:t>
-            </a:r>
-          </a:p>
-        </p:txBody>
-      </p:sp>
-      <p:sp>
-        <p:nvSpPr>
-          <p:cNvPr id="12" name="TextBox 11"/>
+          </a:p>
+        </p:txBody>
+      </p:sp>
+      <p:pic>
+        <p:nvPicPr>
+          <p:cNvPr id="13" name="Picture 12" descr="cookie.png"/>
+          <p:cNvPicPr>
+            <a:picLocks noChangeAspect="1"/>
+          </p:cNvPicPr>
+          <p:nvPr/>
+        </p:nvPicPr>
+        <p:blipFill>
+          <a:blip r:embed="rId3"/>
+          <a:stretch>
+            <a:fillRect/>
+          </a:stretch>
+        </p:blipFill>
+        <p:spPr>
+          <a:xfrm>
+            <a:off x="4730008" y="3404128"/>
+            <a:ext cx="342351" cy="342351"/>
+          </a:xfrm>
+          <a:prstGeom prst="rect">
+            <a:avLst/>
+          </a:prstGeom>
+        </p:spPr>
+      </p:pic>
+      <p:sp>
+        <p:nvSpPr>
+          <p:cNvPr id="14" name="TextBox 13"/>
           <p:cNvSpPr txBox="1"/>
           <p:nvPr/>
         </p:nvSpPr>
@@ -5987,7 +6027,7 @@
       </p:sp>
       <p:sp>
         <p:nvSpPr>
-          <p:cNvPr id="13" name="TextBox 12"/>
+          <p:cNvPr id="15" name="TextBox 14"/>
           <p:cNvSpPr txBox="1"/>
           <p:nvPr/>
         </p:nvSpPr>
@@ -6026,7 +6066,7 @@
       </p:sp>
       <p:sp>
         <p:nvSpPr>
-          <p:cNvPr id="14" name="Rounded Rectangle 13"/>
+          <p:cNvPr id="16" name="Rounded Rectangle 15"/>
           <p:cNvSpPr/>
           <p:nvPr/>
         </p:nvSpPr>
@@ -6074,7 +6114,7 @@
       </p:sp>
       <p:sp>
         <p:nvSpPr>
-          <p:cNvPr id="15" name="Rounded Rectangle 14"/>
+          <p:cNvPr id="17" name="Rounded Rectangle 16"/>
           <p:cNvSpPr/>
           <p:nvPr/>
         </p:nvSpPr>
@@ -6113,20 +6153,40 @@
           </a:fontRef>
         </p:style>
         <p:txBody>
-          <a:bodyPr rtlCol="0" anchor="ctr" wrap="square" lIns="9144" rIns="9144" tIns="9144" bIns="9144"/>
+          <a:bodyPr rtlCol="0" anchor="ctr" wrap="square" lIns="146304" rIns="146304" tIns="109728" bIns="109728"/>
           <a:lstStyle/>
           <a:p>
             <a:pPr algn="ctr"/>
-            <a:r>
-              <a:rPr sz="1700"/>
-              <a:t>⚡</a:t>
-            </a:r>
-          </a:p>
-        </p:txBody>
-      </p:sp>
-      <p:sp>
-        <p:nvSpPr>
-          <p:cNvPr id="16" name="TextBox 15"/>
+          </a:p>
+        </p:txBody>
+      </p:sp>
+      <p:pic>
+        <p:nvPicPr>
+          <p:cNvPr id="18" name="Picture 17" descr="bolt.png"/>
+          <p:cNvPicPr>
+            <a:picLocks noChangeAspect="1"/>
+          </p:cNvPicPr>
+          <p:nvPr/>
+        </p:nvPicPr>
+        <p:blipFill>
+          <a:blip r:embed="rId4"/>
+          <a:stretch>
+            <a:fillRect/>
+          </a:stretch>
+        </p:blipFill>
+        <p:spPr>
+          <a:xfrm>
+            <a:off x="8524768" y="3404128"/>
+            <a:ext cx="342351" cy="342351"/>
+          </a:xfrm>
+          <a:prstGeom prst="rect">
+            <a:avLst/>
+          </a:prstGeom>
+        </p:spPr>
+      </p:pic>
+      <p:sp>
+        <p:nvSpPr>
+          <p:cNvPr id="19" name="TextBox 18"/>
           <p:cNvSpPr txBox="1"/>
           <p:nvPr/>
         </p:nvSpPr>
@@ -6160,7 +6220,7 @@
       </p:sp>
       <p:sp>
         <p:nvSpPr>
-          <p:cNvPr id="17" name="TextBox 16"/>
+          <p:cNvPr id="20" name="TextBox 19"/>
           <p:cNvSpPr txBox="1"/>
           <p:nvPr/>
         </p:nvSpPr>
@@ -6199,7 +6259,7 @@
       </p:sp>
       <p:sp>
         <p:nvSpPr>
-          <p:cNvPr id="18" name="Rectangle 17"/>
+          <p:cNvPr id="21" name="Rectangle 20"/>
           <p:cNvSpPr/>
           <p:nvPr/>
         </p:nvSpPr>
@@ -6243,7 +6303,7 @@
       </p:sp>
       <p:sp>
         <p:nvSpPr>
-          <p:cNvPr id="19" name="TextBox 18"/>
+          <p:cNvPr id="22" name="TextBox 21"/>
           <p:cNvSpPr txBox="1"/>
           <p:nvPr/>
         </p:nvSpPr>
@@ -6286,7 +6346,7 @@
       </p:sp>
       <p:sp>
         <p:nvSpPr>
-          <p:cNvPr id="20" name="TextBox 19"/>
+          <p:cNvPr id="23" name="TextBox 22"/>
           <p:cNvSpPr txBox="1"/>
           <p:nvPr/>
         </p:nvSpPr>
@@ -6668,20 +6728,40 @@
           </a:fontRef>
         </p:style>
         <p:txBody>
-          <a:bodyPr rtlCol="0" anchor="ctr" wrap="square" lIns="9144" rIns="9144" tIns="9144" bIns="9144"/>
+          <a:bodyPr rtlCol="0" anchor="ctr" wrap="square" lIns="146304" rIns="146304" tIns="109728" bIns="109728"/>
           <a:lstStyle/>
           <a:p>
             <a:pPr algn="ctr"/>
-            <a:r>
-              <a:rPr sz="1700"/>
-              <a:t>🔁</a:t>
-            </a:r>
-          </a:p>
-        </p:txBody>
-      </p:sp>
-      <p:sp>
-        <p:nvSpPr>
-          <p:cNvPr id="8" name="TextBox 7"/>
+          </a:p>
+        </p:txBody>
+      </p:sp>
+      <p:pic>
+        <p:nvPicPr>
+          <p:cNvPr id="8" name="Picture 7" descr="refresh.png"/>
+          <p:cNvPicPr>
+            <a:picLocks noChangeAspect="1"/>
+          </p:cNvPicPr>
+          <p:nvPr/>
+        </p:nvPicPr>
+        <p:blipFill>
+          <a:blip r:embed="rId2"/>
+          <a:stretch>
+            <a:fillRect/>
+          </a:stretch>
+        </p:blipFill>
+        <p:spPr>
+          <a:xfrm>
+            <a:off x="935248" y="3404128"/>
+            <a:ext cx="342351" cy="342351"/>
+          </a:xfrm>
+          <a:prstGeom prst="rect">
+            <a:avLst/>
+          </a:prstGeom>
+        </p:spPr>
+      </p:pic>
+      <p:sp>
+        <p:nvSpPr>
+          <p:cNvPr id="9" name="TextBox 8"/>
           <p:cNvSpPr txBox="1"/>
           <p:nvPr/>
         </p:nvSpPr>
@@ -6715,7 +6795,7 @@
       </p:sp>
       <p:sp>
         <p:nvSpPr>
-          <p:cNvPr id="9" name="TextBox 8"/>
+          <p:cNvPr id="10" name="TextBox 9"/>
           <p:cNvSpPr txBox="1"/>
           <p:nvPr/>
         </p:nvSpPr>
@@ -6754,7 +6834,7 @@
       </p:sp>
       <p:sp>
         <p:nvSpPr>
-          <p:cNvPr id="10" name="Rounded Rectangle 9"/>
+          <p:cNvPr id="11" name="Rounded Rectangle 10"/>
           <p:cNvSpPr/>
           <p:nvPr/>
         </p:nvSpPr>
@@ -6802,7 +6882,7 @@
       </p:sp>
       <p:sp>
         <p:nvSpPr>
-          <p:cNvPr id="11" name="Rounded Rectangle 10"/>
+          <p:cNvPr id="12" name="Rounded Rectangle 11"/>
           <p:cNvSpPr/>
           <p:nvPr/>
         </p:nvSpPr>
@@ -6841,20 +6921,40 @@
           </a:fontRef>
         </p:style>
         <p:txBody>
-          <a:bodyPr rtlCol="0" anchor="ctr" wrap="square" lIns="9144" rIns="9144" tIns="9144" bIns="9144"/>
+          <a:bodyPr rtlCol="0" anchor="ctr" wrap="square" lIns="146304" rIns="146304" tIns="109728" bIns="109728"/>
           <a:lstStyle/>
           <a:p>
             <a:pPr algn="ctr"/>
-            <a:r>
-              <a:rPr sz="1700"/>
-              <a:t>✍️</a:t>
-            </a:r>
-          </a:p>
-        </p:txBody>
-      </p:sp>
-      <p:sp>
-        <p:nvSpPr>
-          <p:cNvPr id="12" name="TextBox 11"/>
+          </a:p>
+        </p:txBody>
+      </p:sp>
+      <p:pic>
+        <p:nvPicPr>
+          <p:cNvPr id="13" name="Picture 12" descr="pen.png"/>
+          <p:cNvPicPr>
+            <a:picLocks noChangeAspect="1"/>
+          </p:cNvPicPr>
+          <p:nvPr/>
+        </p:nvPicPr>
+        <p:blipFill>
+          <a:blip r:embed="rId3"/>
+          <a:stretch>
+            <a:fillRect/>
+          </a:stretch>
+        </p:blipFill>
+        <p:spPr>
+          <a:xfrm>
+            <a:off x="4730008" y="3404128"/>
+            <a:ext cx="342351" cy="342351"/>
+          </a:xfrm>
+          <a:prstGeom prst="rect">
+            <a:avLst/>
+          </a:prstGeom>
+        </p:spPr>
+      </p:pic>
+      <p:sp>
+        <p:nvSpPr>
+          <p:cNvPr id="14" name="TextBox 13"/>
           <p:cNvSpPr txBox="1"/>
           <p:nvPr/>
         </p:nvSpPr>
@@ -6888,7 +6988,7 @@
       </p:sp>
       <p:sp>
         <p:nvSpPr>
-          <p:cNvPr id="13" name="TextBox 12"/>
+          <p:cNvPr id="15" name="TextBox 14"/>
           <p:cNvSpPr txBox="1"/>
           <p:nvPr/>
         </p:nvSpPr>
@@ -6927,7 +7027,7 @@
       </p:sp>
       <p:sp>
         <p:nvSpPr>
-          <p:cNvPr id="14" name="Rounded Rectangle 13"/>
+          <p:cNvPr id="16" name="Rounded Rectangle 15"/>
           <p:cNvSpPr/>
           <p:nvPr/>
         </p:nvSpPr>
@@ -6975,7 +7075,7 @@
       </p:sp>
       <p:sp>
         <p:nvSpPr>
-          <p:cNvPr id="15" name="Rounded Rectangle 14"/>
+          <p:cNvPr id="17" name="Rounded Rectangle 16"/>
           <p:cNvSpPr/>
           <p:nvPr/>
         </p:nvSpPr>
@@ -7014,20 +7114,40 @@
           </a:fontRef>
         </p:style>
         <p:txBody>
-          <a:bodyPr rtlCol="0" anchor="ctr" wrap="square" lIns="9144" rIns="9144" tIns="9144" bIns="9144"/>
+          <a:bodyPr rtlCol="0" anchor="ctr" wrap="square" lIns="146304" rIns="146304" tIns="109728" bIns="109728"/>
           <a:lstStyle/>
           <a:p>
             <a:pPr algn="ctr"/>
-            <a:r>
-              <a:rPr sz="1700"/>
-              <a:t>📥</a:t>
-            </a:r>
-          </a:p>
-        </p:txBody>
-      </p:sp>
-      <p:sp>
-        <p:nvSpPr>
-          <p:cNvPr id="16" name="TextBox 15"/>
+          </a:p>
+        </p:txBody>
+      </p:sp>
+      <p:pic>
+        <p:nvPicPr>
+          <p:cNvPr id="18" name="Picture 17" descr="inbox.png"/>
+          <p:cNvPicPr>
+            <a:picLocks noChangeAspect="1"/>
+          </p:cNvPicPr>
+          <p:nvPr/>
+        </p:nvPicPr>
+        <p:blipFill>
+          <a:blip r:embed="rId4"/>
+          <a:stretch>
+            <a:fillRect/>
+          </a:stretch>
+        </p:blipFill>
+        <p:spPr>
+          <a:xfrm>
+            <a:off x="8524768" y="3404128"/>
+            <a:ext cx="342351" cy="342351"/>
+          </a:xfrm>
+          <a:prstGeom prst="rect">
+            <a:avLst/>
+          </a:prstGeom>
+        </p:spPr>
+      </p:pic>
+      <p:sp>
+        <p:nvSpPr>
+          <p:cNvPr id="19" name="TextBox 18"/>
           <p:cNvSpPr txBox="1"/>
           <p:nvPr/>
         </p:nvSpPr>
@@ -7061,7 +7181,7 @@
       </p:sp>
       <p:sp>
         <p:nvSpPr>
-          <p:cNvPr id="17" name="TextBox 16"/>
+          <p:cNvPr id="20" name="TextBox 19"/>
           <p:cNvSpPr txBox="1"/>
           <p:nvPr/>
         </p:nvSpPr>
@@ -7100,7 +7220,7 @@
       </p:sp>
       <p:sp>
         <p:nvSpPr>
-          <p:cNvPr id="18" name="Rectangle 17"/>
+          <p:cNvPr id="21" name="Rectangle 20"/>
           <p:cNvSpPr/>
           <p:nvPr/>
         </p:nvSpPr>
@@ -7144,7 +7264,7 @@
       </p:sp>
       <p:sp>
         <p:nvSpPr>
-          <p:cNvPr id="19" name="TextBox 18"/>
+          <p:cNvPr id="22" name="TextBox 21"/>
           <p:cNvSpPr txBox="1"/>
           <p:nvPr/>
         </p:nvSpPr>
@@ -7187,7 +7307,7 @@
       </p:sp>
       <p:sp>
         <p:nvSpPr>
-          <p:cNvPr id="20" name="TextBox 19"/>
+          <p:cNvPr id="23" name="TextBox 22"/>
           <p:cNvSpPr txBox="1"/>
           <p:nvPr/>
         </p:nvSpPr>
@@ -7438,20 +7558,40 @@
           </a:fontRef>
         </p:style>
         <p:txBody>
-          <a:bodyPr rtlCol="0" anchor="ctr" wrap="square" lIns="9144" rIns="9144" tIns="9144" bIns="9144"/>
+          <a:bodyPr rtlCol="0" anchor="ctr" wrap="square" lIns="146304" rIns="146304" tIns="109728" bIns="109728"/>
           <a:lstStyle/>
           <a:p>
             <a:pPr algn="ctr"/>
-            <a:r>
-              <a:rPr sz="1700"/>
-              <a:t>💵</a:t>
-            </a:r>
-          </a:p>
-        </p:txBody>
-      </p:sp>
-      <p:sp>
-        <p:nvSpPr>
-          <p:cNvPr id="7" name="TextBox 6"/>
+          </a:p>
+        </p:txBody>
+      </p:sp>
+      <p:pic>
+        <p:nvPicPr>
+          <p:cNvPr id="7" name="Picture 6" descr="dbcoin.png"/>
+          <p:cNvPicPr>
+            <a:picLocks noChangeAspect="1"/>
+          </p:cNvPicPr>
+          <p:nvPr/>
+        </p:nvPicPr>
+        <p:blipFill>
+          <a:blip r:embed="rId2"/>
+          <a:stretch>
+            <a:fillRect/>
+          </a:stretch>
+        </p:blipFill>
+        <p:spPr>
+          <a:xfrm>
+            <a:off x="953536" y="2096536"/>
+            <a:ext cx="342351" cy="342351"/>
+          </a:xfrm>
+          <a:prstGeom prst="rect">
+            <a:avLst/>
+          </a:prstGeom>
+        </p:spPr>
+      </p:pic>
+      <p:sp>
+        <p:nvSpPr>
+          <p:cNvPr id="8" name="TextBox 7"/>
           <p:cNvSpPr txBox="1"/>
           <p:nvPr/>
         </p:nvSpPr>
@@ -7485,7 +7625,7 @@
       </p:sp>
       <p:sp>
         <p:nvSpPr>
-          <p:cNvPr id="8" name="TextBox 7"/>
+          <p:cNvPr id="9" name="TextBox 8"/>
           <p:cNvSpPr txBox="1"/>
           <p:nvPr/>
         </p:nvSpPr>
@@ -7620,7 +7760,7 @@
       </p:sp>
       <p:sp>
         <p:nvSpPr>
-          <p:cNvPr id="9" name="Rounded Rectangle 8"/>
+          <p:cNvPr id="10" name="Rounded Rectangle 9"/>
           <p:cNvSpPr/>
           <p:nvPr/>
         </p:nvSpPr>
@@ -7668,7 +7808,7 @@
       </p:sp>
       <p:sp>
         <p:nvSpPr>
-          <p:cNvPr id="10" name="Rounded Rectangle 9"/>
+          <p:cNvPr id="11" name="Rounded Rectangle 10"/>
           <p:cNvSpPr/>
           <p:nvPr/>
         </p:nvSpPr>
@@ -7707,20 +7847,40 @@
           </a:fontRef>
         </p:style>
         <p:txBody>
-          <a:bodyPr rtlCol="0" anchor="ctr" wrap="square" lIns="9144" rIns="9144" tIns="9144" bIns="9144"/>
+          <a:bodyPr rtlCol="0" anchor="ctr" wrap="square" lIns="146304" rIns="146304" tIns="109728" bIns="109728"/>
           <a:lstStyle/>
           <a:p>
             <a:pPr algn="ctr"/>
-            <a:r>
-              <a:rPr sz="1700"/>
-              <a:t>🛡️</a:t>
-            </a:r>
-          </a:p>
-        </p:txBody>
-      </p:sp>
-      <p:sp>
-        <p:nvSpPr>
-          <p:cNvPr id="11" name="TextBox 10"/>
+          </a:p>
+        </p:txBody>
+      </p:sp>
+      <p:pic>
+        <p:nvPicPr>
+          <p:cNvPr id="12" name="Picture 11" descr="shield.png"/>
+          <p:cNvPicPr>
+            <a:picLocks noChangeAspect="1"/>
+          </p:cNvPicPr>
+          <p:nvPr/>
+        </p:nvPicPr>
+        <p:blipFill>
+          <a:blip r:embed="rId3"/>
+          <a:stretch>
+            <a:fillRect/>
+          </a:stretch>
+        </p:blipFill>
+        <p:spPr>
+          <a:xfrm>
+            <a:off x="6531376" y="2096536"/>
+            <a:ext cx="342351" cy="342351"/>
+          </a:xfrm>
+          <a:prstGeom prst="rect">
+            <a:avLst/>
+          </a:prstGeom>
+        </p:spPr>
+      </p:pic>
+      <p:sp>
+        <p:nvSpPr>
+          <p:cNvPr id="13" name="TextBox 12"/>
           <p:cNvSpPr txBox="1"/>
           <p:nvPr/>
         </p:nvSpPr>
@@ -7754,7 +7914,7 @@
       </p:sp>
       <p:sp>
         <p:nvSpPr>
-          <p:cNvPr id="12" name="TextBox 11"/>
+          <p:cNvPr id="14" name="TextBox 13"/>
           <p:cNvSpPr txBox="1"/>
           <p:nvPr/>
         </p:nvSpPr>
@@ -7889,7 +8049,7 @@
       </p:sp>
       <p:sp>
         <p:nvSpPr>
-          <p:cNvPr id="13" name="Rectangle 12"/>
+          <p:cNvPr id="15" name="Rectangle 14"/>
           <p:cNvSpPr/>
           <p:nvPr/>
         </p:nvSpPr>
@@ -7933,7 +8093,7 @@
       </p:sp>
       <p:sp>
         <p:nvSpPr>
-          <p:cNvPr id="14" name="TextBox 13"/>
+          <p:cNvPr id="16" name="TextBox 15"/>
           <p:cNvSpPr txBox="1"/>
           <p:nvPr/>
         </p:nvSpPr>
@@ -7976,7 +8136,7 @@
       </p:sp>
       <p:sp>
         <p:nvSpPr>
-          <p:cNvPr id="15" name="TextBox 14"/>
+          <p:cNvPr id="17" name="TextBox 16"/>
           <p:cNvSpPr txBox="1"/>
           <p:nvPr/>
         </p:nvSpPr>
@@ -8227,20 +8387,40 @@
           </a:fontRef>
         </p:style>
         <p:txBody>
-          <a:bodyPr rtlCol="0" anchor="ctr" wrap="square" lIns="9144" rIns="9144" tIns="9144" bIns="9144"/>
+          <a:bodyPr rtlCol="0" anchor="ctr" wrap="square" lIns="146304" rIns="146304" tIns="109728" bIns="109728"/>
           <a:lstStyle/>
           <a:p>
             <a:pPr algn="ctr"/>
-            <a:r>
-              <a:rPr sz="1700"/>
-              <a:t>✅</a:t>
-            </a:r>
-          </a:p>
-        </p:txBody>
-      </p:sp>
-      <p:sp>
-        <p:nvSpPr>
-          <p:cNvPr id="7" name="TextBox 6"/>
+          </a:p>
+        </p:txBody>
+      </p:sp>
+      <p:pic>
+        <p:nvPicPr>
+          <p:cNvPr id="7" name="Picture 6" descr="check.png"/>
+          <p:cNvPicPr>
+            <a:picLocks noChangeAspect="1"/>
+          </p:cNvPicPr>
+          <p:nvPr/>
+        </p:nvPicPr>
+        <p:blipFill>
+          <a:blip r:embed="rId2"/>
+          <a:stretch>
+            <a:fillRect/>
+          </a:stretch>
+        </p:blipFill>
+        <p:spPr>
+          <a:xfrm>
+            <a:off x="935248" y="2123968"/>
+            <a:ext cx="342351" cy="342351"/>
+          </a:xfrm>
+          <a:prstGeom prst="rect">
+            <a:avLst/>
+          </a:prstGeom>
+        </p:spPr>
+      </p:pic>
+      <p:sp>
+        <p:nvSpPr>
+          <p:cNvPr id="8" name="TextBox 7"/>
           <p:cNvSpPr txBox="1"/>
           <p:nvPr/>
         </p:nvSpPr>
@@ -8274,7 +8454,7 @@
       </p:sp>
       <p:sp>
         <p:nvSpPr>
-          <p:cNvPr id="8" name="TextBox 7"/>
+          <p:cNvPr id="9" name="TextBox 8"/>
           <p:cNvSpPr txBox="1"/>
           <p:nvPr/>
         </p:nvSpPr>
@@ -8313,7 +8493,7 @@
       </p:sp>
       <p:sp>
         <p:nvSpPr>
-          <p:cNvPr id="9" name="Rounded Rectangle 8"/>
+          <p:cNvPr id="10" name="Rounded Rectangle 9"/>
           <p:cNvSpPr/>
           <p:nvPr/>
         </p:nvSpPr>
@@ -8361,7 +8541,7 @@
       </p:sp>
       <p:sp>
         <p:nvSpPr>
-          <p:cNvPr id="10" name="Rounded Rectangle 9"/>
+          <p:cNvPr id="11" name="Rounded Rectangle 10"/>
           <p:cNvSpPr/>
           <p:nvPr/>
         </p:nvSpPr>
@@ -8400,20 +8580,40 @@
           </a:fontRef>
         </p:style>
         <p:txBody>
-          <a:bodyPr rtlCol="0" anchor="ctr" wrap="square" lIns="9144" rIns="9144" tIns="9144" bIns="9144"/>
+          <a:bodyPr rtlCol="0" anchor="ctr" wrap="square" lIns="146304" rIns="146304" tIns="109728" bIns="109728"/>
           <a:lstStyle/>
           <a:p>
             <a:pPr algn="ctr"/>
-            <a:r>
-              <a:rPr sz="1700"/>
-              <a:t>🚧</a:t>
-            </a:r>
-          </a:p>
-        </p:txBody>
-      </p:sp>
-      <p:sp>
-        <p:nvSpPr>
-          <p:cNvPr id="11" name="TextBox 10"/>
+          </a:p>
+        </p:txBody>
+      </p:sp>
+      <p:pic>
+        <p:nvPicPr>
+          <p:cNvPr id="12" name="Picture 11" descr="cone.png"/>
+          <p:cNvPicPr>
+            <a:picLocks noChangeAspect="1"/>
+          </p:cNvPicPr>
+          <p:nvPr/>
+        </p:nvPicPr>
+        <p:blipFill>
+          <a:blip r:embed="rId3"/>
+          <a:stretch>
+            <a:fillRect/>
+          </a:stretch>
+        </p:blipFill>
+        <p:spPr>
+          <a:xfrm>
+            <a:off x="4730008" y="2123968"/>
+            <a:ext cx="342351" cy="342351"/>
+          </a:xfrm>
+          <a:prstGeom prst="rect">
+            <a:avLst/>
+          </a:prstGeom>
+        </p:spPr>
+      </p:pic>
+      <p:sp>
+        <p:nvSpPr>
+          <p:cNvPr id="13" name="TextBox 12"/>
           <p:cNvSpPr txBox="1"/>
           <p:nvPr/>
         </p:nvSpPr>
@@ -8447,7 +8647,7 @@
       </p:sp>
       <p:sp>
         <p:nvSpPr>
-          <p:cNvPr id="12" name="TextBox 11"/>
+          <p:cNvPr id="14" name="TextBox 13"/>
           <p:cNvSpPr txBox="1"/>
           <p:nvPr/>
         </p:nvSpPr>
@@ -8486,7 +8686,7 @@
       </p:sp>
       <p:sp>
         <p:nvSpPr>
-          <p:cNvPr id="13" name="Rounded Rectangle 12"/>
+          <p:cNvPr id="15" name="Rounded Rectangle 14"/>
           <p:cNvSpPr/>
           <p:nvPr/>
         </p:nvSpPr>
@@ -8534,7 +8734,7 @@
       </p:sp>
       <p:sp>
         <p:nvSpPr>
-          <p:cNvPr id="14" name="Rounded Rectangle 13"/>
+          <p:cNvPr id="16" name="Rounded Rectangle 15"/>
           <p:cNvSpPr/>
           <p:nvPr/>
         </p:nvSpPr>
@@ -8573,20 +8773,40 @@
           </a:fontRef>
         </p:style>
         <p:txBody>
-          <a:bodyPr rtlCol="0" anchor="ctr" wrap="square" lIns="9144" rIns="9144" tIns="9144" bIns="9144"/>
+          <a:bodyPr rtlCol="0" anchor="ctr" wrap="square" lIns="146304" rIns="146304" tIns="109728" bIns="109728"/>
           <a:lstStyle/>
           <a:p>
             <a:pPr algn="ctr"/>
-            <a:r>
-              <a:rPr sz="1700"/>
-              <a:t>🎯</a:t>
-            </a:r>
-          </a:p>
-        </p:txBody>
-      </p:sp>
-      <p:sp>
-        <p:nvSpPr>
-          <p:cNvPr id="15" name="TextBox 14"/>
+          </a:p>
+        </p:txBody>
+      </p:sp>
+      <p:pic>
+        <p:nvPicPr>
+          <p:cNvPr id="17" name="Picture 16" descr="target.png"/>
+          <p:cNvPicPr>
+            <a:picLocks noChangeAspect="1"/>
+          </p:cNvPicPr>
+          <p:nvPr/>
+        </p:nvPicPr>
+        <p:blipFill>
+          <a:blip r:embed="rId4"/>
+          <a:stretch>
+            <a:fillRect/>
+          </a:stretch>
+        </p:blipFill>
+        <p:spPr>
+          <a:xfrm>
+            <a:off x="8524768" y="2123968"/>
+            <a:ext cx="342351" cy="342351"/>
+          </a:xfrm>
+          <a:prstGeom prst="rect">
+            <a:avLst/>
+          </a:prstGeom>
+        </p:spPr>
+      </p:pic>
+      <p:sp>
+        <p:nvSpPr>
+          <p:cNvPr id="18" name="TextBox 17"/>
           <p:cNvSpPr txBox="1"/>
           <p:nvPr/>
         </p:nvSpPr>
@@ -8620,7 +8840,7 @@
       </p:sp>
       <p:sp>
         <p:nvSpPr>
-          <p:cNvPr id="16" name="TextBox 15"/>
+          <p:cNvPr id="19" name="TextBox 18"/>
           <p:cNvSpPr txBox="1"/>
           <p:nvPr/>
         </p:nvSpPr>
@@ -8659,7 +8879,7 @@
       </p:sp>
       <p:sp>
         <p:nvSpPr>
-          <p:cNvPr id="17" name="TextBox 16"/>
+          <p:cNvPr id="20" name="TextBox 19"/>
           <p:cNvSpPr txBox="1"/>
           <p:nvPr/>
         </p:nvSpPr>
@@ -8702,7 +8922,7 @@
       </p:sp>
       <p:sp>
         <p:nvSpPr>
-          <p:cNvPr id="18" name="Rectangle 17"/>
+          <p:cNvPr id="21" name="Rectangle 20"/>
           <p:cNvSpPr/>
           <p:nvPr/>
         </p:nvSpPr>
@@ -8746,7 +8966,7 @@
       </p:sp>
       <p:sp>
         <p:nvSpPr>
-          <p:cNvPr id="19" name="TextBox 18"/>
+          <p:cNvPr id="22" name="TextBox 21"/>
           <p:cNvSpPr txBox="1"/>
           <p:nvPr/>
         </p:nvSpPr>
@@ -8789,7 +9009,7 @@
       </p:sp>
       <p:sp>
         <p:nvSpPr>
-          <p:cNvPr id="20" name="TextBox 19"/>
+          <p:cNvPr id="23" name="TextBox 22"/>
           <p:cNvSpPr txBox="1"/>
           <p:nvPr/>
         </p:nvSpPr>
@@ -10181,20 +10401,40 @@
           </a:fontRef>
         </p:style>
         <p:txBody>
-          <a:bodyPr rtlCol="0" anchor="ctr" wrap="square" lIns="9144" rIns="9144" tIns="9144" bIns="9144"/>
+          <a:bodyPr rtlCol="0" anchor="ctr" wrap="square" lIns="146304" rIns="146304" tIns="109728" bIns="109728"/>
           <a:lstStyle/>
           <a:p>
             <a:pPr algn="ctr"/>
-            <a:r>
-              <a:rPr sz="1400"/>
-              <a:t>🏛️</a:t>
-            </a:r>
-          </a:p>
-        </p:txBody>
-      </p:sp>
-      <p:sp>
-        <p:nvSpPr>
-          <p:cNvPr id="7" name="TextBox 6"/>
+          </a:p>
+        </p:txBody>
+      </p:sp>
+      <p:pic>
+        <p:nvPicPr>
+          <p:cNvPr id="7" name="Picture 6" descr="bank.png"/>
+          <p:cNvPicPr>
+            <a:picLocks noChangeAspect="1"/>
+          </p:cNvPicPr>
+          <p:nvPr/>
+        </p:nvPicPr>
+        <p:blipFill>
+          <a:blip r:embed="rId2"/>
+          <a:stretch>
+            <a:fillRect/>
+          </a:stretch>
+        </p:blipFill>
+        <p:spPr>
+          <a:xfrm>
+            <a:off x="925007" y="2068007"/>
+            <a:ext cx="289681" cy="289681"/>
+          </a:xfrm>
+          <a:prstGeom prst="rect">
+            <a:avLst/>
+          </a:prstGeom>
+        </p:spPr>
+      </p:pic>
+      <p:sp>
+        <p:nvSpPr>
+          <p:cNvPr id="8" name="TextBox 7"/>
           <p:cNvSpPr txBox="1"/>
           <p:nvPr/>
         </p:nvSpPr>
@@ -10228,7 +10468,7 @@
       </p:sp>
       <p:sp>
         <p:nvSpPr>
-          <p:cNvPr id="8" name="TextBox 7"/>
+          <p:cNvPr id="9" name="TextBox 8"/>
           <p:cNvSpPr txBox="1"/>
           <p:nvPr/>
         </p:nvSpPr>
@@ -10395,7 +10635,7 @@
       </p:sp>
       <p:sp>
         <p:nvSpPr>
-          <p:cNvPr id="9" name="Rounded Rectangle 8"/>
+          <p:cNvPr id="10" name="Rounded Rectangle 9"/>
           <p:cNvSpPr/>
           <p:nvPr/>
         </p:nvSpPr>
@@ -10443,7 +10683,7 @@
       </p:sp>
       <p:sp>
         <p:nvSpPr>
-          <p:cNvPr id="10" name="Rounded Rectangle 9"/>
+          <p:cNvPr id="11" name="Rounded Rectangle 10"/>
           <p:cNvSpPr/>
           <p:nvPr/>
         </p:nvSpPr>
@@ -10482,20 +10722,40 @@
           </a:fontRef>
         </p:style>
         <p:txBody>
-          <a:bodyPr rtlCol="0" anchor="ctr" wrap="square" lIns="9144" rIns="9144" tIns="9144" bIns="9144"/>
+          <a:bodyPr rtlCol="0" anchor="ctr" wrap="square" lIns="146304" rIns="146304" tIns="109728" bIns="109728"/>
           <a:lstStyle/>
           <a:p>
             <a:pPr algn="ctr"/>
-            <a:r>
-              <a:rPr sz="1400"/>
-              <a:t>🧰</a:t>
-            </a:r>
-          </a:p>
-        </p:txBody>
-      </p:sp>
-      <p:sp>
-        <p:nvSpPr>
-          <p:cNvPr id="11" name="TextBox 10"/>
+          </a:p>
+        </p:txBody>
+      </p:sp>
+      <p:pic>
+        <p:nvPicPr>
+          <p:cNvPr id="12" name="Picture 11" descr="sliders.png"/>
+          <p:cNvPicPr>
+            <a:picLocks noChangeAspect="1"/>
+          </p:cNvPicPr>
+          <p:nvPr/>
+        </p:nvPicPr>
+        <p:blipFill>
+          <a:blip r:embed="rId3"/>
+          <a:stretch>
+            <a:fillRect/>
+          </a:stretch>
+        </p:blipFill>
+        <p:spPr>
+          <a:xfrm>
+            <a:off x="4719767" y="2068007"/>
+            <a:ext cx="289681" cy="289681"/>
+          </a:xfrm>
+          <a:prstGeom prst="rect">
+            <a:avLst/>
+          </a:prstGeom>
+        </p:spPr>
+      </p:pic>
+      <p:sp>
+        <p:nvSpPr>
+          <p:cNvPr id="13" name="TextBox 12"/>
           <p:cNvSpPr txBox="1"/>
           <p:nvPr/>
         </p:nvSpPr>
@@ -10529,7 +10789,7 @@
       </p:sp>
       <p:sp>
         <p:nvSpPr>
-          <p:cNvPr id="12" name="TextBox 11"/>
+          <p:cNvPr id="14" name="TextBox 13"/>
           <p:cNvSpPr txBox="1"/>
           <p:nvPr/>
         </p:nvSpPr>
@@ -10664,7 +10924,7 @@
       </p:sp>
       <p:sp>
         <p:nvSpPr>
-          <p:cNvPr id="13" name="Rounded Rectangle 12"/>
+          <p:cNvPr id="15" name="Rounded Rectangle 14"/>
           <p:cNvSpPr/>
           <p:nvPr/>
         </p:nvSpPr>
@@ -10712,7 +10972,7 @@
       </p:sp>
       <p:sp>
         <p:nvSpPr>
-          <p:cNvPr id="14" name="Rounded Rectangle 13"/>
+          <p:cNvPr id="16" name="Rounded Rectangle 15"/>
           <p:cNvSpPr/>
           <p:nvPr/>
         </p:nvSpPr>
@@ -10751,20 +11011,40 @@
           </a:fontRef>
         </p:style>
         <p:txBody>
-          <a:bodyPr rtlCol="0" anchor="ctr" wrap="square" lIns="9144" rIns="9144" tIns="9144" bIns="9144"/>
+          <a:bodyPr rtlCol="0" anchor="ctr" wrap="square" lIns="146304" rIns="146304" tIns="109728" bIns="109728"/>
           <a:lstStyle/>
           <a:p>
             <a:pPr algn="ctr"/>
-            <a:r>
-              <a:rPr sz="1400"/>
-              <a:t>🧩</a:t>
-            </a:r>
-          </a:p>
-        </p:txBody>
-      </p:sp>
-      <p:sp>
-        <p:nvSpPr>
-          <p:cNvPr id="15" name="TextBox 14"/>
+          </a:p>
+        </p:txBody>
+      </p:sp>
+      <p:pic>
+        <p:nvPicPr>
+          <p:cNvPr id="17" name="Picture 16" descr="plus.png"/>
+          <p:cNvPicPr>
+            <a:picLocks noChangeAspect="1"/>
+          </p:cNvPicPr>
+          <p:nvPr/>
+        </p:nvPicPr>
+        <p:blipFill>
+          <a:blip r:embed="rId4"/>
+          <a:stretch>
+            <a:fillRect/>
+          </a:stretch>
+        </p:blipFill>
+        <p:spPr>
+          <a:xfrm>
+            <a:off x="8514527" y="2068007"/>
+            <a:ext cx="289681" cy="289681"/>
+          </a:xfrm>
+          <a:prstGeom prst="rect">
+            <a:avLst/>
+          </a:prstGeom>
+        </p:spPr>
+      </p:pic>
+      <p:sp>
+        <p:nvSpPr>
+          <p:cNvPr id="18" name="TextBox 17"/>
           <p:cNvSpPr txBox="1"/>
           <p:nvPr/>
         </p:nvSpPr>
@@ -10798,7 +11078,7 @@
       </p:sp>
       <p:sp>
         <p:nvSpPr>
-          <p:cNvPr id="16" name="TextBox 15"/>
+          <p:cNvPr id="19" name="TextBox 18"/>
           <p:cNvSpPr txBox="1"/>
           <p:nvPr/>
         </p:nvSpPr>
@@ -10901,7 +11181,7 @@
       </p:sp>
       <p:sp>
         <p:nvSpPr>
-          <p:cNvPr id="17" name="Rectangle 16"/>
+          <p:cNvPr id="20" name="Rectangle 19"/>
           <p:cNvSpPr/>
           <p:nvPr/>
         </p:nvSpPr>
@@ -10945,7 +11225,7 @@
       </p:sp>
       <p:sp>
         <p:nvSpPr>
-          <p:cNvPr id="18" name="TextBox 17"/>
+          <p:cNvPr id="21" name="TextBox 20"/>
           <p:cNvSpPr txBox="1"/>
           <p:nvPr/>
         </p:nvSpPr>
@@ -10988,7 +11268,7 @@
       </p:sp>
       <p:sp>
         <p:nvSpPr>
-          <p:cNvPr id="19" name="TextBox 18"/>
+          <p:cNvPr id="22" name="TextBox 21"/>
           <p:cNvSpPr txBox="1"/>
           <p:nvPr/>
         </p:nvSpPr>
@@ -11596,20 +11876,40 @@
           </a:fontRef>
         </p:style>
         <p:txBody>
-          <a:bodyPr rtlCol="0" anchor="ctr" wrap="square" lIns="9144" rIns="9144" tIns="9144" bIns="9144"/>
+          <a:bodyPr rtlCol="0" anchor="ctr" wrap="square" lIns="146304" rIns="146304" tIns="109728" bIns="109728"/>
           <a:lstStyle/>
           <a:p>
             <a:pPr algn="ctr"/>
-            <a:r>
-              <a:rPr sz="1700"/>
-              <a:t>🛍️</a:t>
-            </a:r>
-          </a:p>
-        </p:txBody>
-      </p:sp>
-      <p:sp>
-        <p:nvSpPr>
-          <p:cNvPr id="8" name="TextBox 7"/>
+          </a:p>
+        </p:txBody>
+      </p:sp>
+      <p:pic>
+        <p:nvPicPr>
+          <p:cNvPr id="8" name="Picture 7" descr="bag.png"/>
+          <p:cNvPicPr>
+            <a:picLocks noChangeAspect="1"/>
+          </p:cNvPicPr>
+          <p:nvPr/>
+        </p:nvPicPr>
+        <p:blipFill>
+          <a:blip r:embed="rId2"/>
+          <a:stretch>
+            <a:fillRect/>
+          </a:stretch>
+        </p:blipFill>
+        <p:spPr>
+          <a:xfrm>
+            <a:off x="935248" y="2206264"/>
+            <a:ext cx="342351" cy="342351"/>
+          </a:xfrm>
+          <a:prstGeom prst="rect">
+            <a:avLst/>
+          </a:prstGeom>
+        </p:spPr>
+      </p:pic>
+      <p:sp>
+        <p:nvSpPr>
+          <p:cNvPr id="9" name="TextBox 8"/>
           <p:cNvSpPr txBox="1"/>
           <p:nvPr/>
         </p:nvSpPr>
@@ -11643,7 +11943,7 @@
       </p:sp>
       <p:sp>
         <p:nvSpPr>
-          <p:cNvPr id="9" name="TextBox 8"/>
+          <p:cNvPr id="10" name="TextBox 9"/>
           <p:cNvSpPr txBox="1"/>
           <p:nvPr/>
         </p:nvSpPr>
@@ -11682,7 +11982,7 @@
       </p:sp>
       <p:sp>
         <p:nvSpPr>
-          <p:cNvPr id="10" name="Rounded Rectangle 9"/>
+          <p:cNvPr id="11" name="Rounded Rectangle 10"/>
           <p:cNvSpPr/>
           <p:nvPr/>
         </p:nvSpPr>
@@ -11730,7 +12030,7 @@
       </p:sp>
       <p:sp>
         <p:nvSpPr>
-          <p:cNvPr id="11" name="Rounded Rectangle 10"/>
+          <p:cNvPr id="12" name="Rounded Rectangle 11"/>
           <p:cNvSpPr/>
           <p:nvPr/>
         </p:nvSpPr>
@@ -11769,20 +12069,40 @@
           </a:fontRef>
         </p:style>
         <p:txBody>
-          <a:bodyPr rtlCol="0" anchor="ctr" wrap="square" lIns="9144" rIns="9144" tIns="9144" bIns="9144"/>
+          <a:bodyPr rtlCol="0" anchor="ctr" wrap="square" lIns="146304" rIns="146304" tIns="109728" bIns="109728"/>
           <a:lstStyle/>
           <a:p>
             <a:pPr algn="ctr"/>
-            <a:r>
-              <a:rPr sz="1700"/>
-              <a:t>💳</a:t>
-            </a:r>
-          </a:p>
-        </p:txBody>
-      </p:sp>
-      <p:sp>
-        <p:nvSpPr>
-          <p:cNvPr id="12" name="TextBox 11"/>
+          </a:p>
+        </p:txBody>
+      </p:sp>
+      <p:pic>
+        <p:nvPicPr>
+          <p:cNvPr id="13" name="Picture 12" descr="cardpay.png"/>
+          <p:cNvPicPr>
+            <a:picLocks noChangeAspect="1"/>
+          </p:cNvPicPr>
+          <p:nvPr/>
+        </p:nvPicPr>
+        <p:blipFill>
+          <a:blip r:embed="rId3"/>
+          <a:stretch>
+            <a:fillRect/>
+          </a:stretch>
+        </p:blipFill>
+        <p:spPr>
+          <a:xfrm>
+            <a:off x="935248" y="3669304"/>
+            <a:ext cx="342351" cy="342351"/>
+          </a:xfrm>
+          <a:prstGeom prst="rect">
+            <a:avLst/>
+          </a:prstGeom>
+        </p:spPr>
+      </p:pic>
+      <p:sp>
+        <p:nvSpPr>
+          <p:cNvPr id="14" name="TextBox 13"/>
           <p:cNvSpPr txBox="1"/>
           <p:nvPr/>
         </p:nvSpPr>
@@ -11816,7 +12136,7 @@
       </p:sp>
       <p:sp>
         <p:nvSpPr>
-          <p:cNvPr id="13" name="TextBox 12"/>
+          <p:cNvPr id="15" name="TextBox 14"/>
           <p:cNvSpPr txBox="1"/>
           <p:nvPr/>
         </p:nvSpPr>
@@ -11855,7 +12175,7 @@
       </p:sp>
       <p:sp>
         <p:nvSpPr>
-          <p:cNvPr id="14" name="Rounded Rectangle 13"/>
+          <p:cNvPr id="16" name="Rounded Rectangle 15"/>
           <p:cNvSpPr/>
           <p:nvPr/>
         </p:nvSpPr>
@@ -11903,7 +12223,7 @@
       </p:sp>
       <p:sp>
         <p:nvSpPr>
-          <p:cNvPr id="15" name="Rounded Rectangle 14"/>
+          <p:cNvPr id="17" name="Rounded Rectangle 16"/>
           <p:cNvSpPr/>
           <p:nvPr/>
         </p:nvSpPr>
@@ -11942,20 +12262,40 @@
           </a:fontRef>
         </p:style>
         <p:txBody>
-          <a:bodyPr rtlCol="0" anchor="ctr" wrap="square" lIns="9144" rIns="9144" tIns="9144" bIns="9144"/>
+          <a:bodyPr rtlCol="0" anchor="ctr" wrap="square" lIns="146304" rIns="146304" tIns="109728" bIns="109728"/>
           <a:lstStyle/>
           <a:p>
             <a:pPr algn="ctr"/>
-            <a:r>
-              <a:rPr sz="1700"/>
-              <a:t>📣</a:t>
-            </a:r>
-          </a:p>
-        </p:txBody>
-      </p:sp>
-      <p:sp>
-        <p:nvSpPr>
-          <p:cNvPr id="16" name="TextBox 15"/>
+          </a:p>
+        </p:txBody>
+      </p:sp>
+      <p:pic>
+        <p:nvPicPr>
+          <p:cNvPr id="18" name="Picture 17" descr="broadcast.png"/>
+          <p:cNvPicPr>
+            <a:picLocks noChangeAspect="1"/>
+          </p:cNvPicPr>
+          <p:nvPr/>
+        </p:nvPicPr>
+        <p:blipFill>
+          <a:blip r:embed="rId4"/>
+          <a:stretch>
+            <a:fillRect/>
+          </a:stretch>
+        </p:blipFill>
+        <p:spPr>
+          <a:xfrm>
+            <a:off x="935248" y="5132344"/>
+            <a:ext cx="342351" cy="342351"/>
+          </a:xfrm>
+          <a:prstGeom prst="rect">
+            <a:avLst/>
+          </a:prstGeom>
+        </p:spPr>
+      </p:pic>
+      <p:sp>
+        <p:nvSpPr>
+          <p:cNvPr id="19" name="TextBox 18"/>
           <p:cNvSpPr txBox="1"/>
           <p:nvPr/>
         </p:nvSpPr>
@@ -11989,7 +12329,7 @@
       </p:sp>
       <p:sp>
         <p:nvSpPr>
-          <p:cNvPr id="17" name="TextBox 16"/>
+          <p:cNvPr id="20" name="TextBox 19"/>
           <p:cNvSpPr txBox="1"/>
           <p:nvPr/>
         </p:nvSpPr>
@@ -12028,7 +12368,7 @@
       </p:sp>
       <p:sp>
         <p:nvSpPr>
-          <p:cNvPr id="18" name="TextBox 17"/>
+          <p:cNvPr id="21" name="TextBox 20"/>
           <p:cNvSpPr txBox="1"/>
           <p:nvPr/>
         </p:nvSpPr>
@@ -12062,7 +12402,7 @@
       </p:sp>
       <p:sp>
         <p:nvSpPr>
-          <p:cNvPr id="19" name="Rounded Rectangle 18"/>
+          <p:cNvPr id="22" name="Rounded Rectangle 21"/>
           <p:cNvSpPr/>
           <p:nvPr/>
         </p:nvSpPr>
@@ -12110,7 +12450,7 @@
       </p:sp>
       <p:sp>
         <p:nvSpPr>
-          <p:cNvPr id="20" name="Rounded Rectangle 19"/>
+          <p:cNvPr id="23" name="Rounded Rectangle 22"/>
           <p:cNvSpPr/>
           <p:nvPr/>
         </p:nvSpPr>
@@ -12125,7 +12465,7 @@
             </a:avLst>
           </a:prstGeom>
           <a:solidFill>
-            <a:srgbClr val="FFFFFF"/>
+            <a:srgbClr val="E7F1EC"/>
           </a:solidFill>
           <a:ln w="12700">
             <a:solidFill>
@@ -12149,20 +12489,40 @@
           </a:fontRef>
         </p:style>
         <p:txBody>
-          <a:bodyPr rtlCol="0" anchor="ctr" wrap="square" lIns="9144" rIns="9144" tIns="9144" bIns="9144"/>
+          <a:bodyPr rtlCol="0" anchor="ctr" wrap="square" lIns="146304" rIns="146304" tIns="109728" bIns="109728"/>
           <a:lstStyle/>
           <a:p>
             <a:pPr algn="ctr"/>
-            <a:r>
-              <a:rPr sz="1700"/>
-              <a:t>🔗</a:t>
-            </a:r>
-          </a:p>
-        </p:txBody>
-      </p:sp>
-      <p:sp>
-        <p:nvSpPr>
-          <p:cNvPr id="21" name="TextBox 20"/>
+          </a:p>
+        </p:txBody>
+      </p:sp>
+      <p:pic>
+        <p:nvPicPr>
+          <p:cNvPr id="24" name="Picture 23" descr="link.png"/>
+          <p:cNvPicPr>
+            <a:picLocks noChangeAspect="1"/>
+          </p:cNvPicPr>
+          <p:nvPr/>
+        </p:nvPicPr>
+        <p:blipFill>
+          <a:blip r:embed="rId5"/>
+          <a:stretch>
+            <a:fillRect/>
+          </a:stretch>
+        </p:blipFill>
+        <p:spPr>
+          <a:xfrm>
+            <a:off x="6723400" y="2224552"/>
+            <a:ext cx="342351" cy="342351"/>
+          </a:xfrm>
+          <a:prstGeom prst="rect">
+            <a:avLst/>
+          </a:prstGeom>
+        </p:spPr>
+      </p:pic>
+      <p:sp>
+        <p:nvSpPr>
+          <p:cNvPr id="25" name="TextBox 24"/>
           <p:cNvSpPr txBox="1"/>
           <p:nvPr/>
         </p:nvSpPr>
@@ -12226,7 +12586,7 @@
       </p:sp>
       <p:sp>
         <p:nvSpPr>
-          <p:cNvPr id="22" name="Rectangle 21"/>
+          <p:cNvPr id="26" name="Rectangle 25"/>
           <p:cNvSpPr/>
           <p:nvPr/>
         </p:nvSpPr>
@@ -12270,7 +12630,7 @@
       </p:sp>
       <p:sp>
         <p:nvSpPr>
-          <p:cNvPr id="23" name="TextBox 22"/>
+          <p:cNvPr id="27" name="TextBox 26"/>
           <p:cNvSpPr txBox="1"/>
           <p:nvPr/>
         </p:nvSpPr>
@@ -12313,7 +12673,7 @@
       </p:sp>
       <p:sp>
         <p:nvSpPr>
-          <p:cNvPr id="24" name="TextBox 23"/>
+          <p:cNvPr id="28" name="TextBox 27"/>
           <p:cNvSpPr txBox="1"/>
           <p:nvPr/>
         </p:nvSpPr>
@@ -12994,20 +13354,40 @@
           </a:fontRef>
         </p:style>
         <p:txBody>
-          <a:bodyPr rtlCol="0" anchor="ctr" wrap="square" lIns="9144" rIns="9144" tIns="9144" bIns="9144"/>
+          <a:bodyPr rtlCol="0" anchor="ctr" wrap="square" lIns="146304" rIns="146304" tIns="109728" bIns="109728"/>
           <a:lstStyle/>
           <a:p>
             <a:pPr algn="ctr"/>
-            <a:r>
-              <a:rPr sz="1700"/>
-              <a:t>🔗</a:t>
-            </a:r>
-          </a:p>
-        </p:txBody>
-      </p:sp>
-      <p:sp>
-        <p:nvSpPr>
-          <p:cNvPr id="7" name="TextBox 6"/>
+          </a:p>
+        </p:txBody>
+      </p:sp>
+      <p:pic>
+        <p:nvPicPr>
+          <p:cNvPr id="7" name="Picture 6" descr="link.png"/>
+          <p:cNvPicPr>
+            <a:picLocks noChangeAspect="1"/>
+          </p:cNvPicPr>
+          <p:nvPr/>
+        </p:nvPicPr>
+        <p:blipFill>
+          <a:blip r:embed="rId2"/>
+          <a:stretch>
+            <a:fillRect/>
+          </a:stretch>
+        </p:blipFill>
+        <p:spPr>
+          <a:xfrm>
+            <a:off x="935248" y="2352568"/>
+            <a:ext cx="342351" cy="342351"/>
+          </a:xfrm>
+          <a:prstGeom prst="rect">
+            <a:avLst/>
+          </a:prstGeom>
+        </p:spPr>
+      </p:pic>
+      <p:sp>
+        <p:nvSpPr>
+          <p:cNvPr id="8" name="TextBox 7"/>
           <p:cNvSpPr txBox="1"/>
           <p:nvPr/>
         </p:nvSpPr>
@@ -13041,7 +13421,7 @@
       </p:sp>
       <p:sp>
         <p:nvSpPr>
-          <p:cNvPr id="8" name="TextBox 7"/>
+          <p:cNvPr id="9" name="TextBox 8"/>
           <p:cNvSpPr txBox="1"/>
           <p:nvPr/>
         </p:nvSpPr>
@@ -13080,7 +13460,7 @@
       </p:sp>
       <p:sp>
         <p:nvSpPr>
-          <p:cNvPr id="9" name="Rounded Rectangle 8"/>
+          <p:cNvPr id="10" name="Rounded Rectangle 9"/>
           <p:cNvSpPr/>
           <p:nvPr/>
         </p:nvSpPr>
@@ -13128,7 +13508,7 @@
       </p:sp>
       <p:sp>
         <p:nvSpPr>
-          <p:cNvPr id="10" name="Rounded Rectangle 9"/>
+          <p:cNvPr id="11" name="Rounded Rectangle 10"/>
           <p:cNvSpPr/>
           <p:nvPr/>
         </p:nvSpPr>
@@ -13167,20 +13547,40 @@
           </a:fontRef>
         </p:style>
         <p:txBody>
-          <a:bodyPr rtlCol="0" anchor="ctr" wrap="square" lIns="9144" rIns="9144" tIns="9144" bIns="9144"/>
+          <a:bodyPr rtlCol="0" anchor="ctr" wrap="square" lIns="146304" rIns="146304" tIns="109728" bIns="109728"/>
           <a:lstStyle/>
           <a:p>
             <a:pPr algn="ctr"/>
-            <a:r>
-              <a:rPr sz="1700"/>
-              <a:t>🔁</a:t>
-            </a:r>
-          </a:p>
-        </p:txBody>
-      </p:sp>
-      <p:sp>
-        <p:nvSpPr>
-          <p:cNvPr id="11" name="TextBox 10"/>
+          </a:p>
+        </p:txBody>
+      </p:sp>
+      <p:pic>
+        <p:nvPicPr>
+          <p:cNvPr id="12" name="Picture 11" descr="refresh.png"/>
+          <p:cNvPicPr>
+            <a:picLocks noChangeAspect="1"/>
+          </p:cNvPicPr>
+          <p:nvPr/>
+        </p:nvPicPr>
+        <p:blipFill>
+          <a:blip r:embed="rId3"/>
+          <a:stretch>
+            <a:fillRect/>
+          </a:stretch>
+        </p:blipFill>
+        <p:spPr>
+          <a:xfrm>
+            <a:off x="4730008" y="2352568"/>
+            <a:ext cx="342351" cy="342351"/>
+          </a:xfrm>
+          <a:prstGeom prst="rect">
+            <a:avLst/>
+          </a:prstGeom>
+        </p:spPr>
+      </p:pic>
+      <p:sp>
+        <p:nvSpPr>
+          <p:cNvPr id="13" name="TextBox 12"/>
           <p:cNvSpPr txBox="1"/>
           <p:nvPr/>
         </p:nvSpPr>
@@ -13214,7 +13614,7 @@
       </p:sp>
       <p:sp>
         <p:nvSpPr>
-          <p:cNvPr id="12" name="TextBox 11"/>
+          <p:cNvPr id="14" name="TextBox 13"/>
           <p:cNvSpPr txBox="1"/>
           <p:nvPr/>
         </p:nvSpPr>
@@ -13253,7 +13653,7 @@
       </p:sp>
       <p:sp>
         <p:nvSpPr>
-          <p:cNvPr id="13" name="Rounded Rectangle 12"/>
+          <p:cNvPr id="15" name="Rounded Rectangle 14"/>
           <p:cNvSpPr/>
           <p:nvPr/>
         </p:nvSpPr>
@@ -13301,7 +13701,7 @@
       </p:sp>
       <p:sp>
         <p:nvSpPr>
-          <p:cNvPr id="14" name="Rounded Rectangle 13"/>
+          <p:cNvPr id="16" name="Rounded Rectangle 15"/>
           <p:cNvSpPr/>
           <p:nvPr/>
         </p:nvSpPr>
@@ -13340,20 +13740,40 @@
           </a:fontRef>
         </p:style>
         <p:txBody>
-          <a:bodyPr rtlCol="0" anchor="ctr" wrap="square" lIns="9144" rIns="9144" tIns="9144" bIns="9144"/>
+          <a:bodyPr rtlCol="0" anchor="ctr" wrap="square" lIns="146304" rIns="146304" tIns="109728" bIns="109728"/>
           <a:lstStyle/>
           <a:p>
             <a:pPr algn="ctr"/>
-            <a:r>
-              <a:rPr sz="1700"/>
-              <a:t>📥</a:t>
-            </a:r>
-          </a:p>
-        </p:txBody>
-      </p:sp>
-      <p:sp>
-        <p:nvSpPr>
-          <p:cNvPr id="15" name="TextBox 14"/>
+          </a:p>
+        </p:txBody>
+      </p:sp>
+      <p:pic>
+        <p:nvPicPr>
+          <p:cNvPr id="17" name="Picture 16" descr="inbox.png"/>
+          <p:cNvPicPr>
+            <a:picLocks noChangeAspect="1"/>
+          </p:cNvPicPr>
+          <p:nvPr/>
+        </p:nvPicPr>
+        <p:blipFill>
+          <a:blip r:embed="rId4"/>
+          <a:stretch>
+            <a:fillRect/>
+          </a:stretch>
+        </p:blipFill>
+        <p:spPr>
+          <a:xfrm>
+            <a:off x="8524768" y="2352568"/>
+            <a:ext cx="342351" cy="342351"/>
+          </a:xfrm>
+          <a:prstGeom prst="rect">
+            <a:avLst/>
+          </a:prstGeom>
+        </p:spPr>
+      </p:pic>
+      <p:sp>
+        <p:nvSpPr>
+          <p:cNvPr id="18" name="TextBox 17"/>
           <p:cNvSpPr txBox="1"/>
           <p:nvPr/>
         </p:nvSpPr>
@@ -13387,7 +13807,7 @@
       </p:sp>
       <p:sp>
         <p:nvSpPr>
-          <p:cNvPr id="16" name="TextBox 15"/>
+          <p:cNvPr id="19" name="TextBox 18"/>
           <p:cNvSpPr txBox="1"/>
           <p:nvPr/>
         </p:nvSpPr>
@@ -13426,7 +13846,7 @@
       </p:sp>
       <p:sp>
         <p:nvSpPr>
-          <p:cNvPr id="17" name="Rectangle 16"/>
+          <p:cNvPr id="20" name="Rectangle 19"/>
           <p:cNvSpPr/>
           <p:nvPr/>
         </p:nvSpPr>
@@ -13470,7 +13890,7 @@
       </p:sp>
       <p:sp>
         <p:nvSpPr>
-          <p:cNvPr id="18" name="TextBox 17"/>
+          <p:cNvPr id="21" name="TextBox 20"/>
           <p:cNvSpPr txBox="1"/>
           <p:nvPr/>
         </p:nvSpPr>
@@ -13513,7 +13933,7 @@
       </p:sp>
       <p:sp>
         <p:nvSpPr>
-          <p:cNvPr id="19" name="TextBox 18"/>
+          <p:cNvPr id="22" name="TextBox 21"/>
           <p:cNvSpPr txBox="1"/>
           <p:nvPr/>
         </p:nvSpPr>
@@ -13764,20 +14184,40 @@
           </a:fontRef>
         </p:style>
         <p:txBody>
-          <a:bodyPr rtlCol="0" anchor="ctr" wrap="square" lIns="9144" rIns="9144" tIns="9144" bIns="9144"/>
+          <a:bodyPr rtlCol="0" anchor="ctr" wrap="square" lIns="146304" rIns="146304" tIns="109728" bIns="109728"/>
           <a:lstStyle/>
           <a:p>
             <a:pPr algn="ctr"/>
-            <a:r>
-              <a:rPr sz="1700"/>
-              <a:t>💱</a:t>
-            </a:r>
-          </a:p>
-        </p:txBody>
-      </p:sp>
-      <p:sp>
-        <p:nvSpPr>
-          <p:cNvPr id="7" name="TextBox 6"/>
+          </a:p>
+        </p:txBody>
+      </p:sp>
+      <p:pic>
+        <p:nvPicPr>
+          <p:cNvPr id="7" name="Picture 6" descr="exchange.png"/>
+          <p:cNvPicPr>
+            <a:picLocks noChangeAspect="1"/>
+          </p:cNvPicPr>
+          <p:nvPr/>
+        </p:nvPicPr>
+        <p:blipFill>
+          <a:blip r:embed="rId2"/>
+          <a:stretch>
+            <a:fillRect/>
+          </a:stretch>
+        </p:blipFill>
+        <p:spPr>
+          <a:xfrm>
+            <a:off x="935248" y="2352568"/>
+            <a:ext cx="342351" cy="342351"/>
+          </a:xfrm>
+          <a:prstGeom prst="rect">
+            <a:avLst/>
+          </a:prstGeom>
+        </p:spPr>
+      </p:pic>
+      <p:sp>
+        <p:nvSpPr>
+          <p:cNvPr id="8" name="TextBox 7"/>
           <p:cNvSpPr txBox="1"/>
           <p:nvPr/>
         </p:nvSpPr>
@@ -13811,7 +14251,7 @@
       </p:sp>
       <p:sp>
         <p:nvSpPr>
-          <p:cNvPr id="8" name="TextBox 7"/>
+          <p:cNvPr id="9" name="TextBox 8"/>
           <p:cNvSpPr txBox="1"/>
           <p:nvPr/>
         </p:nvSpPr>
@@ -13850,7 +14290,7 @@
       </p:sp>
       <p:sp>
         <p:nvSpPr>
-          <p:cNvPr id="9" name="Rounded Rectangle 8"/>
+          <p:cNvPr id="10" name="Rounded Rectangle 9"/>
           <p:cNvSpPr/>
           <p:nvPr/>
         </p:nvSpPr>
@@ -13898,7 +14338,7 @@
       </p:sp>
       <p:sp>
         <p:nvSpPr>
-          <p:cNvPr id="10" name="Rounded Rectangle 9"/>
+          <p:cNvPr id="11" name="Rounded Rectangle 10"/>
           <p:cNvSpPr/>
           <p:nvPr/>
         </p:nvSpPr>
@@ -13937,20 +14377,40 @@
           </a:fontRef>
         </p:style>
         <p:txBody>
-          <a:bodyPr rtlCol="0" anchor="ctr" wrap="square" lIns="9144" rIns="9144" tIns="9144" bIns="9144"/>
+          <a:bodyPr rtlCol="0" anchor="ctr" wrap="square" lIns="146304" rIns="146304" tIns="109728" bIns="109728"/>
           <a:lstStyle/>
           <a:p>
             <a:pPr algn="ctr"/>
-            <a:r>
-              <a:rPr sz="1700"/>
-              <a:t>📊</a:t>
-            </a:r>
-          </a:p>
-        </p:txBody>
-      </p:sp>
-      <p:sp>
-        <p:nvSpPr>
-          <p:cNvPr id="11" name="TextBox 10"/>
+          </a:p>
+        </p:txBody>
+      </p:sp>
+      <p:pic>
+        <p:nvPicPr>
+          <p:cNvPr id="12" name="Picture 11" descr="chart.png"/>
+          <p:cNvPicPr>
+            <a:picLocks noChangeAspect="1"/>
+          </p:cNvPicPr>
+          <p:nvPr/>
+        </p:nvPicPr>
+        <p:blipFill>
+          <a:blip r:embed="rId3"/>
+          <a:stretch>
+            <a:fillRect/>
+          </a:stretch>
+        </p:blipFill>
+        <p:spPr>
+          <a:xfrm>
+            <a:off x="4730008" y="2352568"/>
+            <a:ext cx="342351" cy="342351"/>
+          </a:xfrm>
+          <a:prstGeom prst="rect">
+            <a:avLst/>
+          </a:prstGeom>
+        </p:spPr>
+      </p:pic>
+      <p:sp>
+        <p:nvSpPr>
+          <p:cNvPr id="13" name="TextBox 12"/>
           <p:cNvSpPr txBox="1"/>
           <p:nvPr/>
         </p:nvSpPr>
@@ -13984,7 +14444,7 @@
       </p:sp>
       <p:sp>
         <p:nvSpPr>
-          <p:cNvPr id="12" name="TextBox 11"/>
+          <p:cNvPr id="14" name="TextBox 13"/>
           <p:cNvSpPr txBox="1"/>
           <p:nvPr/>
         </p:nvSpPr>
@@ -14023,7 +14483,7 @@
       </p:sp>
       <p:sp>
         <p:nvSpPr>
-          <p:cNvPr id="13" name="Rounded Rectangle 12"/>
+          <p:cNvPr id="15" name="Rounded Rectangle 14"/>
           <p:cNvSpPr/>
           <p:nvPr/>
         </p:nvSpPr>
@@ -14071,7 +14531,7 @@
       </p:sp>
       <p:sp>
         <p:nvSpPr>
-          <p:cNvPr id="14" name="Rounded Rectangle 13"/>
+          <p:cNvPr id="16" name="Rounded Rectangle 15"/>
           <p:cNvSpPr/>
           <p:nvPr/>
         </p:nvSpPr>
@@ -14110,20 +14570,40 @@
           </a:fontRef>
         </p:style>
         <p:txBody>
-          <a:bodyPr rtlCol="0" anchor="ctr" wrap="square" lIns="9144" rIns="9144" tIns="9144" bIns="9144"/>
+          <a:bodyPr rtlCol="0" anchor="ctr" wrap="square" lIns="146304" rIns="146304" tIns="109728" bIns="109728"/>
           <a:lstStyle/>
           <a:p>
             <a:pPr algn="ctr"/>
-            <a:r>
-              <a:rPr sz="1700"/>
-              <a:t>🏦</a:t>
-            </a:r>
-          </a:p>
-        </p:txBody>
-      </p:sp>
-      <p:sp>
-        <p:nvSpPr>
-          <p:cNvPr id="15" name="TextBox 14"/>
+          </a:p>
+        </p:txBody>
+      </p:sp>
+      <p:pic>
+        <p:nvPicPr>
+          <p:cNvPr id="17" name="Picture 16" descr="bank.png"/>
+          <p:cNvPicPr>
+            <a:picLocks noChangeAspect="1"/>
+          </p:cNvPicPr>
+          <p:nvPr/>
+        </p:nvPicPr>
+        <p:blipFill>
+          <a:blip r:embed="rId4"/>
+          <a:stretch>
+            <a:fillRect/>
+          </a:stretch>
+        </p:blipFill>
+        <p:spPr>
+          <a:xfrm>
+            <a:off x="8524768" y="2352568"/>
+            <a:ext cx="342351" cy="342351"/>
+          </a:xfrm>
+          <a:prstGeom prst="rect">
+            <a:avLst/>
+          </a:prstGeom>
+        </p:spPr>
+      </p:pic>
+      <p:sp>
+        <p:nvSpPr>
+          <p:cNvPr id="18" name="TextBox 17"/>
           <p:cNvSpPr txBox="1"/>
           <p:nvPr/>
         </p:nvSpPr>
@@ -14157,7 +14637,7 @@
       </p:sp>
       <p:sp>
         <p:nvSpPr>
-          <p:cNvPr id="16" name="TextBox 15"/>
+          <p:cNvPr id="19" name="TextBox 18"/>
           <p:cNvSpPr txBox="1"/>
           <p:nvPr/>
         </p:nvSpPr>
@@ -14196,7 +14676,7 @@
       </p:sp>
       <p:sp>
         <p:nvSpPr>
-          <p:cNvPr id="17" name="Rectangle 16"/>
+          <p:cNvPr id="20" name="Rectangle 19"/>
           <p:cNvSpPr/>
           <p:nvPr/>
         </p:nvSpPr>
@@ -14240,7 +14720,7 @@
       </p:sp>
       <p:sp>
         <p:nvSpPr>
-          <p:cNvPr id="18" name="TextBox 17"/>
+          <p:cNvPr id="21" name="TextBox 20"/>
           <p:cNvSpPr txBox="1"/>
           <p:nvPr/>
         </p:nvSpPr>
@@ -14283,7 +14763,7 @@
       </p:sp>
       <p:sp>
         <p:nvSpPr>
-          <p:cNvPr id="19" name="TextBox 18"/>
+          <p:cNvPr id="22" name="TextBox 21"/>
           <p:cNvSpPr txBox="1"/>
           <p:nvPr/>
         </p:nvSpPr>
@@ -14534,20 +15014,40 @@
           </a:fontRef>
         </p:style>
         <p:txBody>
-          <a:bodyPr rtlCol="0" anchor="ctr" wrap="square" lIns="9144" rIns="9144" tIns="9144" bIns="9144"/>
+          <a:bodyPr rtlCol="0" anchor="ctr" wrap="square" lIns="146304" rIns="146304" tIns="109728" bIns="109728"/>
           <a:lstStyle/>
           <a:p>
             <a:pPr algn="ctr"/>
-            <a:r>
-              <a:rPr sz="1700"/>
-              <a:t>🛒</a:t>
-            </a:r>
-          </a:p>
-        </p:txBody>
-      </p:sp>
-      <p:sp>
-        <p:nvSpPr>
-          <p:cNvPr id="7" name="TextBox 6"/>
+          </a:p>
+        </p:txBody>
+      </p:sp>
+      <p:pic>
+        <p:nvPicPr>
+          <p:cNvPr id="7" name="Picture 6" descr="cart.png"/>
+          <p:cNvPicPr>
+            <a:picLocks noChangeAspect="1"/>
+          </p:cNvPicPr>
+          <p:nvPr/>
+        </p:nvPicPr>
+        <p:blipFill>
+          <a:blip r:embed="rId2"/>
+          <a:stretch>
+            <a:fillRect/>
+          </a:stretch>
+        </p:blipFill>
+        <p:spPr>
+          <a:xfrm>
+            <a:off x="3669304" y="2096536"/>
+            <a:ext cx="342351" cy="342351"/>
+          </a:xfrm>
+          <a:prstGeom prst="rect">
+            <a:avLst/>
+          </a:prstGeom>
+        </p:spPr>
+      </p:pic>
+      <p:sp>
+        <p:nvSpPr>
+          <p:cNvPr id="8" name="TextBox 7"/>
           <p:cNvSpPr txBox="1"/>
           <p:nvPr/>
         </p:nvSpPr>
@@ -14581,7 +15081,7 @@
       </p:sp>
       <p:sp>
         <p:nvSpPr>
-          <p:cNvPr id="8" name="TextBox 7"/>
+          <p:cNvPr id="9" name="TextBox 8"/>
           <p:cNvSpPr txBox="1"/>
           <p:nvPr/>
         </p:nvSpPr>
@@ -14620,7 +15120,7 @@
       </p:sp>
       <p:sp>
         <p:nvSpPr>
-          <p:cNvPr id="9" name="Rounded Rectangle 8"/>
+          <p:cNvPr id="10" name="Rounded Rectangle 9"/>
           <p:cNvSpPr/>
           <p:nvPr/>
         </p:nvSpPr>
@@ -14668,7 +15168,7 @@
       </p:sp>
       <p:sp>
         <p:nvSpPr>
-          <p:cNvPr id="10" name="Rounded Rectangle 9"/>
+          <p:cNvPr id="11" name="Rounded Rectangle 10"/>
           <p:cNvSpPr/>
           <p:nvPr/>
         </p:nvSpPr>
@@ -14707,20 +15207,40 @@
           </a:fontRef>
         </p:style>
         <p:txBody>
-          <a:bodyPr rtlCol="0" anchor="ctr" wrap="square" lIns="9144" rIns="9144" tIns="9144" bIns="9144"/>
+          <a:bodyPr rtlCol="0" anchor="ctr" wrap="square" lIns="146304" rIns="146304" tIns="109728" bIns="109728"/>
           <a:lstStyle/>
           <a:p>
             <a:pPr algn="ctr"/>
-            <a:r>
-              <a:rPr sz="1700"/>
-              <a:t>💬</a:t>
-            </a:r>
-          </a:p>
-        </p:txBody>
-      </p:sp>
-      <p:sp>
-        <p:nvSpPr>
-          <p:cNvPr id="11" name="TextBox 10"/>
+          </a:p>
+        </p:txBody>
+      </p:sp>
+      <p:pic>
+        <p:nvPicPr>
+          <p:cNvPr id="12" name="Picture 11" descr="chat.png"/>
+          <p:cNvPicPr>
+            <a:picLocks noChangeAspect="1"/>
+          </p:cNvPicPr>
+          <p:nvPr/>
+        </p:nvPicPr>
+        <p:blipFill>
+          <a:blip r:embed="rId3"/>
+          <a:stretch>
+            <a:fillRect/>
+          </a:stretch>
+        </p:blipFill>
+        <p:spPr>
+          <a:xfrm>
+            <a:off x="7464064" y="2096536"/>
+            <a:ext cx="342351" cy="342351"/>
+          </a:xfrm>
+          <a:prstGeom prst="rect">
+            <a:avLst/>
+          </a:prstGeom>
+        </p:spPr>
+      </p:pic>
+      <p:sp>
+        <p:nvSpPr>
+          <p:cNvPr id="13" name="TextBox 12"/>
           <p:cNvSpPr txBox="1"/>
           <p:nvPr/>
         </p:nvSpPr>
@@ -14754,7 +15274,7 @@
       </p:sp>
       <p:sp>
         <p:nvSpPr>
-          <p:cNvPr id="12" name="TextBox 11"/>
+          <p:cNvPr id="14" name="TextBox 13"/>
           <p:cNvSpPr txBox="1"/>
           <p:nvPr/>
         </p:nvSpPr>
@@ -14793,7 +15313,7 @@
       </p:sp>
       <p:sp>
         <p:nvSpPr>
-          <p:cNvPr id="13" name="Rounded Rectangle 12"/>
+          <p:cNvPr id="15" name="Rounded Rectangle 14"/>
           <p:cNvSpPr/>
           <p:nvPr/>
         </p:nvSpPr>
@@ -14841,7 +15361,7 @@
       </p:sp>
       <p:sp>
         <p:nvSpPr>
-          <p:cNvPr id="14" name="Rounded Rectangle 13"/>
+          <p:cNvPr id="16" name="Rounded Rectangle 15"/>
           <p:cNvSpPr/>
           <p:nvPr/>
         </p:nvSpPr>
@@ -14880,20 +15400,40 @@
           </a:fontRef>
         </p:style>
         <p:txBody>
-          <a:bodyPr rtlCol="0" anchor="ctr" wrap="square" lIns="9144" rIns="9144" tIns="9144" bIns="9144"/>
+          <a:bodyPr rtlCol="0" anchor="ctr" wrap="square" lIns="146304" rIns="146304" tIns="109728" bIns="109728"/>
           <a:lstStyle/>
           <a:p>
             <a:pPr algn="ctr"/>
-            <a:r>
-              <a:rPr sz="1700"/>
-              <a:t>📈</a:t>
-            </a:r>
-          </a:p>
-        </p:txBody>
-      </p:sp>
-      <p:sp>
-        <p:nvSpPr>
-          <p:cNvPr id="15" name="TextBox 14"/>
+          </a:p>
+        </p:txBody>
+      </p:sp>
+      <p:pic>
+        <p:nvPicPr>
+          <p:cNvPr id="17" name="Picture 16" descr="trend.png"/>
+          <p:cNvPicPr>
+            <a:picLocks noChangeAspect="1"/>
+          </p:cNvPicPr>
+          <p:nvPr/>
+        </p:nvPicPr>
+        <p:blipFill>
+          <a:blip r:embed="rId4"/>
+          <a:stretch>
+            <a:fillRect/>
+          </a:stretch>
+        </p:blipFill>
+        <p:spPr>
+          <a:xfrm>
+            <a:off x="11258824" y="2096536"/>
+            <a:ext cx="342351" cy="342351"/>
+          </a:xfrm>
+          <a:prstGeom prst="rect">
+            <a:avLst/>
+          </a:prstGeom>
+        </p:spPr>
+      </p:pic>
+      <p:sp>
+        <p:nvSpPr>
+          <p:cNvPr id="18" name="TextBox 17"/>
           <p:cNvSpPr txBox="1"/>
           <p:nvPr/>
         </p:nvSpPr>
@@ -14927,7 +15467,7 @@
       </p:sp>
       <p:sp>
         <p:nvSpPr>
-          <p:cNvPr id="16" name="TextBox 15"/>
+          <p:cNvPr id="19" name="TextBox 18"/>
           <p:cNvSpPr txBox="1"/>
           <p:nvPr/>
         </p:nvSpPr>
@@ -14966,7 +15506,7 @@
       </p:sp>
       <p:sp>
         <p:nvSpPr>
-          <p:cNvPr id="17" name="Rounded Rectangle 16"/>
+          <p:cNvPr id="20" name="Rounded Rectangle 19"/>
           <p:cNvSpPr/>
           <p:nvPr/>
         </p:nvSpPr>
@@ -15014,7 +15554,7 @@
       </p:sp>
       <p:sp>
         <p:nvSpPr>
-          <p:cNvPr id="18" name="Rounded Rectangle 17"/>
+          <p:cNvPr id="21" name="Rounded Rectangle 20"/>
           <p:cNvSpPr/>
           <p:nvPr/>
         </p:nvSpPr>
@@ -15053,20 +15593,40 @@
           </a:fontRef>
         </p:style>
         <p:txBody>
-          <a:bodyPr rtlCol="0" anchor="ctr" wrap="square" lIns="9144" rIns="9144" tIns="9144" bIns="9144"/>
+          <a:bodyPr rtlCol="0" anchor="ctr" wrap="square" lIns="146304" rIns="146304" tIns="109728" bIns="109728"/>
           <a:lstStyle/>
           <a:p>
             <a:pPr algn="ctr"/>
-            <a:r>
-              <a:rPr sz="1700"/>
-              <a:t>⏱️</a:t>
-            </a:r>
-          </a:p>
-        </p:txBody>
-      </p:sp>
-      <p:sp>
-        <p:nvSpPr>
-          <p:cNvPr id="19" name="TextBox 18"/>
+          </a:p>
+        </p:txBody>
+      </p:sp>
+      <p:pic>
+        <p:nvPicPr>
+          <p:cNvPr id="22" name="Picture 21" descr="clock.png"/>
+          <p:cNvPicPr>
+            <a:picLocks noChangeAspect="1"/>
+          </p:cNvPicPr>
+          <p:nvPr/>
+        </p:nvPicPr>
+        <p:blipFill>
+          <a:blip r:embed="rId5"/>
+          <a:stretch>
+            <a:fillRect/>
+          </a:stretch>
+        </p:blipFill>
+        <p:spPr>
+          <a:xfrm>
+            <a:off x="3669304" y="4272808"/>
+            <a:ext cx="342351" cy="342351"/>
+          </a:xfrm>
+          <a:prstGeom prst="rect">
+            <a:avLst/>
+          </a:prstGeom>
+        </p:spPr>
+      </p:pic>
+      <p:sp>
+        <p:nvSpPr>
+          <p:cNvPr id="23" name="TextBox 22"/>
           <p:cNvSpPr txBox="1"/>
           <p:nvPr/>
         </p:nvSpPr>
@@ -15100,7 +15660,7 @@
       </p:sp>
       <p:sp>
         <p:nvSpPr>
-          <p:cNvPr id="20" name="TextBox 19"/>
+          <p:cNvPr id="24" name="TextBox 23"/>
           <p:cNvSpPr txBox="1"/>
           <p:nvPr/>
         </p:nvSpPr>
@@ -15139,7 +15699,7 @@
       </p:sp>
       <p:sp>
         <p:nvSpPr>
-          <p:cNvPr id="21" name="Rounded Rectangle 20"/>
+          <p:cNvPr id="25" name="Rounded Rectangle 24"/>
           <p:cNvSpPr/>
           <p:nvPr/>
         </p:nvSpPr>
@@ -15187,7 +15747,7 @@
       </p:sp>
       <p:sp>
         <p:nvSpPr>
-          <p:cNvPr id="22" name="Rounded Rectangle 21"/>
+          <p:cNvPr id="26" name="Rounded Rectangle 25"/>
           <p:cNvSpPr/>
           <p:nvPr/>
         </p:nvSpPr>
@@ -15226,20 +15786,40 @@
           </a:fontRef>
         </p:style>
         <p:txBody>
-          <a:bodyPr rtlCol="0" anchor="ctr" wrap="square" lIns="9144" rIns="9144" tIns="9144" bIns="9144"/>
+          <a:bodyPr rtlCol="0" anchor="ctr" wrap="square" lIns="146304" rIns="146304" tIns="109728" bIns="109728"/>
           <a:lstStyle/>
           <a:p>
             <a:pPr algn="ctr"/>
-            <a:r>
-              <a:rPr sz="1700"/>
-              <a:t>🏦</a:t>
-            </a:r>
-          </a:p>
-        </p:txBody>
-      </p:sp>
-      <p:sp>
-        <p:nvSpPr>
-          <p:cNvPr id="23" name="TextBox 22"/>
+          </a:p>
+        </p:txBody>
+      </p:sp>
+      <p:pic>
+        <p:nvPicPr>
+          <p:cNvPr id="27" name="Picture 26" descr="bank.png"/>
+          <p:cNvPicPr>
+            <a:picLocks noChangeAspect="1"/>
+          </p:cNvPicPr>
+          <p:nvPr/>
+        </p:nvPicPr>
+        <p:blipFill>
+          <a:blip r:embed="rId6"/>
+          <a:stretch>
+            <a:fillRect/>
+          </a:stretch>
+        </p:blipFill>
+        <p:spPr>
+          <a:xfrm>
+            <a:off x="7464064" y="4272808"/>
+            <a:ext cx="342351" cy="342351"/>
+          </a:xfrm>
+          <a:prstGeom prst="rect">
+            <a:avLst/>
+          </a:prstGeom>
+        </p:spPr>
+      </p:pic>
+      <p:sp>
+        <p:nvSpPr>
+          <p:cNvPr id="28" name="TextBox 27"/>
           <p:cNvSpPr txBox="1"/>
           <p:nvPr/>
         </p:nvSpPr>
@@ -15273,7 +15853,7 @@
       </p:sp>
       <p:sp>
         <p:nvSpPr>
-          <p:cNvPr id="24" name="TextBox 23"/>
+          <p:cNvPr id="29" name="TextBox 28"/>
           <p:cNvSpPr txBox="1"/>
           <p:nvPr/>
         </p:nvSpPr>
@@ -15312,7 +15892,7 @@
       </p:sp>
       <p:sp>
         <p:nvSpPr>
-          <p:cNvPr id="25" name="Rounded Rectangle 24"/>
+          <p:cNvPr id="30" name="Rounded Rectangle 29"/>
           <p:cNvSpPr/>
           <p:nvPr/>
         </p:nvSpPr>
@@ -15360,7 +15940,7 @@
       </p:sp>
       <p:sp>
         <p:nvSpPr>
-          <p:cNvPr id="26" name="Rounded Rectangle 25"/>
+          <p:cNvPr id="31" name="Rounded Rectangle 30"/>
           <p:cNvSpPr/>
           <p:nvPr/>
         </p:nvSpPr>
@@ -15399,20 +15979,40 @@
           </a:fontRef>
         </p:style>
         <p:txBody>
-          <a:bodyPr rtlCol="0" anchor="ctr" wrap="square" lIns="9144" rIns="9144" tIns="9144" bIns="9144"/>
+          <a:bodyPr rtlCol="0" anchor="ctr" wrap="square" lIns="146304" rIns="146304" tIns="109728" bIns="109728"/>
           <a:lstStyle/>
           <a:p>
             <a:pPr algn="ctr"/>
-            <a:r>
-              <a:rPr sz="1700"/>
-              <a:t>🎯</a:t>
-            </a:r>
-          </a:p>
-        </p:txBody>
-      </p:sp>
-      <p:sp>
-        <p:nvSpPr>
-          <p:cNvPr id="27" name="TextBox 26"/>
+          </a:p>
+        </p:txBody>
+      </p:sp>
+      <p:pic>
+        <p:nvPicPr>
+          <p:cNvPr id="32" name="Picture 31" descr="target.png"/>
+          <p:cNvPicPr>
+            <a:picLocks noChangeAspect="1"/>
+          </p:cNvPicPr>
+          <p:nvPr/>
+        </p:nvPicPr>
+        <p:blipFill>
+          <a:blip r:embed="rId7"/>
+          <a:stretch>
+            <a:fillRect/>
+          </a:stretch>
+        </p:blipFill>
+        <p:spPr>
+          <a:xfrm>
+            <a:off x="11258824" y="4272808"/>
+            <a:ext cx="342351" cy="342351"/>
+          </a:xfrm>
+          <a:prstGeom prst="rect">
+            <a:avLst/>
+          </a:prstGeom>
+        </p:spPr>
+      </p:pic>
+      <p:sp>
+        <p:nvSpPr>
+          <p:cNvPr id="33" name="TextBox 32"/>
           <p:cNvSpPr txBox="1"/>
           <p:nvPr/>
         </p:nvSpPr>
@@ -15446,7 +16046,7 @@
       </p:sp>
       <p:sp>
         <p:nvSpPr>
-          <p:cNvPr id="28" name="TextBox 27"/>
+          <p:cNvPr id="34" name="TextBox 33"/>
           <p:cNvSpPr txBox="1"/>
           <p:nvPr/>
         </p:nvSpPr>
@@ -15485,7 +16085,7 @@
       </p:sp>
       <p:sp>
         <p:nvSpPr>
-          <p:cNvPr id="29" name="Rectangle 28"/>
+          <p:cNvPr id="35" name="Rectangle 34"/>
           <p:cNvSpPr/>
           <p:nvPr/>
         </p:nvSpPr>
@@ -15529,7 +16129,7 @@
       </p:sp>
       <p:sp>
         <p:nvSpPr>
-          <p:cNvPr id="30" name="TextBox 29"/>
+          <p:cNvPr id="36" name="TextBox 35"/>
           <p:cNvSpPr txBox="1"/>
           <p:nvPr/>
         </p:nvSpPr>
@@ -15572,7 +16172,7 @@
       </p:sp>
       <p:sp>
         <p:nvSpPr>
-          <p:cNvPr id="31" name="TextBox 30"/>
+          <p:cNvPr id="37" name="TextBox 36"/>
           <p:cNvSpPr txBox="1"/>
           <p:nvPr/>
         </p:nvSpPr>
@@ -17607,20 +18207,40 @@
           </a:fontRef>
         </p:style>
         <p:txBody>
-          <a:bodyPr rtlCol="0" anchor="ctr" wrap="square" lIns="9144" rIns="9144" tIns="9144" bIns="9144"/>
+          <a:bodyPr rtlCol="0" anchor="ctr" wrap="square" lIns="146304" rIns="146304" tIns="109728" bIns="109728"/>
           <a:lstStyle/>
           <a:p>
             <a:pPr algn="ctr"/>
-            <a:r>
-              <a:rPr sz="1700"/>
-              <a:t>📦</a:t>
-            </a:r>
-          </a:p>
-        </p:txBody>
-      </p:sp>
-      <p:sp>
-        <p:nvSpPr>
-          <p:cNvPr id="7" name="TextBox 6"/>
+          </a:p>
+        </p:txBody>
+      </p:sp>
+      <p:pic>
+        <p:nvPicPr>
+          <p:cNvPr id="7" name="Picture 6" descr="box.png"/>
+          <p:cNvPicPr>
+            <a:picLocks noChangeAspect="1"/>
+          </p:cNvPicPr>
+          <p:nvPr/>
+        </p:nvPicPr>
+        <p:blipFill>
+          <a:blip r:embed="rId2"/>
+          <a:stretch>
+            <a:fillRect/>
+          </a:stretch>
+        </p:blipFill>
+        <p:spPr>
+          <a:xfrm>
+            <a:off x="907816" y="2142256"/>
+            <a:ext cx="342351" cy="342351"/>
+          </a:xfrm>
+          <a:prstGeom prst="rect">
+            <a:avLst/>
+          </a:prstGeom>
+        </p:spPr>
+      </p:pic>
+      <p:sp>
+        <p:nvSpPr>
+          <p:cNvPr id="8" name="TextBox 7"/>
           <p:cNvSpPr txBox="1"/>
           <p:nvPr/>
         </p:nvSpPr>
@@ -17659,7 +18279,7 @@
       </p:sp>
       <p:sp>
         <p:nvSpPr>
-          <p:cNvPr id="8" name="TextBox 7"/>
+          <p:cNvPr id="9" name="TextBox 8"/>
           <p:cNvSpPr txBox="1"/>
           <p:nvPr/>
         </p:nvSpPr>
@@ -17698,7 +18318,7 @@
       </p:sp>
       <p:sp>
         <p:nvSpPr>
-          <p:cNvPr id="9" name="Rounded Rectangle 8"/>
+          <p:cNvPr id="10" name="Rounded Rectangle 9"/>
           <p:cNvSpPr/>
           <p:nvPr/>
         </p:nvSpPr>
@@ -17746,7 +18366,7 @@
       </p:sp>
       <p:sp>
         <p:nvSpPr>
-          <p:cNvPr id="10" name="Rounded Rectangle 9"/>
+          <p:cNvPr id="11" name="Rounded Rectangle 10"/>
           <p:cNvSpPr/>
           <p:nvPr/>
         </p:nvSpPr>
@@ -17785,20 +18405,40 @@
           </a:fontRef>
         </p:style>
         <p:txBody>
-          <a:bodyPr rtlCol="0" anchor="ctr" wrap="square" lIns="9144" rIns="9144" tIns="9144" bIns="9144"/>
+          <a:bodyPr rtlCol="0" anchor="ctr" wrap="square" lIns="146304" rIns="146304" tIns="109728" bIns="109728"/>
           <a:lstStyle/>
           <a:p>
             <a:pPr algn="ctr"/>
-            <a:r>
-              <a:rPr sz="1700"/>
-              <a:t>🏗️</a:t>
-            </a:r>
-          </a:p>
-        </p:txBody>
-      </p:sp>
-      <p:sp>
-        <p:nvSpPr>
-          <p:cNvPr id="11" name="TextBox 10"/>
+          </a:p>
+        </p:txBody>
+      </p:sp>
+      <p:pic>
+        <p:nvPicPr>
+          <p:cNvPr id="12" name="Picture 11" descr="layers.png"/>
+          <p:cNvPicPr>
+            <a:picLocks noChangeAspect="1"/>
+          </p:cNvPicPr>
+          <p:nvPr/>
+        </p:nvPicPr>
+        <p:blipFill>
+          <a:blip r:embed="rId3"/>
+          <a:stretch>
+            <a:fillRect/>
+          </a:stretch>
+        </p:blipFill>
+        <p:spPr>
+          <a:xfrm>
+            <a:off x="3212104" y="2142256"/>
+            <a:ext cx="342351" cy="342351"/>
+          </a:xfrm>
+          <a:prstGeom prst="rect">
+            <a:avLst/>
+          </a:prstGeom>
+        </p:spPr>
+      </p:pic>
+      <p:sp>
+        <p:nvSpPr>
+          <p:cNvPr id="13" name="TextBox 12"/>
           <p:cNvSpPr txBox="1"/>
           <p:nvPr/>
         </p:nvSpPr>
@@ -17837,7 +18477,7 @@
       </p:sp>
       <p:sp>
         <p:nvSpPr>
-          <p:cNvPr id="12" name="TextBox 11"/>
+          <p:cNvPr id="14" name="TextBox 13"/>
           <p:cNvSpPr txBox="1"/>
           <p:nvPr/>
         </p:nvSpPr>
@@ -17876,7 +18516,7 @@
       </p:sp>
       <p:sp>
         <p:nvSpPr>
-          <p:cNvPr id="13" name="Rounded Rectangle 12"/>
+          <p:cNvPr id="15" name="Rounded Rectangle 14"/>
           <p:cNvSpPr/>
           <p:nvPr/>
         </p:nvSpPr>
@@ -17924,7 +18564,7 @@
       </p:sp>
       <p:sp>
         <p:nvSpPr>
-          <p:cNvPr id="14" name="Rounded Rectangle 13"/>
+          <p:cNvPr id="16" name="Rounded Rectangle 15"/>
           <p:cNvSpPr/>
           <p:nvPr/>
         </p:nvSpPr>
@@ -17963,20 +18603,40 @@
           </a:fontRef>
         </p:style>
         <p:txBody>
-          <a:bodyPr rtlCol="0" anchor="ctr" wrap="square" lIns="9144" rIns="9144" tIns="9144" bIns="9144"/>
+          <a:bodyPr rtlCol="0" anchor="ctr" wrap="square" lIns="146304" rIns="146304" tIns="109728" bIns="109728"/>
           <a:lstStyle/>
           <a:p>
             <a:pPr algn="ctr"/>
-            <a:r>
-              <a:rPr sz="1700"/>
-              <a:t>📜</a:t>
-            </a:r>
-          </a:p>
-        </p:txBody>
-      </p:sp>
-      <p:sp>
-        <p:nvSpPr>
-          <p:cNvPr id="15" name="TextBox 14"/>
+          </a:p>
+        </p:txBody>
+      </p:sp>
+      <p:pic>
+        <p:nvPicPr>
+          <p:cNvPr id="17" name="Picture 16" descr="doc.png"/>
+          <p:cNvPicPr>
+            <a:picLocks noChangeAspect="1"/>
+          </p:cNvPicPr>
+          <p:nvPr/>
+        </p:nvPicPr>
+        <p:blipFill>
+          <a:blip r:embed="rId4"/>
+          <a:stretch>
+            <a:fillRect/>
+          </a:stretch>
+        </p:blipFill>
+        <p:spPr>
+          <a:xfrm>
+            <a:off x="5516392" y="2142256"/>
+            <a:ext cx="342351" cy="342351"/>
+          </a:xfrm>
+          <a:prstGeom prst="rect">
+            <a:avLst/>
+          </a:prstGeom>
+        </p:spPr>
+      </p:pic>
+      <p:sp>
+        <p:nvSpPr>
+          <p:cNvPr id="18" name="TextBox 17"/>
           <p:cNvSpPr txBox="1"/>
           <p:nvPr/>
         </p:nvSpPr>
@@ -18015,7 +18675,7 @@
       </p:sp>
       <p:sp>
         <p:nvSpPr>
-          <p:cNvPr id="16" name="TextBox 15"/>
+          <p:cNvPr id="19" name="TextBox 18"/>
           <p:cNvSpPr txBox="1"/>
           <p:nvPr/>
         </p:nvSpPr>
@@ -18054,7 +18714,7 @@
       </p:sp>
       <p:sp>
         <p:nvSpPr>
-          <p:cNvPr id="17" name="Rounded Rectangle 16"/>
+          <p:cNvPr id="20" name="Rounded Rectangle 19"/>
           <p:cNvSpPr/>
           <p:nvPr/>
         </p:nvSpPr>
@@ -18102,7 +18762,7 @@
       </p:sp>
       <p:sp>
         <p:nvSpPr>
-          <p:cNvPr id="18" name="Rounded Rectangle 17"/>
+          <p:cNvPr id="21" name="Rounded Rectangle 20"/>
           <p:cNvSpPr/>
           <p:nvPr/>
         </p:nvSpPr>
@@ -18141,20 +18801,40 @@
           </a:fontRef>
         </p:style>
         <p:txBody>
-          <a:bodyPr rtlCol="0" anchor="ctr" wrap="square" lIns="9144" rIns="9144" tIns="9144" bIns="9144"/>
+          <a:bodyPr rtlCol="0" anchor="ctr" wrap="square" lIns="146304" rIns="146304" tIns="109728" bIns="109728"/>
           <a:lstStyle/>
           <a:p>
             <a:pPr algn="ctr"/>
-            <a:r>
-              <a:rPr sz="1700"/>
-              <a:t>💸</a:t>
-            </a:r>
-          </a:p>
-        </p:txBody>
-      </p:sp>
-      <p:sp>
-        <p:nvSpPr>
-          <p:cNvPr id="19" name="TextBox 18"/>
+          </a:p>
+        </p:txBody>
+      </p:sp>
+      <p:pic>
+        <p:nvPicPr>
+          <p:cNvPr id="22" name="Picture 21" descr="dbcoin.png"/>
+          <p:cNvPicPr>
+            <a:picLocks noChangeAspect="1"/>
+          </p:cNvPicPr>
+          <p:nvPr/>
+        </p:nvPicPr>
+        <p:blipFill>
+          <a:blip r:embed="rId5"/>
+          <a:stretch>
+            <a:fillRect/>
+          </a:stretch>
+        </p:blipFill>
+        <p:spPr>
+          <a:xfrm>
+            <a:off x="7820680" y="2142256"/>
+            <a:ext cx="342351" cy="342351"/>
+          </a:xfrm>
+          <a:prstGeom prst="rect">
+            <a:avLst/>
+          </a:prstGeom>
+        </p:spPr>
+      </p:pic>
+      <p:sp>
+        <p:nvSpPr>
+          <p:cNvPr id="23" name="TextBox 22"/>
           <p:cNvSpPr txBox="1"/>
           <p:nvPr/>
         </p:nvSpPr>
@@ -18193,7 +18873,7 @@
       </p:sp>
       <p:sp>
         <p:nvSpPr>
-          <p:cNvPr id="20" name="TextBox 19"/>
+          <p:cNvPr id="24" name="TextBox 23"/>
           <p:cNvSpPr txBox="1"/>
           <p:nvPr/>
         </p:nvSpPr>
@@ -18232,7 +18912,7 @@
       </p:sp>
       <p:sp>
         <p:nvSpPr>
-          <p:cNvPr id="21" name="Rounded Rectangle 20"/>
+          <p:cNvPr id="25" name="Rounded Rectangle 24"/>
           <p:cNvSpPr/>
           <p:nvPr/>
         </p:nvSpPr>
@@ -18280,7 +18960,7 @@
       </p:sp>
       <p:sp>
         <p:nvSpPr>
-          <p:cNvPr id="22" name="Rounded Rectangle 21"/>
+          <p:cNvPr id="26" name="Rounded Rectangle 25"/>
           <p:cNvSpPr/>
           <p:nvPr/>
         </p:nvSpPr>
@@ -18319,20 +18999,40 @@
           </a:fontRef>
         </p:style>
         <p:txBody>
-          <a:bodyPr rtlCol="0" anchor="ctr" wrap="square" lIns="9144" rIns="9144" tIns="9144" bIns="9144"/>
+          <a:bodyPr rtlCol="0" anchor="ctr" wrap="square" lIns="146304" rIns="146304" tIns="109728" bIns="109728"/>
           <a:lstStyle/>
           <a:p>
             <a:pPr algn="ctr"/>
-            <a:r>
-              <a:rPr sz="1700"/>
-              <a:t>⚡</a:t>
-            </a:r>
-          </a:p>
-        </p:txBody>
-      </p:sp>
-      <p:sp>
-        <p:nvSpPr>
-          <p:cNvPr id="23" name="TextBox 22"/>
+          </a:p>
+        </p:txBody>
+      </p:sp>
+      <p:pic>
+        <p:nvPicPr>
+          <p:cNvPr id="27" name="Picture 26" descr="bolt.png"/>
+          <p:cNvPicPr>
+            <a:picLocks noChangeAspect="1"/>
+          </p:cNvPicPr>
+          <p:nvPr/>
+        </p:nvPicPr>
+        <p:blipFill>
+          <a:blip r:embed="rId6"/>
+          <a:stretch>
+            <a:fillRect/>
+          </a:stretch>
+        </p:blipFill>
+        <p:spPr>
+          <a:xfrm>
+            <a:off x="10124968" y="2142256"/>
+            <a:ext cx="342351" cy="342351"/>
+          </a:xfrm>
+          <a:prstGeom prst="rect">
+            <a:avLst/>
+          </a:prstGeom>
+        </p:spPr>
+      </p:pic>
+      <p:sp>
+        <p:nvSpPr>
+          <p:cNvPr id="28" name="TextBox 27"/>
           <p:cNvSpPr txBox="1"/>
           <p:nvPr/>
         </p:nvSpPr>
@@ -18371,7 +19071,7 @@
       </p:sp>
       <p:sp>
         <p:nvSpPr>
-          <p:cNvPr id="24" name="TextBox 23"/>
+          <p:cNvPr id="29" name="TextBox 28"/>
           <p:cNvSpPr txBox="1"/>
           <p:nvPr/>
         </p:nvSpPr>
@@ -18410,7 +19110,7 @@
       </p:sp>
       <p:sp>
         <p:nvSpPr>
-          <p:cNvPr id="25" name="Rectangle 24"/>
+          <p:cNvPr id="30" name="Rectangle 29"/>
           <p:cNvSpPr/>
           <p:nvPr/>
         </p:nvSpPr>
@@ -18454,7 +19154,7 @@
       </p:sp>
       <p:sp>
         <p:nvSpPr>
-          <p:cNvPr id="26" name="TextBox 25"/>
+          <p:cNvPr id="31" name="TextBox 30"/>
           <p:cNvSpPr txBox="1"/>
           <p:nvPr/>
         </p:nvSpPr>
@@ -18497,7 +19197,7 @@
       </p:sp>
       <p:sp>
         <p:nvSpPr>
-          <p:cNvPr id="27" name="TextBox 26"/>
+          <p:cNvPr id="32" name="TextBox 31"/>
           <p:cNvSpPr txBox="1"/>
           <p:nvPr/>
         </p:nvSpPr>
@@ -19143,20 +19843,40 @@
           </a:fontRef>
         </p:style>
         <p:txBody>
-          <a:bodyPr rtlCol="0" anchor="ctr" wrap="square" lIns="9144" rIns="9144" tIns="9144" bIns="9144"/>
+          <a:bodyPr rtlCol="0" anchor="ctr" wrap="square" lIns="146304" rIns="146304" tIns="109728" bIns="109728"/>
           <a:lstStyle/>
           <a:p>
             <a:pPr algn="ctr"/>
-            <a:r>
-              <a:rPr sz="1400"/>
-              <a:t>🪪</a:t>
-            </a:r>
-          </a:p>
-        </p:txBody>
-      </p:sp>
-      <p:sp>
-        <p:nvSpPr>
-          <p:cNvPr id="9" name="TextBox 8"/>
+          </a:p>
+        </p:txBody>
+      </p:sp>
+      <p:pic>
+        <p:nvPicPr>
+          <p:cNvPr id="9" name="Picture 8" descr="idcard.png"/>
+          <p:cNvPicPr>
+            <a:picLocks noChangeAspect="1"/>
+          </p:cNvPicPr>
+          <p:nvPr/>
+        </p:nvPicPr>
+        <p:blipFill>
+          <a:blip r:embed="rId3"/>
+          <a:stretch>
+            <a:fillRect/>
+          </a:stretch>
+        </p:blipFill>
+        <p:spPr>
+          <a:xfrm>
+            <a:off x="879287" y="4427159"/>
+            <a:ext cx="289681" cy="289681"/>
+          </a:xfrm>
+          <a:prstGeom prst="rect">
+            <a:avLst/>
+          </a:prstGeom>
+        </p:spPr>
+      </p:pic>
+      <p:sp>
+        <p:nvSpPr>
+          <p:cNvPr id="10" name="TextBox 9"/>
           <p:cNvSpPr txBox="1"/>
           <p:nvPr/>
         </p:nvSpPr>
@@ -19190,7 +19910,7 @@
       </p:sp>
       <p:sp>
         <p:nvSpPr>
-          <p:cNvPr id="10" name="TextBox 9"/>
+          <p:cNvPr id="11" name="TextBox 10"/>
           <p:cNvSpPr txBox="1"/>
           <p:nvPr/>
         </p:nvSpPr>
@@ -19229,7 +19949,7 @@
       </p:sp>
       <p:sp>
         <p:nvSpPr>
-          <p:cNvPr id="11" name="Rounded Rectangle 10"/>
+          <p:cNvPr id="12" name="Rounded Rectangle 11"/>
           <p:cNvSpPr/>
           <p:nvPr/>
         </p:nvSpPr>
@@ -19277,7 +19997,7 @@
       </p:sp>
       <p:sp>
         <p:nvSpPr>
-          <p:cNvPr id="12" name="Rounded Rectangle 11"/>
+          <p:cNvPr id="13" name="Rounded Rectangle 12"/>
           <p:cNvSpPr/>
           <p:nvPr/>
         </p:nvSpPr>
@@ -19316,20 +20036,40 @@
           </a:fontRef>
         </p:style>
         <p:txBody>
-          <a:bodyPr rtlCol="0" anchor="ctr" wrap="square" lIns="9144" rIns="9144" tIns="9144" bIns="9144"/>
+          <a:bodyPr rtlCol="0" anchor="ctr" wrap="square" lIns="146304" rIns="146304" tIns="109728" bIns="109728"/>
           <a:lstStyle/>
           <a:p>
             <a:pPr algn="ctr"/>
-            <a:r>
-              <a:rPr sz="1400"/>
-              <a:t>🧾</a:t>
-            </a:r>
-          </a:p>
-        </p:txBody>
-      </p:sp>
-      <p:sp>
-        <p:nvSpPr>
-          <p:cNvPr id="13" name="TextBox 12"/>
+          </a:p>
+        </p:txBody>
+      </p:sp>
+      <p:pic>
+        <p:nvPicPr>
+          <p:cNvPr id="14" name="Picture 13" descr="receipt.png"/>
+          <p:cNvPicPr>
+            <a:picLocks noChangeAspect="1"/>
+          </p:cNvPicPr>
+          <p:nvPr/>
+        </p:nvPicPr>
+        <p:blipFill>
+          <a:blip r:embed="rId4"/>
+          <a:stretch>
+            <a:fillRect/>
+          </a:stretch>
+        </p:blipFill>
+        <p:spPr>
+          <a:xfrm>
+            <a:off x="3732215" y="4427159"/>
+            <a:ext cx="289681" cy="289681"/>
+          </a:xfrm>
+          <a:prstGeom prst="rect">
+            <a:avLst/>
+          </a:prstGeom>
+        </p:spPr>
+      </p:pic>
+      <p:sp>
+        <p:nvSpPr>
+          <p:cNvPr id="15" name="TextBox 14"/>
           <p:cNvSpPr txBox="1"/>
           <p:nvPr/>
         </p:nvSpPr>
@@ -19363,7 +20103,7 @@
       </p:sp>
       <p:sp>
         <p:nvSpPr>
-          <p:cNvPr id="14" name="TextBox 13"/>
+          <p:cNvPr id="16" name="TextBox 15"/>
           <p:cNvSpPr txBox="1"/>
           <p:nvPr/>
         </p:nvSpPr>
@@ -19402,7 +20142,7 @@
       </p:sp>
       <p:sp>
         <p:nvSpPr>
-          <p:cNvPr id="15" name="Rounded Rectangle 14"/>
+          <p:cNvPr id="17" name="Rounded Rectangle 16"/>
           <p:cNvSpPr/>
           <p:nvPr/>
         </p:nvSpPr>
@@ -19450,7 +20190,7 @@
       </p:sp>
       <p:sp>
         <p:nvSpPr>
-          <p:cNvPr id="16" name="Rounded Rectangle 15"/>
+          <p:cNvPr id="18" name="Rounded Rectangle 17"/>
           <p:cNvSpPr/>
           <p:nvPr/>
         </p:nvSpPr>
@@ -19489,20 +20229,40 @@
           </a:fontRef>
         </p:style>
         <p:txBody>
-          <a:bodyPr rtlCol="0" anchor="ctr" wrap="square" lIns="9144" rIns="9144" tIns="9144" bIns="9144"/>
+          <a:bodyPr rtlCol="0" anchor="ctr" wrap="square" lIns="146304" rIns="146304" tIns="109728" bIns="109728"/>
           <a:lstStyle/>
           <a:p>
             <a:pPr algn="ctr"/>
-            <a:r>
-              <a:rPr sz="1400"/>
-              <a:t>⚙️</a:t>
-            </a:r>
-          </a:p>
-        </p:txBody>
-      </p:sp>
-      <p:sp>
-        <p:nvSpPr>
-          <p:cNvPr id="17" name="TextBox 16"/>
+          </a:p>
+        </p:txBody>
+      </p:sp>
+      <p:pic>
+        <p:nvPicPr>
+          <p:cNvPr id="19" name="Picture 18" descr="grid.png"/>
+          <p:cNvPicPr>
+            <a:picLocks noChangeAspect="1"/>
+          </p:cNvPicPr>
+          <p:nvPr/>
+        </p:nvPicPr>
+        <p:blipFill>
+          <a:blip r:embed="rId5"/>
+          <a:stretch>
+            <a:fillRect/>
+          </a:stretch>
+        </p:blipFill>
+        <p:spPr>
+          <a:xfrm>
+            <a:off x="6585143" y="4427159"/>
+            <a:ext cx="289681" cy="289681"/>
+          </a:xfrm>
+          <a:prstGeom prst="rect">
+            <a:avLst/>
+          </a:prstGeom>
+        </p:spPr>
+      </p:pic>
+      <p:sp>
+        <p:nvSpPr>
+          <p:cNvPr id="20" name="TextBox 19"/>
           <p:cNvSpPr txBox="1"/>
           <p:nvPr/>
         </p:nvSpPr>
@@ -19536,7 +20296,7 @@
       </p:sp>
       <p:sp>
         <p:nvSpPr>
-          <p:cNvPr id="18" name="TextBox 17"/>
+          <p:cNvPr id="21" name="TextBox 20"/>
           <p:cNvSpPr txBox="1"/>
           <p:nvPr/>
         </p:nvSpPr>
@@ -19575,7 +20335,7 @@
       </p:sp>
       <p:sp>
         <p:nvSpPr>
-          <p:cNvPr id="19" name="Rounded Rectangle 18"/>
+          <p:cNvPr id="22" name="Rounded Rectangle 21"/>
           <p:cNvSpPr/>
           <p:nvPr/>
         </p:nvSpPr>
@@ -19623,7 +20383,7 @@
       </p:sp>
       <p:sp>
         <p:nvSpPr>
-          <p:cNvPr id="20" name="Rounded Rectangle 19"/>
+          <p:cNvPr id="23" name="Rounded Rectangle 22"/>
           <p:cNvSpPr/>
           <p:nvPr/>
         </p:nvSpPr>
@@ -19662,20 +20422,40 @@
           </a:fontRef>
         </p:style>
         <p:txBody>
-          <a:bodyPr rtlCol="0" anchor="ctr" wrap="square" lIns="9144" rIns="9144" tIns="9144" bIns="9144"/>
+          <a:bodyPr rtlCol="0" anchor="ctr" wrap="square" lIns="146304" rIns="146304" tIns="109728" bIns="109728"/>
           <a:lstStyle/>
           <a:p>
             <a:pPr algn="ctr"/>
-            <a:r>
-              <a:rPr sz="1400"/>
-              <a:t>🔒</a:t>
-            </a:r>
-          </a:p>
-        </p:txBody>
-      </p:sp>
-      <p:sp>
-        <p:nvSpPr>
-          <p:cNvPr id="21" name="TextBox 20"/>
+          </a:p>
+        </p:txBody>
+      </p:sp>
+      <p:pic>
+        <p:nvPicPr>
+          <p:cNvPr id="24" name="Picture 23" descr="lock.png"/>
+          <p:cNvPicPr>
+            <a:picLocks noChangeAspect="1"/>
+          </p:cNvPicPr>
+          <p:nvPr/>
+        </p:nvPicPr>
+        <p:blipFill>
+          <a:blip r:embed="rId6"/>
+          <a:stretch>
+            <a:fillRect/>
+          </a:stretch>
+        </p:blipFill>
+        <p:spPr>
+          <a:xfrm>
+            <a:off x="9438071" y="4427159"/>
+            <a:ext cx="289681" cy="289681"/>
+          </a:xfrm>
+          <a:prstGeom prst="rect">
+            <a:avLst/>
+          </a:prstGeom>
+        </p:spPr>
+      </p:pic>
+      <p:sp>
+        <p:nvSpPr>
+          <p:cNvPr id="25" name="TextBox 24"/>
           <p:cNvSpPr txBox="1"/>
           <p:nvPr/>
         </p:nvSpPr>
@@ -19709,7 +20489,7 @@
       </p:sp>
       <p:sp>
         <p:nvSpPr>
-          <p:cNvPr id="22" name="TextBox 21"/>
+          <p:cNvPr id="26" name="TextBox 25"/>
           <p:cNvSpPr txBox="1"/>
           <p:nvPr/>
         </p:nvSpPr>
@@ -19748,7 +20528,7 @@
       </p:sp>
       <p:sp>
         <p:nvSpPr>
-          <p:cNvPr id="23" name="Rectangle 22"/>
+          <p:cNvPr id="27" name="Rectangle 26"/>
           <p:cNvSpPr/>
           <p:nvPr/>
         </p:nvSpPr>
@@ -19792,7 +20572,7 @@
       </p:sp>
       <p:sp>
         <p:nvSpPr>
-          <p:cNvPr id="24" name="TextBox 23"/>
+          <p:cNvPr id="28" name="TextBox 27"/>
           <p:cNvSpPr txBox="1"/>
           <p:nvPr/>
         </p:nvSpPr>
@@ -19835,7 +20615,7 @@
       </p:sp>
       <p:sp>
         <p:nvSpPr>
-          <p:cNvPr id="25" name="TextBox 24"/>
+          <p:cNvPr id="29" name="TextBox 28"/>
           <p:cNvSpPr txBox="1"/>
           <p:nvPr/>
         </p:nvSpPr>
@@ -20086,20 +20866,40 @@
           </a:fontRef>
         </p:style>
         <p:txBody>
-          <a:bodyPr rtlCol="0" anchor="ctr" wrap="square" lIns="9144" rIns="9144" tIns="9144" bIns="9144"/>
+          <a:bodyPr rtlCol="0" anchor="ctr" wrap="square" lIns="146304" rIns="146304" tIns="109728" bIns="109728"/>
           <a:lstStyle/>
           <a:p>
             <a:pPr algn="ctr"/>
-            <a:r>
-              <a:rPr sz="1700"/>
-              <a:t>🔐</a:t>
-            </a:r>
-          </a:p>
-        </p:txBody>
-      </p:sp>
-      <p:sp>
-        <p:nvSpPr>
-          <p:cNvPr id="7" name="TextBox 6"/>
+          </a:p>
+        </p:txBody>
+      </p:sp>
+      <p:pic>
+        <p:nvPicPr>
+          <p:cNvPr id="7" name="Picture 6" descr="key.png"/>
+          <p:cNvPicPr>
+            <a:picLocks noChangeAspect="1"/>
+          </p:cNvPicPr>
+          <p:nvPr/>
+        </p:nvPicPr>
+        <p:blipFill>
+          <a:blip r:embed="rId2"/>
+          <a:stretch>
+            <a:fillRect/>
+          </a:stretch>
+        </p:blipFill>
+        <p:spPr>
+          <a:xfrm>
+            <a:off x="935248" y="2078248"/>
+            <a:ext cx="342351" cy="342351"/>
+          </a:xfrm>
+          <a:prstGeom prst="rect">
+            <a:avLst/>
+          </a:prstGeom>
+        </p:spPr>
+      </p:pic>
+      <p:sp>
+        <p:nvSpPr>
+          <p:cNvPr id="8" name="TextBox 7"/>
           <p:cNvSpPr txBox="1"/>
           <p:nvPr/>
         </p:nvSpPr>
@@ -20133,7 +20933,7 @@
       </p:sp>
       <p:sp>
         <p:nvSpPr>
-          <p:cNvPr id="8" name="TextBox 7"/>
+          <p:cNvPr id="9" name="TextBox 8"/>
           <p:cNvSpPr txBox="1"/>
           <p:nvPr/>
         </p:nvSpPr>
@@ -20172,7 +20972,7 @@
       </p:sp>
       <p:sp>
         <p:nvSpPr>
-          <p:cNvPr id="9" name="Rounded Rectangle 8"/>
+          <p:cNvPr id="10" name="Rounded Rectangle 9"/>
           <p:cNvSpPr/>
           <p:nvPr/>
         </p:nvSpPr>
@@ -20220,7 +21020,7 @@
       </p:sp>
       <p:sp>
         <p:nvSpPr>
-          <p:cNvPr id="10" name="Rounded Rectangle 9"/>
+          <p:cNvPr id="11" name="Rounded Rectangle 10"/>
           <p:cNvSpPr/>
           <p:nvPr/>
         </p:nvSpPr>
@@ -20259,20 +21059,40 @@
           </a:fontRef>
         </p:style>
         <p:txBody>
-          <a:bodyPr rtlCol="0" anchor="ctr" wrap="square" lIns="9144" rIns="9144" tIns="9144" bIns="9144"/>
+          <a:bodyPr rtlCol="0" anchor="ctr" wrap="square" lIns="146304" rIns="146304" tIns="109728" bIns="109728"/>
           <a:lstStyle/>
           <a:p>
             <a:pPr algn="ctr"/>
-            <a:r>
-              <a:rPr sz="1700"/>
-              <a:t>📲</a:t>
-            </a:r>
-          </a:p>
-        </p:txBody>
-      </p:sp>
-      <p:sp>
-        <p:nvSpPr>
-          <p:cNvPr id="11" name="TextBox 10"/>
+          </a:p>
+        </p:txBody>
+      </p:sp>
+      <p:pic>
+        <p:nvPicPr>
+          <p:cNvPr id="12" name="Picture 11" descr="phone.png"/>
+          <p:cNvPicPr>
+            <a:picLocks noChangeAspect="1"/>
+          </p:cNvPicPr>
+          <p:nvPr/>
+        </p:nvPicPr>
+        <p:blipFill>
+          <a:blip r:embed="rId3"/>
+          <a:stretch>
+            <a:fillRect/>
+          </a:stretch>
+        </p:blipFill>
+        <p:spPr>
+          <a:xfrm>
+            <a:off x="4730008" y="2078248"/>
+            <a:ext cx="342351" cy="342351"/>
+          </a:xfrm>
+          <a:prstGeom prst="rect">
+            <a:avLst/>
+          </a:prstGeom>
+        </p:spPr>
+      </p:pic>
+      <p:sp>
+        <p:nvSpPr>
+          <p:cNvPr id="13" name="TextBox 12"/>
           <p:cNvSpPr txBox="1"/>
           <p:nvPr/>
         </p:nvSpPr>
@@ -20306,7 +21126,7 @@
       </p:sp>
       <p:sp>
         <p:nvSpPr>
-          <p:cNvPr id="12" name="TextBox 11"/>
+          <p:cNvPr id="14" name="TextBox 13"/>
           <p:cNvSpPr txBox="1"/>
           <p:nvPr/>
         </p:nvSpPr>
@@ -20345,7 +21165,7 @@
       </p:sp>
       <p:sp>
         <p:nvSpPr>
-          <p:cNvPr id="13" name="Rounded Rectangle 12"/>
+          <p:cNvPr id="15" name="Rounded Rectangle 14"/>
           <p:cNvSpPr/>
           <p:nvPr/>
         </p:nvSpPr>
@@ -20393,7 +21213,7 @@
       </p:sp>
       <p:sp>
         <p:nvSpPr>
-          <p:cNvPr id="14" name="Rounded Rectangle 13"/>
+          <p:cNvPr id="16" name="Rounded Rectangle 15"/>
           <p:cNvSpPr/>
           <p:nvPr/>
         </p:nvSpPr>
@@ -20432,20 +21252,40 @@
           </a:fontRef>
         </p:style>
         <p:txBody>
-          <a:bodyPr rtlCol="0" anchor="ctr" wrap="square" lIns="9144" rIns="9144" tIns="9144" bIns="9144"/>
+          <a:bodyPr rtlCol="0" anchor="ctr" wrap="square" lIns="146304" rIns="146304" tIns="109728" bIns="109728"/>
           <a:lstStyle/>
           <a:p>
             <a:pPr algn="ctr"/>
-            <a:r>
-              <a:rPr sz="1700"/>
-              <a:t>👆</a:t>
-            </a:r>
-          </a:p>
-        </p:txBody>
-      </p:sp>
-      <p:sp>
-        <p:nvSpPr>
-          <p:cNvPr id="15" name="TextBox 14"/>
+          </a:p>
+        </p:txBody>
+      </p:sp>
+      <p:pic>
+        <p:nvPicPr>
+          <p:cNvPr id="17" name="Picture 16" descr="facescan.png"/>
+          <p:cNvPicPr>
+            <a:picLocks noChangeAspect="1"/>
+          </p:cNvPicPr>
+          <p:nvPr/>
+        </p:nvPicPr>
+        <p:blipFill>
+          <a:blip r:embed="rId4"/>
+          <a:stretch>
+            <a:fillRect/>
+          </a:stretch>
+        </p:blipFill>
+        <p:spPr>
+          <a:xfrm>
+            <a:off x="8524768" y="2078248"/>
+            <a:ext cx="342351" cy="342351"/>
+          </a:xfrm>
+          <a:prstGeom prst="rect">
+            <a:avLst/>
+          </a:prstGeom>
+        </p:spPr>
+      </p:pic>
+      <p:sp>
+        <p:nvSpPr>
+          <p:cNvPr id="18" name="TextBox 17"/>
           <p:cNvSpPr txBox="1"/>
           <p:nvPr/>
         </p:nvSpPr>
@@ -20479,7 +21319,7 @@
       </p:sp>
       <p:sp>
         <p:nvSpPr>
-          <p:cNvPr id="16" name="TextBox 15"/>
+          <p:cNvPr id="19" name="TextBox 18"/>
           <p:cNvSpPr txBox="1"/>
           <p:nvPr/>
         </p:nvSpPr>
@@ -20518,7 +21358,7 @@
       </p:sp>
       <p:sp>
         <p:nvSpPr>
-          <p:cNvPr id="17" name="Rounded Rectangle 16"/>
+          <p:cNvPr id="20" name="Rounded Rectangle 19"/>
           <p:cNvSpPr/>
           <p:nvPr/>
         </p:nvSpPr>
@@ -20566,7 +21406,7 @@
       </p:sp>
       <p:sp>
         <p:nvSpPr>
-          <p:cNvPr id="18" name="Rounded Rectangle 17"/>
+          <p:cNvPr id="21" name="Rounded Rectangle 20"/>
           <p:cNvSpPr/>
           <p:nvPr/>
         </p:nvSpPr>
@@ -20605,20 +21445,40 @@
           </a:fontRef>
         </p:style>
         <p:txBody>
-          <a:bodyPr rtlCol="0" anchor="ctr" wrap="square" lIns="9144" rIns="9144" tIns="9144" bIns="9144"/>
+          <a:bodyPr rtlCol="0" anchor="ctr" wrap="square" lIns="146304" rIns="146304" tIns="109728" bIns="109728"/>
           <a:lstStyle/>
           <a:p>
             <a:pPr algn="ctr"/>
-            <a:r>
-              <a:rPr sz="1700"/>
-              <a:t>🛡️</a:t>
-            </a:r>
-          </a:p>
-        </p:txBody>
-      </p:sp>
-      <p:sp>
-        <p:nvSpPr>
-          <p:cNvPr id="19" name="TextBox 18"/>
+          </a:p>
+        </p:txBody>
+      </p:sp>
+      <p:pic>
+        <p:nvPicPr>
+          <p:cNvPr id="22" name="Picture 21" descr="shield.png"/>
+          <p:cNvPicPr>
+            <a:picLocks noChangeAspect="1"/>
+          </p:cNvPicPr>
+          <p:nvPr/>
+        </p:nvPicPr>
+        <p:blipFill>
+          <a:blip r:embed="rId5"/>
+          <a:stretch>
+            <a:fillRect/>
+          </a:stretch>
+        </p:blipFill>
+        <p:spPr>
+          <a:xfrm>
+            <a:off x="935248" y="4291096"/>
+            <a:ext cx="342351" cy="342351"/>
+          </a:xfrm>
+          <a:prstGeom prst="rect">
+            <a:avLst/>
+          </a:prstGeom>
+        </p:spPr>
+      </p:pic>
+      <p:sp>
+        <p:nvSpPr>
+          <p:cNvPr id="23" name="TextBox 22"/>
           <p:cNvSpPr txBox="1"/>
           <p:nvPr/>
         </p:nvSpPr>
@@ -20652,7 +21512,7 @@
       </p:sp>
       <p:sp>
         <p:nvSpPr>
-          <p:cNvPr id="20" name="TextBox 19"/>
+          <p:cNvPr id="24" name="TextBox 23"/>
           <p:cNvSpPr txBox="1"/>
           <p:nvPr/>
         </p:nvSpPr>
@@ -20691,7 +21551,7 @@
       </p:sp>
       <p:sp>
         <p:nvSpPr>
-          <p:cNvPr id="21" name="Rounded Rectangle 20"/>
+          <p:cNvPr id="25" name="Rounded Rectangle 24"/>
           <p:cNvSpPr/>
           <p:nvPr/>
         </p:nvSpPr>
@@ -20739,7 +21599,7 @@
       </p:sp>
       <p:sp>
         <p:nvSpPr>
-          <p:cNvPr id="22" name="Rounded Rectangle 21"/>
+          <p:cNvPr id="26" name="Rounded Rectangle 25"/>
           <p:cNvSpPr/>
           <p:nvPr/>
         </p:nvSpPr>
@@ -20778,20 +21638,40 @@
           </a:fontRef>
         </p:style>
         <p:txBody>
-          <a:bodyPr rtlCol="0" anchor="ctr" wrap="square" lIns="9144" rIns="9144" tIns="9144" bIns="9144"/>
+          <a:bodyPr rtlCol="0" anchor="ctr" wrap="square" lIns="146304" rIns="146304" tIns="109728" bIns="109728"/>
           <a:lstStyle/>
           <a:p>
             <a:pPr algn="ctr"/>
-            <a:r>
-              <a:rPr sz="1700"/>
-              <a:t>🧑‍💼</a:t>
-            </a:r>
-          </a:p>
-        </p:txBody>
-      </p:sp>
-      <p:sp>
-        <p:nvSpPr>
-          <p:cNvPr id="23" name="TextBox 22"/>
+          </a:p>
+        </p:txBody>
+      </p:sp>
+      <p:pic>
+        <p:nvPicPr>
+          <p:cNvPr id="27" name="Picture 26" descr="briefcase.png"/>
+          <p:cNvPicPr>
+            <a:picLocks noChangeAspect="1"/>
+          </p:cNvPicPr>
+          <p:nvPr/>
+        </p:nvPicPr>
+        <p:blipFill>
+          <a:blip r:embed="rId6"/>
+          <a:stretch>
+            <a:fillRect/>
+          </a:stretch>
+        </p:blipFill>
+        <p:spPr>
+          <a:xfrm>
+            <a:off x="4730008" y="4291096"/>
+            <a:ext cx="342351" cy="342351"/>
+          </a:xfrm>
+          <a:prstGeom prst="rect">
+            <a:avLst/>
+          </a:prstGeom>
+        </p:spPr>
+      </p:pic>
+      <p:sp>
+        <p:nvSpPr>
+          <p:cNvPr id="28" name="TextBox 27"/>
           <p:cNvSpPr txBox="1"/>
           <p:nvPr/>
         </p:nvSpPr>
@@ -20825,7 +21705,7 @@
       </p:sp>
       <p:sp>
         <p:nvSpPr>
-          <p:cNvPr id="24" name="TextBox 23"/>
+          <p:cNvPr id="29" name="TextBox 28"/>
           <p:cNvSpPr txBox="1"/>
           <p:nvPr/>
         </p:nvSpPr>
@@ -20864,7 +21744,7 @@
       </p:sp>
       <p:sp>
         <p:nvSpPr>
-          <p:cNvPr id="25" name="TextBox 24"/>
+          <p:cNvPr id="30" name="TextBox 29"/>
           <p:cNvSpPr txBox="1"/>
           <p:nvPr/>
         </p:nvSpPr>
@@ -20913,7 +21793,7 @@
       </p:sp>
       <p:sp>
         <p:nvSpPr>
-          <p:cNvPr id="26" name="Rectangle 25"/>
+          <p:cNvPr id="31" name="Rectangle 30"/>
           <p:cNvSpPr/>
           <p:nvPr/>
         </p:nvSpPr>
@@ -20957,7 +21837,7 @@
       </p:sp>
       <p:sp>
         <p:nvSpPr>
-          <p:cNvPr id="27" name="TextBox 26"/>
+          <p:cNvPr id="32" name="TextBox 31"/>
           <p:cNvSpPr txBox="1"/>
           <p:nvPr/>
         </p:nvSpPr>
@@ -21000,7 +21880,7 @@
       </p:sp>
       <p:sp>
         <p:nvSpPr>
-          <p:cNvPr id="28" name="TextBox 27"/>
+          <p:cNvPr id="33" name="TextBox 32"/>
           <p:cNvSpPr txBox="1"/>
           <p:nvPr/>
         </p:nvSpPr>

</xml_diff>

<commit_message>
docs(slides): architecture diagram - separate customer and employee Cognito pools
Co-Authored-By: Claude Fable 5 <noreply@anthropic.com>
Claude-Session: https://claude.ai/code/session_01Gs4wvsmdiVbeWdpfy8uDk7
</commit_message>
<xml_diff>
--- a/slides/wanthat-presentation.pptx
+++ b/slides/wanthat-presentation.pptx
@@ -18952,7 +18952,7 @@
         <p:spPr>
           <a:xfrm>
             <a:off x="307695" y="1709928"/>
-            <a:ext cx="11576304" cy="3938849"/>
+            <a:ext cx="11576304" cy="3673114"/>
           </a:xfrm>
           <a:prstGeom prst="roundRect">
             <a:avLst>
@@ -19008,7 +19008,7 @@
         <p:spPr>
           <a:xfrm>
             <a:off x="472287" y="1874519"/>
-            <a:ext cx="11247120" cy="3609665"/>
+            <a:ext cx="11247120" cy="3343930"/>
           </a:xfrm>
           <a:prstGeom prst="rect">
             <a:avLst/>

</xml_diff>

<commit_message>
docs: add observability + analytics to the architecture diagrams
Both diagrams gain the ObservabilityStack layer: CloudWatch + X-Ray with the
per-surface dashboards and alarm set (Lambda errors, API 5xx, Aurora conns,
SMS spend) -> SNS alarms topic -> ops email, plus the us-east-1 edge dashboard
(docs diagram); funnel analytics node now spells out the mechanism (CW Logs
subscription filters -> Firehose -> S3 -> Glue funnel_events -> Athena).

Co-Authored-By: Claude Fable 5 <noreply@anthropic.com>
Claude-Session: https://claude.ai/code/session_01Gs4wvsmdiVbeWdpfy8uDk7
</commit_message>
<xml_diff>
--- a/slides/wanthat-presentation.pptx
+++ b/slides/wanthat-presentation.pptx
@@ -18952,7 +18952,7 @@
         <p:spPr>
           <a:xfrm>
             <a:off x="307695" y="1709928"/>
-            <a:ext cx="11576304" cy="3673114"/>
+            <a:ext cx="11576304" cy="3539235"/>
           </a:xfrm>
           <a:prstGeom prst="roundRect">
             <a:avLst>
@@ -19008,7 +19008,7 @@
         <p:spPr>
           <a:xfrm>
             <a:off x="472287" y="1874519"/>
-            <a:ext cx="11247120" cy="3343930"/>
+            <a:ext cx="11247120" cy="3210051"/>
           </a:xfrm>
           <a:prstGeom prst="rect">
             <a:avLst/>

</xml_diff>

<commit_message>
docs(slides): per-table DynamoDB split in the deck architecture diagram
One cylinder per table with real per-table flows; subgraph title carries the
transaction rule (no cross-table tx - the only same-tx pair is a table with
its own counter row, marked *). Labels compacted to keep the slide legible.

Co-Authored-By: Claude Fable 5 <noreply@anthropic.com>
Claude-Session: https://claude.ai/code/session_01Gs4wvsmdiVbeWdpfy8uDk7
</commit_message>
<xml_diff>
--- a/slides/wanthat-presentation.pptx
+++ b/slides/wanthat-presentation.pptx
@@ -18952,7 +18952,7 @@
         <p:spPr>
           <a:xfrm>
             <a:off x="307695" y="1709928"/>
-            <a:ext cx="11576304" cy="3539235"/>
+            <a:ext cx="11576304" cy="2544704"/>
           </a:xfrm>
           <a:prstGeom prst="roundRect">
             <a:avLst>
@@ -19008,7 +19008,7 @@
         <p:spPr>
           <a:xfrm>
             <a:off x="472287" y="1874519"/>
-            <a:ext cx="11247120" cy="3210051"/>
+            <a:ext cx="11247120" cy="2215520"/>
           </a:xfrm>
           <a:prstGeom prst="rect">
             <a:avLst/>

</xml_diff>

<commit_message>
docs: read arrows flow store-to-component in both architecture diagrams
Arrow direction now follows the data: writes point into a store, reads point
out of it (deck: cursor split into write + read edges; docs: r/w access drawn
bidirectional, legend updated).

Co-Authored-By: Claude Fable 5 <noreply@anthropic.com>
Claude-Session: https://claude.ai/code/session_01Gs4wvsmdiVbeWdpfy8uDk7
</commit_message>
<xml_diff>
--- a/slides/wanthat-presentation.pptx
+++ b/slides/wanthat-presentation.pptx
@@ -18952,7 +18952,7 @@
         <p:spPr>
           <a:xfrm>
             <a:off x="307695" y="1709928"/>
-            <a:ext cx="11576304" cy="2544704"/>
+            <a:ext cx="11576304" cy="4094430"/>
           </a:xfrm>
           <a:prstGeom prst="roundRect">
             <a:avLst>
@@ -19008,7 +19008,7 @@
         <p:spPr>
           <a:xfrm>
             <a:off x="472287" y="1874519"/>
-            <a:ext cx="11247120" cy="2215520"/>
+            <a:ext cx="11247120" cy="3765246"/>
           </a:xfrm>
           <a:prstGeom prst="rect">
             <a:avLst/>

</xml_diff>

<commit_message>
docs(slides): tighter architecture diagram layout
Init directive (nodeSpacing 26, rankSpacing 40), non-VPC services grouped in
their own subgraph, declarations reordered by narrative - same nodes and
edges, cleaner clustering and ~7 percent narrower canvas.

Co-Authored-By: Claude Fable 5 <noreply@anthropic.com>
Claude-Session: https://claude.ai/code/session_01Gs4wvsmdiVbeWdpfy8uDk7
</commit_message>
<xml_diff>
--- a/slides/wanthat-presentation.pptx
+++ b/slides/wanthat-presentation.pptx
@@ -18952,7 +18952,7 @@
         <p:spPr>
           <a:xfrm>
             <a:off x="307695" y="1709928"/>
-            <a:ext cx="11576304" cy="4094430"/>
+            <a:ext cx="11576304" cy="3836962"/>
           </a:xfrm>
           <a:prstGeom prst="roundRect">
             <a:avLst>
@@ -19008,7 +19008,7 @@
         <p:spPr>
           <a:xfrm>
             <a:off x="472287" y="1874519"/>
-            <a:ext cx="11247120" cy="3765246"/>
+            <a:ext cx="11247120" cy="3507778"/>
           </a:xfrm>
           <a:prstGeom prst="rect">
             <a:avLst/>

</xml_diff>

<commit_message>
docs: draw EVERY read arrow from the stores in both diagrams
All previously footnoted reads are now edges (runtime_config to its 7-8
readers, fx_rate to 4, recommendation/product/counters/otp_sink/outbox/
unattributed_order admin reads, audit-log activity feed, proxy settle reads).
Deck: writes into stores drawn thick, reads thin, for visual hierarchy.
Docs legend: no omissions remain.

Co-Authored-By: Claude Fable 5 <noreply@anthropic.com>
Claude-Session: https://claude.ai/code/session_01Gs4wvsmdiVbeWdpfy8uDk7
</commit_message>
<xml_diff>
--- a/slides/wanthat-presentation.pptx
+++ b/slides/wanthat-presentation.pptx
@@ -18951,8 +18951,8 @@
         </p:nvSpPr>
         <p:spPr>
           <a:xfrm>
-            <a:off x="307695" y="1709928"/>
-            <a:ext cx="11576304" cy="3836962"/>
+            <a:off x="1646027" y="1709928"/>
+            <a:ext cx="8899641" cy="4764024"/>
           </a:xfrm>
           <a:prstGeom prst="roundRect">
             <a:avLst>
@@ -19007,8 +19007,8 @@
         </p:blipFill>
         <p:spPr>
           <a:xfrm>
-            <a:off x="472287" y="1874519"/>
-            <a:ext cx="11247120" cy="3507778"/>
+            <a:off x="1810619" y="1874519"/>
+            <a:ext cx="8570457" cy="4434840"/>
           </a:xfrm>
           <a:prstGeom prst="rect">
             <a:avLst/>

</xml_diff>

<commit_message>
docs: architecture diagram layout via ELK; omit only runtime_config read fan-out
Deck slide-7 mermaid renders with the ELK layout engine (LR): orthogonal
routing, table column, clean left-to-right story - clients, edge, data,
services, VPC/money, externals. Per review: the only omitted read edges are
runtime_config -> every service (annotated on the node, admin sole-writer
edge kept); all other reads drawn. Docs diagram matches semantically (dagre,
GitHub-compatible).

Co-Authored-By: Claude Fable 5 <noreply@anthropic.com>
Claude-Session: https://claude.ai/code/session_01Gs4wvsmdiVbeWdpfy8uDk7
</commit_message>
<xml_diff>
--- a/slides/wanthat-presentation.pptx
+++ b/slides/wanthat-presentation.pptx
@@ -18951,8 +18951,8 @@
         </p:nvSpPr>
         <p:spPr>
           <a:xfrm>
-            <a:off x="1646027" y="1709928"/>
-            <a:ext cx="8899641" cy="4764024"/>
+            <a:off x="307695" y="1709928"/>
+            <a:ext cx="11576304" cy="4671613"/>
           </a:xfrm>
           <a:prstGeom prst="roundRect">
             <a:avLst>
@@ -19007,8 +19007,8 @@
         </p:blipFill>
         <p:spPr>
           <a:xfrm>
-            <a:off x="1810619" y="1874519"/>
-            <a:ext cx="8570457" cy="4434840"/>
+            <a:off x="472287" y="1874519"/>
+            <a:ext cx="11247120" cy="4342429"/>
           </a:xfrm>
           <a:prstGeom prst="rect">
             <a:avLst/>

</xml_diff>

<commit_message>
docs(slides): layered architecture diagram - explicit tier columns
Hierarchy pins (users > edge > auth+services > stores > analytics/obs) with
the layer axis horizontal (ELK LR): browsers, edge, pools, services, the
DynamoDB table column, VPC/money, analytics+observability read left to right.

Co-Authored-By: Claude Fable 5 <noreply@anthropic.com>
Claude-Session: https://claude.ai/code/session_01Gs4wvsmdiVbeWdpfy8uDk7
</commit_message>
<xml_diff>
--- a/slides/wanthat-presentation.pptx
+++ b/slides/wanthat-presentation.pptx
@@ -18952,7 +18952,7 @@
         <p:spPr>
           <a:xfrm>
             <a:off x="307695" y="1709928"/>
-            <a:ext cx="11576304" cy="4671613"/>
+            <a:ext cx="11576304" cy="4141527"/>
           </a:xfrm>
           <a:prstGeom prst="roundRect">
             <a:avLst>
@@ -19008,7 +19008,7 @@
         <p:spPr>
           <a:xfrm>
             <a:off x="472287" y="1874519"/>
-            <a:ext cx="11247120" cy="4342429"/>
+            <a:ext cx="11247120" cy="3812343"/>
           </a:xfrm>
           <a:prstGeom prst="rect">
             <a:avLst/>

</xml_diff>

<commit_message>
docs(slides): vertical (top-down) layered architecture diagram
Same tier pins, TB direction: users, edge, auth+services, the DynamoDB table
band, VPC/money, analytics+observability read top to bottom. Slide panel
height enlarged for the portrait aspect.

Co-Authored-By: Claude Fable 5 <noreply@anthropic.com>
Claude-Session: https://claude.ai/code/session_01Gs4wvsmdiVbeWdpfy8uDk7
</commit_message>
<xml_diff>
--- a/slides/wanthat-presentation.pptx
+++ b/slides/wanthat-presentation.pptx
@@ -18951,8 +18951,8 @@
         </p:nvSpPr>
         <p:spPr>
           <a:xfrm>
-            <a:off x="307695" y="1709928"/>
-            <a:ext cx="11576304" cy="4141527"/>
+            <a:off x="3148745" y="1481328"/>
+            <a:ext cx="5894204" cy="5084064"/>
           </a:xfrm>
           <a:prstGeom prst="roundRect">
             <a:avLst>
@@ -19007,8 +19007,8 @@
         </p:blipFill>
         <p:spPr>
           <a:xfrm>
-            <a:off x="472287" y="1874519"/>
-            <a:ext cx="11247120" cy="3812343"/>
+            <a:off x="3313337" y="1645920"/>
+            <a:ext cx="5565020" cy="4754880"/>
           </a:xfrm>
           <a:prstGeom prst="rect">
             <a:avLst/>

</xml_diff>

<commit_message>
docs(slides): fix diagram crop (viewport margin removed)
Co-Authored-By: Claude Fable 5 <noreply@anthropic.com>
Claude-Session: https://claude.ai/code/session_01Gs4wvsmdiVbeWdpfy8uDk7
</commit_message>
<xml_diff>
--- a/slides/wanthat-presentation.pptx
+++ b/slides/wanthat-presentation.pptx
@@ -18951,8 +18951,8 @@
         </p:nvSpPr>
         <p:spPr>
           <a:xfrm>
-            <a:off x="3148745" y="1481328"/>
-            <a:ext cx="5894204" cy="5084064"/>
+            <a:off x="4246592" y="1481328"/>
+            <a:ext cx="3698509" cy="5084064"/>
           </a:xfrm>
           <a:prstGeom prst="roundRect">
             <a:avLst>
@@ -19007,8 +19007,8 @@
         </p:blipFill>
         <p:spPr>
           <a:xfrm>
-            <a:off x="3313337" y="1645920"/>
-            <a:ext cx="5565020" cy="4754880"/>
+            <a:off x="4411184" y="1645920"/>
+            <a:ext cx="3369325" cy="4754880"/>
           </a:xfrm>
           <a:prstGeom prst="rect">
             <a:avLst/>

</xml_diff>

<commit_message>
docs(slides): add the three API Gateway nodes to the architecture diagram
App / Admin / Landing HTTP APIs drawn as a gateway tier (JWT authorizer +
throttle on each node, dashed JWKS validation edges to their Cognito pools) -
the Bearer arrows now terminate at the layer that actually rejects and
throttles, instead of passing through invisible gateways.

Co-Authored-By: Claude Fable 5 <noreply@anthropic.com>
Claude-Session: https://claude.ai/code/session_01Gs4wvsmdiVbeWdpfy8uDk7
</commit_message>
<xml_diff>
--- a/slides/wanthat-presentation.pptx
+++ b/slides/wanthat-presentation.pptx
@@ -18951,8 +18951,8 @@
         </p:nvSpPr>
         <p:spPr>
           <a:xfrm>
-            <a:off x="4246592" y="1481328"/>
-            <a:ext cx="3698509" cy="5084064"/>
+            <a:off x="4023389" y="1481328"/>
+            <a:ext cx="4144916" cy="5084064"/>
           </a:xfrm>
           <a:prstGeom prst="roundRect">
             <a:avLst>
@@ -19007,8 +19007,8 @@
         </p:blipFill>
         <p:spPr>
           <a:xfrm>
-            <a:off x="4411184" y="1645920"/>
-            <a:ext cx="3369325" cy="4754880"/>
+            <a:off x="4187981" y="1645920"/>
+            <a:ext cx="3815732" cy="4754880"/>
           </a:xfrm>
           <a:prstGeom prst="rect">
             <a:avLst/>

</xml_diff>

<commit_message>
slides: mirror working-deck structure - walkthrough placeholders, B17 cost progression, renumber
- main deck is now 18 slides: data stores moved BEFORE architecture; architecture
  becomes an 8-slide use-case walkthrough (intro + UC1-UC6 + wrap) with the diagram
  card RESERVED empty - Dennis maintains those diagrams in the working deck
- Dennis's text edits backported: title byline, retailer list (AliExpress/Shein/Amazon),
  recommender+buyer split wording, principles rewording (typo 'spyke' fixed)
- numbering fixed: 02-18 main + B1-B17 backup, footers matched
- NEW backup B17: cost progression 10 -> 100k active users (incl. the RDS Proxy line)
- cost slide points to B17; titles synced (Data stores and cost / Known limits)

Co-Authored-By: Claude Fable 5 <noreply@anthropic.com>
Claude-Session: https://claude.ai/code/session_01FECrSGSMqWYxFMSwWq9E5s
</commit_message>
<xml_diff>
--- a/slides/wanthat-presentation.pptx
+++ b/slides/wanthat-presentation.pptx
@@ -12,8 +12,15 @@
     <p:sldId id="260" r:id="rId12"/>
     <p:sldId id="261" r:id="rId13"/>
     <p:sldId id="278" r:id="rId30"/>
+    <p:sldId id="263" r:id="rId15"/>
     <p:sldId id="262" r:id="rId14"/>
-    <p:sldId id="263" r:id="rId15"/>
+    <p:sldId id="284" r:id="rId36"/>
+    <p:sldId id="285" r:id="rId37"/>
+    <p:sldId id="286" r:id="rId38"/>
+    <p:sldId id="287" r:id="rId39"/>
+    <p:sldId id="288" r:id="rId40"/>
+    <p:sldId id="289" r:id="rId41"/>
+    <p:sldId id="290" r:id="rId42"/>
     <p:sldId id="267" r:id="rId19"/>
     <p:sldId id="268" r:id="rId20"/>
     <p:sldId id="269" r:id="rId21"/>
@@ -33,6 +40,7 @@
     <p:sldId id="275" r:id="rId27"/>
     <p:sldId id="276" r:id="rId28"/>
     <p:sldId id="277" r:id="rId29"/>
+    <p:sldId id="291" r:id="rId43"/>
   </p:sldIdLst>
   <p:sldSz cx="12191695" cy="6858000" type="screen4x3"/>
   <p:notesSz cx="6858000" cy="9144000"/>
@@ -1604,6 +1612,426 @@
 </p:notes>
 </file>
 
+<file path=ppt/notesSlides/notesSlide24.xml><?xml version="1.0" encoding="utf-8"?>
+<p:notes xmlns:a="http://schemas.openxmlformats.org/drawingml/2006/main" xmlns:p="http://schemas.openxmlformats.org/presentationml/2006/main" xmlns:r="http://schemas.openxmlformats.org/officeDocument/2006/relationships">
+  <p:cSld>
+    <p:spTree>
+      <p:nvGrpSpPr>
+        <p:cNvPr id="1" name=""/>
+        <p:cNvGrpSpPr/>
+        <p:nvPr/>
+      </p:nvGrpSpPr>
+      <p:grpSpPr>
+        <a:xfrm>
+          <a:off x="0" y="0"/>
+          <a:ext cx="0" cy="0"/>
+          <a:chOff x="0" y="0"/>
+          <a:chExt cx="0" cy="0"/>
+        </a:xfrm>
+      </p:grpSpPr>
+      <p:sp>
+        <p:nvSpPr>
+          <p:cNvPr id="2" name="Slide Image Placeholder 1"/>
+          <p:cNvSpPr>
+            <a:spLocks noGrp="1"/>
+          </p:cNvSpPr>
+          <p:nvPr>
+            <p:ph type="sldImg" idx="2"/>
+          </p:nvPr>
+        </p:nvSpPr>
+        <p:spPr/>
+      </p:sp>
+      <p:sp>
+        <p:nvSpPr>
+          <p:cNvPr id="3" name="Notes Placeholder 2"/>
+          <p:cNvSpPr>
+            <a:spLocks noGrp="1"/>
+          </p:cNvSpPr>
+          <p:nvPr>
+            <p:ph type="body" idx="3" sz="quarter"/>
+          </p:nvPr>
+        </p:nvSpPr>
+        <p:spPr/>
+        <p:txBody>
+          <a:bodyPr/>
+          <a:lstStyle/>
+          <a:p>
+            <a:r>
+              <a:t>Diagram maintained by Dennis in the working deck - the card is reserved space.</a:t>
+            </a:r>
+          </a:p>
+        </p:txBody>
+      </p:sp>
+      <p:sp>
+        <p:nvSpPr>
+          <p:cNvPr id="4" name="Slide Number Placeholder 3"/>
+          <p:cNvSpPr>
+            <a:spLocks noGrp="1"/>
+          </p:cNvSpPr>
+          <p:nvPr>
+            <p:ph type="sldNum" idx="5" sz="quarter"/>
+          </p:nvPr>
+        </p:nvSpPr>
+        <p:spPr/>
+      </p:sp>
+    </p:spTree>
+  </p:cSld>
+  <p:clrMapOvr>
+    <a:masterClrMapping/>
+  </p:clrMapOvr>
+</p:notes>
+</file>
+
+<file path=ppt/notesSlides/notesSlide25.xml><?xml version="1.0" encoding="utf-8"?>
+<p:notes xmlns:a="http://schemas.openxmlformats.org/drawingml/2006/main" xmlns:p="http://schemas.openxmlformats.org/presentationml/2006/main" xmlns:r="http://schemas.openxmlformats.org/officeDocument/2006/relationships">
+  <p:cSld>
+    <p:spTree>
+      <p:nvGrpSpPr>
+        <p:cNvPr id="1" name=""/>
+        <p:cNvGrpSpPr/>
+        <p:nvPr/>
+      </p:nvGrpSpPr>
+      <p:grpSpPr>
+        <a:xfrm>
+          <a:off x="0" y="0"/>
+          <a:ext cx="0" cy="0"/>
+          <a:chOff x="0" y="0"/>
+          <a:chExt cx="0" cy="0"/>
+        </a:xfrm>
+      </p:grpSpPr>
+      <p:sp>
+        <p:nvSpPr>
+          <p:cNvPr id="2" name="Slide Image Placeholder 1"/>
+          <p:cNvSpPr>
+            <a:spLocks noGrp="1"/>
+          </p:cNvSpPr>
+          <p:nvPr>
+            <p:ph type="sldImg" idx="2"/>
+          </p:nvPr>
+        </p:nvSpPr>
+        <p:spPr/>
+      </p:sp>
+      <p:sp>
+        <p:nvSpPr>
+          <p:cNvPr id="3" name="Notes Placeholder 2"/>
+          <p:cNvSpPr>
+            <a:spLocks noGrp="1"/>
+          </p:cNvSpPr>
+          <p:nvPr>
+            <p:ph type="body" idx="3" sz="quarter"/>
+          </p:nvPr>
+        </p:nvSpPr>
+        <p:spPr/>
+        <p:txBody>
+          <a:bodyPr/>
+          <a:lstStyle/>
+          <a:p>
+            <a:r>
+              <a:t>Diagram maintained by Dennis in the working deck - the card is reserved space.</a:t>
+            </a:r>
+          </a:p>
+        </p:txBody>
+      </p:sp>
+      <p:sp>
+        <p:nvSpPr>
+          <p:cNvPr id="4" name="Slide Number Placeholder 3"/>
+          <p:cNvSpPr>
+            <a:spLocks noGrp="1"/>
+          </p:cNvSpPr>
+          <p:nvPr>
+            <p:ph type="sldNum" idx="5" sz="quarter"/>
+          </p:nvPr>
+        </p:nvSpPr>
+        <p:spPr/>
+      </p:sp>
+    </p:spTree>
+  </p:cSld>
+  <p:clrMapOvr>
+    <a:masterClrMapping/>
+  </p:clrMapOvr>
+</p:notes>
+</file>
+
+<file path=ppt/notesSlides/notesSlide26.xml><?xml version="1.0" encoding="utf-8"?>
+<p:notes xmlns:a="http://schemas.openxmlformats.org/drawingml/2006/main" xmlns:p="http://schemas.openxmlformats.org/presentationml/2006/main" xmlns:r="http://schemas.openxmlformats.org/officeDocument/2006/relationships">
+  <p:cSld>
+    <p:spTree>
+      <p:nvGrpSpPr>
+        <p:cNvPr id="1" name=""/>
+        <p:cNvGrpSpPr/>
+        <p:nvPr/>
+      </p:nvGrpSpPr>
+      <p:grpSpPr>
+        <a:xfrm>
+          <a:off x="0" y="0"/>
+          <a:ext cx="0" cy="0"/>
+          <a:chOff x="0" y="0"/>
+          <a:chExt cx="0" cy="0"/>
+        </a:xfrm>
+      </p:grpSpPr>
+      <p:sp>
+        <p:nvSpPr>
+          <p:cNvPr id="2" name="Slide Image Placeholder 1"/>
+          <p:cNvSpPr>
+            <a:spLocks noGrp="1"/>
+          </p:cNvSpPr>
+          <p:nvPr>
+            <p:ph type="sldImg" idx="2"/>
+          </p:nvPr>
+        </p:nvSpPr>
+        <p:spPr/>
+      </p:sp>
+      <p:sp>
+        <p:nvSpPr>
+          <p:cNvPr id="3" name="Notes Placeholder 2"/>
+          <p:cNvSpPr>
+            <a:spLocks noGrp="1"/>
+          </p:cNvSpPr>
+          <p:nvPr>
+            <p:ph type="body" idx="3" sz="quarter"/>
+          </p:nvPr>
+        </p:nvSpPr>
+        <p:spPr/>
+        <p:txBody>
+          <a:bodyPr/>
+          <a:lstStyle/>
+          <a:p>
+            <a:r>
+              <a:t>Diagram maintained by Dennis in the working deck - the card is reserved space.</a:t>
+            </a:r>
+          </a:p>
+        </p:txBody>
+      </p:sp>
+      <p:sp>
+        <p:nvSpPr>
+          <p:cNvPr id="4" name="Slide Number Placeholder 3"/>
+          <p:cNvSpPr>
+            <a:spLocks noGrp="1"/>
+          </p:cNvSpPr>
+          <p:nvPr>
+            <p:ph type="sldNum" idx="5" sz="quarter"/>
+          </p:nvPr>
+        </p:nvSpPr>
+        <p:spPr/>
+      </p:sp>
+    </p:spTree>
+  </p:cSld>
+  <p:clrMapOvr>
+    <a:masterClrMapping/>
+  </p:clrMapOvr>
+</p:notes>
+</file>
+
+<file path=ppt/notesSlides/notesSlide27.xml><?xml version="1.0" encoding="utf-8"?>
+<p:notes xmlns:a="http://schemas.openxmlformats.org/drawingml/2006/main" xmlns:p="http://schemas.openxmlformats.org/presentationml/2006/main" xmlns:r="http://schemas.openxmlformats.org/officeDocument/2006/relationships">
+  <p:cSld>
+    <p:spTree>
+      <p:nvGrpSpPr>
+        <p:cNvPr id="1" name=""/>
+        <p:cNvGrpSpPr/>
+        <p:nvPr/>
+      </p:nvGrpSpPr>
+      <p:grpSpPr>
+        <a:xfrm>
+          <a:off x="0" y="0"/>
+          <a:ext cx="0" cy="0"/>
+          <a:chOff x="0" y="0"/>
+          <a:chExt cx="0" cy="0"/>
+        </a:xfrm>
+      </p:grpSpPr>
+      <p:sp>
+        <p:nvSpPr>
+          <p:cNvPr id="2" name="Slide Image Placeholder 1"/>
+          <p:cNvSpPr>
+            <a:spLocks noGrp="1"/>
+          </p:cNvSpPr>
+          <p:nvPr>
+            <p:ph type="sldImg" idx="2"/>
+          </p:nvPr>
+        </p:nvSpPr>
+        <p:spPr/>
+      </p:sp>
+      <p:sp>
+        <p:nvSpPr>
+          <p:cNvPr id="3" name="Notes Placeholder 2"/>
+          <p:cNvSpPr>
+            <a:spLocks noGrp="1"/>
+          </p:cNvSpPr>
+          <p:nvPr>
+            <p:ph type="body" idx="3" sz="quarter"/>
+          </p:nvPr>
+        </p:nvSpPr>
+        <p:spPr/>
+        <p:txBody>
+          <a:bodyPr/>
+          <a:lstStyle/>
+          <a:p>
+            <a:r>
+              <a:t>Diagram maintained by Dennis in the working deck - the card is reserved space.</a:t>
+            </a:r>
+          </a:p>
+        </p:txBody>
+      </p:sp>
+      <p:sp>
+        <p:nvSpPr>
+          <p:cNvPr id="4" name="Slide Number Placeholder 3"/>
+          <p:cNvSpPr>
+            <a:spLocks noGrp="1"/>
+          </p:cNvSpPr>
+          <p:nvPr>
+            <p:ph type="sldNum" idx="5" sz="quarter"/>
+          </p:nvPr>
+        </p:nvSpPr>
+        <p:spPr/>
+      </p:sp>
+    </p:spTree>
+  </p:cSld>
+  <p:clrMapOvr>
+    <a:masterClrMapping/>
+  </p:clrMapOvr>
+</p:notes>
+</file>
+
+<file path=ppt/notesSlides/notesSlide28.xml><?xml version="1.0" encoding="utf-8"?>
+<p:notes xmlns:a="http://schemas.openxmlformats.org/drawingml/2006/main" xmlns:p="http://schemas.openxmlformats.org/presentationml/2006/main" xmlns:r="http://schemas.openxmlformats.org/officeDocument/2006/relationships">
+  <p:cSld>
+    <p:spTree>
+      <p:nvGrpSpPr>
+        <p:cNvPr id="1" name=""/>
+        <p:cNvGrpSpPr/>
+        <p:nvPr/>
+      </p:nvGrpSpPr>
+      <p:grpSpPr>
+        <a:xfrm>
+          <a:off x="0" y="0"/>
+          <a:ext cx="0" cy="0"/>
+          <a:chOff x="0" y="0"/>
+          <a:chExt cx="0" cy="0"/>
+        </a:xfrm>
+      </p:grpSpPr>
+      <p:sp>
+        <p:nvSpPr>
+          <p:cNvPr id="2" name="Slide Image Placeholder 1"/>
+          <p:cNvSpPr>
+            <a:spLocks noGrp="1"/>
+          </p:cNvSpPr>
+          <p:nvPr>
+            <p:ph type="sldImg" idx="2"/>
+          </p:nvPr>
+        </p:nvSpPr>
+        <p:spPr/>
+      </p:sp>
+      <p:sp>
+        <p:nvSpPr>
+          <p:cNvPr id="3" name="Notes Placeholder 2"/>
+          <p:cNvSpPr>
+            <a:spLocks noGrp="1"/>
+          </p:cNvSpPr>
+          <p:nvPr>
+            <p:ph type="body" idx="3" sz="quarter"/>
+          </p:nvPr>
+        </p:nvSpPr>
+        <p:spPr/>
+        <p:txBody>
+          <a:bodyPr/>
+          <a:lstStyle/>
+          <a:p>
+            <a:r>
+              <a:t>Diagram maintained by Dennis in the working deck - the card is reserved space.</a:t>
+            </a:r>
+          </a:p>
+        </p:txBody>
+      </p:sp>
+      <p:sp>
+        <p:nvSpPr>
+          <p:cNvPr id="4" name="Slide Number Placeholder 3"/>
+          <p:cNvSpPr>
+            <a:spLocks noGrp="1"/>
+          </p:cNvSpPr>
+          <p:nvPr>
+            <p:ph type="sldNum" idx="5" sz="quarter"/>
+          </p:nvPr>
+        </p:nvSpPr>
+        <p:spPr/>
+      </p:sp>
+    </p:spTree>
+  </p:cSld>
+  <p:clrMapOvr>
+    <a:masterClrMapping/>
+  </p:clrMapOvr>
+</p:notes>
+</file>
+
+<file path=ppt/notesSlides/notesSlide29.xml><?xml version="1.0" encoding="utf-8"?>
+<p:notes xmlns:a="http://schemas.openxmlformats.org/drawingml/2006/main" xmlns:p="http://schemas.openxmlformats.org/presentationml/2006/main" xmlns:r="http://schemas.openxmlformats.org/officeDocument/2006/relationships">
+  <p:cSld>
+    <p:spTree>
+      <p:nvGrpSpPr>
+        <p:cNvPr id="1" name=""/>
+        <p:cNvGrpSpPr/>
+        <p:nvPr/>
+      </p:nvGrpSpPr>
+      <p:grpSpPr>
+        <a:xfrm>
+          <a:off x="0" y="0"/>
+          <a:ext cx="0" cy="0"/>
+          <a:chOff x="0" y="0"/>
+          <a:chExt cx="0" cy="0"/>
+        </a:xfrm>
+      </p:grpSpPr>
+      <p:sp>
+        <p:nvSpPr>
+          <p:cNvPr id="2" name="Slide Image Placeholder 1"/>
+          <p:cNvSpPr>
+            <a:spLocks noGrp="1"/>
+          </p:cNvSpPr>
+          <p:nvPr>
+            <p:ph type="sldImg" idx="2"/>
+          </p:nvPr>
+        </p:nvSpPr>
+        <p:spPr/>
+      </p:sp>
+      <p:sp>
+        <p:nvSpPr>
+          <p:cNvPr id="3" name="Notes Placeholder 2"/>
+          <p:cNvSpPr>
+            <a:spLocks noGrp="1"/>
+          </p:cNvSpPr>
+          <p:nvPr>
+            <p:ph type="body" idx="3" sz="quarter"/>
+          </p:nvPr>
+        </p:nvSpPr>
+        <p:spPr/>
+        <p:txBody>
+          <a:bodyPr/>
+          <a:lstStyle/>
+          <a:p>
+            <a:r>
+              <a:t>Diagram maintained by Dennis in the working deck - the card is reserved space.</a:t>
+            </a:r>
+          </a:p>
+        </p:txBody>
+      </p:sp>
+      <p:sp>
+        <p:nvSpPr>
+          <p:cNvPr id="4" name="Slide Number Placeholder 3"/>
+          <p:cNvSpPr>
+            <a:spLocks noGrp="1"/>
+          </p:cNvSpPr>
+          <p:nvPr>
+            <p:ph type="sldNum" idx="5" sz="quarter"/>
+          </p:nvPr>
+        </p:nvSpPr>
+        <p:spPr/>
+      </p:sp>
+    </p:spTree>
+  </p:cSld>
+  <p:clrMapOvr>
+    <a:masterClrMapping/>
+  </p:clrMapOvr>
+</p:notes>
+</file>
+
 <file path=ppt/notesSlides/notesSlide3.xml><?xml version="1.0" encoding="utf-8"?>
 <p:notes xmlns:a="http://schemas.openxmlformats.org/drawingml/2006/main" xmlns:p="http://schemas.openxmlformats.org/presentationml/2006/main" xmlns:r="http://schemas.openxmlformats.org/officeDocument/2006/relationships">
   <p:cSld>
@@ -1650,6 +2078,146 @@
           <a:p>
             <a:r>
               <a:t>the gates decide Phase 2 (group sharing, two-sided rewards) and a pre-seed raise.</a:t>
+            </a:r>
+          </a:p>
+        </p:txBody>
+      </p:sp>
+      <p:sp>
+        <p:nvSpPr>
+          <p:cNvPr id="4" name="Slide Number Placeholder 3"/>
+          <p:cNvSpPr>
+            <a:spLocks noGrp="1"/>
+          </p:cNvSpPr>
+          <p:nvPr>
+            <p:ph type="sldNum" idx="5" sz="quarter"/>
+          </p:nvPr>
+        </p:nvSpPr>
+        <p:spPr/>
+      </p:sp>
+    </p:spTree>
+  </p:cSld>
+  <p:clrMapOvr>
+    <a:masterClrMapping/>
+  </p:clrMapOvr>
+</p:notes>
+</file>
+
+<file path=ppt/notesSlides/notesSlide30.xml><?xml version="1.0" encoding="utf-8"?>
+<p:notes xmlns:a="http://schemas.openxmlformats.org/drawingml/2006/main" xmlns:p="http://schemas.openxmlformats.org/presentationml/2006/main" xmlns:r="http://schemas.openxmlformats.org/officeDocument/2006/relationships">
+  <p:cSld>
+    <p:spTree>
+      <p:nvGrpSpPr>
+        <p:cNvPr id="1" name=""/>
+        <p:cNvGrpSpPr/>
+        <p:nvPr/>
+      </p:nvGrpSpPr>
+      <p:grpSpPr>
+        <a:xfrm>
+          <a:off x="0" y="0"/>
+          <a:ext cx="0" cy="0"/>
+          <a:chOff x="0" y="0"/>
+          <a:chExt cx="0" cy="0"/>
+        </a:xfrm>
+      </p:grpSpPr>
+      <p:sp>
+        <p:nvSpPr>
+          <p:cNvPr id="2" name="Slide Image Placeholder 1"/>
+          <p:cNvSpPr>
+            <a:spLocks noGrp="1"/>
+          </p:cNvSpPr>
+          <p:nvPr>
+            <p:ph type="sldImg" idx="2"/>
+          </p:nvPr>
+        </p:nvSpPr>
+        <p:spPr/>
+      </p:sp>
+      <p:sp>
+        <p:nvSpPr>
+          <p:cNvPr id="3" name="Notes Placeholder 2"/>
+          <p:cNvSpPr>
+            <a:spLocks noGrp="1"/>
+          </p:cNvSpPr>
+          <p:nvPr>
+            <p:ph type="body" idx="3" sz="quarter"/>
+          </p:nvPr>
+        </p:nvSpPr>
+        <p:spPr/>
+        <p:txBody>
+          <a:bodyPr/>
+          <a:lstStyle/>
+          <a:p>
+            <a:r>
+              <a:t>Diagram maintained by Dennis in the working deck - the card is reserved space.</a:t>
+            </a:r>
+          </a:p>
+        </p:txBody>
+      </p:sp>
+      <p:sp>
+        <p:nvSpPr>
+          <p:cNvPr id="4" name="Slide Number Placeholder 3"/>
+          <p:cNvSpPr>
+            <a:spLocks noGrp="1"/>
+          </p:cNvSpPr>
+          <p:nvPr>
+            <p:ph type="sldNum" idx="5" sz="quarter"/>
+          </p:nvPr>
+        </p:nvSpPr>
+        <p:spPr/>
+      </p:sp>
+    </p:spTree>
+  </p:cSld>
+  <p:clrMapOvr>
+    <a:masterClrMapping/>
+  </p:clrMapOvr>
+</p:notes>
+</file>
+
+<file path=ppt/notesSlides/notesSlide31.xml><?xml version="1.0" encoding="utf-8"?>
+<p:notes xmlns:a="http://schemas.openxmlformats.org/drawingml/2006/main" xmlns:p="http://schemas.openxmlformats.org/presentationml/2006/main" xmlns:r="http://schemas.openxmlformats.org/officeDocument/2006/relationships">
+  <p:cSld>
+    <p:spTree>
+      <p:nvGrpSpPr>
+        <p:cNvPr id="1" name=""/>
+        <p:cNvGrpSpPr/>
+        <p:nvPr/>
+      </p:nvGrpSpPr>
+      <p:grpSpPr>
+        <a:xfrm>
+          <a:off x="0" y="0"/>
+          <a:ext cx="0" cy="0"/>
+          <a:chOff x="0" y="0"/>
+          <a:chExt cx="0" cy="0"/>
+        </a:xfrm>
+      </p:grpSpPr>
+      <p:sp>
+        <p:nvSpPr>
+          <p:cNvPr id="2" name="Slide Image Placeholder 1"/>
+          <p:cNvSpPr>
+            <a:spLocks noGrp="1"/>
+          </p:cNvSpPr>
+          <p:nvPr>
+            <p:ph type="sldImg" idx="2"/>
+          </p:nvPr>
+        </p:nvSpPr>
+        <p:spPr/>
+      </p:sp>
+      <p:sp>
+        <p:nvSpPr>
+          <p:cNvPr id="3" name="Notes Placeholder 2"/>
+          <p:cNvSpPr>
+            <a:spLocks noGrp="1"/>
+          </p:cNvSpPr>
+          <p:nvPr>
+            <p:ph type="body" idx="3" sz="quarter"/>
+          </p:nvPr>
+        </p:nvSpPr>
+        <p:spPr/>
+        <p:txBody>
+          <a:bodyPr/>
+          <a:lstStyle/>
+          <a:p>
+            <a:r>
+              <a:t>WAF stays flat at every scale - member API operations bypass CloudFront entirely. The scaling costs live in identity (Cognito MAU), Aurora always-on, and the per-request stack (~$90/month combined at 100k).</a:t>
             </a:r>
           </a:p>
         </p:txBody>
@@ -1929,7 +2497,7 @@
           <a:lstStyle/>
           <a:p>
             <a:r>
-              <a:t>(walk it left to right) (1) there is no auth service — the browser talks to Cognito directly; OTP rides a custom sender with WhatsApp-default and kill switches. (2) The member APIs split into non-VPC member-catalog and in-VPC member-wallet — only what touches money enters the VPC; the admin surface splits the same way (console vs ledger view). (3) The friend's click never leaves DynamoDB. (4) Money enters only through the scheduled pipeline on the right — retailer-settlement fetches, the in-VPC ledger-writer appends and returns the totals the poll projects back onto the links. Full per-table version lives in `docs/AWS_Architecture.md`.</a:t>
+              <a:t>Diagram maintained by Dennis in the working deck - the card is reserved space.</a:t>
             </a:r>
           </a:p>
         </p:txBody>
@@ -5267,7 +5835,7 @@
                 </a:solidFill>
                 <a:latin typeface="Hanken Grotesk"/>
               </a:rPr>
-              <a:t>Product &amp; architecture overview — 19 minutes</a:t>
+              <a:t>Product &amp; architecture overview  ·  Dennis Potashnik  ·  July 2026</a:t>
             </a:r>
           </a:p>
         </p:txBody>
@@ -5556,7 +6124,7 @@
                 </a:solidFill>
                 <a:latin typeface="Space Grotesk"/>
               </a:rPr>
-              <a:t>10</a:t>
+              <a:t>17</a:t>
             </a:r>
           </a:p>
         </p:txBody>
@@ -6231,6 +6799,17 @@
               <a:t>the redirect hot path costs micro-cents per thousand clicks and cannot touch Aurora — cost scales with revenue-bearing traffic, not with virality.</a:t>
             </a:r>
           </a:p>
+          <a:p>
+            <a:r>
+              <a:rPr sz="1250" b="1">
+                <a:solidFill>
+                  <a:srgbClr val="15201C"/>
+                </a:solidFill>
+                <a:latin typeface="Hanken Grotesk"/>
+              </a:rPr>
+              <a:t>Scale projection (10 → 100k users): backup B17.</a:t>
+            </a:r>
+          </a:p>
         </p:txBody>
       </p:sp>
       <p:sp>
@@ -6350,7 +6929,7 @@
                 </a:solidFill>
                 <a:latin typeface="Space Mono"/>
               </a:rPr>
-              <a:t>10</a:t>
+              <a:t>17</a:t>
             </a:r>
           </a:p>
         </p:txBody>
@@ -6411,7 +6990,7 @@
                 </a:solidFill>
                 <a:latin typeface="Space Grotesk"/>
               </a:rPr>
-              <a:t>11</a:t>
+              <a:t>18</a:t>
             </a:r>
           </a:p>
         </p:txBody>
@@ -6479,7 +7058,7 @@
                 </a:solidFill>
                 <a:latin typeface="Space Grotesk"/>
               </a:rPr>
-              <a:t>Limits I know about — and their revisit triggers</a:t>
+              <a:t>Known limits — and their revisit triggers</a:t>
             </a:r>
           </a:p>
         </p:txBody>
@@ -7252,7 +7831,7 @@
                 </a:solidFill>
                 <a:latin typeface="Space Mono"/>
               </a:rPr>
-              <a:t>11</a:t>
+              <a:t>18</a:t>
             </a:r>
           </a:p>
         </p:txBody>
@@ -12004,7 +12583,7 @@
                 </a:solidFill>
                 <a:latin typeface="Space Grotesk"/>
               </a:rPr>
-              <a:t>Brands</a:t>
+              <a:t>Organic word-of-mouth</a:t>
             </a:r>
           </a:p>
         </p:txBody>
@@ -12043,7 +12622,7 @@
                 </a:solidFill>
                 <a:latin typeface="Hanken Grotesk"/>
               </a:rPr>
-              <a:t>influencer budgets keep growing while organic word-of-mouth — which converts better — stays invisible.</a:t>
+              <a:t>brands keep growing influencer budgets while organic word-of-mouth — which converts better — stays invisible</a:t>
             </a:r>
           </a:p>
         </p:txBody>
@@ -12252,13 +12831,13 @@
               </a:spcAft>
             </a:pPr>
             <a:r>
-              <a:rPr sz="1500" b="0">
+              <a:rPr sz="1500" b="1">
                 <a:solidFill>
                   <a:srgbClr val="15201C"/>
                 </a:solidFill>
                 <a:latin typeface="Hanken Grotesk"/>
               </a:rPr>
-              <a:t>Wanthat is the single registered affiliate across AliExpress / Awin / eBay; when a friend buys, the commission flows in and the majority is credited back to the recommender as cashback.</a:t>
+              <a:t>Wanthat is the single registered affiliate across AliExpress / Shein / Amazon and others — when a friend buys, the commission flows in and is split between the recommender and the buyer.</a:t>
             </a:r>
           </a:p>
           <a:p>
@@ -12271,13 +12850,13 @@
               </a:spcAft>
             </a:pPr>
             <a:r>
-              <a:rPr sz="1400" b="1">
-                <a:solidFill>
-                  <a:srgbClr val="1F7A57"/>
-                </a:solidFill>
-                <a:latin typeface="Space Grotesk"/>
-              </a:rPr>
-              <a:t>It monetizes a behavior that already exists — without changing it.</a:t>
+              <a:rPr sz="1500" b="1">
+                <a:solidFill>
+                  <a:srgbClr val="15201C"/>
+                </a:solidFill>
+                <a:latin typeface="Hanken Grotesk"/>
+              </a:rPr>
+              <a:t>It monetizes a behavior that already exists.</a:t>
             </a:r>
           </a:p>
         </p:txBody>
@@ -19281,6 +19860,353 @@
 </p:sld>
 </file>
 
+<file path=ppt/slides/slide29.xml><?xml version="1.0" encoding="utf-8"?>
+<p:sld xmlns:a="http://schemas.openxmlformats.org/drawingml/2006/main" xmlns:p="http://schemas.openxmlformats.org/presentationml/2006/main" xmlns:r="http://schemas.openxmlformats.org/officeDocument/2006/relationships">
+  <p:cSld>
+    <p:spTree>
+      <p:nvGrpSpPr>
+        <p:cNvPr id="1" name=""/>
+        <p:cNvGrpSpPr/>
+        <p:nvPr/>
+      </p:nvGrpSpPr>
+      <p:grpSpPr/>
+      <p:sp>
+        <p:nvSpPr>
+          <p:cNvPr id="2" name="TextBox 1"/>
+          <p:cNvSpPr txBox="1"/>
+          <p:nvPr/>
+        </p:nvSpPr>
+        <p:spPr>
+          <a:xfrm>
+            <a:off x="10195560" y="256032"/>
+            <a:ext cx="1371600" cy="1005840"/>
+          </a:xfrm>
+          <a:prstGeom prst="rect">
+            <a:avLst/>
+          </a:prstGeom>
+          <a:noFill/>
+        </p:spPr>
+        <p:txBody>
+          <a:bodyPr wrap="square" anchor="t" lIns="0" rIns="0" tIns="0" bIns="0">
+            <a:spAutoFit/>
+          </a:bodyPr>
+          <a:lstStyle/>
+          <a:p>
+            <a:pPr algn="r"/>
+            <a:r>
+              <a:rPr sz="4600" b="1">
+                <a:solidFill>
+                  <a:srgbClr val="DCE5E0"/>
+                </a:solidFill>
+                <a:latin typeface="Space Grotesk"/>
+              </a:rPr>
+              <a:t>10</a:t>
+            </a:r>
+          </a:p>
+        </p:txBody>
+      </p:sp>
+      <p:sp>
+        <p:nvSpPr>
+          <p:cNvPr id="3" name="TextBox 2"/>
+          <p:cNvSpPr txBox="1"/>
+          <p:nvPr/>
+        </p:nvSpPr>
+        <p:spPr>
+          <a:xfrm>
+            <a:off x="640080" y="420624"/>
+            <a:ext cx="9418320" cy="292608"/>
+          </a:xfrm>
+          <a:prstGeom prst="rect">
+            <a:avLst/>
+          </a:prstGeom>
+          <a:noFill/>
+        </p:spPr>
+        <p:txBody>
+          <a:bodyPr wrap="square" anchor="t" lIns="0" rIns="0" tIns="0" bIns="0">
+            <a:spAutoFit/>
+          </a:bodyPr>
+          <a:lstStyle/>
+          <a:p>
+            <a:r>
+              <a:rPr sz="1150" b="1">
+                <a:solidFill>
+                  <a:srgbClr val="1F7A57"/>
+                </a:solidFill>
+                <a:latin typeface="Space Mono"/>
+              </a:rPr>
+              <a:t>ENGINEERING</a:t>
+            </a:r>
+          </a:p>
+        </p:txBody>
+      </p:sp>
+      <p:sp>
+        <p:nvSpPr>
+          <p:cNvPr id="4" name="TextBox 3"/>
+          <p:cNvSpPr txBox="1"/>
+          <p:nvPr/>
+        </p:nvSpPr>
+        <p:spPr>
+          <a:xfrm>
+            <a:off x="621792" y="731520"/>
+            <a:ext cx="9509760" cy="868680"/>
+          </a:xfrm>
+          <a:prstGeom prst="rect">
+            <a:avLst/>
+          </a:prstGeom>
+          <a:noFill/>
+        </p:spPr>
+        <p:txBody>
+          <a:bodyPr wrap="square" anchor="t" lIns="0" rIns="0" tIns="0" bIns="0">
+            <a:spAutoFit/>
+          </a:bodyPr>
+          <a:lstStyle/>
+          <a:p>
+            <a:r>
+              <a:rPr sz="2700" b="1">
+                <a:solidFill>
+                  <a:srgbClr val="15201C"/>
+                </a:solidFill>
+                <a:latin typeface="Space Grotesk"/>
+              </a:rPr>
+              <a:t>Architecture UC1 — member creates a recommendation</a:t>
+            </a:r>
+          </a:p>
+        </p:txBody>
+      </p:sp>
+      <p:sp>
+        <p:nvSpPr>
+          <p:cNvPr id="5" name="Rounded Rectangle 4"/>
+          <p:cNvSpPr/>
+          <p:nvPr/>
+        </p:nvSpPr>
+        <p:spPr>
+          <a:xfrm>
+            <a:off x="3886200" y="1600200"/>
+            <a:ext cx="7653527" cy="4709160"/>
+          </a:xfrm>
+          <a:prstGeom prst="roundRect">
+            <a:avLst>
+              <a:gd name="adj" fmla="val 3000"/>
+            </a:avLst>
+          </a:prstGeom>
+          <a:solidFill>
+            <a:srgbClr val="FFFFFF"/>
+          </a:solidFill>
+          <a:ln w="12700">
+            <a:solidFill>
+              <a:srgbClr val="E6EBE8"/>
+            </a:solidFill>
+          </a:ln>
+          <a:effectLst/>
+        </p:spPr>
+        <p:style>
+          <a:lnRef idx="1">
+            <a:schemeClr val="accent1"/>
+          </a:lnRef>
+          <a:fillRef idx="3">
+            <a:schemeClr val="accent1"/>
+          </a:fillRef>
+          <a:effectRef idx="2">
+            <a:schemeClr val="accent1"/>
+          </a:effectRef>
+          <a:fontRef idx="minor">
+            <a:schemeClr val="lt1"/>
+          </a:fontRef>
+        </p:style>
+        <p:txBody>
+          <a:bodyPr rtlCol="0" anchor="ctr"/>
+          <a:lstStyle/>
+          <a:p>
+            <a:pPr algn="ctr"/>
+          </a:p>
+        </p:txBody>
+      </p:sp>
+      <p:sp>
+        <p:nvSpPr>
+          <p:cNvPr id="7" name="Rectangle 6"/>
+          <p:cNvSpPr/>
+          <p:nvPr/>
+        </p:nvSpPr>
+        <p:spPr>
+          <a:xfrm>
+            <a:off x="640080" y="6455664"/>
+            <a:ext cx="10908792" cy="9144"/>
+          </a:xfrm>
+          <a:prstGeom prst="rect">
+            <a:avLst/>
+          </a:prstGeom>
+          <a:solidFill>
+            <a:srgbClr val="E6EBE8"/>
+          </a:solidFill>
+          <a:ln>
+            <a:noFill/>
+          </a:ln>
+          <a:effectLst/>
+        </p:spPr>
+        <p:style>
+          <a:lnRef idx="1">
+            <a:schemeClr val="accent1"/>
+          </a:lnRef>
+          <a:fillRef idx="3">
+            <a:schemeClr val="accent1"/>
+          </a:fillRef>
+          <a:effectRef idx="2">
+            <a:schemeClr val="accent1"/>
+          </a:effectRef>
+          <a:fontRef idx="minor">
+            <a:schemeClr val="lt1"/>
+          </a:fontRef>
+        </p:style>
+        <p:txBody>
+          <a:bodyPr rtlCol="0" anchor="ctr"/>
+          <a:lstStyle/>
+          <a:p>
+            <a:pPr algn="ctr"/>
+          </a:p>
+        </p:txBody>
+      </p:sp>
+      <p:sp>
+        <p:nvSpPr>
+          <p:cNvPr id="8" name="TextBox 7"/>
+          <p:cNvSpPr txBox="1"/>
+          <p:nvPr/>
+        </p:nvSpPr>
+        <p:spPr>
+          <a:xfrm>
+            <a:off x="640080" y="6510528"/>
+            <a:ext cx="2743200" cy="274320"/>
+          </a:xfrm>
+          <a:prstGeom prst="rect">
+            <a:avLst/>
+          </a:prstGeom>
+          <a:noFill/>
+        </p:spPr>
+        <p:txBody>
+          <a:bodyPr wrap="square" anchor="t" lIns="0" rIns="0" tIns="0" bIns="0">
+            <a:spAutoFit/>
+          </a:bodyPr>
+          <a:lstStyle/>
+          <a:p>
+            <a:r>
+              <a:rPr sz="1100" b="1">
+                <a:solidFill>
+                  <a:srgbClr val="6B7B73"/>
+                </a:solidFill>
+                <a:latin typeface="Space Grotesk"/>
+              </a:rPr>
+              <a:t>want</a:t>
+            </a:r>
+            <a:r>
+              <a:rPr sz="1100" b="1">
+                <a:solidFill>
+                  <a:srgbClr val="1F7A57"/>
+                </a:solidFill>
+                <a:latin typeface="Space Grotesk"/>
+              </a:rPr>
+              <a:t>hat</a:t>
+            </a:r>
+          </a:p>
+        </p:txBody>
+      </p:sp>
+      <p:sp>
+        <p:nvSpPr>
+          <p:cNvPr id="9" name="TextBox 8"/>
+          <p:cNvSpPr txBox="1"/>
+          <p:nvPr/>
+        </p:nvSpPr>
+        <p:spPr>
+          <a:xfrm>
+            <a:off x="10607040" y="6510528"/>
+            <a:ext cx="941832" cy="274320"/>
+          </a:xfrm>
+          <a:prstGeom prst="rect">
+            <a:avLst/>
+          </a:prstGeom>
+          <a:noFill/>
+        </p:spPr>
+        <p:txBody>
+          <a:bodyPr wrap="square" anchor="t" lIns="0" rIns="0" tIns="0" bIns="0">
+            <a:spAutoFit/>
+          </a:bodyPr>
+          <a:lstStyle/>
+          <a:p>
+            <a:pPr algn="r"/>
+            <a:r>
+              <a:rPr sz="1000" b="0">
+                <a:solidFill>
+                  <a:srgbClr val="8A968F"/>
+                </a:solidFill>
+                <a:latin typeface="Space Mono"/>
+              </a:rPr>
+              <a:t>10</a:t>
+            </a:r>
+          </a:p>
+        </p:txBody>
+      </p:sp>
+      <p:sp>
+        <p:nvSpPr>
+          <p:cNvPr id="10" name="TextBox 9"/>
+          <p:cNvSpPr txBox="1"/>
+          <p:nvPr/>
+        </p:nvSpPr>
+        <p:spPr>
+          <a:xfrm>
+            <a:off x="658368" y="1783080"/>
+            <a:ext cx="3063240" cy="4480560"/>
+          </a:xfrm>
+          <a:prstGeom prst="rect">
+            <a:avLst/>
+          </a:prstGeom>
+          <a:noFill/>
+        </p:spPr>
+        <p:txBody>
+          <a:bodyPr wrap="square">
+            <a:spAutoFit/>
+          </a:bodyPr>
+          <a:lstStyle/>
+          <a:p>
+            <a:r>
+              <a:rPr sz="1200" b="0">
+                <a:solidFill>
+                  <a:srgbClr val="15201C"/>
+                </a:solidFill>
+                <a:latin typeface="Hanken Grotesk"/>
+              </a:rPr>
+              <a:t>-  SPA is served from S3 via CloudFront.</a:t>
+            </a:r>
+          </a:p>
+          <a:p>
+            <a:r>
+              <a:rPr sz="1200" b="0">
+                <a:solidFill>
+                  <a:srgbClr val="15201C"/>
+                </a:solidFill>
+                <a:latin typeface="Hanken Grotesk"/>
+              </a:rPr>
+              <a:t>-  Cognito-native authentication at the application level.</a:t>
+            </a:r>
+          </a:p>
+          <a:p>
+            <a:r>
+              <a:rPr sz="1200" b="0">
+                <a:solidFill>
+                  <a:srgbClr val="15201C"/>
+                </a:solidFill>
+                <a:latin typeface="Hanken Grotesk"/>
+              </a:rPr>
+              <a:t>-  The retailer link is created ONCE per product (cache; linkgen is the sole writer).</a:t>
+            </a:r>
+          </a:p>
+        </p:txBody>
+      </p:sp>
+    </p:spTree>
+  </p:cSld>
+  <p:clrMapOvr>
+    <a:masterClrMapping/>
+  </p:clrMapOvr>
+</p:sld>
+</file>
+
 <file path=ppt/slides/slide3.xml><?xml version="1.0" encoding="utf-8"?>
 <p:sld xmlns:a="http://schemas.openxmlformats.org/drawingml/2006/main" xmlns:p="http://schemas.openxmlformats.org/presentationml/2006/main" xmlns:r="http://schemas.openxmlformats.org/officeDocument/2006/relationships">
   <p:cSld>
@@ -20678,6 +21604,2811 @@
                 <a:latin typeface="Space Mono"/>
               </a:rPr>
               <a:t>3</a:t>
+            </a:r>
+          </a:p>
+        </p:txBody>
+      </p:sp>
+    </p:spTree>
+  </p:cSld>
+  <p:clrMapOvr>
+    <a:masterClrMapping/>
+  </p:clrMapOvr>
+</p:sld>
+</file>
+
+<file path=ppt/slides/slide30.xml><?xml version="1.0" encoding="utf-8"?>
+<p:sld xmlns:a="http://schemas.openxmlformats.org/drawingml/2006/main" xmlns:p="http://schemas.openxmlformats.org/presentationml/2006/main" xmlns:r="http://schemas.openxmlformats.org/officeDocument/2006/relationships">
+  <p:cSld>
+    <p:spTree>
+      <p:nvGrpSpPr>
+        <p:cNvPr id="1" name=""/>
+        <p:cNvGrpSpPr/>
+        <p:nvPr/>
+      </p:nvGrpSpPr>
+      <p:grpSpPr/>
+      <p:sp>
+        <p:nvSpPr>
+          <p:cNvPr id="2" name="TextBox 1"/>
+          <p:cNvSpPr txBox="1"/>
+          <p:nvPr/>
+        </p:nvSpPr>
+        <p:spPr>
+          <a:xfrm>
+            <a:off x="10195560" y="256032"/>
+            <a:ext cx="1371600" cy="1005840"/>
+          </a:xfrm>
+          <a:prstGeom prst="rect">
+            <a:avLst/>
+          </a:prstGeom>
+          <a:noFill/>
+        </p:spPr>
+        <p:txBody>
+          <a:bodyPr wrap="square" anchor="t" lIns="0" rIns="0" tIns="0" bIns="0">
+            <a:spAutoFit/>
+          </a:bodyPr>
+          <a:lstStyle/>
+          <a:p>
+            <a:pPr algn="r"/>
+            <a:r>
+              <a:rPr sz="4600" b="1">
+                <a:solidFill>
+                  <a:srgbClr val="DCE5E0"/>
+                </a:solidFill>
+                <a:latin typeface="Space Grotesk"/>
+              </a:rPr>
+              <a:t>11</a:t>
+            </a:r>
+          </a:p>
+        </p:txBody>
+      </p:sp>
+      <p:sp>
+        <p:nvSpPr>
+          <p:cNvPr id="3" name="TextBox 2"/>
+          <p:cNvSpPr txBox="1"/>
+          <p:nvPr/>
+        </p:nvSpPr>
+        <p:spPr>
+          <a:xfrm>
+            <a:off x="640080" y="420624"/>
+            <a:ext cx="9418320" cy="292608"/>
+          </a:xfrm>
+          <a:prstGeom prst="rect">
+            <a:avLst/>
+          </a:prstGeom>
+          <a:noFill/>
+        </p:spPr>
+        <p:txBody>
+          <a:bodyPr wrap="square" anchor="t" lIns="0" rIns="0" tIns="0" bIns="0">
+            <a:spAutoFit/>
+          </a:bodyPr>
+          <a:lstStyle/>
+          <a:p>
+            <a:r>
+              <a:rPr sz="1150" b="1">
+                <a:solidFill>
+                  <a:srgbClr val="1F7A57"/>
+                </a:solidFill>
+                <a:latin typeface="Space Mono"/>
+              </a:rPr>
+              <a:t>ENGINEERING</a:t>
+            </a:r>
+          </a:p>
+        </p:txBody>
+      </p:sp>
+      <p:sp>
+        <p:nvSpPr>
+          <p:cNvPr id="4" name="TextBox 3"/>
+          <p:cNvSpPr txBox="1"/>
+          <p:nvPr/>
+        </p:nvSpPr>
+        <p:spPr>
+          <a:xfrm>
+            <a:off x="621792" y="731520"/>
+            <a:ext cx="9509760" cy="868680"/>
+          </a:xfrm>
+          <a:prstGeom prst="rect">
+            <a:avLst/>
+          </a:prstGeom>
+          <a:noFill/>
+        </p:spPr>
+        <p:txBody>
+          <a:bodyPr wrap="square" anchor="t" lIns="0" rIns="0" tIns="0" bIns="0">
+            <a:spAutoFit/>
+          </a:bodyPr>
+          <a:lstStyle/>
+          <a:p>
+            <a:r>
+              <a:rPr sz="2700" b="1">
+                <a:solidFill>
+                  <a:srgbClr val="15201C"/>
+                </a:solidFill>
+                <a:latin typeface="Space Grotesk"/>
+              </a:rPr>
+              <a:t>Architecture UC2 — the recommendation is shared</a:t>
+            </a:r>
+          </a:p>
+        </p:txBody>
+      </p:sp>
+      <p:sp>
+        <p:nvSpPr>
+          <p:cNvPr id="5" name="Rounded Rectangle 4"/>
+          <p:cNvSpPr/>
+          <p:nvPr/>
+        </p:nvSpPr>
+        <p:spPr>
+          <a:xfrm>
+            <a:off x="3886200" y="1600200"/>
+            <a:ext cx="7653527" cy="4709160"/>
+          </a:xfrm>
+          <a:prstGeom prst="roundRect">
+            <a:avLst>
+              <a:gd name="adj" fmla="val 3000"/>
+            </a:avLst>
+          </a:prstGeom>
+          <a:solidFill>
+            <a:srgbClr val="FFFFFF"/>
+          </a:solidFill>
+          <a:ln w="12700">
+            <a:solidFill>
+              <a:srgbClr val="E6EBE8"/>
+            </a:solidFill>
+          </a:ln>
+          <a:effectLst/>
+        </p:spPr>
+        <p:style>
+          <a:lnRef idx="1">
+            <a:schemeClr val="accent1"/>
+          </a:lnRef>
+          <a:fillRef idx="3">
+            <a:schemeClr val="accent1"/>
+          </a:fillRef>
+          <a:effectRef idx="2">
+            <a:schemeClr val="accent1"/>
+          </a:effectRef>
+          <a:fontRef idx="minor">
+            <a:schemeClr val="lt1"/>
+          </a:fontRef>
+        </p:style>
+        <p:txBody>
+          <a:bodyPr rtlCol="0" anchor="ctr"/>
+          <a:lstStyle/>
+          <a:p>
+            <a:pPr algn="ctr"/>
+          </a:p>
+        </p:txBody>
+      </p:sp>
+      <p:sp>
+        <p:nvSpPr>
+          <p:cNvPr id="7" name="Rectangle 6"/>
+          <p:cNvSpPr/>
+          <p:nvPr/>
+        </p:nvSpPr>
+        <p:spPr>
+          <a:xfrm>
+            <a:off x="640080" y="6455664"/>
+            <a:ext cx="10908792" cy="9144"/>
+          </a:xfrm>
+          <a:prstGeom prst="rect">
+            <a:avLst/>
+          </a:prstGeom>
+          <a:solidFill>
+            <a:srgbClr val="E6EBE8"/>
+          </a:solidFill>
+          <a:ln>
+            <a:noFill/>
+          </a:ln>
+          <a:effectLst/>
+        </p:spPr>
+        <p:style>
+          <a:lnRef idx="1">
+            <a:schemeClr val="accent1"/>
+          </a:lnRef>
+          <a:fillRef idx="3">
+            <a:schemeClr val="accent1"/>
+          </a:fillRef>
+          <a:effectRef idx="2">
+            <a:schemeClr val="accent1"/>
+          </a:effectRef>
+          <a:fontRef idx="minor">
+            <a:schemeClr val="lt1"/>
+          </a:fontRef>
+        </p:style>
+        <p:txBody>
+          <a:bodyPr rtlCol="0" anchor="ctr"/>
+          <a:lstStyle/>
+          <a:p>
+            <a:pPr algn="ctr"/>
+          </a:p>
+        </p:txBody>
+      </p:sp>
+      <p:sp>
+        <p:nvSpPr>
+          <p:cNvPr id="8" name="TextBox 7"/>
+          <p:cNvSpPr txBox="1"/>
+          <p:nvPr/>
+        </p:nvSpPr>
+        <p:spPr>
+          <a:xfrm>
+            <a:off x="640080" y="6510528"/>
+            <a:ext cx="2743200" cy="274320"/>
+          </a:xfrm>
+          <a:prstGeom prst="rect">
+            <a:avLst/>
+          </a:prstGeom>
+          <a:noFill/>
+        </p:spPr>
+        <p:txBody>
+          <a:bodyPr wrap="square" anchor="t" lIns="0" rIns="0" tIns="0" bIns="0">
+            <a:spAutoFit/>
+          </a:bodyPr>
+          <a:lstStyle/>
+          <a:p>
+            <a:r>
+              <a:rPr sz="1100" b="1">
+                <a:solidFill>
+                  <a:srgbClr val="6B7B73"/>
+                </a:solidFill>
+                <a:latin typeface="Space Grotesk"/>
+              </a:rPr>
+              <a:t>want</a:t>
+            </a:r>
+            <a:r>
+              <a:rPr sz="1100" b="1">
+                <a:solidFill>
+                  <a:srgbClr val="1F7A57"/>
+                </a:solidFill>
+                <a:latin typeface="Space Grotesk"/>
+              </a:rPr>
+              <a:t>hat</a:t>
+            </a:r>
+          </a:p>
+        </p:txBody>
+      </p:sp>
+      <p:sp>
+        <p:nvSpPr>
+          <p:cNvPr id="9" name="TextBox 8"/>
+          <p:cNvSpPr txBox="1"/>
+          <p:nvPr/>
+        </p:nvSpPr>
+        <p:spPr>
+          <a:xfrm>
+            <a:off x="10607040" y="6510528"/>
+            <a:ext cx="941832" cy="274320"/>
+          </a:xfrm>
+          <a:prstGeom prst="rect">
+            <a:avLst/>
+          </a:prstGeom>
+          <a:noFill/>
+        </p:spPr>
+        <p:txBody>
+          <a:bodyPr wrap="square" anchor="t" lIns="0" rIns="0" tIns="0" bIns="0">
+            <a:spAutoFit/>
+          </a:bodyPr>
+          <a:lstStyle/>
+          <a:p>
+            <a:pPr algn="r"/>
+            <a:r>
+              <a:rPr sz="1000" b="0">
+                <a:solidFill>
+                  <a:srgbClr val="8A968F"/>
+                </a:solidFill>
+                <a:latin typeface="Space Mono"/>
+              </a:rPr>
+              <a:t>11</a:t>
+            </a:r>
+          </a:p>
+        </p:txBody>
+      </p:sp>
+      <p:sp>
+        <p:nvSpPr>
+          <p:cNvPr id="10" name="TextBox 9"/>
+          <p:cNvSpPr txBox="1"/>
+          <p:nvPr/>
+        </p:nvSpPr>
+        <p:spPr>
+          <a:xfrm>
+            <a:off x="658368" y="1783080"/>
+            <a:ext cx="3063240" cy="4480560"/>
+          </a:xfrm>
+          <a:prstGeom prst="rect">
+            <a:avLst/>
+          </a:prstGeom>
+          <a:noFill/>
+        </p:spPr>
+        <p:txBody>
+          <a:bodyPr wrap="square">
+            <a:spAutoFit/>
+          </a:bodyPr>
+          <a:lstStyle/>
+          <a:p>
+            <a:r>
+              <a:rPr sz="1200" b="0">
+                <a:solidFill>
+                  <a:srgbClr val="15201C"/>
+                </a:solidFill>
+                <a:latin typeface="Hanken Grotesk"/>
+              </a:rPr>
+              <a:t>-  This is the hot path.</a:t>
+            </a:r>
+          </a:p>
+          <a:p>
+            <a:r>
+              <a:rPr sz="1200" b="0">
+                <a:solidFill>
+                  <a:srgbClr val="15201C"/>
+                </a:solidFill>
+                <a:latin typeface="Hanken Grotesk"/>
+              </a:rPr>
+              <a:t>-  The recommendation page is server-rendered and cached on CloudFront (60 s, origin-controlled).</a:t>
+            </a:r>
+          </a:p>
+          <a:p>
+            <a:r>
+              <a:rPr sz="1200" b="0">
+                <a:solidFill>
+                  <a:srgbClr val="15201C"/>
+                </a:solidFill>
+                <a:latin typeface="Hanken Grotesk"/>
+              </a:rPr>
+              <a:t>-  The TS landing app boots on the page for auth / registration and redirect-link generation.</a:t>
+            </a:r>
+          </a:p>
+        </p:txBody>
+      </p:sp>
+    </p:spTree>
+  </p:cSld>
+  <p:clrMapOvr>
+    <a:masterClrMapping/>
+  </p:clrMapOvr>
+</p:sld>
+</file>
+
+<file path=ppt/slides/slide31.xml><?xml version="1.0" encoding="utf-8"?>
+<p:sld xmlns:a="http://schemas.openxmlformats.org/drawingml/2006/main" xmlns:p="http://schemas.openxmlformats.org/presentationml/2006/main" xmlns:r="http://schemas.openxmlformats.org/officeDocument/2006/relationships">
+  <p:cSld>
+    <p:spTree>
+      <p:nvGrpSpPr>
+        <p:cNvPr id="1" name=""/>
+        <p:cNvGrpSpPr/>
+        <p:nvPr/>
+      </p:nvGrpSpPr>
+      <p:grpSpPr/>
+      <p:sp>
+        <p:nvSpPr>
+          <p:cNvPr id="2" name="TextBox 1"/>
+          <p:cNvSpPr txBox="1"/>
+          <p:nvPr/>
+        </p:nvSpPr>
+        <p:spPr>
+          <a:xfrm>
+            <a:off x="10195560" y="256032"/>
+            <a:ext cx="1371600" cy="1005840"/>
+          </a:xfrm>
+          <a:prstGeom prst="rect">
+            <a:avLst/>
+          </a:prstGeom>
+          <a:noFill/>
+        </p:spPr>
+        <p:txBody>
+          <a:bodyPr wrap="square" anchor="t" lIns="0" rIns="0" tIns="0" bIns="0">
+            <a:spAutoFit/>
+          </a:bodyPr>
+          <a:lstStyle/>
+          <a:p>
+            <a:pPr algn="r"/>
+            <a:r>
+              <a:rPr sz="4600" b="1">
+                <a:solidFill>
+                  <a:srgbClr val="DCE5E0"/>
+                </a:solidFill>
+                <a:latin typeface="Space Grotesk"/>
+              </a:rPr>
+              <a:t>12</a:t>
+            </a:r>
+          </a:p>
+        </p:txBody>
+      </p:sp>
+      <p:sp>
+        <p:nvSpPr>
+          <p:cNvPr id="3" name="TextBox 2"/>
+          <p:cNvSpPr txBox="1"/>
+          <p:nvPr/>
+        </p:nvSpPr>
+        <p:spPr>
+          <a:xfrm>
+            <a:off x="640080" y="420624"/>
+            <a:ext cx="9418320" cy="292608"/>
+          </a:xfrm>
+          <a:prstGeom prst="rect">
+            <a:avLst/>
+          </a:prstGeom>
+          <a:noFill/>
+        </p:spPr>
+        <p:txBody>
+          <a:bodyPr wrap="square" anchor="t" lIns="0" rIns="0" tIns="0" bIns="0">
+            <a:spAutoFit/>
+          </a:bodyPr>
+          <a:lstStyle/>
+          <a:p>
+            <a:r>
+              <a:rPr sz="1150" b="1">
+                <a:solidFill>
+                  <a:srgbClr val="1F7A57"/>
+                </a:solidFill>
+                <a:latin typeface="Space Mono"/>
+              </a:rPr>
+              <a:t>ENGINEERING</a:t>
+            </a:r>
+          </a:p>
+        </p:txBody>
+      </p:sp>
+      <p:sp>
+        <p:nvSpPr>
+          <p:cNvPr id="4" name="TextBox 3"/>
+          <p:cNvSpPr txBox="1"/>
+          <p:nvPr/>
+        </p:nvSpPr>
+        <p:spPr>
+          <a:xfrm>
+            <a:off x="621792" y="731520"/>
+            <a:ext cx="9509760" cy="868680"/>
+          </a:xfrm>
+          <a:prstGeom prst="rect">
+            <a:avLst/>
+          </a:prstGeom>
+          <a:noFill/>
+        </p:spPr>
+        <p:txBody>
+          <a:bodyPr wrap="square" anchor="t" lIns="0" rIns="0" tIns="0" bIns="0">
+            <a:spAutoFit/>
+          </a:bodyPr>
+          <a:lstStyle/>
+          <a:p>
+            <a:r>
+              <a:rPr sz="2700" b="1">
+                <a:solidFill>
+                  <a:srgbClr val="15201C"/>
+                </a:solidFill>
+                <a:latin typeface="Space Grotesk"/>
+              </a:rPr>
+              <a:t>Architecture UC3 — registration, login, guest + redirect</a:t>
+            </a:r>
+          </a:p>
+        </p:txBody>
+      </p:sp>
+      <p:sp>
+        <p:nvSpPr>
+          <p:cNvPr id="5" name="Rounded Rectangle 4"/>
+          <p:cNvSpPr/>
+          <p:nvPr/>
+        </p:nvSpPr>
+        <p:spPr>
+          <a:xfrm>
+            <a:off x="3886200" y="1600200"/>
+            <a:ext cx="7653527" cy="4709160"/>
+          </a:xfrm>
+          <a:prstGeom prst="roundRect">
+            <a:avLst>
+              <a:gd name="adj" fmla="val 3000"/>
+            </a:avLst>
+          </a:prstGeom>
+          <a:solidFill>
+            <a:srgbClr val="FFFFFF"/>
+          </a:solidFill>
+          <a:ln w="12700">
+            <a:solidFill>
+              <a:srgbClr val="E6EBE8"/>
+            </a:solidFill>
+          </a:ln>
+          <a:effectLst/>
+        </p:spPr>
+        <p:style>
+          <a:lnRef idx="1">
+            <a:schemeClr val="accent1"/>
+          </a:lnRef>
+          <a:fillRef idx="3">
+            <a:schemeClr val="accent1"/>
+          </a:fillRef>
+          <a:effectRef idx="2">
+            <a:schemeClr val="accent1"/>
+          </a:effectRef>
+          <a:fontRef idx="minor">
+            <a:schemeClr val="lt1"/>
+          </a:fontRef>
+        </p:style>
+        <p:txBody>
+          <a:bodyPr rtlCol="0" anchor="ctr"/>
+          <a:lstStyle/>
+          <a:p>
+            <a:pPr algn="ctr"/>
+          </a:p>
+        </p:txBody>
+      </p:sp>
+      <p:sp>
+        <p:nvSpPr>
+          <p:cNvPr id="7" name="Rectangle 6"/>
+          <p:cNvSpPr/>
+          <p:nvPr/>
+        </p:nvSpPr>
+        <p:spPr>
+          <a:xfrm>
+            <a:off x="640080" y="6455664"/>
+            <a:ext cx="10908792" cy="9144"/>
+          </a:xfrm>
+          <a:prstGeom prst="rect">
+            <a:avLst/>
+          </a:prstGeom>
+          <a:solidFill>
+            <a:srgbClr val="E6EBE8"/>
+          </a:solidFill>
+          <a:ln>
+            <a:noFill/>
+          </a:ln>
+          <a:effectLst/>
+        </p:spPr>
+        <p:style>
+          <a:lnRef idx="1">
+            <a:schemeClr val="accent1"/>
+          </a:lnRef>
+          <a:fillRef idx="3">
+            <a:schemeClr val="accent1"/>
+          </a:fillRef>
+          <a:effectRef idx="2">
+            <a:schemeClr val="accent1"/>
+          </a:effectRef>
+          <a:fontRef idx="minor">
+            <a:schemeClr val="lt1"/>
+          </a:fontRef>
+        </p:style>
+        <p:txBody>
+          <a:bodyPr rtlCol="0" anchor="ctr"/>
+          <a:lstStyle/>
+          <a:p>
+            <a:pPr algn="ctr"/>
+          </a:p>
+        </p:txBody>
+      </p:sp>
+      <p:sp>
+        <p:nvSpPr>
+          <p:cNvPr id="8" name="TextBox 7"/>
+          <p:cNvSpPr txBox="1"/>
+          <p:nvPr/>
+        </p:nvSpPr>
+        <p:spPr>
+          <a:xfrm>
+            <a:off x="640080" y="6510528"/>
+            <a:ext cx="2743200" cy="274320"/>
+          </a:xfrm>
+          <a:prstGeom prst="rect">
+            <a:avLst/>
+          </a:prstGeom>
+          <a:noFill/>
+        </p:spPr>
+        <p:txBody>
+          <a:bodyPr wrap="square" anchor="t" lIns="0" rIns="0" tIns="0" bIns="0">
+            <a:spAutoFit/>
+          </a:bodyPr>
+          <a:lstStyle/>
+          <a:p>
+            <a:r>
+              <a:rPr sz="1100" b="1">
+                <a:solidFill>
+                  <a:srgbClr val="6B7B73"/>
+                </a:solidFill>
+                <a:latin typeface="Space Grotesk"/>
+              </a:rPr>
+              <a:t>want</a:t>
+            </a:r>
+            <a:r>
+              <a:rPr sz="1100" b="1">
+                <a:solidFill>
+                  <a:srgbClr val="1F7A57"/>
+                </a:solidFill>
+                <a:latin typeface="Space Grotesk"/>
+              </a:rPr>
+              <a:t>hat</a:t>
+            </a:r>
+          </a:p>
+        </p:txBody>
+      </p:sp>
+      <p:sp>
+        <p:nvSpPr>
+          <p:cNvPr id="9" name="TextBox 8"/>
+          <p:cNvSpPr txBox="1"/>
+          <p:nvPr/>
+        </p:nvSpPr>
+        <p:spPr>
+          <a:xfrm>
+            <a:off x="10607040" y="6510528"/>
+            <a:ext cx="941832" cy="274320"/>
+          </a:xfrm>
+          <a:prstGeom prst="rect">
+            <a:avLst/>
+          </a:prstGeom>
+          <a:noFill/>
+        </p:spPr>
+        <p:txBody>
+          <a:bodyPr wrap="square" anchor="t" lIns="0" rIns="0" tIns="0" bIns="0">
+            <a:spAutoFit/>
+          </a:bodyPr>
+          <a:lstStyle/>
+          <a:p>
+            <a:pPr algn="r"/>
+            <a:r>
+              <a:rPr sz="1000" b="0">
+                <a:solidFill>
+                  <a:srgbClr val="8A968F"/>
+                </a:solidFill>
+                <a:latin typeface="Space Mono"/>
+              </a:rPr>
+              <a:t>12</a:t>
+            </a:r>
+          </a:p>
+        </p:txBody>
+      </p:sp>
+      <p:sp>
+        <p:nvSpPr>
+          <p:cNvPr id="10" name="TextBox 9"/>
+          <p:cNvSpPr txBox="1"/>
+          <p:nvPr/>
+        </p:nvSpPr>
+        <p:spPr>
+          <a:xfrm>
+            <a:off x="658368" y="1783080"/>
+            <a:ext cx="3063240" cy="4480560"/>
+          </a:xfrm>
+          <a:prstGeom prst="rect">
+            <a:avLst/>
+          </a:prstGeom>
+          <a:noFill/>
+        </p:spPr>
+        <p:txBody>
+          <a:bodyPr wrap="square">
+            <a:spAutoFit/>
+          </a:bodyPr>
+          <a:lstStyle/>
+          <a:p>
+            <a:r>
+              <a:rPr sz="1200" b="0">
+                <a:solidFill>
+                  <a:srgbClr val="15201C"/>
+                </a:solidFill>
+                <a:latin typeface="Hanken Grotesk"/>
+              </a:rPr>
+              <a:t>-  Every registration appends a hash-chained audit row — each row carries the previous row's hash.</a:t>
+            </a:r>
+          </a:p>
+          <a:p>
+            <a:r>
+              <a:rPr sz="1200" b="0">
+                <a:solidFill>
+                  <a:srgbClr val="15201C"/>
+                </a:solidFill>
+                <a:latin typeface="Hanken Grotesk"/>
+              </a:rPr>
+              <a:t>-  audit_writer is granted EXECUTE on the procedure ONLY.</a:t>
+            </a:r>
+          </a:p>
+          <a:p>
+            <a:r>
+              <a:rPr sz="1200" b="0">
+                <a:solidFill>
+                  <a:srgbClr val="15201C"/>
+                </a:solidFill>
+                <a:latin typeface="Hanken Grotesk"/>
+              </a:rPr>
+              <a:t>-  The stored procedure serializes concurrent appends (advisory lock).</a:t>
+            </a:r>
+          </a:p>
+        </p:txBody>
+      </p:sp>
+    </p:spTree>
+  </p:cSld>
+  <p:clrMapOvr>
+    <a:masterClrMapping/>
+  </p:clrMapOvr>
+</p:sld>
+</file>
+
+<file path=ppt/slides/slide32.xml><?xml version="1.0" encoding="utf-8"?>
+<p:sld xmlns:a="http://schemas.openxmlformats.org/drawingml/2006/main" xmlns:p="http://schemas.openxmlformats.org/presentationml/2006/main" xmlns:r="http://schemas.openxmlformats.org/officeDocument/2006/relationships">
+  <p:cSld>
+    <p:spTree>
+      <p:nvGrpSpPr>
+        <p:cNvPr id="1" name=""/>
+        <p:cNvGrpSpPr/>
+        <p:nvPr/>
+      </p:nvGrpSpPr>
+      <p:grpSpPr/>
+      <p:sp>
+        <p:nvSpPr>
+          <p:cNvPr id="2" name="TextBox 1"/>
+          <p:cNvSpPr txBox="1"/>
+          <p:nvPr/>
+        </p:nvSpPr>
+        <p:spPr>
+          <a:xfrm>
+            <a:off x="10195560" y="256032"/>
+            <a:ext cx="1371600" cy="1005840"/>
+          </a:xfrm>
+          <a:prstGeom prst="rect">
+            <a:avLst/>
+          </a:prstGeom>
+          <a:noFill/>
+        </p:spPr>
+        <p:txBody>
+          <a:bodyPr wrap="square" anchor="t" lIns="0" rIns="0" tIns="0" bIns="0">
+            <a:spAutoFit/>
+          </a:bodyPr>
+          <a:lstStyle/>
+          <a:p>
+            <a:pPr algn="r"/>
+            <a:r>
+              <a:rPr sz="4600" b="1">
+                <a:solidFill>
+                  <a:srgbClr val="DCE5E0"/>
+                </a:solidFill>
+                <a:latin typeface="Space Grotesk"/>
+              </a:rPr>
+              <a:t>13</a:t>
+            </a:r>
+          </a:p>
+        </p:txBody>
+      </p:sp>
+      <p:sp>
+        <p:nvSpPr>
+          <p:cNvPr id="3" name="TextBox 2"/>
+          <p:cNvSpPr txBox="1"/>
+          <p:nvPr/>
+        </p:nvSpPr>
+        <p:spPr>
+          <a:xfrm>
+            <a:off x="640080" y="420624"/>
+            <a:ext cx="9418320" cy="292608"/>
+          </a:xfrm>
+          <a:prstGeom prst="rect">
+            <a:avLst/>
+          </a:prstGeom>
+          <a:noFill/>
+        </p:spPr>
+        <p:txBody>
+          <a:bodyPr wrap="square" anchor="t" lIns="0" rIns="0" tIns="0" bIns="0">
+            <a:spAutoFit/>
+          </a:bodyPr>
+          <a:lstStyle/>
+          <a:p>
+            <a:r>
+              <a:rPr sz="1150" b="1">
+                <a:solidFill>
+                  <a:srgbClr val="1F7A57"/>
+                </a:solidFill>
+                <a:latin typeface="Space Mono"/>
+              </a:rPr>
+              <a:t>ENGINEERING</a:t>
+            </a:r>
+          </a:p>
+        </p:txBody>
+      </p:sp>
+      <p:sp>
+        <p:nvSpPr>
+          <p:cNvPr id="4" name="TextBox 3"/>
+          <p:cNvSpPr txBox="1"/>
+          <p:nvPr/>
+        </p:nvSpPr>
+        <p:spPr>
+          <a:xfrm>
+            <a:off x="621792" y="731520"/>
+            <a:ext cx="9509760" cy="868680"/>
+          </a:xfrm>
+          <a:prstGeom prst="rect">
+            <a:avLst/>
+          </a:prstGeom>
+          <a:noFill/>
+        </p:spPr>
+        <p:txBody>
+          <a:bodyPr wrap="square" anchor="t" lIns="0" rIns="0" tIns="0" bIns="0">
+            <a:spAutoFit/>
+          </a:bodyPr>
+          <a:lstStyle/>
+          <a:p>
+            <a:r>
+              <a:rPr sz="2700" b="1">
+                <a:solidFill>
+                  <a:srgbClr val="15201C"/>
+                </a:solidFill>
+                <a:latin typeface="Space Grotesk"/>
+              </a:rPr>
+              <a:t>Architecture UC4 — settlement pulled in the background</a:t>
+            </a:r>
+          </a:p>
+        </p:txBody>
+      </p:sp>
+      <p:sp>
+        <p:nvSpPr>
+          <p:cNvPr id="5" name="Rounded Rectangle 4"/>
+          <p:cNvSpPr/>
+          <p:nvPr/>
+        </p:nvSpPr>
+        <p:spPr>
+          <a:xfrm>
+            <a:off x="3886200" y="1600200"/>
+            <a:ext cx="7653527" cy="4709160"/>
+          </a:xfrm>
+          <a:prstGeom prst="roundRect">
+            <a:avLst>
+              <a:gd name="adj" fmla="val 3000"/>
+            </a:avLst>
+          </a:prstGeom>
+          <a:solidFill>
+            <a:srgbClr val="FFFFFF"/>
+          </a:solidFill>
+          <a:ln w="12700">
+            <a:solidFill>
+              <a:srgbClr val="E6EBE8"/>
+            </a:solidFill>
+          </a:ln>
+          <a:effectLst/>
+        </p:spPr>
+        <p:style>
+          <a:lnRef idx="1">
+            <a:schemeClr val="accent1"/>
+          </a:lnRef>
+          <a:fillRef idx="3">
+            <a:schemeClr val="accent1"/>
+          </a:fillRef>
+          <a:effectRef idx="2">
+            <a:schemeClr val="accent1"/>
+          </a:effectRef>
+          <a:fontRef idx="minor">
+            <a:schemeClr val="lt1"/>
+          </a:fontRef>
+        </p:style>
+        <p:txBody>
+          <a:bodyPr rtlCol="0" anchor="ctr"/>
+          <a:lstStyle/>
+          <a:p>
+            <a:pPr algn="ctr"/>
+          </a:p>
+        </p:txBody>
+      </p:sp>
+      <p:sp>
+        <p:nvSpPr>
+          <p:cNvPr id="7" name="Rectangle 6"/>
+          <p:cNvSpPr/>
+          <p:nvPr/>
+        </p:nvSpPr>
+        <p:spPr>
+          <a:xfrm>
+            <a:off x="640080" y="6455664"/>
+            <a:ext cx="10908792" cy="9144"/>
+          </a:xfrm>
+          <a:prstGeom prst="rect">
+            <a:avLst/>
+          </a:prstGeom>
+          <a:solidFill>
+            <a:srgbClr val="E6EBE8"/>
+          </a:solidFill>
+          <a:ln>
+            <a:noFill/>
+          </a:ln>
+          <a:effectLst/>
+        </p:spPr>
+        <p:style>
+          <a:lnRef idx="1">
+            <a:schemeClr val="accent1"/>
+          </a:lnRef>
+          <a:fillRef idx="3">
+            <a:schemeClr val="accent1"/>
+          </a:fillRef>
+          <a:effectRef idx="2">
+            <a:schemeClr val="accent1"/>
+          </a:effectRef>
+          <a:fontRef idx="minor">
+            <a:schemeClr val="lt1"/>
+          </a:fontRef>
+        </p:style>
+        <p:txBody>
+          <a:bodyPr rtlCol="0" anchor="ctr"/>
+          <a:lstStyle/>
+          <a:p>
+            <a:pPr algn="ctr"/>
+          </a:p>
+        </p:txBody>
+      </p:sp>
+      <p:sp>
+        <p:nvSpPr>
+          <p:cNvPr id="8" name="TextBox 7"/>
+          <p:cNvSpPr txBox="1"/>
+          <p:nvPr/>
+        </p:nvSpPr>
+        <p:spPr>
+          <a:xfrm>
+            <a:off x="640080" y="6510528"/>
+            <a:ext cx="2743200" cy="274320"/>
+          </a:xfrm>
+          <a:prstGeom prst="rect">
+            <a:avLst/>
+          </a:prstGeom>
+          <a:noFill/>
+        </p:spPr>
+        <p:txBody>
+          <a:bodyPr wrap="square" anchor="t" lIns="0" rIns="0" tIns="0" bIns="0">
+            <a:spAutoFit/>
+          </a:bodyPr>
+          <a:lstStyle/>
+          <a:p>
+            <a:r>
+              <a:rPr sz="1100" b="1">
+                <a:solidFill>
+                  <a:srgbClr val="6B7B73"/>
+                </a:solidFill>
+                <a:latin typeface="Space Grotesk"/>
+              </a:rPr>
+              <a:t>want</a:t>
+            </a:r>
+            <a:r>
+              <a:rPr sz="1100" b="1">
+                <a:solidFill>
+                  <a:srgbClr val="1F7A57"/>
+                </a:solidFill>
+                <a:latin typeface="Space Grotesk"/>
+              </a:rPr>
+              <a:t>hat</a:t>
+            </a:r>
+          </a:p>
+        </p:txBody>
+      </p:sp>
+      <p:sp>
+        <p:nvSpPr>
+          <p:cNvPr id="9" name="TextBox 8"/>
+          <p:cNvSpPr txBox="1"/>
+          <p:nvPr/>
+        </p:nvSpPr>
+        <p:spPr>
+          <a:xfrm>
+            <a:off x="10607040" y="6510528"/>
+            <a:ext cx="941832" cy="274320"/>
+          </a:xfrm>
+          <a:prstGeom prst="rect">
+            <a:avLst/>
+          </a:prstGeom>
+          <a:noFill/>
+        </p:spPr>
+        <p:txBody>
+          <a:bodyPr wrap="square" anchor="t" lIns="0" rIns="0" tIns="0" bIns="0">
+            <a:spAutoFit/>
+          </a:bodyPr>
+          <a:lstStyle/>
+          <a:p>
+            <a:pPr algn="r"/>
+            <a:r>
+              <a:rPr sz="1000" b="0">
+                <a:solidFill>
+                  <a:srgbClr val="8A968F"/>
+                </a:solidFill>
+                <a:latin typeface="Space Mono"/>
+              </a:rPr>
+              <a:t>13</a:t>
+            </a:r>
+          </a:p>
+        </p:txBody>
+      </p:sp>
+      <p:sp>
+        <p:nvSpPr>
+          <p:cNvPr id="10" name="TextBox 9"/>
+          <p:cNvSpPr txBox="1"/>
+          <p:nvPr/>
+        </p:nvSpPr>
+        <p:spPr>
+          <a:xfrm>
+            <a:off x="658368" y="1783080"/>
+            <a:ext cx="3063240" cy="4480560"/>
+          </a:xfrm>
+          <a:prstGeom prst="rect">
+            <a:avLst/>
+          </a:prstGeom>
+          <a:noFill/>
+        </p:spPr>
+        <p:txBody>
+          <a:bodyPr wrap="square">
+            <a:spAutoFit/>
+          </a:bodyPr>
+          <a:lstStyle/>
+          <a:p>
+            <a:r>
+              <a:rPr sz="1200" b="0">
+                <a:solidFill>
+                  <a:srgbClr val="15201C"/>
+                </a:solidFill>
+                <a:latin typeface="Hanken Grotesk"/>
+              </a:rPr>
+              <a:t>-  Internal-only flow — the ONLY path that can append wallet entries (GRANT-enforced).</a:t>
+            </a:r>
+          </a:p>
+          <a:p>
+            <a:r>
+              <a:rPr sz="1200" b="0">
+                <a:solidFill>
+                  <a:srgbClr val="15201C"/>
+                </a:solidFill>
+                <a:latin typeface="Hanken Grotesk"/>
+              </a:rPr>
+              <a:t>-  Side use case: FX rates pulled from the exchange-rate provider.</a:t>
+            </a:r>
+          </a:p>
+        </p:txBody>
+      </p:sp>
+    </p:spTree>
+  </p:cSld>
+  <p:clrMapOvr>
+    <a:masterClrMapping/>
+  </p:clrMapOvr>
+</p:sld>
+</file>
+
+<file path=ppt/slides/slide33.xml><?xml version="1.0" encoding="utf-8"?>
+<p:sld xmlns:a="http://schemas.openxmlformats.org/drawingml/2006/main" xmlns:p="http://schemas.openxmlformats.org/presentationml/2006/main" xmlns:r="http://schemas.openxmlformats.org/officeDocument/2006/relationships">
+  <p:cSld>
+    <p:spTree>
+      <p:nvGrpSpPr>
+        <p:cNvPr id="1" name=""/>
+        <p:cNvGrpSpPr/>
+        <p:nvPr/>
+      </p:nvGrpSpPr>
+      <p:grpSpPr/>
+      <p:sp>
+        <p:nvSpPr>
+          <p:cNvPr id="2" name="TextBox 1"/>
+          <p:cNvSpPr txBox="1"/>
+          <p:nvPr/>
+        </p:nvSpPr>
+        <p:spPr>
+          <a:xfrm>
+            <a:off x="10195560" y="256032"/>
+            <a:ext cx="1371600" cy="1005840"/>
+          </a:xfrm>
+          <a:prstGeom prst="rect">
+            <a:avLst/>
+          </a:prstGeom>
+          <a:noFill/>
+        </p:spPr>
+        <p:txBody>
+          <a:bodyPr wrap="square" anchor="t" lIns="0" rIns="0" tIns="0" bIns="0">
+            <a:spAutoFit/>
+          </a:bodyPr>
+          <a:lstStyle/>
+          <a:p>
+            <a:pPr algn="r"/>
+            <a:r>
+              <a:rPr sz="4600" b="1">
+                <a:solidFill>
+                  <a:srgbClr val="DCE5E0"/>
+                </a:solidFill>
+                <a:latin typeface="Space Grotesk"/>
+              </a:rPr>
+              <a:t>14</a:t>
+            </a:r>
+          </a:p>
+        </p:txBody>
+      </p:sp>
+      <p:sp>
+        <p:nvSpPr>
+          <p:cNvPr id="3" name="TextBox 2"/>
+          <p:cNvSpPr txBox="1"/>
+          <p:nvPr/>
+        </p:nvSpPr>
+        <p:spPr>
+          <a:xfrm>
+            <a:off x="640080" y="420624"/>
+            <a:ext cx="9418320" cy="292608"/>
+          </a:xfrm>
+          <a:prstGeom prst="rect">
+            <a:avLst/>
+          </a:prstGeom>
+          <a:noFill/>
+        </p:spPr>
+        <p:txBody>
+          <a:bodyPr wrap="square" anchor="t" lIns="0" rIns="0" tIns="0" bIns="0">
+            <a:spAutoFit/>
+          </a:bodyPr>
+          <a:lstStyle/>
+          <a:p>
+            <a:r>
+              <a:rPr sz="1150" b="1">
+                <a:solidFill>
+                  <a:srgbClr val="1F7A57"/>
+                </a:solidFill>
+                <a:latin typeface="Space Mono"/>
+              </a:rPr>
+              <a:t>ENGINEERING</a:t>
+            </a:r>
+          </a:p>
+        </p:txBody>
+      </p:sp>
+      <p:sp>
+        <p:nvSpPr>
+          <p:cNvPr id="4" name="TextBox 3"/>
+          <p:cNvSpPr txBox="1"/>
+          <p:nvPr/>
+        </p:nvSpPr>
+        <p:spPr>
+          <a:xfrm>
+            <a:off x="621792" y="731520"/>
+            <a:ext cx="9509760" cy="868680"/>
+          </a:xfrm>
+          <a:prstGeom prst="rect">
+            <a:avLst/>
+          </a:prstGeom>
+          <a:noFill/>
+        </p:spPr>
+        <p:txBody>
+          <a:bodyPr wrap="square" anchor="t" lIns="0" rIns="0" tIns="0" bIns="0">
+            <a:spAutoFit/>
+          </a:bodyPr>
+          <a:lstStyle/>
+          <a:p>
+            <a:r>
+              <a:rPr sz="2700" b="1">
+                <a:solidFill>
+                  <a:srgbClr val="15201C"/>
+                </a:solidFill>
+                <a:latin typeface="Space Grotesk"/>
+              </a:rPr>
+              <a:t>Architecture UC5 — the member home page</a:t>
+            </a:r>
+          </a:p>
+        </p:txBody>
+      </p:sp>
+      <p:sp>
+        <p:nvSpPr>
+          <p:cNvPr id="5" name="Rounded Rectangle 4"/>
+          <p:cNvSpPr/>
+          <p:nvPr/>
+        </p:nvSpPr>
+        <p:spPr>
+          <a:xfrm>
+            <a:off x="3886200" y="1600200"/>
+            <a:ext cx="7653527" cy="4709160"/>
+          </a:xfrm>
+          <a:prstGeom prst="roundRect">
+            <a:avLst>
+              <a:gd name="adj" fmla="val 3000"/>
+            </a:avLst>
+          </a:prstGeom>
+          <a:solidFill>
+            <a:srgbClr val="FFFFFF"/>
+          </a:solidFill>
+          <a:ln w="12700">
+            <a:solidFill>
+              <a:srgbClr val="E6EBE8"/>
+            </a:solidFill>
+          </a:ln>
+          <a:effectLst/>
+        </p:spPr>
+        <p:style>
+          <a:lnRef idx="1">
+            <a:schemeClr val="accent1"/>
+          </a:lnRef>
+          <a:fillRef idx="3">
+            <a:schemeClr val="accent1"/>
+          </a:fillRef>
+          <a:effectRef idx="2">
+            <a:schemeClr val="accent1"/>
+          </a:effectRef>
+          <a:fontRef idx="minor">
+            <a:schemeClr val="lt1"/>
+          </a:fontRef>
+        </p:style>
+        <p:txBody>
+          <a:bodyPr rtlCol="0" anchor="ctr"/>
+          <a:lstStyle/>
+          <a:p>
+            <a:pPr algn="ctr"/>
+          </a:p>
+        </p:txBody>
+      </p:sp>
+      <p:sp>
+        <p:nvSpPr>
+          <p:cNvPr id="7" name="Rectangle 6"/>
+          <p:cNvSpPr/>
+          <p:nvPr/>
+        </p:nvSpPr>
+        <p:spPr>
+          <a:xfrm>
+            <a:off x="640080" y="6455664"/>
+            <a:ext cx="10908792" cy="9144"/>
+          </a:xfrm>
+          <a:prstGeom prst="rect">
+            <a:avLst/>
+          </a:prstGeom>
+          <a:solidFill>
+            <a:srgbClr val="E6EBE8"/>
+          </a:solidFill>
+          <a:ln>
+            <a:noFill/>
+          </a:ln>
+          <a:effectLst/>
+        </p:spPr>
+        <p:style>
+          <a:lnRef idx="1">
+            <a:schemeClr val="accent1"/>
+          </a:lnRef>
+          <a:fillRef idx="3">
+            <a:schemeClr val="accent1"/>
+          </a:fillRef>
+          <a:effectRef idx="2">
+            <a:schemeClr val="accent1"/>
+          </a:effectRef>
+          <a:fontRef idx="minor">
+            <a:schemeClr val="lt1"/>
+          </a:fontRef>
+        </p:style>
+        <p:txBody>
+          <a:bodyPr rtlCol="0" anchor="ctr"/>
+          <a:lstStyle/>
+          <a:p>
+            <a:pPr algn="ctr"/>
+          </a:p>
+        </p:txBody>
+      </p:sp>
+      <p:sp>
+        <p:nvSpPr>
+          <p:cNvPr id="8" name="TextBox 7"/>
+          <p:cNvSpPr txBox="1"/>
+          <p:nvPr/>
+        </p:nvSpPr>
+        <p:spPr>
+          <a:xfrm>
+            <a:off x="640080" y="6510528"/>
+            <a:ext cx="2743200" cy="274320"/>
+          </a:xfrm>
+          <a:prstGeom prst="rect">
+            <a:avLst/>
+          </a:prstGeom>
+          <a:noFill/>
+        </p:spPr>
+        <p:txBody>
+          <a:bodyPr wrap="square" anchor="t" lIns="0" rIns="0" tIns="0" bIns="0">
+            <a:spAutoFit/>
+          </a:bodyPr>
+          <a:lstStyle/>
+          <a:p>
+            <a:r>
+              <a:rPr sz="1100" b="1">
+                <a:solidFill>
+                  <a:srgbClr val="6B7B73"/>
+                </a:solidFill>
+                <a:latin typeface="Space Grotesk"/>
+              </a:rPr>
+              <a:t>want</a:t>
+            </a:r>
+            <a:r>
+              <a:rPr sz="1100" b="1">
+                <a:solidFill>
+                  <a:srgbClr val="1F7A57"/>
+                </a:solidFill>
+                <a:latin typeface="Space Grotesk"/>
+              </a:rPr>
+              <a:t>hat</a:t>
+            </a:r>
+          </a:p>
+        </p:txBody>
+      </p:sp>
+      <p:sp>
+        <p:nvSpPr>
+          <p:cNvPr id="9" name="TextBox 8"/>
+          <p:cNvSpPr txBox="1"/>
+          <p:nvPr/>
+        </p:nvSpPr>
+        <p:spPr>
+          <a:xfrm>
+            <a:off x="10607040" y="6510528"/>
+            <a:ext cx="941832" cy="274320"/>
+          </a:xfrm>
+          <a:prstGeom prst="rect">
+            <a:avLst/>
+          </a:prstGeom>
+          <a:noFill/>
+        </p:spPr>
+        <p:txBody>
+          <a:bodyPr wrap="square" anchor="t" lIns="0" rIns="0" tIns="0" bIns="0">
+            <a:spAutoFit/>
+          </a:bodyPr>
+          <a:lstStyle/>
+          <a:p>
+            <a:pPr algn="r"/>
+            <a:r>
+              <a:rPr sz="1000" b="0">
+                <a:solidFill>
+                  <a:srgbClr val="8A968F"/>
+                </a:solidFill>
+                <a:latin typeface="Space Mono"/>
+              </a:rPr>
+              <a:t>14</a:t>
+            </a:r>
+          </a:p>
+        </p:txBody>
+      </p:sp>
+      <p:sp>
+        <p:nvSpPr>
+          <p:cNvPr id="10" name="TextBox 9"/>
+          <p:cNvSpPr txBox="1"/>
+          <p:nvPr/>
+        </p:nvSpPr>
+        <p:spPr>
+          <a:xfrm>
+            <a:off x="658368" y="1783080"/>
+            <a:ext cx="3063240" cy="4480560"/>
+          </a:xfrm>
+          <a:prstGeom prst="rect">
+            <a:avLst/>
+          </a:prstGeom>
+          <a:noFill/>
+        </p:spPr>
+        <p:txBody>
+          <a:bodyPr wrap="square">
+            <a:spAutoFit/>
+          </a:bodyPr>
+          <a:lstStyle/>
+          <a:p>
+            <a:r>
+              <a:rPr sz="1200" b="0">
+                <a:solidFill>
+                  <a:srgbClr val="15201C"/>
+                </a:solidFill>
+                <a:latin typeface="Hanken Grotesk"/>
+              </a:rPr>
+              <a:t>-  An Aurora cold resume may delay the wallet total + recent activity.</a:t>
+            </a:r>
+          </a:p>
+          <a:p>
+            <a:r>
+              <a:rPr sz="1200" b="0">
+                <a:solidFill>
+                  <a:srgbClr val="15201C"/>
+                </a:solidFill>
+                <a:latin typeface="Hanken Grotesk"/>
+              </a:rPr>
+              <a:t>-  Everything else is operational immediately.</a:t>
+            </a:r>
+          </a:p>
+        </p:txBody>
+      </p:sp>
+    </p:spTree>
+  </p:cSld>
+  <p:clrMapOvr>
+    <a:masterClrMapping/>
+  </p:clrMapOvr>
+</p:sld>
+</file>
+
+<file path=ppt/slides/slide34.xml><?xml version="1.0" encoding="utf-8"?>
+<p:sld xmlns:a="http://schemas.openxmlformats.org/drawingml/2006/main" xmlns:p="http://schemas.openxmlformats.org/presentationml/2006/main" xmlns:r="http://schemas.openxmlformats.org/officeDocument/2006/relationships">
+  <p:cSld>
+    <p:spTree>
+      <p:nvGrpSpPr>
+        <p:cNvPr id="1" name=""/>
+        <p:cNvGrpSpPr/>
+        <p:nvPr/>
+      </p:nvGrpSpPr>
+      <p:grpSpPr/>
+      <p:sp>
+        <p:nvSpPr>
+          <p:cNvPr id="2" name="TextBox 1"/>
+          <p:cNvSpPr txBox="1"/>
+          <p:nvPr/>
+        </p:nvSpPr>
+        <p:spPr>
+          <a:xfrm>
+            <a:off x="10195560" y="256032"/>
+            <a:ext cx="1371600" cy="1005840"/>
+          </a:xfrm>
+          <a:prstGeom prst="rect">
+            <a:avLst/>
+          </a:prstGeom>
+          <a:noFill/>
+        </p:spPr>
+        <p:txBody>
+          <a:bodyPr wrap="square" anchor="t" lIns="0" rIns="0" tIns="0" bIns="0">
+            <a:spAutoFit/>
+          </a:bodyPr>
+          <a:lstStyle/>
+          <a:p>
+            <a:pPr algn="r"/>
+            <a:r>
+              <a:rPr sz="4600" b="1">
+                <a:solidFill>
+                  <a:srgbClr val="DCE5E0"/>
+                </a:solidFill>
+                <a:latin typeface="Space Grotesk"/>
+              </a:rPr>
+              <a:t>15</a:t>
+            </a:r>
+          </a:p>
+        </p:txBody>
+      </p:sp>
+      <p:sp>
+        <p:nvSpPr>
+          <p:cNvPr id="3" name="TextBox 2"/>
+          <p:cNvSpPr txBox="1"/>
+          <p:nvPr/>
+        </p:nvSpPr>
+        <p:spPr>
+          <a:xfrm>
+            <a:off x="640080" y="420624"/>
+            <a:ext cx="9418320" cy="292608"/>
+          </a:xfrm>
+          <a:prstGeom prst="rect">
+            <a:avLst/>
+          </a:prstGeom>
+          <a:noFill/>
+        </p:spPr>
+        <p:txBody>
+          <a:bodyPr wrap="square" anchor="t" lIns="0" rIns="0" tIns="0" bIns="0">
+            <a:spAutoFit/>
+          </a:bodyPr>
+          <a:lstStyle/>
+          <a:p>
+            <a:r>
+              <a:rPr sz="1150" b="1">
+                <a:solidFill>
+                  <a:srgbClr val="1F7A57"/>
+                </a:solidFill>
+                <a:latin typeface="Space Mono"/>
+              </a:rPr>
+              <a:t>ENGINEERING</a:t>
+            </a:r>
+          </a:p>
+        </p:txBody>
+      </p:sp>
+      <p:sp>
+        <p:nvSpPr>
+          <p:cNvPr id="4" name="TextBox 3"/>
+          <p:cNvSpPr txBox="1"/>
+          <p:nvPr/>
+        </p:nvSpPr>
+        <p:spPr>
+          <a:xfrm>
+            <a:off x="621792" y="731520"/>
+            <a:ext cx="9509760" cy="868680"/>
+          </a:xfrm>
+          <a:prstGeom prst="rect">
+            <a:avLst/>
+          </a:prstGeom>
+          <a:noFill/>
+        </p:spPr>
+        <p:txBody>
+          <a:bodyPr wrap="square" anchor="t" lIns="0" rIns="0" tIns="0" bIns="0">
+            <a:spAutoFit/>
+          </a:bodyPr>
+          <a:lstStyle/>
+          <a:p>
+            <a:r>
+              <a:rPr sz="2700" b="1">
+                <a:solidFill>
+                  <a:srgbClr val="15201C"/>
+                </a:solidFill>
+                <a:latin typeface="Space Grotesk"/>
+              </a:rPr>
+              <a:t>Architecture UC6 — the admin console</a:t>
+            </a:r>
+          </a:p>
+        </p:txBody>
+      </p:sp>
+      <p:sp>
+        <p:nvSpPr>
+          <p:cNvPr id="5" name="Rounded Rectangle 4"/>
+          <p:cNvSpPr/>
+          <p:nvPr/>
+        </p:nvSpPr>
+        <p:spPr>
+          <a:xfrm>
+            <a:off x="3886200" y="1600200"/>
+            <a:ext cx="7653527" cy="4709160"/>
+          </a:xfrm>
+          <a:prstGeom prst="roundRect">
+            <a:avLst>
+              <a:gd name="adj" fmla="val 3000"/>
+            </a:avLst>
+          </a:prstGeom>
+          <a:solidFill>
+            <a:srgbClr val="FFFFFF"/>
+          </a:solidFill>
+          <a:ln w="12700">
+            <a:solidFill>
+              <a:srgbClr val="E6EBE8"/>
+            </a:solidFill>
+          </a:ln>
+          <a:effectLst/>
+        </p:spPr>
+        <p:style>
+          <a:lnRef idx="1">
+            <a:schemeClr val="accent1"/>
+          </a:lnRef>
+          <a:fillRef idx="3">
+            <a:schemeClr val="accent1"/>
+          </a:fillRef>
+          <a:effectRef idx="2">
+            <a:schemeClr val="accent1"/>
+          </a:effectRef>
+          <a:fontRef idx="minor">
+            <a:schemeClr val="lt1"/>
+          </a:fontRef>
+        </p:style>
+        <p:txBody>
+          <a:bodyPr rtlCol="0" anchor="ctr"/>
+          <a:lstStyle/>
+          <a:p>
+            <a:pPr algn="ctr"/>
+          </a:p>
+        </p:txBody>
+      </p:sp>
+      <p:sp>
+        <p:nvSpPr>
+          <p:cNvPr id="7" name="Rectangle 6"/>
+          <p:cNvSpPr/>
+          <p:nvPr/>
+        </p:nvSpPr>
+        <p:spPr>
+          <a:xfrm>
+            <a:off x="640080" y="6455664"/>
+            <a:ext cx="10908792" cy="9144"/>
+          </a:xfrm>
+          <a:prstGeom prst="rect">
+            <a:avLst/>
+          </a:prstGeom>
+          <a:solidFill>
+            <a:srgbClr val="E6EBE8"/>
+          </a:solidFill>
+          <a:ln>
+            <a:noFill/>
+          </a:ln>
+          <a:effectLst/>
+        </p:spPr>
+        <p:style>
+          <a:lnRef idx="1">
+            <a:schemeClr val="accent1"/>
+          </a:lnRef>
+          <a:fillRef idx="3">
+            <a:schemeClr val="accent1"/>
+          </a:fillRef>
+          <a:effectRef idx="2">
+            <a:schemeClr val="accent1"/>
+          </a:effectRef>
+          <a:fontRef idx="minor">
+            <a:schemeClr val="lt1"/>
+          </a:fontRef>
+        </p:style>
+        <p:txBody>
+          <a:bodyPr rtlCol="0" anchor="ctr"/>
+          <a:lstStyle/>
+          <a:p>
+            <a:pPr algn="ctr"/>
+          </a:p>
+        </p:txBody>
+      </p:sp>
+      <p:sp>
+        <p:nvSpPr>
+          <p:cNvPr id="8" name="TextBox 7"/>
+          <p:cNvSpPr txBox="1"/>
+          <p:nvPr/>
+        </p:nvSpPr>
+        <p:spPr>
+          <a:xfrm>
+            <a:off x="640080" y="6510528"/>
+            <a:ext cx="2743200" cy="274320"/>
+          </a:xfrm>
+          <a:prstGeom prst="rect">
+            <a:avLst/>
+          </a:prstGeom>
+          <a:noFill/>
+        </p:spPr>
+        <p:txBody>
+          <a:bodyPr wrap="square" anchor="t" lIns="0" rIns="0" tIns="0" bIns="0">
+            <a:spAutoFit/>
+          </a:bodyPr>
+          <a:lstStyle/>
+          <a:p>
+            <a:r>
+              <a:rPr sz="1100" b="1">
+                <a:solidFill>
+                  <a:srgbClr val="6B7B73"/>
+                </a:solidFill>
+                <a:latin typeface="Space Grotesk"/>
+              </a:rPr>
+              <a:t>want</a:t>
+            </a:r>
+            <a:r>
+              <a:rPr sz="1100" b="1">
+                <a:solidFill>
+                  <a:srgbClr val="1F7A57"/>
+                </a:solidFill>
+                <a:latin typeface="Space Grotesk"/>
+              </a:rPr>
+              <a:t>hat</a:t>
+            </a:r>
+          </a:p>
+        </p:txBody>
+      </p:sp>
+      <p:sp>
+        <p:nvSpPr>
+          <p:cNvPr id="9" name="TextBox 8"/>
+          <p:cNvSpPr txBox="1"/>
+          <p:nvPr/>
+        </p:nvSpPr>
+        <p:spPr>
+          <a:xfrm>
+            <a:off x="10607040" y="6510528"/>
+            <a:ext cx="941832" cy="274320"/>
+          </a:xfrm>
+          <a:prstGeom prst="rect">
+            <a:avLst/>
+          </a:prstGeom>
+          <a:noFill/>
+        </p:spPr>
+        <p:txBody>
+          <a:bodyPr wrap="square" anchor="t" lIns="0" rIns="0" tIns="0" bIns="0">
+            <a:spAutoFit/>
+          </a:bodyPr>
+          <a:lstStyle/>
+          <a:p>
+            <a:pPr algn="r"/>
+            <a:r>
+              <a:rPr sz="1000" b="0">
+                <a:solidFill>
+                  <a:srgbClr val="8A968F"/>
+                </a:solidFill>
+                <a:latin typeface="Space Mono"/>
+              </a:rPr>
+              <a:t>15</a:t>
+            </a:r>
+          </a:p>
+        </p:txBody>
+      </p:sp>
+      <p:sp>
+        <p:nvSpPr>
+          <p:cNvPr id="10" name="TextBox 9"/>
+          <p:cNvSpPr txBox="1"/>
+          <p:nvPr/>
+        </p:nvSpPr>
+        <p:spPr>
+          <a:xfrm>
+            <a:off x="658368" y="1783080"/>
+            <a:ext cx="3063240" cy="4480560"/>
+          </a:xfrm>
+          <a:prstGeom prst="rect">
+            <a:avLst/>
+          </a:prstGeom>
+          <a:noFill/>
+        </p:spPr>
+        <p:txBody>
+          <a:bodyPr wrap="square">
+            <a:spAutoFit/>
+          </a:bodyPr>
+          <a:lstStyle/>
+          <a:p>
+            <a:r>
+              <a:rPr sz="1200" b="0">
+                <a:solidFill>
+                  <a:srgbClr val="15201C"/>
+                </a:solidFill>
+                <a:latin typeface="Hanken Grotesk"/>
+              </a:rPr>
+              <a:t>-  Cognito Managed Login; a SEPARATE employee pool.</a:t>
+            </a:r>
+          </a:p>
+          <a:p>
+            <a:r>
+              <a:rPr sz="1200" b="0">
+                <a:solidFill>
+                  <a:srgbClr val="15201C"/>
+                </a:solidFill>
+                <a:latin typeface="Hanken Grotesk"/>
+              </a:rPr>
+              <a:t>-  Operational-data management; money views are read-only.</a:t>
+            </a:r>
+          </a:p>
+        </p:txBody>
+      </p:sp>
+    </p:spTree>
+  </p:cSld>
+  <p:clrMapOvr>
+    <a:masterClrMapping/>
+  </p:clrMapOvr>
+</p:sld>
+</file>
+
+<file path=ppt/slides/slide35.xml><?xml version="1.0" encoding="utf-8"?>
+<p:sld xmlns:a="http://schemas.openxmlformats.org/drawingml/2006/main" xmlns:p="http://schemas.openxmlformats.org/presentationml/2006/main" xmlns:r="http://schemas.openxmlformats.org/officeDocument/2006/relationships">
+  <p:cSld>
+    <p:spTree>
+      <p:nvGrpSpPr>
+        <p:cNvPr id="1" name=""/>
+        <p:cNvGrpSpPr/>
+        <p:nvPr/>
+      </p:nvGrpSpPr>
+      <p:grpSpPr/>
+      <p:sp>
+        <p:nvSpPr>
+          <p:cNvPr id="2" name="TextBox 1"/>
+          <p:cNvSpPr txBox="1"/>
+          <p:nvPr/>
+        </p:nvSpPr>
+        <p:spPr>
+          <a:xfrm>
+            <a:off x="10195560" y="256032"/>
+            <a:ext cx="1371600" cy="1005840"/>
+          </a:xfrm>
+          <a:prstGeom prst="rect">
+            <a:avLst/>
+          </a:prstGeom>
+          <a:noFill/>
+        </p:spPr>
+        <p:txBody>
+          <a:bodyPr wrap="square" anchor="t" lIns="0" rIns="0" tIns="0" bIns="0">
+            <a:spAutoFit/>
+          </a:bodyPr>
+          <a:lstStyle/>
+          <a:p>
+            <a:pPr algn="r"/>
+            <a:r>
+              <a:rPr sz="4600" b="1">
+                <a:solidFill>
+                  <a:srgbClr val="DCE5E0"/>
+                </a:solidFill>
+                <a:latin typeface="Space Grotesk"/>
+              </a:rPr>
+              <a:t>16</a:t>
+            </a:r>
+          </a:p>
+        </p:txBody>
+      </p:sp>
+      <p:sp>
+        <p:nvSpPr>
+          <p:cNvPr id="3" name="TextBox 2"/>
+          <p:cNvSpPr txBox="1"/>
+          <p:nvPr/>
+        </p:nvSpPr>
+        <p:spPr>
+          <a:xfrm>
+            <a:off x="640080" y="420624"/>
+            <a:ext cx="9418320" cy="292608"/>
+          </a:xfrm>
+          <a:prstGeom prst="rect">
+            <a:avLst/>
+          </a:prstGeom>
+          <a:noFill/>
+        </p:spPr>
+        <p:txBody>
+          <a:bodyPr wrap="square" anchor="t" lIns="0" rIns="0" tIns="0" bIns="0">
+            <a:spAutoFit/>
+          </a:bodyPr>
+          <a:lstStyle/>
+          <a:p>
+            <a:r>
+              <a:rPr sz="1150" b="1">
+                <a:solidFill>
+                  <a:srgbClr val="1F7A57"/>
+                </a:solidFill>
+                <a:latin typeface="Space Mono"/>
+              </a:rPr>
+              <a:t>ENGINEERING</a:t>
+            </a:r>
+          </a:p>
+        </p:txBody>
+      </p:sp>
+      <p:sp>
+        <p:nvSpPr>
+          <p:cNvPr id="4" name="TextBox 3"/>
+          <p:cNvSpPr txBox="1"/>
+          <p:nvPr/>
+        </p:nvSpPr>
+        <p:spPr>
+          <a:xfrm>
+            <a:off x="621792" y="731520"/>
+            <a:ext cx="9509760" cy="868680"/>
+          </a:xfrm>
+          <a:prstGeom prst="rect">
+            <a:avLst/>
+          </a:prstGeom>
+          <a:noFill/>
+        </p:spPr>
+        <p:txBody>
+          <a:bodyPr wrap="square" anchor="t" lIns="0" rIns="0" tIns="0" bIns="0">
+            <a:spAutoFit/>
+          </a:bodyPr>
+          <a:lstStyle/>
+          <a:p>
+            <a:r>
+              <a:rPr sz="2700" b="1">
+                <a:solidFill>
+                  <a:srgbClr val="15201C"/>
+                </a:solidFill>
+                <a:latin typeface="Space Grotesk"/>
+              </a:rPr>
+              <a:t>Architecture — additional use cases, same principles</a:t>
+            </a:r>
+          </a:p>
+        </p:txBody>
+      </p:sp>
+      <p:sp>
+        <p:nvSpPr>
+          <p:cNvPr id="5" name="Rounded Rectangle 4"/>
+          <p:cNvSpPr/>
+          <p:nvPr/>
+        </p:nvSpPr>
+        <p:spPr>
+          <a:xfrm>
+            <a:off x="3886200" y="1600200"/>
+            <a:ext cx="7653527" cy="4709160"/>
+          </a:xfrm>
+          <a:prstGeom prst="roundRect">
+            <a:avLst>
+              <a:gd name="adj" fmla="val 3000"/>
+            </a:avLst>
+          </a:prstGeom>
+          <a:solidFill>
+            <a:srgbClr val="FFFFFF"/>
+          </a:solidFill>
+          <a:ln w="12700">
+            <a:solidFill>
+              <a:srgbClr val="E6EBE8"/>
+            </a:solidFill>
+          </a:ln>
+          <a:effectLst/>
+        </p:spPr>
+        <p:style>
+          <a:lnRef idx="1">
+            <a:schemeClr val="accent1"/>
+          </a:lnRef>
+          <a:fillRef idx="3">
+            <a:schemeClr val="accent1"/>
+          </a:fillRef>
+          <a:effectRef idx="2">
+            <a:schemeClr val="accent1"/>
+          </a:effectRef>
+          <a:fontRef idx="minor">
+            <a:schemeClr val="lt1"/>
+          </a:fontRef>
+        </p:style>
+        <p:txBody>
+          <a:bodyPr rtlCol="0" anchor="ctr"/>
+          <a:lstStyle/>
+          <a:p>
+            <a:pPr algn="ctr"/>
+          </a:p>
+        </p:txBody>
+      </p:sp>
+      <p:sp>
+        <p:nvSpPr>
+          <p:cNvPr id="7" name="Rectangle 6"/>
+          <p:cNvSpPr/>
+          <p:nvPr/>
+        </p:nvSpPr>
+        <p:spPr>
+          <a:xfrm>
+            <a:off x="640080" y="6455664"/>
+            <a:ext cx="10908792" cy="9144"/>
+          </a:xfrm>
+          <a:prstGeom prst="rect">
+            <a:avLst/>
+          </a:prstGeom>
+          <a:solidFill>
+            <a:srgbClr val="E6EBE8"/>
+          </a:solidFill>
+          <a:ln>
+            <a:noFill/>
+          </a:ln>
+          <a:effectLst/>
+        </p:spPr>
+        <p:style>
+          <a:lnRef idx="1">
+            <a:schemeClr val="accent1"/>
+          </a:lnRef>
+          <a:fillRef idx="3">
+            <a:schemeClr val="accent1"/>
+          </a:fillRef>
+          <a:effectRef idx="2">
+            <a:schemeClr val="accent1"/>
+          </a:effectRef>
+          <a:fontRef idx="minor">
+            <a:schemeClr val="lt1"/>
+          </a:fontRef>
+        </p:style>
+        <p:txBody>
+          <a:bodyPr rtlCol="0" anchor="ctr"/>
+          <a:lstStyle/>
+          <a:p>
+            <a:pPr algn="ctr"/>
+          </a:p>
+        </p:txBody>
+      </p:sp>
+      <p:sp>
+        <p:nvSpPr>
+          <p:cNvPr id="8" name="TextBox 7"/>
+          <p:cNvSpPr txBox="1"/>
+          <p:nvPr/>
+        </p:nvSpPr>
+        <p:spPr>
+          <a:xfrm>
+            <a:off x="640080" y="6510528"/>
+            <a:ext cx="2743200" cy="274320"/>
+          </a:xfrm>
+          <a:prstGeom prst="rect">
+            <a:avLst/>
+          </a:prstGeom>
+          <a:noFill/>
+        </p:spPr>
+        <p:txBody>
+          <a:bodyPr wrap="square" anchor="t" lIns="0" rIns="0" tIns="0" bIns="0">
+            <a:spAutoFit/>
+          </a:bodyPr>
+          <a:lstStyle/>
+          <a:p>
+            <a:r>
+              <a:rPr sz="1100" b="1">
+                <a:solidFill>
+                  <a:srgbClr val="6B7B73"/>
+                </a:solidFill>
+                <a:latin typeface="Space Grotesk"/>
+              </a:rPr>
+              <a:t>want</a:t>
+            </a:r>
+            <a:r>
+              <a:rPr sz="1100" b="1">
+                <a:solidFill>
+                  <a:srgbClr val="1F7A57"/>
+                </a:solidFill>
+                <a:latin typeface="Space Grotesk"/>
+              </a:rPr>
+              <a:t>hat</a:t>
+            </a:r>
+          </a:p>
+        </p:txBody>
+      </p:sp>
+      <p:sp>
+        <p:nvSpPr>
+          <p:cNvPr id="9" name="TextBox 8"/>
+          <p:cNvSpPr txBox="1"/>
+          <p:nvPr/>
+        </p:nvSpPr>
+        <p:spPr>
+          <a:xfrm>
+            <a:off x="10607040" y="6510528"/>
+            <a:ext cx="941832" cy="274320"/>
+          </a:xfrm>
+          <a:prstGeom prst="rect">
+            <a:avLst/>
+          </a:prstGeom>
+          <a:noFill/>
+        </p:spPr>
+        <p:txBody>
+          <a:bodyPr wrap="square" anchor="t" lIns="0" rIns="0" tIns="0" bIns="0">
+            <a:spAutoFit/>
+          </a:bodyPr>
+          <a:lstStyle/>
+          <a:p>
+            <a:pPr algn="r"/>
+            <a:r>
+              <a:rPr sz="1000" b="0">
+                <a:solidFill>
+                  <a:srgbClr val="8A968F"/>
+                </a:solidFill>
+                <a:latin typeface="Space Mono"/>
+              </a:rPr>
+              <a:t>16</a:t>
+            </a:r>
+          </a:p>
+        </p:txBody>
+      </p:sp>
+      <p:sp>
+        <p:nvSpPr>
+          <p:cNvPr id="10" name="TextBox 9"/>
+          <p:cNvSpPr txBox="1"/>
+          <p:nvPr/>
+        </p:nvSpPr>
+        <p:spPr>
+          <a:xfrm>
+            <a:off x="658368" y="1783080"/>
+            <a:ext cx="3063240" cy="4480560"/>
+          </a:xfrm>
+          <a:prstGeom prst="rect">
+            <a:avLst/>
+          </a:prstGeom>
+          <a:noFill/>
+        </p:spPr>
+        <p:txBody>
+          <a:bodyPr wrap="square">
+            <a:spAutoFit/>
+          </a:bodyPr>
+          <a:lstStyle/>
+          <a:p>
+            <a:r>
+              <a:rPr sz="1200" b="0">
+                <a:solidFill>
+                  <a:srgbClr val="15201C"/>
+                </a:solidFill>
+                <a:latin typeface="Hanken Grotesk"/>
+              </a:rPr>
+              <a:t>-  Observability.</a:t>
+            </a:r>
+          </a:p>
+          <a:p>
+            <a:r>
+              <a:rPr sz="1200" b="0">
+                <a:solidFill>
+                  <a:srgbClr val="15201C"/>
+                </a:solidFill>
+                <a:latin typeface="Hanken Grotesk"/>
+              </a:rPr>
+              <a:t>-  Guest attribution within the affiliation window.</a:t>
+            </a:r>
+          </a:p>
+          <a:p>
+            <a:r>
+              <a:rPr sz="1200" b="0">
+                <a:solidFill>
+                  <a:srgbClr val="15201C"/>
+                </a:solidFill>
+                <a:latin typeface="Hanken Grotesk"/>
+              </a:rPr>
+              <a:t>-  Manual attribution of unattributed settlements.</a:t>
+            </a:r>
+          </a:p>
+          <a:p>
+            <a:r>
+              <a:rPr sz="1200" b="0">
+                <a:solidFill>
+                  <a:srgbClr val="15201C"/>
+                </a:solidFill>
+                <a:latin typeface="Hanken Grotesk"/>
+              </a:rPr>
+              <a:t>-  Ops counters for real-time admin stats.</a:t>
+            </a:r>
+          </a:p>
+          <a:p>
+            <a:r>
+              <a:rPr sz="1200" b="0">
+                <a:solidFill>
+                  <a:srgbClr val="15201C"/>
+                </a:solidFill>
+                <a:latin typeface="Hanken Grotesk"/>
+              </a:rPr>
+              <a:t>-  Offline analytics.</a:t>
+            </a:r>
+          </a:p>
+        </p:txBody>
+      </p:sp>
+    </p:spTree>
+  </p:cSld>
+  <p:clrMapOvr>
+    <a:masterClrMapping/>
+  </p:clrMapOvr>
+</p:sld>
+</file>
+
+<file path=ppt/slides/slide36.xml><?xml version="1.0" encoding="utf-8"?>
+<p:sld xmlns:a="http://schemas.openxmlformats.org/drawingml/2006/main" xmlns:p="http://schemas.openxmlformats.org/presentationml/2006/main" xmlns:r="http://schemas.openxmlformats.org/officeDocument/2006/relationships">
+  <p:cSld>
+    <p:spTree>
+      <p:nvGrpSpPr>
+        <p:cNvPr id="1" name=""/>
+        <p:cNvGrpSpPr/>
+        <p:nvPr/>
+      </p:nvGrpSpPr>
+      <p:grpSpPr/>
+      <p:sp>
+        <p:nvSpPr>
+          <p:cNvPr id="2" name="TextBox 1"/>
+          <p:cNvSpPr txBox="1"/>
+          <p:nvPr/>
+        </p:nvSpPr>
+        <p:spPr>
+          <a:xfrm>
+            <a:off x="10195560" y="256032"/>
+            <a:ext cx="1371600" cy="1005840"/>
+          </a:xfrm>
+          <a:prstGeom prst="rect">
+            <a:avLst/>
+          </a:prstGeom>
+          <a:noFill/>
+        </p:spPr>
+        <p:txBody>
+          <a:bodyPr wrap="square" anchor="t" lIns="0" rIns="0" tIns="0" bIns="0">
+            <a:spAutoFit/>
+          </a:bodyPr>
+          <a:lstStyle/>
+          <a:p>
+            <a:pPr algn="r"/>
+            <a:r>
+              <a:rPr sz="4600" b="1">
+                <a:solidFill>
+                  <a:srgbClr val="DCE5E0"/>
+                </a:solidFill>
+                <a:latin typeface="Space Grotesk"/>
+              </a:rPr>
+              <a:t>B17</a:t>
+            </a:r>
+          </a:p>
+        </p:txBody>
+      </p:sp>
+      <p:sp>
+        <p:nvSpPr>
+          <p:cNvPr id="3" name="TextBox 2"/>
+          <p:cNvSpPr txBox="1"/>
+          <p:nvPr/>
+        </p:nvSpPr>
+        <p:spPr>
+          <a:xfrm>
+            <a:off x="640080" y="420624"/>
+            <a:ext cx="9418320" cy="292608"/>
+          </a:xfrm>
+          <a:prstGeom prst="rect">
+            <a:avLst/>
+          </a:prstGeom>
+          <a:noFill/>
+        </p:spPr>
+        <p:txBody>
+          <a:bodyPr wrap="square" anchor="t" lIns="0" rIns="0" tIns="0" bIns="0">
+            <a:spAutoFit/>
+          </a:bodyPr>
+          <a:lstStyle/>
+          <a:p>
+            <a:r>
+              <a:rPr sz="1150" b="1">
+                <a:solidFill>
+                  <a:srgbClr val="1F7A57"/>
+                </a:solidFill>
+                <a:latin typeface="Space Mono"/>
+              </a:rPr>
+              <a:t>BACKUP</a:t>
+            </a:r>
+          </a:p>
+        </p:txBody>
+      </p:sp>
+      <p:sp>
+        <p:nvSpPr>
+          <p:cNvPr id="4" name="TextBox 3"/>
+          <p:cNvSpPr txBox="1"/>
+          <p:nvPr/>
+        </p:nvSpPr>
+        <p:spPr>
+          <a:xfrm>
+            <a:off x="621792" y="731520"/>
+            <a:ext cx="9509760" cy="868680"/>
+          </a:xfrm>
+          <a:prstGeom prst="rect">
+            <a:avLst/>
+          </a:prstGeom>
+          <a:noFill/>
+        </p:spPr>
+        <p:txBody>
+          <a:bodyPr wrap="square" anchor="t" lIns="0" rIns="0" tIns="0" bIns="0">
+            <a:spAutoFit/>
+          </a:bodyPr>
+          <a:lstStyle/>
+          <a:p>
+            <a:r>
+              <a:rPr sz="2700" b="1">
+                <a:solidFill>
+                  <a:srgbClr val="15201C"/>
+                </a:solidFill>
+                <a:latin typeface="Space Grotesk"/>
+              </a:rPr>
+              <a:t>Cost progression — 10 to 100k active users</a:t>
+            </a:r>
+          </a:p>
+        </p:txBody>
+      </p:sp>
+      <p:sp>
+        <p:nvSpPr>
+          <p:cNvPr id="6" name="Rectangle 5"/>
+          <p:cNvSpPr/>
+          <p:nvPr/>
+        </p:nvSpPr>
+        <p:spPr>
+          <a:xfrm>
+            <a:off x="640080" y="6455664"/>
+            <a:ext cx="10908792" cy="9144"/>
+          </a:xfrm>
+          <a:prstGeom prst="rect">
+            <a:avLst/>
+          </a:prstGeom>
+          <a:solidFill>
+            <a:srgbClr val="E6EBE8"/>
+          </a:solidFill>
+          <a:ln>
+            <a:noFill/>
+          </a:ln>
+          <a:effectLst/>
+        </p:spPr>
+        <p:style>
+          <a:lnRef idx="1">
+            <a:schemeClr val="accent1"/>
+          </a:lnRef>
+          <a:fillRef idx="3">
+            <a:schemeClr val="accent1"/>
+          </a:fillRef>
+          <a:effectRef idx="2">
+            <a:schemeClr val="accent1"/>
+          </a:effectRef>
+          <a:fontRef idx="minor">
+            <a:schemeClr val="lt1"/>
+          </a:fontRef>
+        </p:style>
+        <p:txBody>
+          <a:bodyPr rtlCol="0" anchor="ctr"/>
+          <a:lstStyle/>
+          <a:p>
+            <a:pPr algn="ctr"/>
+          </a:p>
+        </p:txBody>
+      </p:sp>
+      <p:sp>
+        <p:nvSpPr>
+          <p:cNvPr id="7" name="TextBox 6"/>
+          <p:cNvSpPr txBox="1"/>
+          <p:nvPr/>
+        </p:nvSpPr>
+        <p:spPr>
+          <a:xfrm>
+            <a:off x="640080" y="6510528"/>
+            <a:ext cx="2743200" cy="274320"/>
+          </a:xfrm>
+          <a:prstGeom prst="rect">
+            <a:avLst/>
+          </a:prstGeom>
+          <a:noFill/>
+        </p:spPr>
+        <p:txBody>
+          <a:bodyPr wrap="square" anchor="t" lIns="0" rIns="0" tIns="0" bIns="0">
+            <a:spAutoFit/>
+          </a:bodyPr>
+          <a:lstStyle/>
+          <a:p>
+            <a:r>
+              <a:rPr sz="1100" b="1">
+                <a:solidFill>
+                  <a:srgbClr val="6B7B73"/>
+                </a:solidFill>
+                <a:latin typeface="Space Grotesk"/>
+              </a:rPr>
+              <a:t>want</a:t>
+            </a:r>
+            <a:r>
+              <a:rPr sz="1100" b="1">
+                <a:solidFill>
+                  <a:srgbClr val="1F7A57"/>
+                </a:solidFill>
+                <a:latin typeface="Space Grotesk"/>
+              </a:rPr>
+              <a:t>hat</a:t>
+            </a:r>
+          </a:p>
+        </p:txBody>
+      </p:sp>
+      <p:sp>
+        <p:nvSpPr>
+          <p:cNvPr id="8" name="TextBox 7"/>
+          <p:cNvSpPr txBox="1"/>
+          <p:nvPr/>
+        </p:nvSpPr>
+        <p:spPr>
+          <a:xfrm>
+            <a:off x="10607040" y="6510528"/>
+            <a:ext cx="941832" cy="274320"/>
+          </a:xfrm>
+          <a:prstGeom prst="rect">
+            <a:avLst/>
+          </a:prstGeom>
+          <a:noFill/>
+        </p:spPr>
+        <p:txBody>
+          <a:bodyPr wrap="square" anchor="t" lIns="0" rIns="0" tIns="0" bIns="0">
+            <a:spAutoFit/>
+          </a:bodyPr>
+          <a:lstStyle/>
+          <a:p>
+            <a:pPr algn="r"/>
+            <a:r>
+              <a:rPr sz="1000" b="0">
+                <a:solidFill>
+                  <a:srgbClr val="8A968F"/>
+                </a:solidFill>
+                <a:latin typeface="Space Mono"/>
+              </a:rPr>
+              <a:t>B17</a:t>
+            </a:r>
+          </a:p>
+        </p:txBody>
+      </p:sp>
+      <p:graphicFrame>
+        <p:nvGraphicFramePr>
+          <p:cNvPr id="9" name="Table 8"/>
+          <p:cNvGraphicFramePr>
+            <a:graphicFrameLocks noGrp="1"/>
+          </p:cNvGraphicFramePr>
+          <p:nvPr/>
+        </p:nvGraphicFramePr>
+        <p:xfrm>
+          <a:off x="658368" y="1600200"/>
+          <a:ext cx="10881360" cy="2651760"/>
+        </p:xfrm>
+        <a:graphic>
+          <a:graphicData uri="http://schemas.openxmlformats.org/drawingml/2006/table">
+            <a:tbl>
+              <a:tblPr firstRow="1" bandRow="1">
+                <a:tableStyleId>{5C22544A-7EE6-4342-B048-85BDC9FD1C3A}</a:tableStyleId>
+              </a:tblPr>
+              <a:tblGrid>
+                <a:gridCol w="3627120"/>
+                <a:gridCol w="3627120"/>
+                <a:gridCol w="3627120"/>
+              </a:tblGrid>
+              <a:tr h="441960">
+                <a:tc>
+                  <a:txBody>
+                    <a:bodyPr/>
+                    <a:lstStyle/>
+                    <a:p>
+                      <a:r>
+                        <a:rPr sz="1100" b="1">
+                          <a:solidFill>
+                            <a:srgbClr val="7FE0B0"/>
+                          </a:solidFill>
+                          <a:latin typeface="Space Grotesk"/>
+                        </a:rPr>
+                        <a:t>Active users</a:t>
+                      </a:r>
+                    </a:p>
+                  </a:txBody>
+                  <a:tcPr>
+                    <a:solidFill>
+                      <a:srgbClr val="15201C"/>
+                    </a:solidFill>
+                  </a:tcPr>
+                </a:tc>
+                <a:tc>
+                  <a:txBody>
+                    <a:bodyPr/>
+                    <a:lstStyle/>
+                    <a:p>
+                      <a:r>
+                        <a:rPr sz="1100" b="1">
+                          <a:solidFill>
+                            <a:srgbClr val="7FE0B0"/>
+                          </a:solidFill>
+                          <a:latin typeface="Space Grotesk"/>
+                        </a:rPr>
+                        <a:t>Monthly (prod)</a:t>
+                      </a:r>
+                    </a:p>
+                  </a:txBody>
+                  <a:tcPr>
+                    <a:solidFill>
+                      <a:srgbClr val="15201C"/>
+                    </a:solidFill>
+                  </a:tcPr>
+                </a:tc>
+                <a:tc>
+                  <a:txBody>
+                    <a:bodyPr/>
+                    <a:lstStyle/>
+                    <a:p>
+                      <a:r>
+                        <a:rPr sz="1100" b="1">
+                          <a:solidFill>
+                            <a:srgbClr val="7FE0B0"/>
+                          </a:solidFill>
+                          <a:latin typeface="Space Grotesk"/>
+                        </a:rPr>
+                        <a:t>What dominates</a:t>
+                      </a:r>
+                    </a:p>
+                  </a:txBody>
+                  <a:tcPr>
+                    <a:solidFill>
+                      <a:srgbClr val="15201C"/>
+                    </a:solidFill>
+                  </a:tcPr>
+                </a:tc>
+              </a:tr>
+              <a:tr h="441960">
+                <a:tc>
+                  <a:txBody>
+                    <a:bodyPr/>
+                    <a:lstStyle/>
+                    <a:p>
+                      <a:r>
+                        <a:rPr sz="1050" b="1">
+                          <a:solidFill>
+                            <a:srgbClr val="15201C"/>
+                          </a:solidFill>
+                          <a:latin typeface="Hanken Grotesk"/>
+                        </a:rPr>
+                        <a:t>10</a:t>
+                      </a:r>
+                    </a:p>
+                  </a:txBody>
+                  <a:tcPr>
+                    <a:solidFill>
+                      <a:srgbClr val="FFFFFF"/>
+                    </a:solidFill>
+                  </a:tcPr>
+                </a:tc>
+                <a:tc>
+                  <a:txBody>
+                    <a:bodyPr/>
+                    <a:lstStyle/>
+                    <a:p>
+                      <a:r>
+                        <a:rPr sz="1050" b="1">
+                          <a:solidFill>
+                            <a:srgbClr val="15201C"/>
+                          </a:solidFill>
+                          <a:latin typeface="Hanken Grotesk"/>
+                        </a:rPr>
+                        <a:t>~$20</a:t>
+                      </a:r>
+                    </a:p>
+                  </a:txBody>
+                  <a:tcPr>
+                    <a:solidFill>
+                      <a:srgbClr val="FFFFFF"/>
+                    </a:solidFill>
+                  </a:tcPr>
+                </a:tc>
+                <a:tc>
+                  <a:txBody>
+                    <a:bodyPr/>
+                    <a:lstStyle/>
+                    <a:p>
+                      <a:r>
+                        <a:rPr sz="1050" b="1">
+                          <a:solidFill>
+                            <a:srgbClr val="15201C"/>
+                          </a:solidFill>
+                          <a:latin typeface="Hanken Grotesk"/>
+                        </a:rPr>
+                        <a:t>the fixed floor (WAF $14 + Aurora storage)</a:t>
+                      </a:r>
+                    </a:p>
+                  </a:txBody>
+                  <a:tcPr>
+                    <a:solidFill>
+                      <a:srgbClr val="FFFFFF"/>
+                    </a:solidFill>
+                  </a:tcPr>
+                </a:tc>
+              </a:tr>
+              <a:tr h="441960">
+                <a:tc>
+                  <a:txBody>
+                    <a:bodyPr/>
+                    <a:lstStyle/>
+                    <a:p>
+                      <a:r>
+                        <a:rPr sz="1050" b="1">
+                          <a:solidFill>
+                            <a:srgbClr val="15201C"/>
+                          </a:solidFill>
+                          <a:latin typeface="Hanken Grotesk"/>
+                        </a:rPr>
+                        <a:t>1,000</a:t>
+                      </a:r>
+                    </a:p>
+                  </a:txBody>
+                  <a:tcPr>
+                    <a:solidFill>
+                      <a:srgbClr val="FFFFFF"/>
+                    </a:solidFill>
+                  </a:tcPr>
+                </a:tc>
+                <a:tc>
+                  <a:txBody>
+                    <a:bodyPr/>
+                    <a:lstStyle/>
+                    <a:p>
+                      <a:r>
+                        <a:rPr sz="1050" b="1">
+                          <a:solidFill>
+                            <a:srgbClr val="15201C"/>
+                          </a:solidFill>
+                          <a:latin typeface="Hanken Grotesk"/>
+                        </a:rPr>
+                        <a:t>~$55-75</a:t>
+                      </a:r>
+                    </a:p>
+                  </a:txBody>
+                  <a:tcPr>
+                    <a:solidFill>
+                      <a:srgbClr val="FFFFFF"/>
+                    </a:solidFill>
+                  </a:tcPr>
+                </a:tc>
+                <a:tc>
+                  <a:txBody>
+                    <a:bodyPr/>
+                    <a:lstStyle/>
+                    <a:p>
+                      <a:r>
+                        <a:rPr sz="1050" b="1">
+                          <a:solidFill>
+                            <a:srgbClr val="15201C"/>
+                          </a:solidFill>
+                          <a:latin typeface="Hanken Grotesk"/>
+                        </a:rPr>
+                        <a:t>Aurora stops scaling to zero (~$35-55)</a:t>
+                      </a:r>
+                    </a:p>
+                  </a:txBody>
+                  <a:tcPr>
+                    <a:solidFill>
+                      <a:srgbClr val="FFFFFF"/>
+                    </a:solidFill>
+                  </a:tcPr>
+                </a:tc>
+              </a:tr>
+              <a:tr h="441960">
+                <a:tc>
+                  <a:txBody>
+                    <a:bodyPr/>
+                    <a:lstStyle/>
+                    <a:p>
+                      <a:r>
+                        <a:rPr sz="1050" b="1">
+                          <a:solidFill>
+                            <a:srgbClr val="15201C"/>
+                          </a:solidFill>
+                          <a:latin typeface="Hanken Grotesk"/>
+                        </a:rPr>
+                        <a:t>10,000</a:t>
+                      </a:r>
+                    </a:p>
+                  </a:txBody>
+                  <a:tcPr>
+                    <a:solidFill>
+                      <a:srgbClr val="FFFFFF"/>
+                    </a:solidFill>
+                  </a:tcPr>
+                </a:tc>
+                <a:tc>
+                  <a:txBody>
+                    <a:bodyPr/>
+                    <a:lstStyle/>
+                    <a:p>
+                      <a:r>
+                        <a:rPr sz="1050" b="1">
+                          <a:solidFill>
+                            <a:srgbClr val="15201C"/>
+                          </a:solidFill>
+                          <a:latin typeface="Hanken Grotesk"/>
+                        </a:rPr>
+                        <a:t>~$90-150</a:t>
+                      </a:r>
+                    </a:p>
+                  </a:txBody>
+                  <a:tcPr>
+                    <a:solidFill>
+                      <a:srgbClr val="FFFFFF"/>
+                    </a:solidFill>
+                  </a:tcPr>
+                </a:tc>
+                <a:tc>
+                  <a:txBody>
+                    <a:bodyPr/>
+                    <a:lstStyle/>
+                    <a:p>
+                      <a:r>
+                        <a:rPr sz="1050" b="1">
+                          <a:solidFill>
+                            <a:srgbClr val="15201C"/>
+                          </a:solidFill>
+                          <a:latin typeface="Hanken Grotesk"/>
+                        </a:rPr>
+                        <a:t>still inside the Cognito free tier (10k MAU)</a:t>
+                      </a:r>
+                    </a:p>
+                  </a:txBody>
+                  <a:tcPr>
+                    <a:solidFill>
+                      <a:srgbClr val="FFFFFF"/>
+                    </a:solidFill>
+                  </a:tcPr>
+                </a:tc>
+              </a:tr>
+              <a:tr h="441960">
+                <a:tc>
+                  <a:txBody>
+                    <a:bodyPr/>
+                    <a:lstStyle/>
+                    <a:p>
+                      <a:r>
+                        <a:rPr sz="1050" b="1">
+                          <a:solidFill>
+                            <a:srgbClr val="15201C"/>
+                          </a:solidFill>
+                          <a:latin typeface="Hanken Grotesk"/>
+                        </a:rPr>
+                        <a:t>10,000 + RDS Proxy</a:t>
+                      </a:r>
+                    </a:p>
+                  </a:txBody>
+                  <a:tcPr>
+                    <a:solidFill>
+                      <a:srgbClr val="FFFFFF"/>
+                    </a:solidFill>
+                  </a:tcPr>
+                </a:tc>
+                <a:tc>
+                  <a:txBody>
+                    <a:bodyPr/>
+                    <a:lstStyle/>
+                    <a:p>
+                      <a:r>
+                        <a:rPr sz="1050" b="1">
+                          <a:solidFill>
+                            <a:srgbClr val="15201C"/>
+                          </a:solidFill>
+                          <a:latin typeface="Hanken Grotesk"/>
+                        </a:rPr>
+                        <a:t>~$190-250</a:t>
+                      </a:r>
+                    </a:p>
+                  </a:txBody>
+                  <a:tcPr>
+                    <a:solidFill>
+                      <a:srgbClr val="FFFFFF"/>
+                    </a:solidFill>
+                  </a:tcPr>
+                </a:tc>
+                <a:tc>
+                  <a:txBody>
+                    <a:bodyPr/>
+                    <a:lstStyle/>
+                    <a:p>
+                      <a:r>
+                        <a:rPr sz="1050" b="1">
+                          <a:solidFill>
+                            <a:srgbClr val="15201C"/>
+                          </a:solidFill>
+                          <a:latin typeface="Hanken Grotesk"/>
+                        </a:rPr>
+                        <a:t>proxy 8-ACU minimum = ~$100/month FLAT</a:t>
+                      </a:r>
+                    </a:p>
+                  </a:txBody>
+                  <a:tcPr>
+                    <a:solidFill>
+                      <a:srgbClr val="FFFFFF"/>
+                    </a:solidFill>
+                  </a:tcPr>
+                </a:tc>
+              </a:tr>
+              <a:tr h="441960">
+                <a:tc>
+                  <a:txBody>
+                    <a:bodyPr/>
+                    <a:lstStyle/>
+                    <a:p>
+                      <a:r>
+                        <a:rPr sz="1050" b="1">
+                          <a:solidFill>
+                            <a:srgbClr val="15201C"/>
+                          </a:solidFill>
+                          <a:latin typeface="Hanken Grotesk"/>
+                        </a:rPr>
+                        <a:t>100,000</a:t>
+                      </a:r>
+                    </a:p>
+                  </a:txBody>
+                  <a:tcPr>
+                    <a:solidFill>
+                      <a:srgbClr val="FFFFFF"/>
+                    </a:solidFill>
+                  </a:tcPr>
+                </a:tc>
+                <a:tc>
+                  <a:txBody>
+                    <a:bodyPr/>
+                    <a:lstStyle/>
+                    <a:p>
+                      <a:r>
+                        <a:rPr sz="1050" b="1">
+                          <a:solidFill>
+                            <a:srgbClr val="15201C"/>
+                          </a:solidFill>
+                          <a:latin typeface="Hanken Grotesk"/>
+                        </a:rPr>
+                        <a:t>~$1,730</a:t>
+                      </a:r>
+                    </a:p>
+                  </a:txBody>
+                  <a:tcPr>
+                    <a:solidFill>
+                      <a:srgbClr val="FFFFFF"/>
+                    </a:solidFill>
+                  </a:tcPr>
+                </a:tc>
+                <a:tc>
+                  <a:txBody>
+                    <a:bodyPr/>
+                    <a:lstStyle/>
+                    <a:p>
+                      <a:r>
+                        <a:rPr sz="1050" b="1">
+                          <a:solidFill>
+                            <a:srgbClr val="15201C"/>
+                          </a:solidFill>
+                          <a:latin typeface="Hanken Grotesk"/>
+                        </a:rPr>
+                        <a:t>Cognito MAU $1,350 = 78% of the bill</a:t>
+                      </a:r>
+                    </a:p>
+                  </a:txBody>
+                  <a:tcPr>
+                    <a:solidFill>
+                      <a:srgbClr val="FFFFFF"/>
+                    </a:solidFill>
+                  </a:tcPr>
+                </a:tc>
+              </a:tr>
+            </a:tbl>
+          </a:graphicData>
+        </a:graphic>
+      </p:graphicFrame>
+      <p:sp>
+        <p:nvSpPr>
+          <p:cNvPr id="10" name="TextBox 9"/>
+          <p:cNvSpPr txBox="1"/>
+          <p:nvPr/>
+        </p:nvSpPr>
+        <p:spPr>
+          <a:xfrm>
+            <a:off x="658368" y="4572000"/>
+            <a:ext cx="10881360" cy="1737360"/>
+          </a:xfrm>
+          <a:prstGeom prst="rect">
+            <a:avLst/>
+          </a:prstGeom>
+          <a:noFill/>
+        </p:spPr>
+        <p:txBody>
+          <a:bodyPr wrap="square">
+            <a:spAutoFit/>
+          </a:bodyPr>
+          <a:lstStyle/>
+          <a:p>
+            <a:r>
+              <a:rPr sz="1150" b="0">
+                <a:solidFill>
+                  <a:srgbClr val="6B7B73"/>
+                </a:solidFill>
+                <a:latin typeface="Hanken Grotesk"/>
+              </a:rPr>
+              <a:t>Assumptions: 10 operations/user/day (wallet refresh, create recommendation), ~70/30 read-write, il-central-1 approximate prices, prod only; every active user = 1 Cognito MAU.</a:t>
+            </a:r>
+          </a:p>
+          <a:p>
+            <a:r>
+              <a:rPr sz="1150" b="0">
+                <a:solidFill>
+                  <a:srgbClr val="6B7B73"/>
+                </a:solidFill>
+                <a:latin typeface="Hanken Grotesk"/>
+              </a:rPr>
+              <a:t>Two step functions, then linear: Aurora stops sleeping (~1k users); the Cognito free tier ends at exactly 10k MAU ($0.015/MAU after). Per-user at 100k: ~$0.017/month.</a:t>
+            </a:r>
+          </a:p>
+          <a:p>
+            <a:r>
+              <a:rPr sz="1150" b="0">
+                <a:solidFill>
+                  <a:srgbClr val="6B7B73"/>
+                </a:solidFill>
+                <a:latin typeface="Hanken Grotesk"/>
+              </a:rPr>
+              <a:t>Breaks BEFORE the bill: account concurrency 10 (~10k users, peaks) - AliExpress rate limits (ADR-0021) - Aurora 50 connections post-quota-raise (only THEN the proxy) - the 2-ACU max.</a:t>
             </a:r>
           </a:p>
         </p:txBody>
@@ -22986,7 +26717,7 @@
                 </a:solidFill>
                 <a:latin typeface="Hanken Grotesk"/>
               </a:rPr>
-              <a:t>AWS CDK v2; per-env stacks; zero console changes. PRs run CI + a cdk diff dry run; merge deploys dev, prod promotes explicitly; SQL migrations run in-deploy.</a:t>
+              <a:t>AWS CDK v2; per-env stacks; zero console changes. PRs run CI + cdk diff; merge deploys dev; SQL migrations run in-deploy; verify no orphaned resources after deploys.</a:t>
             </a:r>
           </a:p>
         </p:txBody>
@@ -23184,7 +26915,7 @@
                 </a:solidFill>
                 <a:latin typeface="Hanken Grotesk"/>
               </a:rPr>
-              <a:t>21 ADRs beside the code. Locked: change = a new superseding ADR, never an edit.</a:t>
+              <a:t>ADRs beside the code. Locked: change is a new superseding ADR, never an edit.</a:t>
             </a:r>
           </a:p>
         </p:txBody>
@@ -23382,7 +27113,7 @@
                 </a:solidFill>
                 <a:latin typeface="Hanken Grotesk"/>
               </a:rPr>
-              <a:t>No NAT, no RDS Proxy, zero interface endpoints, scale-to-zero Aurora, on-demand DynamoDB. The dominant cost line is OTP delivery, not infrastructure.</a:t>
+              <a:t>Avoid constant costs: zero interface endpoints, scale-to-zero, on-demand DBs.</a:t>
             </a:r>
           </a:p>
         </p:txBody>
@@ -23580,7 +27311,7 @@
                 </a:solidFill>
                 <a:latin typeface="Hanken Grotesk"/>
               </a:rPr>
-              <a:t>A link going viral in a WhatsApp group is the design load: the redirect hot path is non-VPC Lambda + DynamoDB and never touches SQL.</a:t>
+              <a:t>A link going viral in a WhatsApp group is the design spike.</a:t>
             </a:r>
           </a:p>
         </p:txBody>
@@ -24112,7 +27843,7 @@
                 </a:solidFill>
                 <a:latin typeface="Space Grotesk"/>
               </a:rPr>
-              <a:t>08</a:t>
+              <a:t>09</a:t>
             </a:r>
           </a:p>
         </p:txBody>
@@ -24180,7 +27911,7 @@
                 </a:solidFill>
                 <a:latin typeface="Space Grotesk"/>
               </a:rPr>
-              <a:t>Architecture — the whole system</a:t>
+              <a:t>Architecture — the starting point</a:t>
             </a:r>
           </a:p>
         </p:txBody>
@@ -24193,8 +27924,8 @@
         </p:nvSpPr>
         <p:spPr>
           <a:xfrm>
-            <a:off x="3615319" y="1481328"/>
-            <a:ext cx="4961056" cy="5084064"/>
+            <a:off x="658368" y="1600200"/>
+            <a:ext cx="10881360" cy="4114800"/>
           </a:xfrm>
           <a:prstGeom prst="roundRect">
             <a:avLst>
@@ -24233,30 +27964,6 @@
           </a:p>
         </p:txBody>
       </p:sp>
-      <p:pic>
-        <p:nvPicPr>
-          <p:cNvPr id="6" name="Picture 5" descr="slide-7.png"/>
-          <p:cNvPicPr>
-            <a:picLocks noChangeAspect="1"/>
-          </p:cNvPicPr>
-          <p:nvPr/>
-        </p:nvPicPr>
-        <p:blipFill>
-          <a:blip r:embed="rId2"/>
-          <a:stretch>
-            <a:fillRect/>
-          </a:stretch>
-        </p:blipFill>
-        <p:spPr>
-          <a:xfrm>
-            <a:off x="3779911" y="1645920"/>
-            <a:ext cx="4631872" cy="4754880"/>
-          </a:xfrm>
-          <a:prstGeom prst="rect">
-            <a:avLst/>
-          </a:prstGeom>
-        </p:spPr>
-      </p:pic>
       <p:sp>
         <p:nvSpPr>
           <p:cNvPr id="7" name="Rectangle 6"/>
@@ -24374,7 +28081,41 @@
                 </a:solidFill>
                 <a:latin typeface="Space Mono"/>
               </a:rPr>
-              <a:t>8</a:t>
+              <a:t>9</a:t>
+            </a:r>
+          </a:p>
+        </p:txBody>
+      </p:sp>
+      <p:sp>
+        <p:nvSpPr>
+          <p:cNvPr id="10" name="TextBox 9"/>
+          <p:cNvSpPr txBox="1"/>
+          <p:nvPr/>
+        </p:nvSpPr>
+        <p:spPr>
+          <a:xfrm>
+            <a:off x="658368" y="5852160"/>
+            <a:ext cx="10881360" cy="457200"/>
+          </a:xfrm>
+          <a:prstGeom prst="rect">
+            <a:avLst/>
+          </a:prstGeom>
+          <a:noFill/>
+        </p:spPr>
+        <p:txBody>
+          <a:bodyPr wrap="square">
+            <a:spAutoFit/>
+          </a:bodyPr>
+          <a:lstStyle/>
+          <a:p>
+            <a:r>
+              <a:rPr sz="1400" b="1">
+                <a:solidFill>
+                  <a:srgbClr val="15201C"/>
+                </a:solidFill>
+                <a:latin typeface="Hanken Grotesk"/>
+              </a:rPr>
+              <a:t>Starting with:  in-VPC Aurora Serverless v2   and   DynamoDB on-demand.</a:t>
             </a:r>
           </a:p>
         </p:txBody>
@@ -24435,7 +28176,7 @@
                 </a:solidFill>
                 <a:latin typeface="Space Grotesk"/>
               </a:rPr>
-              <a:t>09</a:t>
+              <a:t>08</a:t>
             </a:r>
           </a:p>
         </p:txBody>
@@ -24503,7 +28244,7 @@
                 </a:solidFill>
                 <a:latin typeface="Space Grotesk"/>
               </a:rPr>
-              <a:t>Data — one store per job, and what each costs us</a:t>
+              <a:t>Data stores and cost</a:t>
             </a:r>
           </a:p>
         </p:txBody>
@@ -25141,7 +28882,7 @@
                 </a:solidFill>
                 <a:latin typeface="Space Mono"/>
               </a:rPr>
-              <a:t>9</a:t>
+              <a:t>8</a:t>
             </a:r>
           </a:p>
         </p:txBody>

</xml_diff>

<commit_message>
slides: B17 becomes the full cost matrix (service rows x 10..100k user columns)
10 / 100 / 1,000 / 10,000 / 100,000 active-user columns, per-service rows,
total at the bottom; RDS Proxy included at 10k and 100k (8-ACU minimum,
~$100/month flat). Same numbers as the in-session analysis, 100-user tier
interpolated with the same assumptions.

Co-Authored-By: Claude Fable 5 <noreply@anthropic.com>
Claude-Session: https://claude.ai/code/session_01FECrSGSMqWYxFMSwWq9E5s
</commit_message>
<xml_diff>
--- a/slides/wanthat-presentation.pptx
+++ b/slides/wanthat-presentation.pptx
@@ -2217,7 +2217,7 @@
           <a:lstStyle/>
           <a:p>
             <a:r>
-              <a:t>WAF stays flat at every scale - member API operations bypass CloudFront entirely. The scaling costs live in identity (Cognito MAU), Aurora always-on, and the per-request stack (~$90/month combined at 100k).</a:t>
+              <a:t>WAF stays flat at every scale - member API operations bypass CloudFront entirely. Breaks BEFORE the bill: account concurrency 10 (~10k users, peaks) - AliExpress rate limits (ADR-0021) - Aurora's 50-connection cap post-quota-raise (only THEN does the proxy earn its cost) - the 2-ACU max.</a:t>
             </a:r>
           </a:p>
         </p:txBody>
@@ -23950,8 +23950,8 @@
           <p:nvPr/>
         </p:nvGraphicFramePr>
         <p:xfrm>
-          <a:off x="658368" y="1600200"/>
-          <a:ext cx="10881360" cy="2651760"/>
+          <a:off x="658368" y="1554480"/>
+          <a:ext cx="10881360" cy="3931920"/>
         </p:xfrm>
         <a:graphic>
           <a:graphicData uri="http://schemas.openxmlformats.org/drawingml/2006/table">
@@ -23960,33 +23960,14 @@
                 <a:tableStyleId>{5C22544A-7EE6-4342-B048-85BDC9FD1C3A}</a:tableStyleId>
               </a:tblPr>
               <a:tblGrid>
-                <a:gridCol w="3627120"/>
-                <a:gridCol w="3627120"/>
-                <a:gridCol w="3627120"/>
+                <a:gridCol w="3566160"/>
+                <a:gridCol w="1463040"/>
+                <a:gridCol w="1463040"/>
+                <a:gridCol w="1463040"/>
+                <a:gridCol w="1463040"/>
+                <a:gridCol w="1463040"/>
               </a:tblGrid>
-              <a:tr h="441960">
-                <a:tc>
-                  <a:txBody>
-                    <a:bodyPr/>
-                    <a:lstStyle/>
-                    <a:p>
-                      <a:r>
-                        <a:rPr sz="1100" b="1">
-                          <a:solidFill>
-                            <a:srgbClr val="7FE0B0"/>
-                          </a:solidFill>
-                          <a:latin typeface="Space Grotesk"/>
-                        </a:rPr>
-                        <a:t>Active users</a:t>
-                      </a:r>
-                    </a:p>
-                  </a:txBody>
-                  <a:tcPr>
-                    <a:solidFill>
-                      <a:srgbClr val="15201C"/>
-                    </a:solidFill>
-                  </a:tcPr>
-                </a:tc>
+              <a:tr h="393192">
                 <a:tc>
                   <a:txBody>
                     <a:bodyPr/>
@@ -24021,7 +24002,95 @@
                           </a:solidFill>
                           <a:latin typeface="Space Grotesk"/>
                         </a:rPr>
-                        <a:t>What dominates</a:t>
+                        <a:t>10</a:t>
+                      </a:r>
+                    </a:p>
+                  </a:txBody>
+                  <a:tcPr>
+                    <a:solidFill>
+                      <a:srgbClr val="15201C"/>
+                    </a:solidFill>
+                  </a:tcPr>
+                </a:tc>
+                <a:tc>
+                  <a:txBody>
+                    <a:bodyPr/>
+                    <a:lstStyle/>
+                    <a:p>
+                      <a:r>
+                        <a:rPr sz="1100" b="1">
+                          <a:solidFill>
+                            <a:srgbClr val="7FE0B0"/>
+                          </a:solidFill>
+                          <a:latin typeface="Space Grotesk"/>
+                        </a:rPr>
+                        <a:t>100</a:t>
+                      </a:r>
+                    </a:p>
+                  </a:txBody>
+                  <a:tcPr>
+                    <a:solidFill>
+                      <a:srgbClr val="15201C"/>
+                    </a:solidFill>
+                  </a:tcPr>
+                </a:tc>
+                <a:tc>
+                  <a:txBody>
+                    <a:bodyPr/>
+                    <a:lstStyle/>
+                    <a:p>
+                      <a:r>
+                        <a:rPr sz="1100" b="1">
+                          <a:solidFill>
+                            <a:srgbClr val="7FE0B0"/>
+                          </a:solidFill>
+                          <a:latin typeface="Space Grotesk"/>
+                        </a:rPr>
+                        <a:t>1,000</a:t>
+                      </a:r>
+                    </a:p>
+                  </a:txBody>
+                  <a:tcPr>
+                    <a:solidFill>
+                      <a:srgbClr val="15201C"/>
+                    </a:solidFill>
+                  </a:tcPr>
+                </a:tc>
+                <a:tc>
+                  <a:txBody>
+                    <a:bodyPr/>
+                    <a:lstStyle/>
+                    <a:p>
+                      <a:r>
+                        <a:rPr sz="1100" b="1">
+                          <a:solidFill>
+                            <a:srgbClr val="7FE0B0"/>
+                          </a:solidFill>
+                          <a:latin typeface="Space Grotesk"/>
+                        </a:rPr>
+                        <a:t>10,000</a:t>
+                      </a:r>
+                    </a:p>
+                  </a:txBody>
+                  <a:tcPr>
+                    <a:solidFill>
+                      <a:srgbClr val="15201C"/>
+                    </a:solidFill>
+                  </a:tcPr>
+                </a:tc>
+                <a:tc>
+                  <a:txBody>
+                    <a:bodyPr/>
+                    <a:lstStyle/>
+                    <a:p>
+                      <a:r>
+                        <a:rPr sz="1100" b="1">
+                          <a:solidFill>
+                            <a:srgbClr val="7FE0B0"/>
+                          </a:solidFill>
+                          <a:latin typeface="Space Grotesk"/>
+                        </a:rPr>
+                        <a:t>100,000</a:t>
                       </a:r>
                     </a:p>
                   </a:txBody>
@@ -24032,7 +24101,7 @@
                   </a:tcPr>
                 </a:tc>
               </a:tr>
-              <a:tr h="441960">
+              <a:tr h="393192">
                 <a:tc>
                   <a:txBody>
                     <a:bodyPr/>
@@ -24045,13 +24114,1085 @@
                           </a:solidFill>
                           <a:latin typeface="Hanken Grotesk"/>
                         </a:rPr>
-                        <a:t>10</a:t>
+                        <a:t>WAF (2 ACLs, fixed + $0.60/M req)</a:t>
                       </a:r>
                     </a:p>
                   </a:txBody>
                   <a:tcPr>
                     <a:solidFill>
                       <a:srgbClr val="FFFFFF"/>
+                    </a:solidFill>
+                  </a:tcPr>
+                </a:tc>
+                <a:tc>
+                  <a:txBody>
+                    <a:bodyPr/>
+                    <a:lstStyle/>
+                    <a:p>
+                      <a:r>
+                        <a:rPr sz="1050" b="0">
+                          <a:solidFill>
+                            <a:srgbClr val="15201C"/>
+                          </a:solidFill>
+                          <a:latin typeface="Hanken Grotesk"/>
+                        </a:rPr>
+                        <a:t>$14</a:t>
+                      </a:r>
+                    </a:p>
+                  </a:txBody>
+                  <a:tcPr>
+                    <a:solidFill>
+                      <a:srgbClr val="FFFFFF"/>
+                    </a:solidFill>
+                  </a:tcPr>
+                </a:tc>
+                <a:tc>
+                  <a:txBody>
+                    <a:bodyPr/>
+                    <a:lstStyle/>
+                    <a:p>
+                      <a:r>
+                        <a:rPr sz="1050" b="0">
+                          <a:solidFill>
+                            <a:srgbClr val="15201C"/>
+                          </a:solidFill>
+                          <a:latin typeface="Hanken Grotesk"/>
+                        </a:rPr>
+                        <a:t>$14</a:t>
+                      </a:r>
+                    </a:p>
+                  </a:txBody>
+                  <a:tcPr>
+                    <a:solidFill>
+                      <a:srgbClr val="FFFFFF"/>
+                    </a:solidFill>
+                  </a:tcPr>
+                </a:tc>
+                <a:tc>
+                  <a:txBody>
+                    <a:bodyPr/>
+                    <a:lstStyle/>
+                    <a:p>
+                      <a:r>
+                        <a:rPr sz="1050" b="0">
+                          <a:solidFill>
+                            <a:srgbClr val="15201C"/>
+                          </a:solidFill>
+                          <a:latin typeface="Hanken Grotesk"/>
+                        </a:rPr>
+                        <a:t>$14</a:t>
+                      </a:r>
+                    </a:p>
+                  </a:txBody>
+                  <a:tcPr>
+                    <a:solidFill>
+                      <a:srgbClr val="FFFFFF"/>
+                    </a:solidFill>
+                  </a:tcPr>
+                </a:tc>
+                <a:tc>
+                  <a:txBody>
+                    <a:bodyPr/>
+                    <a:lstStyle/>
+                    <a:p>
+                      <a:r>
+                        <a:rPr sz="1050" b="0">
+                          <a:solidFill>
+                            <a:srgbClr val="15201C"/>
+                          </a:solidFill>
+                          <a:latin typeface="Hanken Grotesk"/>
+                        </a:rPr>
+                        <a:t>$15</a:t>
+                      </a:r>
+                    </a:p>
+                  </a:txBody>
+                  <a:tcPr>
+                    <a:solidFill>
+                      <a:srgbClr val="FFFFFF"/>
+                    </a:solidFill>
+                  </a:tcPr>
+                </a:tc>
+                <a:tc>
+                  <a:txBody>
+                    <a:bodyPr/>
+                    <a:lstStyle/>
+                    <a:p>
+                      <a:r>
+                        <a:rPr sz="1050" b="0">
+                          <a:solidFill>
+                            <a:srgbClr val="15201C"/>
+                          </a:solidFill>
+                          <a:latin typeface="Hanken Grotesk"/>
+                        </a:rPr>
+                        <a:t>$27</a:t>
+                      </a:r>
+                    </a:p>
+                  </a:txBody>
+                  <a:tcPr>
+                    <a:solidFill>
+                      <a:srgbClr val="FFFFFF"/>
+                    </a:solidFill>
+                  </a:tcPr>
+                </a:tc>
+              </a:tr>
+              <a:tr h="393192">
+                <a:tc>
+                  <a:txBody>
+                    <a:bodyPr/>
+                    <a:lstStyle/>
+                    <a:p>
+                      <a:r>
+                        <a:rPr sz="1050" b="1">
+                          <a:solidFill>
+                            <a:srgbClr val="15201C"/>
+                          </a:solidFill>
+                          <a:latin typeface="Hanken Grotesk"/>
+                        </a:rPr>
+                        <a:t>API Gateway (~$1.2/M)</a:t>
+                      </a:r>
+                    </a:p>
+                  </a:txBody>
+                  <a:tcPr>
+                    <a:solidFill>
+                      <a:srgbClr val="FFFFFF"/>
+                    </a:solidFill>
+                  </a:tcPr>
+                </a:tc>
+                <a:tc>
+                  <a:txBody>
+                    <a:bodyPr/>
+                    <a:lstStyle/>
+                    <a:p>
+                      <a:r>
+                        <a:rPr sz="1050" b="0">
+                          <a:solidFill>
+                            <a:srgbClr val="15201C"/>
+                          </a:solidFill>
+                          <a:latin typeface="Hanken Grotesk"/>
+                        </a:rPr>
+                        <a:t>~$0</a:t>
+                      </a:r>
+                    </a:p>
+                  </a:txBody>
+                  <a:tcPr>
+                    <a:solidFill>
+                      <a:srgbClr val="FFFFFF"/>
+                    </a:solidFill>
+                  </a:tcPr>
+                </a:tc>
+                <a:tc>
+                  <a:txBody>
+                    <a:bodyPr/>
+                    <a:lstStyle/>
+                    <a:p>
+                      <a:r>
+                        <a:rPr sz="1050" b="0">
+                          <a:solidFill>
+                            <a:srgbClr val="15201C"/>
+                          </a:solidFill>
+                          <a:latin typeface="Hanken Grotesk"/>
+                        </a:rPr>
+                        <a:t>~$0</a:t>
+                      </a:r>
+                    </a:p>
+                  </a:txBody>
+                  <a:tcPr>
+                    <a:solidFill>
+                      <a:srgbClr val="FFFFFF"/>
+                    </a:solidFill>
+                  </a:tcPr>
+                </a:tc>
+                <a:tc>
+                  <a:txBody>
+                    <a:bodyPr/>
+                    <a:lstStyle/>
+                    <a:p>
+                      <a:r>
+                        <a:rPr sz="1050" b="0">
+                          <a:solidFill>
+                            <a:srgbClr val="15201C"/>
+                          </a:solidFill>
+                          <a:latin typeface="Hanken Grotesk"/>
+                        </a:rPr>
+                        <a:t>$0.40</a:t>
+                      </a:r>
+                    </a:p>
+                  </a:txBody>
+                  <a:tcPr>
+                    <a:solidFill>
+                      <a:srgbClr val="FFFFFF"/>
+                    </a:solidFill>
+                  </a:tcPr>
+                </a:tc>
+                <a:tc>
+                  <a:txBody>
+                    <a:bodyPr/>
+                    <a:lstStyle/>
+                    <a:p>
+                      <a:r>
+                        <a:rPr sz="1050" b="0">
+                          <a:solidFill>
+                            <a:srgbClr val="15201C"/>
+                          </a:solidFill>
+                          <a:latin typeface="Hanken Grotesk"/>
+                        </a:rPr>
+                        <a:t>$4</a:t>
+                      </a:r>
+                    </a:p>
+                  </a:txBody>
+                  <a:tcPr>
+                    <a:solidFill>
+                      <a:srgbClr val="FFFFFF"/>
+                    </a:solidFill>
+                  </a:tcPr>
+                </a:tc>
+                <a:tc>
+                  <a:txBody>
+                    <a:bodyPr/>
+                    <a:lstStyle/>
+                    <a:p>
+                      <a:r>
+                        <a:rPr sz="1050" b="0">
+                          <a:solidFill>
+                            <a:srgbClr val="15201C"/>
+                          </a:solidFill>
+                          <a:latin typeface="Hanken Grotesk"/>
+                        </a:rPr>
+                        <a:t>$36</a:t>
+                      </a:r>
+                    </a:p>
+                  </a:txBody>
+                  <a:tcPr>
+                    <a:solidFill>
+                      <a:srgbClr val="FFFFFF"/>
+                    </a:solidFill>
+                  </a:tcPr>
+                </a:tc>
+              </a:tr>
+              <a:tr h="393192">
+                <a:tc>
+                  <a:txBody>
+                    <a:bodyPr/>
+                    <a:lstStyle/>
+                    <a:p>
+                      <a:r>
+                        <a:rPr sz="1050" b="1">
+                          <a:solidFill>
+                            <a:srgbClr val="15201C"/>
+                          </a:solidFill>
+                          <a:latin typeface="Hanken Grotesk"/>
+                        </a:rPr>
+                        <a:t>Lambda (256MB arm64)</a:t>
+                      </a:r>
+                    </a:p>
+                  </a:txBody>
+                  <a:tcPr>
+                    <a:solidFill>
+                      <a:srgbClr val="FFFFFF"/>
+                    </a:solidFill>
+                  </a:tcPr>
+                </a:tc>
+                <a:tc>
+                  <a:txBody>
+                    <a:bodyPr/>
+                    <a:lstStyle/>
+                    <a:p>
+                      <a:r>
+                        <a:rPr sz="1050" b="0">
+                          <a:solidFill>
+                            <a:srgbClr val="15201C"/>
+                          </a:solidFill>
+                          <a:latin typeface="Hanken Grotesk"/>
+                        </a:rPr>
+                        <a:t>~$0</a:t>
+                      </a:r>
+                    </a:p>
+                  </a:txBody>
+                  <a:tcPr>
+                    <a:solidFill>
+                      <a:srgbClr val="FFFFFF"/>
+                    </a:solidFill>
+                  </a:tcPr>
+                </a:tc>
+                <a:tc>
+                  <a:txBody>
+                    <a:bodyPr/>
+                    <a:lstStyle/>
+                    <a:p>
+                      <a:r>
+                        <a:rPr sz="1050" b="0">
+                          <a:solidFill>
+                            <a:srgbClr val="15201C"/>
+                          </a:solidFill>
+                          <a:latin typeface="Hanken Grotesk"/>
+                        </a:rPr>
+                        <a:t>~$0</a:t>
+                      </a:r>
+                    </a:p>
+                  </a:txBody>
+                  <a:tcPr>
+                    <a:solidFill>
+                      <a:srgbClr val="FFFFFF"/>
+                    </a:solidFill>
+                  </a:tcPr>
+                </a:tc>
+                <a:tc>
+                  <a:txBody>
+                    <a:bodyPr/>
+                    <a:lstStyle/>
+                    <a:p>
+                      <a:r>
+                        <a:rPr sz="1050" b="0">
+                          <a:solidFill>
+                            <a:srgbClr val="15201C"/>
+                          </a:solidFill>
+                          <a:latin typeface="Hanken Grotesk"/>
+                        </a:rPr>
+                        <a:t>$0.20</a:t>
+                      </a:r>
+                    </a:p>
+                  </a:txBody>
+                  <a:tcPr>
+                    <a:solidFill>
+                      <a:srgbClr val="FFFFFF"/>
+                    </a:solidFill>
+                  </a:tcPr>
+                </a:tc>
+                <a:tc>
+                  <a:txBody>
+                    <a:bodyPr/>
+                    <a:lstStyle/>
+                    <a:p>
+                      <a:r>
+                        <a:rPr sz="1050" b="0">
+                          <a:solidFill>
+                            <a:srgbClr val="15201C"/>
+                          </a:solidFill>
+                          <a:latin typeface="Hanken Grotesk"/>
+                        </a:rPr>
+                        <a:t>$2</a:t>
+                      </a:r>
+                    </a:p>
+                  </a:txBody>
+                  <a:tcPr>
+                    <a:solidFill>
+                      <a:srgbClr val="FFFFFF"/>
+                    </a:solidFill>
+                  </a:tcPr>
+                </a:tc>
+                <a:tc>
+                  <a:txBody>
+                    <a:bodyPr/>
+                    <a:lstStyle/>
+                    <a:p>
+                      <a:r>
+                        <a:rPr sz="1050" b="0">
+                          <a:solidFill>
+                            <a:srgbClr val="15201C"/>
+                          </a:solidFill>
+                          <a:latin typeface="Hanken Grotesk"/>
+                        </a:rPr>
+                        <a:t>$18</a:t>
+                      </a:r>
+                    </a:p>
+                  </a:txBody>
+                  <a:tcPr>
+                    <a:solidFill>
+                      <a:srgbClr val="FFFFFF"/>
+                    </a:solidFill>
+                  </a:tcPr>
+                </a:tc>
+              </a:tr>
+              <a:tr h="393192">
+                <a:tc>
+                  <a:txBody>
+                    <a:bodyPr/>
+                    <a:lstStyle/>
+                    <a:p>
+                      <a:r>
+                        <a:rPr sz="1050" b="1">
+                          <a:solidFill>
+                            <a:srgbClr val="15201C"/>
+                          </a:solidFill>
+                          <a:latin typeface="Hanken Grotesk"/>
+                        </a:rPr>
+                        <a:t>DynamoDB on-demand</a:t>
+                      </a:r>
+                    </a:p>
+                  </a:txBody>
+                  <a:tcPr>
+                    <a:solidFill>
+                      <a:srgbClr val="FFFFFF"/>
+                    </a:solidFill>
+                  </a:tcPr>
+                </a:tc>
+                <a:tc>
+                  <a:txBody>
+                    <a:bodyPr/>
+                    <a:lstStyle/>
+                    <a:p>
+                      <a:r>
+                        <a:rPr sz="1050" b="0">
+                          <a:solidFill>
+                            <a:srgbClr val="15201C"/>
+                          </a:solidFill>
+                          <a:latin typeface="Hanken Grotesk"/>
+                        </a:rPr>
+                        <a:t>~$0</a:t>
+                      </a:r>
+                    </a:p>
+                  </a:txBody>
+                  <a:tcPr>
+                    <a:solidFill>
+                      <a:srgbClr val="FFFFFF"/>
+                    </a:solidFill>
+                  </a:tcPr>
+                </a:tc>
+                <a:tc>
+                  <a:txBody>
+                    <a:bodyPr/>
+                    <a:lstStyle/>
+                    <a:p>
+                      <a:r>
+                        <a:rPr sz="1050" b="0">
+                          <a:solidFill>
+                            <a:srgbClr val="15201C"/>
+                          </a:solidFill>
+                          <a:latin typeface="Hanken Grotesk"/>
+                        </a:rPr>
+                        <a:t>~$0</a:t>
+                      </a:r>
+                    </a:p>
+                  </a:txBody>
+                  <a:tcPr>
+                    <a:solidFill>
+                      <a:srgbClr val="FFFFFF"/>
+                    </a:solidFill>
+                  </a:tcPr>
+                </a:tc>
+                <a:tc>
+                  <a:txBody>
+                    <a:bodyPr/>
+                    <a:lstStyle/>
+                    <a:p>
+                      <a:r>
+                        <a:rPr sz="1050" b="0">
+                          <a:solidFill>
+                            <a:srgbClr val="15201C"/>
+                          </a:solidFill>
+                          <a:latin typeface="Hanken Grotesk"/>
+                        </a:rPr>
+                        <a:t>$0.40</a:t>
+                      </a:r>
+                    </a:p>
+                  </a:txBody>
+                  <a:tcPr>
+                    <a:solidFill>
+                      <a:srgbClr val="FFFFFF"/>
+                    </a:solidFill>
+                  </a:tcPr>
+                </a:tc>
+                <a:tc>
+                  <a:txBody>
+                    <a:bodyPr/>
+                    <a:lstStyle/>
+                    <a:p>
+                      <a:r>
+                        <a:rPr sz="1050" b="0">
+                          <a:solidFill>
+                            <a:srgbClr val="15201C"/>
+                          </a:solidFill>
+                          <a:latin typeface="Hanken Grotesk"/>
+                        </a:rPr>
+                        <a:t>$4</a:t>
+                      </a:r>
+                    </a:p>
+                  </a:txBody>
+                  <a:tcPr>
+                    <a:solidFill>
+                      <a:srgbClr val="FFFFFF"/>
+                    </a:solidFill>
+                  </a:tcPr>
+                </a:tc>
+                <a:tc>
+                  <a:txBody>
+                    <a:bodyPr/>
+                    <a:lstStyle/>
+                    <a:p>
+                      <a:r>
+                        <a:rPr sz="1050" b="0">
+                          <a:solidFill>
+                            <a:srgbClr val="15201C"/>
+                          </a:solidFill>
+                          <a:latin typeface="Hanken Grotesk"/>
+                        </a:rPr>
+                        <a:t>$40</a:t>
+                      </a:r>
+                    </a:p>
+                  </a:txBody>
+                  <a:tcPr>
+                    <a:solidFill>
+                      <a:srgbClr val="FFFFFF"/>
+                    </a:solidFill>
+                  </a:tcPr>
+                </a:tc>
+              </a:tr>
+              <a:tr h="393192">
+                <a:tc>
+                  <a:txBody>
+                    <a:bodyPr/>
+                    <a:lstStyle/>
+                    <a:p>
+                      <a:r>
+                        <a:rPr sz="1050" b="1">
+                          <a:solidFill>
+                            <a:srgbClr val="15201C"/>
+                          </a:solidFill>
+                          <a:latin typeface="Hanken Grotesk"/>
+                        </a:rPr>
+                        <a:t>Aurora (compute + storage)</a:t>
+                      </a:r>
+                    </a:p>
+                  </a:txBody>
+                  <a:tcPr>
+                    <a:solidFill>
+                      <a:srgbClr val="FFFFFF"/>
+                    </a:solidFill>
+                  </a:tcPr>
+                </a:tc>
+                <a:tc>
+                  <a:txBody>
+                    <a:bodyPr/>
+                    <a:lstStyle/>
+                    <a:p>
+                      <a:r>
+                        <a:rPr sz="1050" b="0">
+                          <a:solidFill>
+                            <a:srgbClr val="15201C"/>
+                          </a:solidFill>
+                          <a:latin typeface="Hanken Grotesk"/>
+                        </a:rPr>
+                        <a:t>~$3</a:t>
+                      </a:r>
+                    </a:p>
+                  </a:txBody>
+                  <a:tcPr>
+                    <a:solidFill>
+                      <a:srgbClr val="FFFFFF"/>
+                    </a:solidFill>
+                  </a:tcPr>
+                </a:tc>
+                <a:tc>
+                  <a:txBody>
+                    <a:bodyPr/>
+                    <a:lstStyle/>
+                    <a:p>
+                      <a:r>
+                        <a:rPr sz="1050" b="0">
+                          <a:solidFill>
+                            <a:srgbClr val="15201C"/>
+                          </a:solidFill>
+                          <a:latin typeface="Hanken Grotesk"/>
+                        </a:rPr>
+                        <a:t>~$8</a:t>
+                      </a:r>
+                    </a:p>
+                  </a:txBody>
+                  <a:tcPr>
+                    <a:solidFill>
+                      <a:srgbClr val="FFFFFF"/>
+                    </a:solidFill>
+                  </a:tcPr>
+                </a:tc>
+                <a:tc>
+                  <a:txBody>
+                    <a:bodyPr/>
+                    <a:lstStyle/>
+                    <a:p>
+                      <a:r>
+                        <a:rPr sz="1050" b="0">
+                          <a:solidFill>
+                            <a:srgbClr val="15201C"/>
+                          </a:solidFill>
+                          <a:latin typeface="Hanken Grotesk"/>
+                        </a:rPr>
+                        <a:t>~$45</a:t>
+                      </a:r>
+                    </a:p>
+                  </a:txBody>
+                  <a:tcPr>
+                    <a:solidFill>
+                      <a:srgbClr val="FFFFFF"/>
+                    </a:solidFill>
+                  </a:tcPr>
+                </a:tc>
+                <a:tc>
+                  <a:txBody>
+                    <a:bodyPr/>
+                    <a:lstStyle/>
+                    <a:p>
+                      <a:r>
+                        <a:rPr sz="1050" b="0">
+                          <a:solidFill>
+                            <a:srgbClr val="15201C"/>
+                          </a:solidFill>
+                          <a:latin typeface="Hanken Grotesk"/>
+                        </a:rPr>
+                        <a:t>~$80</a:t>
+                      </a:r>
+                    </a:p>
+                  </a:txBody>
+                  <a:tcPr>
+                    <a:solidFill>
+                      <a:srgbClr val="FFFFFF"/>
+                    </a:solidFill>
+                  </a:tcPr>
+                </a:tc>
+                <a:tc>
+                  <a:txBody>
+                    <a:bodyPr/>
+                    <a:lstStyle/>
+                    <a:p>
+                      <a:r>
+                        <a:rPr sz="1050" b="0">
+                          <a:solidFill>
+                            <a:srgbClr val="15201C"/>
+                          </a:solidFill>
+                          <a:latin typeface="Hanken Grotesk"/>
+                        </a:rPr>
+                        <a:t>~$220</a:t>
+                      </a:r>
+                    </a:p>
+                  </a:txBody>
+                  <a:tcPr>
+                    <a:solidFill>
+                      <a:srgbClr val="FFFFFF"/>
+                    </a:solidFill>
+                  </a:tcPr>
+                </a:tc>
+              </a:tr>
+              <a:tr h="393192">
+                <a:tc>
+                  <a:txBody>
+                    <a:bodyPr/>
+                    <a:lstStyle/>
+                    <a:p>
+                      <a:r>
+                        <a:rPr sz="1050" b="1">
+                          <a:solidFill>
+                            <a:srgbClr val="15201C"/>
+                          </a:solidFill>
+                          <a:latin typeface="Hanken Grotesk"/>
+                        </a:rPr>
+                        <a:t>RDS Proxy (8-ACU minimum)</a:t>
+                      </a:r>
+                    </a:p>
+                  </a:txBody>
+                  <a:tcPr>
+                    <a:solidFill>
+                      <a:srgbClr val="FFFFFF"/>
+                    </a:solidFill>
+                  </a:tcPr>
+                </a:tc>
+                <a:tc>
+                  <a:txBody>
+                    <a:bodyPr/>
+                    <a:lstStyle/>
+                    <a:p>
+                      <a:r>
+                        <a:rPr sz="1050" b="0">
+                          <a:solidFill>
+                            <a:srgbClr val="15201C"/>
+                          </a:solidFill>
+                          <a:latin typeface="Hanken Grotesk"/>
+                        </a:rPr>
+                        <a:t>—</a:t>
+                      </a:r>
+                    </a:p>
+                  </a:txBody>
+                  <a:tcPr>
+                    <a:solidFill>
+                      <a:srgbClr val="FFFFFF"/>
+                    </a:solidFill>
+                  </a:tcPr>
+                </a:tc>
+                <a:tc>
+                  <a:txBody>
+                    <a:bodyPr/>
+                    <a:lstStyle/>
+                    <a:p>
+                      <a:r>
+                        <a:rPr sz="1050" b="0">
+                          <a:solidFill>
+                            <a:srgbClr val="15201C"/>
+                          </a:solidFill>
+                          <a:latin typeface="Hanken Grotesk"/>
+                        </a:rPr>
+                        <a:t>—</a:t>
+                      </a:r>
+                    </a:p>
+                  </a:txBody>
+                  <a:tcPr>
+                    <a:solidFill>
+                      <a:srgbClr val="FFFFFF"/>
+                    </a:solidFill>
+                  </a:tcPr>
+                </a:tc>
+                <a:tc>
+                  <a:txBody>
+                    <a:bodyPr/>
+                    <a:lstStyle/>
+                    <a:p>
+                      <a:r>
+                        <a:rPr sz="1050" b="0">
+                          <a:solidFill>
+                            <a:srgbClr val="15201C"/>
+                          </a:solidFill>
+                          <a:latin typeface="Hanken Grotesk"/>
+                        </a:rPr>
+                        <a:t>—</a:t>
+                      </a:r>
+                    </a:p>
+                  </a:txBody>
+                  <a:tcPr>
+                    <a:solidFill>
+                      <a:srgbClr val="FFFFFF"/>
+                    </a:solidFill>
+                  </a:tcPr>
+                </a:tc>
+                <a:tc>
+                  <a:txBody>
+                    <a:bodyPr/>
+                    <a:lstStyle/>
+                    <a:p>
+                      <a:r>
+                        <a:rPr sz="1050" b="0">
+                          <a:solidFill>
+                            <a:srgbClr val="15201C"/>
+                          </a:solidFill>
+                          <a:latin typeface="Hanken Grotesk"/>
+                        </a:rPr>
+                        <a:t>~$100</a:t>
+                      </a:r>
+                    </a:p>
+                  </a:txBody>
+                  <a:tcPr>
+                    <a:solidFill>
+                      <a:srgbClr val="FFFFFF"/>
+                    </a:solidFill>
+                  </a:tcPr>
+                </a:tc>
+                <a:tc>
+                  <a:txBody>
+                    <a:bodyPr/>
+                    <a:lstStyle/>
+                    <a:p>
+                      <a:r>
+                        <a:rPr sz="1050" b="0">
+                          <a:solidFill>
+                            <a:srgbClr val="15201C"/>
+                          </a:solidFill>
+                          <a:latin typeface="Hanken Grotesk"/>
+                        </a:rPr>
+                        <a:t>~$100</a:t>
+                      </a:r>
+                    </a:p>
+                  </a:txBody>
+                  <a:tcPr>
+                    <a:solidFill>
+                      <a:srgbClr val="FFFFFF"/>
+                    </a:solidFill>
+                  </a:tcPr>
+                </a:tc>
+              </a:tr>
+              <a:tr h="393192">
+                <a:tc>
+                  <a:txBody>
+                    <a:bodyPr/>
+                    <a:lstStyle/>
+                    <a:p>
+                      <a:r>
+                        <a:rPr sz="1050" b="1">
+                          <a:solidFill>
+                            <a:srgbClr val="15201C"/>
+                          </a:solidFill>
+                          <a:latin typeface="Hanken Grotesk"/>
+                        </a:rPr>
+                        <a:t>Cognito ($0.015/MAU after 10k free)</a:t>
+                      </a:r>
+                    </a:p>
+                  </a:txBody>
+                  <a:tcPr>
+                    <a:solidFill>
+                      <a:srgbClr val="FFFFFF"/>
+                    </a:solidFill>
+                  </a:tcPr>
+                </a:tc>
+                <a:tc>
+                  <a:txBody>
+                    <a:bodyPr/>
+                    <a:lstStyle/>
+                    <a:p>
+                      <a:r>
+                        <a:rPr sz="1050" b="0">
+                          <a:solidFill>
+                            <a:srgbClr val="15201C"/>
+                          </a:solidFill>
+                          <a:latin typeface="Hanken Grotesk"/>
+                        </a:rPr>
+                        <a:t>$0</a:t>
+                      </a:r>
+                    </a:p>
+                  </a:txBody>
+                  <a:tcPr>
+                    <a:solidFill>
+                      <a:srgbClr val="FFFFFF"/>
+                    </a:solidFill>
+                  </a:tcPr>
+                </a:tc>
+                <a:tc>
+                  <a:txBody>
+                    <a:bodyPr/>
+                    <a:lstStyle/>
+                    <a:p>
+                      <a:r>
+                        <a:rPr sz="1050" b="0">
+                          <a:solidFill>
+                            <a:srgbClr val="15201C"/>
+                          </a:solidFill>
+                          <a:latin typeface="Hanken Grotesk"/>
+                        </a:rPr>
+                        <a:t>$0</a:t>
+                      </a:r>
+                    </a:p>
+                  </a:txBody>
+                  <a:tcPr>
+                    <a:solidFill>
+                      <a:srgbClr val="FFFFFF"/>
+                    </a:solidFill>
+                  </a:tcPr>
+                </a:tc>
+                <a:tc>
+                  <a:txBody>
+                    <a:bodyPr/>
+                    <a:lstStyle/>
+                    <a:p>
+                      <a:r>
+                        <a:rPr sz="1050" b="0">
+                          <a:solidFill>
+                            <a:srgbClr val="15201C"/>
+                          </a:solidFill>
+                          <a:latin typeface="Hanken Grotesk"/>
+                        </a:rPr>
+                        <a:t>$0</a:t>
+                      </a:r>
+                    </a:p>
+                  </a:txBody>
+                  <a:tcPr>
+                    <a:solidFill>
+                      <a:srgbClr val="FFFFFF"/>
+                    </a:solidFill>
+                  </a:tcPr>
+                </a:tc>
+                <a:tc>
+                  <a:txBody>
+                    <a:bodyPr/>
+                    <a:lstStyle/>
+                    <a:p>
+                      <a:r>
+                        <a:rPr sz="1050" b="0">
+                          <a:solidFill>
+                            <a:srgbClr val="15201C"/>
+                          </a:solidFill>
+                          <a:latin typeface="Hanken Grotesk"/>
+                        </a:rPr>
+                        <a:t>$0</a:t>
+                      </a:r>
+                    </a:p>
+                  </a:txBody>
+                  <a:tcPr>
+                    <a:solidFill>
+                      <a:srgbClr val="FFFFFF"/>
+                    </a:solidFill>
+                  </a:tcPr>
+                </a:tc>
+                <a:tc>
+                  <a:txBody>
+                    <a:bodyPr/>
+                    <a:lstStyle/>
+                    <a:p>
+                      <a:r>
+                        <a:rPr sz="1050" b="0">
+                          <a:solidFill>
+                            <a:srgbClr val="15201C"/>
+                          </a:solidFill>
+                          <a:latin typeface="Hanken Grotesk"/>
+                        </a:rPr>
+                        <a:t>$1,350</a:t>
+                      </a:r>
+                    </a:p>
+                  </a:txBody>
+                  <a:tcPr>
+                    <a:solidFill>
+                      <a:srgbClr val="FFFFFF"/>
+                    </a:solidFill>
+                  </a:tcPr>
+                </a:tc>
+              </a:tr>
+              <a:tr h="393192">
+                <a:tc>
+                  <a:txBody>
+                    <a:bodyPr/>
+                    <a:lstStyle/>
+                    <a:p>
+                      <a:r>
+                        <a:rPr sz="1050" b="1">
+                          <a:solidFill>
+                            <a:srgbClr val="15201C"/>
+                          </a:solidFill>
+                          <a:latin typeface="Hanken Grotesk"/>
+                        </a:rPr>
+                        <a:t>CloudFront + misc</a:t>
+                      </a:r>
+                    </a:p>
+                  </a:txBody>
+                  <a:tcPr>
+                    <a:solidFill>
+                      <a:srgbClr val="FFFFFF"/>
+                    </a:solidFill>
+                  </a:tcPr>
+                </a:tc>
+                <a:tc>
+                  <a:txBody>
+                    <a:bodyPr/>
+                    <a:lstStyle/>
+                    <a:p>
+                      <a:r>
+                        <a:rPr sz="1050" b="0">
+                          <a:solidFill>
+                            <a:srgbClr val="15201C"/>
+                          </a:solidFill>
+                          <a:latin typeface="Hanken Grotesk"/>
+                        </a:rPr>
+                        <a:t>~$3</a:t>
+                      </a:r>
+                    </a:p>
+                  </a:txBody>
+                  <a:tcPr>
+                    <a:solidFill>
+                      <a:srgbClr val="FFFFFF"/>
+                    </a:solidFill>
+                  </a:tcPr>
+                </a:tc>
+                <a:tc>
+                  <a:txBody>
+                    <a:bodyPr/>
+                    <a:lstStyle/>
+                    <a:p>
+                      <a:r>
+                        <a:rPr sz="1050" b="0">
+                          <a:solidFill>
+                            <a:srgbClr val="15201C"/>
+                          </a:solidFill>
+                          <a:latin typeface="Hanken Grotesk"/>
+                        </a:rPr>
+                        <a:t>~$3</a:t>
+                      </a:r>
+                    </a:p>
+                  </a:txBody>
+                  <a:tcPr>
+                    <a:solidFill>
+                      <a:srgbClr val="FFFFFF"/>
+                    </a:solidFill>
+                  </a:tcPr>
+                </a:tc>
+                <a:tc>
+                  <a:txBody>
+                    <a:bodyPr/>
+                    <a:lstStyle/>
+                    <a:p>
+                      <a:r>
+                        <a:rPr sz="1050" b="0">
+                          <a:solidFill>
+                            <a:srgbClr val="15201C"/>
+                          </a:solidFill>
+                          <a:latin typeface="Hanken Grotesk"/>
+                        </a:rPr>
+                        <a:t>~$5</a:t>
+                      </a:r>
+                    </a:p>
+                  </a:txBody>
+                  <a:tcPr>
+                    <a:solidFill>
+                      <a:srgbClr val="FFFFFF"/>
+                    </a:solidFill>
+                  </a:tcPr>
+                </a:tc>
+                <a:tc>
+                  <a:txBody>
+                    <a:bodyPr/>
+                    <a:lstStyle/>
+                    <a:p>
+                      <a:r>
+                        <a:rPr sz="1050" b="0">
+                          <a:solidFill>
+                            <a:srgbClr val="15201C"/>
+                          </a:solidFill>
+                          <a:latin typeface="Hanken Grotesk"/>
+                        </a:rPr>
+                        <a:t>~$12</a:t>
+                      </a:r>
+                    </a:p>
+                  </a:txBody>
+                  <a:tcPr>
+                    <a:solidFill>
+                      <a:srgbClr val="FFFFFF"/>
+                    </a:solidFill>
+                  </a:tcPr>
+                </a:tc>
+                <a:tc>
+                  <a:txBody>
+                    <a:bodyPr/>
+                    <a:lstStyle/>
+                    <a:p>
+                      <a:r>
+                        <a:rPr sz="1050" b="0">
+                          <a:solidFill>
+                            <a:srgbClr val="15201C"/>
+                          </a:solidFill>
+                          <a:latin typeface="Hanken Grotesk"/>
+                        </a:rPr>
+                        <a:t>~$42</a:t>
+                      </a:r>
+                    </a:p>
+                  </a:txBody>
+                  <a:tcPr>
+                    <a:solidFill>
+                      <a:srgbClr val="FFFFFF"/>
+                    </a:solidFill>
+                  </a:tcPr>
+                </a:tc>
+              </a:tr>
+              <a:tr h="393192">
+                <a:tc>
+                  <a:txBody>
+                    <a:bodyPr/>
+                    <a:lstStyle/>
+                    <a:p>
+                      <a:r>
+                        <a:rPr sz="1050" b="1">
+                          <a:solidFill>
+                            <a:srgbClr val="15201C"/>
+                          </a:solidFill>
+                          <a:latin typeface="Hanken Grotesk"/>
+                        </a:rPr>
+                        <a:t>Total</a:t>
+                      </a:r>
+                    </a:p>
+                  </a:txBody>
+                  <a:tcPr>
+                    <a:solidFill>
+                      <a:srgbClr val="EAF5EF"/>
                     </a:solidFill>
                   </a:tcPr>
                 </a:tc>
@@ -24073,7 +25214,7 @@
                   </a:txBody>
                   <a:tcPr>
                     <a:solidFill>
-                      <a:srgbClr val="FFFFFF"/>
+                      <a:srgbClr val="EAF5EF"/>
                     </a:solidFill>
                   </a:tcPr>
                 </a:tc>
@@ -24089,37 +25230,13 @@
                           </a:solidFill>
                           <a:latin typeface="Hanken Grotesk"/>
                         </a:rPr>
-                        <a:t>the fixed floor (WAF $14 + Aurora storage)</a:t>
+                        <a:t>~$25</a:t>
                       </a:r>
                     </a:p>
                   </a:txBody>
                   <a:tcPr>
                     <a:solidFill>
-                      <a:srgbClr val="FFFFFF"/>
-                    </a:solidFill>
-                  </a:tcPr>
-                </a:tc>
-              </a:tr>
-              <a:tr h="441960">
-                <a:tc>
-                  <a:txBody>
-                    <a:bodyPr/>
-                    <a:lstStyle/>
-                    <a:p>
-                      <a:r>
-                        <a:rPr sz="1050" b="1">
-                          <a:solidFill>
-                            <a:srgbClr val="15201C"/>
-                          </a:solidFill>
-                          <a:latin typeface="Hanken Grotesk"/>
-                        </a:rPr>
-                        <a:t>1,000</a:t>
-                      </a:r>
-                    </a:p>
-                  </a:txBody>
-                  <a:tcPr>
-                    <a:solidFill>
-                      <a:srgbClr val="FFFFFF"/>
+                      <a:srgbClr val="EAF5EF"/>
                     </a:solidFill>
                   </a:tcPr>
                 </a:tc>
@@ -24135,13 +25252,13 @@
                           </a:solidFill>
                           <a:latin typeface="Hanken Grotesk"/>
                         </a:rPr>
-                        <a:t>~$55-75</a:t>
+                        <a:t>~$65</a:t>
                       </a:r>
                     </a:p>
                   </a:txBody>
                   <a:tcPr>
                     <a:solidFill>
-                      <a:srgbClr val="FFFFFF"/>
+                      <a:srgbClr val="EAF5EF"/>
                     </a:solidFill>
                   </a:tcPr>
                 </a:tc>
@@ -24157,37 +25274,13 @@
                           </a:solidFill>
                           <a:latin typeface="Hanken Grotesk"/>
                         </a:rPr>
-                        <a:t>Aurora stops scaling to zero (~$35-55)</a:t>
+                        <a:t>~$215</a:t>
                       </a:r>
                     </a:p>
                   </a:txBody>
                   <a:tcPr>
                     <a:solidFill>
-                      <a:srgbClr val="FFFFFF"/>
-                    </a:solidFill>
-                  </a:tcPr>
-                </a:tc>
-              </a:tr>
-              <a:tr h="441960">
-                <a:tc>
-                  <a:txBody>
-                    <a:bodyPr/>
-                    <a:lstStyle/>
-                    <a:p>
-                      <a:r>
-                        <a:rPr sz="1050" b="1">
-                          <a:solidFill>
-                            <a:srgbClr val="15201C"/>
-                          </a:solidFill>
-                          <a:latin typeface="Hanken Grotesk"/>
-                        </a:rPr>
-                        <a:t>10,000</a:t>
-                      </a:r>
-                    </a:p>
-                  </a:txBody>
-                  <a:tcPr>
-                    <a:solidFill>
-                      <a:srgbClr val="FFFFFF"/>
+                      <a:srgbClr val="EAF5EF"/>
                     </a:solidFill>
                   </a:tcPr>
                 </a:tc>
@@ -24203,171 +25296,13 @@
                           </a:solidFill>
                           <a:latin typeface="Hanken Grotesk"/>
                         </a:rPr>
-                        <a:t>~$90-150</a:t>
+                        <a:t>~$1,835</a:t>
                       </a:r>
                     </a:p>
                   </a:txBody>
                   <a:tcPr>
                     <a:solidFill>
-                      <a:srgbClr val="FFFFFF"/>
-                    </a:solidFill>
-                  </a:tcPr>
-                </a:tc>
-                <a:tc>
-                  <a:txBody>
-                    <a:bodyPr/>
-                    <a:lstStyle/>
-                    <a:p>
-                      <a:r>
-                        <a:rPr sz="1050" b="1">
-                          <a:solidFill>
-                            <a:srgbClr val="15201C"/>
-                          </a:solidFill>
-                          <a:latin typeface="Hanken Grotesk"/>
-                        </a:rPr>
-                        <a:t>still inside the Cognito free tier (10k MAU)</a:t>
-                      </a:r>
-                    </a:p>
-                  </a:txBody>
-                  <a:tcPr>
-                    <a:solidFill>
-                      <a:srgbClr val="FFFFFF"/>
-                    </a:solidFill>
-                  </a:tcPr>
-                </a:tc>
-              </a:tr>
-              <a:tr h="441960">
-                <a:tc>
-                  <a:txBody>
-                    <a:bodyPr/>
-                    <a:lstStyle/>
-                    <a:p>
-                      <a:r>
-                        <a:rPr sz="1050" b="1">
-                          <a:solidFill>
-                            <a:srgbClr val="15201C"/>
-                          </a:solidFill>
-                          <a:latin typeface="Hanken Grotesk"/>
-                        </a:rPr>
-                        <a:t>10,000 + RDS Proxy</a:t>
-                      </a:r>
-                    </a:p>
-                  </a:txBody>
-                  <a:tcPr>
-                    <a:solidFill>
-                      <a:srgbClr val="FFFFFF"/>
-                    </a:solidFill>
-                  </a:tcPr>
-                </a:tc>
-                <a:tc>
-                  <a:txBody>
-                    <a:bodyPr/>
-                    <a:lstStyle/>
-                    <a:p>
-                      <a:r>
-                        <a:rPr sz="1050" b="1">
-                          <a:solidFill>
-                            <a:srgbClr val="15201C"/>
-                          </a:solidFill>
-                          <a:latin typeface="Hanken Grotesk"/>
-                        </a:rPr>
-                        <a:t>~$190-250</a:t>
-                      </a:r>
-                    </a:p>
-                  </a:txBody>
-                  <a:tcPr>
-                    <a:solidFill>
-                      <a:srgbClr val="FFFFFF"/>
-                    </a:solidFill>
-                  </a:tcPr>
-                </a:tc>
-                <a:tc>
-                  <a:txBody>
-                    <a:bodyPr/>
-                    <a:lstStyle/>
-                    <a:p>
-                      <a:r>
-                        <a:rPr sz="1050" b="1">
-                          <a:solidFill>
-                            <a:srgbClr val="15201C"/>
-                          </a:solidFill>
-                          <a:latin typeface="Hanken Grotesk"/>
-                        </a:rPr>
-                        <a:t>proxy 8-ACU minimum = ~$100/month FLAT</a:t>
-                      </a:r>
-                    </a:p>
-                  </a:txBody>
-                  <a:tcPr>
-                    <a:solidFill>
-                      <a:srgbClr val="FFFFFF"/>
-                    </a:solidFill>
-                  </a:tcPr>
-                </a:tc>
-              </a:tr>
-              <a:tr h="441960">
-                <a:tc>
-                  <a:txBody>
-                    <a:bodyPr/>
-                    <a:lstStyle/>
-                    <a:p>
-                      <a:r>
-                        <a:rPr sz="1050" b="1">
-                          <a:solidFill>
-                            <a:srgbClr val="15201C"/>
-                          </a:solidFill>
-                          <a:latin typeface="Hanken Grotesk"/>
-                        </a:rPr>
-                        <a:t>100,000</a:t>
-                      </a:r>
-                    </a:p>
-                  </a:txBody>
-                  <a:tcPr>
-                    <a:solidFill>
-                      <a:srgbClr val="FFFFFF"/>
-                    </a:solidFill>
-                  </a:tcPr>
-                </a:tc>
-                <a:tc>
-                  <a:txBody>
-                    <a:bodyPr/>
-                    <a:lstStyle/>
-                    <a:p>
-                      <a:r>
-                        <a:rPr sz="1050" b="1">
-                          <a:solidFill>
-                            <a:srgbClr val="15201C"/>
-                          </a:solidFill>
-                          <a:latin typeface="Hanken Grotesk"/>
-                        </a:rPr>
-                        <a:t>~$1,730</a:t>
-                      </a:r>
-                    </a:p>
-                  </a:txBody>
-                  <a:tcPr>
-                    <a:solidFill>
-                      <a:srgbClr val="FFFFFF"/>
-                    </a:solidFill>
-                  </a:tcPr>
-                </a:tc>
-                <a:tc>
-                  <a:txBody>
-                    <a:bodyPr/>
-                    <a:lstStyle/>
-                    <a:p>
-                      <a:r>
-                        <a:rPr sz="1050" b="1">
-                          <a:solidFill>
-                            <a:srgbClr val="15201C"/>
-                          </a:solidFill>
-                          <a:latin typeface="Hanken Grotesk"/>
-                        </a:rPr>
-                        <a:t>Cognito MAU $1,350 = 78% of the bill</a:t>
-                      </a:r>
-                    </a:p>
-                  </a:txBody>
-                  <a:tcPr>
-                    <a:solidFill>
-                      <a:srgbClr val="FFFFFF"/>
+                      <a:srgbClr val="EAF5EF"/>
                     </a:solidFill>
                   </a:tcPr>
                 </a:tc>
@@ -24384,8 +25319,8 @@
         </p:nvSpPr>
         <p:spPr>
           <a:xfrm>
-            <a:off x="658368" y="4572000"/>
-            <a:ext cx="10881360" cy="1737360"/>
+            <a:off x="658368" y="5623560"/>
+            <a:ext cx="10881360" cy="731520"/>
           </a:xfrm>
           <a:prstGeom prst="rect">
             <a:avLst/>
@@ -24399,35 +25334,24 @@
           <a:lstStyle/>
           <a:p>
             <a:r>
-              <a:rPr sz="1150" b="0">
+              <a:rPr sz="1100">
                 <a:solidFill>
                   <a:srgbClr val="6B7B73"/>
                 </a:solidFill>
                 <a:latin typeface="Hanken Grotesk"/>
               </a:rPr>
-              <a:t>Assumptions: 10 operations/user/day (wallet refresh, create recommendation), ~70/30 read-write, il-central-1 approximate prices, prod only; every active user = 1 Cognito MAU.</a:t>
-            </a:r>
-          </a:p>
-          <a:p>
-            <a:r>
-              <a:rPr sz="1150" b="0">
+              <a:t>Assumptions: 10 operations/user/day, ~70/30 read-write, il-central-1 approximate prices, prod only; every active user = 1 Cognito MAU; RDS Proxy included from 10k users.</a:t>
+            </a:r>
+          </a:p>
+          <a:p>
+            <a:r>
+              <a:rPr sz="1100">
                 <a:solidFill>
                   <a:srgbClr val="6B7B73"/>
                 </a:solidFill>
                 <a:latin typeface="Hanken Grotesk"/>
               </a:rPr>
-              <a:t>Two step functions, then linear: Aurora stops sleeping (~1k users); the Cognito free tier ends at exactly 10k MAU ($0.015/MAU after). Per-user at 100k: ~$0.017/month.</a:t>
-            </a:r>
-          </a:p>
-          <a:p>
-            <a:r>
-              <a:rPr sz="1150" b="0">
-                <a:solidFill>
-                  <a:srgbClr val="6B7B73"/>
-                </a:solidFill>
-                <a:latin typeface="Hanken Grotesk"/>
-              </a:rPr>
-              <a:t>Breaks BEFORE the bill: account concurrency 10 (~10k users, peaks) - AliExpress rate limits (ADR-0021) - Aurora 50 connections post-quota-raise (only THEN the proxy) - the 2-ACU max.</a:t>
+              <a:t>Two step functions, then linear: Aurora stops sleeping (~1k users); the Cognito free tier ends at exactly 10k MAU. Per-user at 100k: ~$0.018/month.</a:t>
             </a:r>
           </a:p>
         </p:txBody>

</xml_diff>

<commit_message>
slides: B17 becomes the full cost matrix (service rows x 10..100k user columns) (#206)
10 / 100 / 1,000 / 10,000 / 100,000 active-user columns, per-service rows,
total at the bottom; RDS Proxy included at 10k and 100k (8-ACU minimum,
~$100/month flat). Same numbers as the in-session analysis, 100-user tier
interpolated with the same assumptions.


Claude-Session: https://claude.ai/code/session_01FECrSGSMqWYxFMSwWq9E5s

Co-authored-by: Claude Fable 5 <noreply@anthropic.com>
</commit_message>
<xml_diff>
--- a/slides/wanthat-presentation.pptx
+++ b/slides/wanthat-presentation.pptx
@@ -2217,7 +2217,7 @@
           <a:lstStyle/>
           <a:p>
             <a:r>
-              <a:t>WAF stays flat at every scale - member API operations bypass CloudFront entirely. The scaling costs live in identity (Cognito MAU), Aurora always-on, and the per-request stack (~$90/month combined at 100k).</a:t>
+              <a:t>WAF stays flat at every scale - member API operations bypass CloudFront entirely. Breaks BEFORE the bill: account concurrency 10 (~10k users, peaks) - AliExpress rate limits (ADR-0021) - Aurora's 50-connection cap post-quota-raise (only THEN does the proxy earn its cost) - the 2-ACU max.</a:t>
             </a:r>
           </a:p>
         </p:txBody>
@@ -23950,8 +23950,8 @@
           <p:nvPr/>
         </p:nvGraphicFramePr>
         <p:xfrm>
-          <a:off x="658368" y="1600200"/>
-          <a:ext cx="10881360" cy="2651760"/>
+          <a:off x="658368" y="1554480"/>
+          <a:ext cx="10881360" cy="3931920"/>
         </p:xfrm>
         <a:graphic>
           <a:graphicData uri="http://schemas.openxmlformats.org/drawingml/2006/table">
@@ -23960,33 +23960,14 @@
                 <a:tableStyleId>{5C22544A-7EE6-4342-B048-85BDC9FD1C3A}</a:tableStyleId>
               </a:tblPr>
               <a:tblGrid>
-                <a:gridCol w="3627120"/>
-                <a:gridCol w="3627120"/>
-                <a:gridCol w="3627120"/>
+                <a:gridCol w="3566160"/>
+                <a:gridCol w="1463040"/>
+                <a:gridCol w="1463040"/>
+                <a:gridCol w="1463040"/>
+                <a:gridCol w="1463040"/>
+                <a:gridCol w="1463040"/>
               </a:tblGrid>
-              <a:tr h="441960">
-                <a:tc>
-                  <a:txBody>
-                    <a:bodyPr/>
-                    <a:lstStyle/>
-                    <a:p>
-                      <a:r>
-                        <a:rPr sz="1100" b="1">
-                          <a:solidFill>
-                            <a:srgbClr val="7FE0B0"/>
-                          </a:solidFill>
-                          <a:latin typeface="Space Grotesk"/>
-                        </a:rPr>
-                        <a:t>Active users</a:t>
-                      </a:r>
-                    </a:p>
-                  </a:txBody>
-                  <a:tcPr>
-                    <a:solidFill>
-                      <a:srgbClr val="15201C"/>
-                    </a:solidFill>
-                  </a:tcPr>
-                </a:tc>
+              <a:tr h="393192">
                 <a:tc>
                   <a:txBody>
                     <a:bodyPr/>
@@ -24021,7 +24002,95 @@
                           </a:solidFill>
                           <a:latin typeface="Space Grotesk"/>
                         </a:rPr>
-                        <a:t>What dominates</a:t>
+                        <a:t>10</a:t>
+                      </a:r>
+                    </a:p>
+                  </a:txBody>
+                  <a:tcPr>
+                    <a:solidFill>
+                      <a:srgbClr val="15201C"/>
+                    </a:solidFill>
+                  </a:tcPr>
+                </a:tc>
+                <a:tc>
+                  <a:txBody>
+                    <a:bodyPr/>
+                    <a:lstStyle/>
+                    <a:p>
+                      <a:r>
+                        <a:rPr sz="1100" b="1">
+                          <a:solidFill>
+                            <a:srgbClr val="7FE0B0"/>
+                          </a:solidFill>
+                          <a:latin typeface="Space Grotesk"/>
+                        </a:rPr>
+                        <a:t>100</a:t>
+                      </a:r>
+                    </a:p>
+                  </a:txBody>
+                  <a:tcPr>
+                    <a:solidFill>
+                      <a:srgbClr val="15201C"/>
+                    </a:solidFill>
+                  </a:tcPr>
+                </a:tc>
+                <a:tc>
+                  <a:txBody>
+                    <a:bodyPr/>
+                    <a:lstStyle/>
+                    <a:p>
+                      <a:r>
+                        <a:rPr sz="1100" b="1">
+                          <a:solidFill>
+                            <a:srgbClr val="7FE0B0"/>
+                          </a:solidFill>
+                          <a:latin typeface="Space Grotesk"/>
+                        </a:rPr>
+                        <a:t>1,000</a:t>
+                      </a:r>
+                    </a:p>
+                  </a:txBody>
+                  <a:tcPr>
+                    <a:solidFill>
+                      <a:srgbClr val="15201C"/>
+                    </a:solidFill>
+                  </a:tcPr>
+                </a:tc>
+                <a:tc>
+                  <a:txBody>
+                    <a:bodyPr/>
+                    <a:lstStyle/>
+                    <a:p>
+                      <a:r>
+                        <a:rPr sz="1100" b="1">
+                          <a:solidFill>
+                            <a:srgbClr val="7FE0B0"/>
+                          </a:solidFill>
+                          <a:latin typeface="Space Grotesk"/>
+                        </a:rPr>
+                        <a:t>10,000</a:t>
+                      </a:r>
+                    </a:p>
+                  </a:txBody>
+                  <a:tcPr>
+                    <a:solidFill>
+                      <a:srgbClr val="15201C"/>
+                    </a:solidFill>
+                  </a:tcPr>
+                </a:tc>
+                <a:tc>
+                  <a:txBody>
+                    <a:bodyPr/>
+                    <a:lstStyle/>
+                    <a:p>
+                      <a:r>
+                        <a:rPr sz="1100" b="1">
+                          <a:solidFill>
+                            <a:srgbClr val="7FE0B0"/>
+                          </a:solidFill>
+                          <a:latin typeface="Space Grotesk"/>
+                        </a:rPr>
+                        <a:t>100,000</a:t>
                       </a:r>
                     </a:p>
                   </a:txBody>
@@ -24032,7 +24101,7 @@
                   </a:tcPr>
                 </a:tc>
               </a:tr>
-              <a:tr h="441960">
+              <a:tr h="393192">
                 <a:tc>
                   <a:txBody>
                     <a:bodyPr/>
@@ -24045,13 +24114,1085 @@
                           </a:solidFill>
                           <a:latin typeface="Hanken Grotesk"/>
                         </a:rPr>
-                        <a:t>10</a:t>
+                        <a:t>WAF (2 ACLs, fixed + $0.60/M req)</a:t>
                       </a:r>
                     </a:p>
                   </a:txBody>
                   <a:tcPr>
                     <a:solidFill>
                       <a:srgbClr val="FFFFFF"/>
+                    </a:solidFill>
+                  </a:tcPr>
+                </a:tc>
+                <a:tc>
+                  <a:txBody>
+                    <a:bodyPr/>
+                    <a:lstStyle/>
+                    <a:p>
+                      <a:r>
+                        <a:rPr sz="1050" b="0">
+                          <a:solidFill>
+                            <a:srgbClr val="15201C"/>
+                          </a:solidFill>
+                          <a:latin typeface="Hanken Grotesk"/>
+                        </a:rPr>
+                        <a:t>$14</a:t>
+                      </a:r>
+                    </a:p>
+                  </a:txBody>
+                  <a:tcPr>
+                    <a:solidFill>
+                      <a:srgbClr val="FFFFFF"/>
+                    </a:solidFill>
+                  </a:tcPr>
+                </a:tc>
+                <a:tc>
+                  <a:txBody>
+                    <a:bodyPr/>
+                    <a:lstStyle/>
+                    <a:p>
+                      <a:r>
+                        <a:rPr sz="1050" b="0">
+                          <a:solidFill>
+                            <a:srgbClr val="15201C"/>
+                          </a:solidFill>
+                          <a:latin typeface="Hanken Grotesk"/>
+                        </a:rPr>
+                        <a:t>$14</a:t>
+                      </a:r>
+                    </a:p>
+                  </a:txBody>
+                  <a:tcPr>
+                    <a:solidFill>
+                      <a:srgbClr val="FFFFFF"/>
+                    </a:solidFill>
+                  </a:tcPr>
+                </a:tc>
+                <a:tc>
+                  <a:txBody>
+                    <a:bodyPr/>
+                    <a:lstStyle/>
+                    <a:p>
+                      <a:r>
+                        <a:rPr sz="1050" b="0">
+                          <a:solidFill>
+                            <a:srgbClr val="15201C"/>
+                          </a:solidFill>
+                          <a:latin typeface="Hanken Grotesk"/>
+                        </a:rPr>
+                        <a:t>$14</a:t>
+                      </a:r>
+                    </a:p>
+                  </a:txBody>
+                  <a:tcPr>
+                    <a:solidFill>
+                      <a:srgbClr val="FFFFFF"/>
+                    </a:solidFill>
+                  </a:tcPr>
+                </a:tc>
+                <a:tc>
+                  <a:txBody>
+                    <a:bodyPr/>
+                    <a:lstStyle/>
+                    <a:p>
+                      <a:r>
+                        <a:rPr sz="1050" b="0">
+                          <a:solidFill>
+                            <a:srgbClr val="15201C"/>
+                          </a:solidFill>
+                          <a:latin typeface="Hanken Grotesk"/>
+                        </a:rPr>
+                        <a:t>$15</a:t>
+                      </a:r>
+                    </a:p>
+                  </a:txBody>
+                  <a:tcPr>
+                    <a:solidFill>
+                      <a:srgbClr val="FFFFFF"/>
+                    </a:solidFill>
+                  </a:tcPr>
+                </a:tc>
+                <a:tc>
+                  <a:txBody>
+                    <a:bodyPr/>
+                    <a:lstStyle/>
+                    <a:p>
+                      <a:r>
+                        <a:rPr sz="1050" b="0">
+                          <a:solidFill>
+                            <a:srgbClr val="15201C"/>
+                          </a:solidFill>
+                          <a:latin typeface="Hanken Grotesk"/>
+                        </a:rPr>
+                        <a:t>$27</a:t>
+                      </a:r>
+                    </a:p>
+                  </a:txBody>
+                  <a:tcPr>
+                    <a:solidFill>
+                      <a:srgbClr val="FFFFFF"/>
+                    </a:solidFill>
+                  </a:tcPr>
+                </a:tc>
+              </a:tr>
+              <a:tr h="393192">
+                <a:tc>
+                  <a:txBody>
+                    <a:bodyPr/>
+                    <a:lstStyle/>
+                    <a:p>
+                      <a:r>
+                        <a:rPr sz="1050" b="1">
+                          <a:solidFill>
+                            <a:srgbClr val="15201C"/>
+                          </a:solidFill>
+                          <a:latin typeface="Hanken Grotesk"/>
+                        </a:rPr>
+                        <a:t>API Gateway (~$1.2/M)</a:t>
+                      </a:r>
+                    </a:p>
+                  </a:txBody>
+                  <a:tcPr>
+                    <a:solidFill>
+                      <a:srgbClr val="FFFFFF"/>
+                    </a:solidFill>
+                  </a:tcPr>
+                </a:tc>
+                <a:tc>
+                  <a:txBody>
+                    <a:bodyPr/>
+                    <a:lstStyle/>
+                    <a:p>
+                      <a:r>
+                        <a:rPr sz="1050" b="0">
+                          <a:solidFill>
+                            <a:srgbClr val="15201C"/>
+                          </a:solidFill>
+                          <a:latin typeface="Hanken Grotesk"/>
+                        </a:rPr>
+                        <a:t>~$0</a:t>
+                      </a:r>
+                    </a:p>
+                  </a:txBody>
+                  <a:tcPr>
+                    <a:solidFill>
+                      <a:srgbClr val="FFFFFF"/>
+                    </a:solidFill>
+                  </a:tcPr>
+                </a:tc>
+                <a:tc>
+                  <a:txBody>
+                    <a:bodyPr/>
+                    <a:lstStyle/>
+                    <a:p>
+                      <a:r>
+                        <a:rPr sz="1050" b="0">
+                          <a:solidFill>
+                            <a:srgbClr val="15201C"/>
+                          </a:solidFill>
+                          <a:latin typeface="Hanken Grotesk"/>
+                        </a:rPr>
+                        <a:t>~$0</a:t>
+                      </a:r>
+                    </a:p>
+                  </a:txBody>
+                  <a:tcPr>
+                    <a:solidFill>
+                      <a:srgbClr val="FFFFFF"/>
+                    </a:solidFill>
+                  </a:tcPr>
+                </a:tc>
+                <a:tc>
+                  <a:txBody>
+                    <a:bodyPr/>
+                    <a:lstStyle/>
+                    <a:p>
+                      <a:r>
+                        <a:rPr sz="1050" b="0">
+                          <a:solidFill>
+                            <a:srgbClr val="15201C"/>
+                          </a:solidFill>
+                          <a:latin typeface="Hanken Grotesk"/>
+                        </a:rPr>
+                        <a:t>$0.40</a:t>
+                      </a:r>
+                    </a:p>
+                  </a:txBody>
+                  <a:tcPr>
+                    <a:solidFill>
+                      <a:srgbClr val="FFFFFF"/>
+                    </a:solidFill>
+                  </a:tcPr>
+                </a:tc>
+                <a:tc>
+                  <a:txBody>
+                    <a:bodyPr/>
+                    <a:lstStyle/>
+                    <a:p>
+                      <a:r>
+                        <a:rPr sz="1050" b="0">
+                          <a:solidFill>
+                            <a:srgbClr val="15201C"/>
+                          </a:solidFill>
+                          <a:latin typeface="Hanken Grotesk"/>
+                        </a:rPr>
+                        <a:t>$4</a:t>
+                      </a:r>
+                    </a:p>
+                  </a:txBody>
+                  <a:tcPr>
+                    <a:solidFill>
+                      <a:srgbClr val="FFFFFF"/>
+                    </a:solidFill>
+                  </a:tcPr>
+                </a:tc>
+                <a:tc>
+                  <a:txBody>
+                    <a:bodyPr/>
+                    <a:lstStyle/>
+                    <a:p>
+                      <a:r>
+                        <a:rPr sz="1050" b="0">
+                          <a:solidFill>
+                            <a:srgbClr val="15201C"/>
+                          </a:solidFill>
+                          <a:latin typeface="Hanken Grotesk"/>
+                        </a:rPr>
+                        <a:t>$36</a:t>
+                      </a:r>
+                    </a:p>
+                  </a:txBody>
+                  <a:tcPr>
+                    <a:solidFill>
+                      <a:srgbClr val="FFFFFF"/>
+                    </a:solidFill>
+                  </a:tcPr>
+                </a:tc>
+              </a:tr>
+              <a:tr h="393192">
+                <a:tc>
+                  <a:txBody>
+                    <a:bodyPr/>
+                    <a:lstStyle/>
+                    <a:p>
+                      <a:r>
+                        <a:rPr sz="1050" b="1">
+                          <a:solidFill>
+                            <a:srgbClr val="15201C"/>
+                          </a:solidFill>
+                          <a:latin typeface="Hanken Grotesk"/>
+                        </a:rPr>
+                        <a:t>Lambda (256MB arm64)</a:t>
+                      </a:r>
+                    </a:p>
+                  </a:txBody>
+                  <a:tcPr>
+                    <a:solidFill>
+                      <a:srgbClr val="FFFFFF"/>
+                    </a:solidFill>
+                  </a:tcPr>
+                </a:tc>
+                <a:tc>
+                  <a:txBody>
+                    <a:bodyPr/>
+                    <a:lstStyle/>
+                    <a:p>
+                      <a:r>
+                        <a:rPr sz="1050" b="0">
+                          <a:solidFill>
+                            <a:srgbClr val="15201C"/>
+                          </a:solidFill>
+                          <a:latin typeface="Hanken Grotesk"/>
+                        </a:rPr>
+                        <a:t>~$0</a:t>
+                      </a:r>
+                    </a:p>
+                  </a:txBody>
+                  <a:tcPr>
+                    <a:solidFill>
+                      <a:srgbClr val="FFFFFF"/>
+                    </a:solidFill>
+                  </a:tcPr>
+                </a:tc>
+                <a:tc>
+                  <a:txBody>
+                    <a:bodyPr/>
+                    <a:lstStyle/>
+                    <a:p>
+                      <a:r>
+                        <a:rPr sz="1050" b="0">
+                          <a:solidFill>
+                            <a:srgbClr val="15201C"/>
+                          </a:solidFill>
+                          <a:latin typeface="Hanken Grotesk"/>
+                        </a:rPr>
+                        <a:t>~$0</a:t>
+                      </a:r>
+                    </a:p>
+                  </a:txBody>
+                  <a:tcPr>
+                    <a:solidFill>
+                      <a:srgbClr val="FFFFFF"/>
+                    </a:solidFill>
+                  </a:tcPr>
+                </a:tc>
+                <a:tc>
+                  <a:txBody>
+                    <a:bodyPr/>
+                    <a:lstStyle/>
+                    <a:p>
+                      <a:r>
+                        <a:rPr sz="1050" b="0">
+                          <a:solidFill>
+                            <a:srgbClr val="15201C"/>
+                          </a:solidFill>
+                          <a:latin typeface="Hanken Grotesk"/>
+                        </a:rPr>
+                        <a:t>$0.20</a:t>
+                      </a:r>
+                    </a:p>
+                  </a:txBody>
+                  <a:tcPr>
+                    <a:solidFill>
+                      <a:srgbClr val="FFFFFF"/>
+                    </a:solidFill>
+                  </a:tcPr>
+                </a:tc>
+                <a:tc>
+                  <a:txBody>
+                    <a:bodyPr/>
+                    <a:lstStyle/>
+                    <a:p>
+                      <a:r>
+                        <a:rPr sz="1050" b="0">
+                          <a:solidFill>
+                            <a:srgbClr val="15201C"/>
+                          </a:solidFill>
+                          <a:latin typeface="Hanken Grotesk"/>
+                        </a:rPr>
+                        <a:t>$2</a:t>
+                      </a:r>
+                    </a:p>
+                  </a:txBody>
+                  <a:tcPr>
+                    <a:solidFill>
+                      <a:srgbClr val="FFFFFF"/>
+                    </a:solidFill>
+                  </a:tcPr>
+                </a:tc>
+                <a:tc>
+                  <a:txBody>
+                    <a:bodyPr/>
+                    <a:lstStyle/>
+                    <a:p>
+                      <a:r>
+                        <a:rPr sz="1050" b="0">
+                          <a:solidFill>
+                            <a:srgbClr val="15201C"/>
+                          </a:solidFill>
+                          <a:latin typeface="Hanken Grotesk"/>
+                        </a:rPr>
+                        <a:t>$18</a:t>
+                      </a:r>
+                    </a:p>
+                  </a:txBody>
+                  <a:tcPr>
+                    <a:solidFill>
+                      <a:srgbClr val="FFFFFF"/>
+                    </a:solidFill>
+                  </a:tcPr>
+                </a:tc>
+              </a:tr>
+              <a:tr h="393192">
+                <a:tc>
+                  <a:txBody>
+                    <a:bodyPr/>
+                    <a:lstStyle/>
+                    <a:p>
+                      <a:r>
+                        <a:rPr sz="1050" b="1">
+                          <a:solidFill>
+                            <a:srgbClr val="15201C"/>
+                          </a:solidFill>
+                          <a:latin typeface="Hanken Grotesk"/>
+                        </a:rPr>
+                        <a:t>DynamoDB on-demand</a:t>
+                      </a:r>
+                    </a:p>
+                  </a:txBody>
+                  <a:tcPr>
+                    <a:solidFill>
+                      <a:srgbClr val="FFFFFF"/>
+                    </a:solidFill>
+                  </a:tcPr>
+                </a:tc>
+                <a:tc>
+                  <a:txBody>
+                    <a:bodyPr/>
+                    <a:lstStyle/>
+                    <a:p>
+                      <a:r>
+                        <a:rPr sz="1050" b="0">
+                          <a:solidFill>
+                            <a:srgbClr val="15201C"/>
+                          </a:solidFill>
+                          <a:latin typeface="Hanken Grotesk"/>
+                        </a:rPr>
+                        <a:t>~$0</a:t>
+                      </a:r>
+                    </a:p>
+                  </a:txBody>
+                  <a:tcPr>
+                    <a:solidFill>
+                      <a:srgbClr val="FFFFFF"/>
+                    </a:solidFill>
+                  </a:tcPr>
+                </a:tc>
+                <a:tc>
+                  <a:txBody>
+                    <a:bodyPr/>
+                    <a:lstStyle/>
+                    <a:p>
+                      <a:r>
+                        <a:rPr sz="1050" b="0">
+                          <a:solidFill>
+                            <a:srgbClr val="15201C"/>
+                          </a:solidFill>
+                          <a:latin typeface="Hanken Grotesk"/>
+                        </a:rPr>
+                        <a:t>~$0</a:t>
+                      </a:r>
+                    </a:p>
+                  </a:txBody>
+                  <a:tcPr>
+                    <a:solidFill>
+                      <a:srgbClr val="FFFFFF"/>
+                    </a:solidFill>
+                  </a:tcPr>
+                </a:tc>
+                <a:tc>
+                  <a:txBody>
+                    <a:bodyPr/>
+                    <a:lstStyle/>
+                    <a:p>
+                      <a:r>
+                        <a:rPr sz="1050" b="0">
+                          <a:solidFill>
+                            <a:srgbClr val="15201C"/>
+                          </a:solidFill>
+                          <a:latin typeface="Hanken Grotesk"/>
+                        </a:rPr>
+                        <a:t>$0.40</a:t>
+                      </a:r>
+                    </a:p>
+                  </a:txBody>
+                  <a:tcPr>
+                    <a:solidFill>
+                      <a:srgbClr val="FFFFFF"/>
+                    </a:solidFill>
+                  </a:tcPr>
+                </a:tc>
+                <a:tc>
+                  <a:txBody>
+                    <a:bodyPr/>
+                    <a:lstStyle/>
+                    <a:p>
+                      <a:r>
+                        <a:rPr sz="1050" b="0">
+                          <a:solidFill>
+                            <a:srgbClr val="15201C"/>
+                          </a:solidFill>
+                          <a:latin typeface="Hanken Grotesk"/>
+                        </a:rPr>
+                        <a:t>$4</a:t>
+                      </a:r>
+                    </a:p>
+                  </a:txBody>
+                  <a:tcPr>
+                    <a:solidFill>
+                      <a:srgbClr val="FFFFFF"/>
+                    </a:solidFill>
+                  </a:tcPr>
+                </a:tc>
+                <a:tc>
+                  <a:txBody>
+                    <a:bodyPr/>
+                    <a:lstStyle/>
+                    <a:p>
+                      <a:r>
+                        <a:rPr sz="1050" b="0">
+                          <a:solidFill>
+                            <a:srgbClr val="15201C"/>
+                          </a:solidFill>
+                          <a:latin typeface="Hanken Grotesk"/>
+                        </a:rPr>
+                        <a:t>$40</a:t>
+                      </a:r>
+                    </a:p>
+                  </a:txBody>
+                  <a:tcPr>
+                    <a:solidFill>
+                      <a:srgbClr val="FFFFFF"/>
+                    </a:solidFill>
+                  </a:tcPr>
+                </a:tc>
+              </a:tr>
+              <a:tr h="393192">
+                <a:tc>
+                  <a:txBody>
+                    <a:bodyPr/>
+                    <a:lstStyle/>
+                    <a:p>
+                      <a:r>
+                        <a:rPr sz="1050" b="1">
+                          <a:solidFill>
+                            <a:srgbClr val="15201C"/>
+                          </a:solidFill>
+                          <a:latin typeface="Hanken Grotesk"/>
+                        </a:rPr>
+                        <a:t>Aurora (compute + storage)</a:t>
+                      </a:r>
+                    </a:p>
+                  </a:txBody>
+                  <a:tcPr>
+                    <a:solidFill>
+                      <a:srgbClr val="FFFFFF"/>
+                    </a:solidFill>
+                  </a:tcPr>
+                </a:tc>
+                <a:tc>
+                  <a:txBody>
+                    <a:bodyPr/>
+                    <a:lstStyle/>
+                    <a:p>
+                      <a:r>
+                        <a:rPr sz="1050" b="0">
+                          <a:solidFill>
+                            <a:srgbClr val="15201C"/>
+                          </a:solidFill>
+                          <a:latin typeface="Hanken Grotesk"/>
+                        </a:rPr>
+                        <a:t>~$3</a:t>
+                      </a:r>
+                    </a:p>
+                  </a:txBody>
+                  <a:tcPr>
+                    <a:solidFill>
+                      <a:srgbClr val="FFFFFF"/>
+                    </a:solidFill>
+                  </a:tcPr>
+                </a:tc>
+                <a:tc>
+                  <a:txBody>
+                    <a:bodyPr/>
+                    <a:lstStyle/>
+                    <a:p>
+                      <a:r>
+                        <a:rPr sz="1050" b="0">
+                          <a:solidFill>
+                            <a:srgbClr val="15201C"/>
+                          </a:solidFill>
+                          <a:latin typeface="Hanken Grotesk"/>
+                        </a:rPr>
+                        <a:t>~$8</a:t>
+                      </a:r>
+                    </a:p>
+                  </a:txBody>
+                  <a:tcPr>
+                    <a:solidFill>
+                      <a:srgbClr val="FFFFFF"/>
+                    </a:solidFill>
+                  </a:tcPr>
+                </a:tc>
+                <a:tc>
+                  <a:txBody>
+                    <a:bodyPr/>
+                    <a:lstStyle/>
+                    <a:p>
+                      <a:r>
+                        <a:rPr sz="1050" b="0">
+                          <a:solidFill>
+                            <a:srgbClr val="15201C"/>
+                          </a:solidFill>
+                          <a:latin typeface="Hanken Grotesk"/>
+                        </a:rPr>
+                        <a:t>~$45</a:t>
+                      </a:r>
+                    </a:p>
+                  </a:txBody>
+                  <a:tcPr>
+                    <a:solidFill>
+                      <a:srgbClr val="FFFFFF"/>
+                    </a:solidFill>
+                  </a:tcPr>
+                </a:tc>
+                <a:tc>
+                  <a:txBody>
+                    <a:bodyPr/>
+                    <a:lstStyle/>
+                    <a:p>
+                      <a:r>
+                        <a:rPr sz="1050" b="0">
+                          <a:solidFill>
+                            <a:srgbClr val="15201C"/>
+                          </a:solidFill>
+                          <a:latin typeface="Hanken Grotesk"/>
+                        </a:rPr>
+                        <a:t>~$80</a:t>
+                      </a:r>
+                    </a:p>
+                  </a:txBody>
+                  <a:tcPr>
+                    <a:solidFill>
+                      <a:srgbClr val="FFFFFF"/>
+                    </a:solidFill>
+                  </a:tcPr>
+                </a:tc>
+                <a:tc>
+                  <a:txBody>
+                    <a:bodyPr/>
+                    <a:lstStyle/>
+                    <a:p>
+                      <a:r>
+                        <a:rPr sz="1050" b="0">
+                          <a:solidFill>
+                            <a:srgbClr val="15201C"/>
+                          </a:solidFill>
+                          <a:latin typeface="Hanken Grotesk"/>
+                        </a:rPr>
+                        <a:t>~$220</a:t>
+                      </a:r>
+                    </a:p>
+                  </a:txBody>
+                  <a:tcPr>
+                    <a:solidFill>
+                      <a:srgbClr val="FFFFFF"/>
+                    </a:solidFill>
+                  </a:tcPr>
+                </a:tc>
+              </a:tr>
+              <a:tr h="393192">
+                <a:tc>
+                  <a:txBody>
+                    <a:bodyPr/>
+                    <a:lstStyle/>
+                    <a:p>
+                      <a:r>
+                        <a:rPr sz="1050" b="1">
+                          <a:solidFill>
+                            <a:srgbClr val="15201C"/>
+                          </a:solidFill>
+                          <a:latin typeface="Hanken Grotesk"/>
+                        </a:rPr>
+                        <a:t>RDS Proxy (8-ACU minimum)</a:t>
+                      </a:r>
+                    </a:p>
+                  </a:txBody>
+                  <a:tcPr>
+                    <a:solidFill>
+                      <a:srgbClr val="FFFFFF"/>
+                    </a:solidFill>
+                  </a:tcPr>
+                </a:tc>
+                <a:tc>
+                  <a:txBody>
+                    <a:bodyPr/>
+                    <a:lstStyle/>
+                    <a:p>
+                      <a:r>
+                        <a:rPr sz="1050" b="0">
+                          <a:solidFill>
+                            <a:srgbClr val="15201C"/>
+                          </a:solidFill>
+                          <a:latin typeface="Hanken Grotesk"/>
+                        </a:rPr>
+                        <a:t>—</a:t>
+                      </a:r>
+                    </a:p>
+                  </a:txBody>
+                  <a:tcPr>
+                    <a:solidFill>
+                      <a:srgbClr val="FFFFFF"/>
+                    </a:solidFill>
+                  </a:tcPr>
+                </a:tc>
+                <a:tc>
+                  <a:txBody>
+                    <a:bodyPr/>
+                    <a:lstStyle/>
+                    <a:p>
+                      <a:r>
+                        <a:rPr sz="1050" b="0">
+                          <a:solidFill>
+                            <a:srgbClr val="15201C"/>
+                          </a:solidFill>
+                          <a:latin typeface="Hanken Grotesk"/>
+                        </a:rPr>
+                        <a:t>—</a:t>
+                      </a:r>
+                    </a:p>
+                  </a:txBody>
+                  <a:tcPr>
+                    <a:solidFill>
+                      <a:srgbClr val="FFFFFF"/>
+                    </a:solidFill>
+                  </a:tcPr>
+                </a:tc>
+                <a:tc>
+                  <a:txBody>
+                    <a:bodyPr/>
+                    <a:lstStyle/>
+                    <a:p>
+                      <a:r>
+                        <a:rPr sz="1050" b="0">
+                          <a:solidFill>
+                            <a:srgbClr val="15201C"/>
+                          </a:solidFill>
+                          <a:latin typeface="Hanken Grotesk"/>
+                        </a:rPr>
+                        <a:t>—</a:t>
+                      </a:r>
+                    </a:p>
+                  </a:txBody>
+                  <a:tcPr>
+                    <a:solidFill>
+                      <a:srgbClr val="FFFFFF"/>
+                    </a:solidFill>
+                  </a:tcPr>
+                </a:tc>
+                <a:tc>
+                  <a:txBody>
+                    <a:bodyPr/>
+                    <a:lstStyle/>
+                    <a:p>
+                      <a:r>
+                        <a:rPr sz="1050" b="0">
+                          <a:solidFill>
+                            <a:srgbClr val="15201C"/>
+                          </a:solidFill>
+                          <a:latin typeface="Hanken Grotesk"/>
+                        </a:rPr>
+                        <a:t>~$100</a:t>
+                      </a:r>
+                    </a:p>
+                  </a:txBody>
+                  <a:tcPr>
+                    <a:solidFill>
+                      <a:srgbClr val="FFFFFF"/>
+                    </a:solidFill>
+                  </a:tcPr>
+                </a:tc>
+                <a:tc>
+                  <a:txBody>
+                    <a:bodyPr/>
+                    <a:lstStyle/>
+                    <a:p>
+                      <a:r>
+                        <a:rPr sz="1050" b="0">
+                          <a:solidFill>
+                            <a:srgbClr val="15201C"/>
+                          </a:solidFill>
+                          <a:latin typeface="Hanken Grotesk"/>
+                        </a:rPr>
+                        <a:t>~$100</a:t>
+                      </a:r>
+                    </a:p>
+                  </a:txBody>
+                  <a:tcPr>
+                    <a:solidFill>
+                      <a:srgbClr val="FFFFFF"/>
+                    </a:solidFill>
+                  </a:tcPr>
+                </a:tc>
+              </a:tr>
+              <a:tr h="393192">
+                <a:tc>
+                  <a:txBody>
+                    <a:bodyPr/>
+                    <a:lstStyle/>
+                    <a:p>
+                      <a:r>
+                        <a:rPr sz="1050" b="1">
+                          <a:solidFill>
+                            <a:srgbClr val="15201C"/>
+                          </a:solidFill>
+                          <a:latin typeface="Hanken Grotesk"/>
+                        </a:rPr>
+                        <a:t>Cognito ($0.015/MAU after 10k free)</a:t>
+                      </a:r>
+                    </a:p>
+                  </a:txBody>
+                  <a:tcPr>
+                    <a:solidFill>
+                      <a:srgbClr val="FFFFFF"/>
+                    </a:solidFill>
+                  </a:tcPr>
+                </a:tc>
+                <a:tc>
+                  <a:txBody>
+                    <a:bodyPr/>
+                    <a:lstStyle/>
+                    <a:p>
+                      <a:r>
+                        <a:rPr sz="1050" b="0">
+                          <a:solidFill>
+                            <a:srgbClr val="15201C"/>
+                          </a:solidFill>
+                          <a:latin typeface="Hanken Grotesk"/>
+                        </a:rPr>
+                        <a:t>$0</a:t>
+                      </a:r>
+                    </a:p>
+                  </a:txBody>
+                  <a:tcPr>
+                    <a:solidFill>
+                      <a:srgbClr val="FFFFFF"/>
+                    </a:solidFill>
+                  </a:tcPr>
+                </a:tc>
+                <a:tc>
+                  <a:txBody>
+                    <a:bodyPr/>
+                    <a:lstStyle/>
+                    <a:p>
+                      <a:r>
+                        <a:rPr sz="1050" b="0">
+                          <a:solidFill>
+                            <a:srgbClr val="15201C"/>
+                          </a:solidFill>
+                          <a:latin typeface="Hanken Grotesk"/>
+                        </a:rPr>
+                        <a:t>$0</a:t>
+                      </a:r>
+                    </a:p>
+                  </a:txBody>
+                  <a:tcPr>
+                    <a:solidFill>
+                      <a:srgbClr val="FFFFFF"/>
+                    </a:solidFill>
+                  </a:tcPr>
+                </a:tc>
+                <a:tc>
+                  <a:txBody>
+                    <a:bodyPr/>
+                    <a:lstStyle/>
+                    <a:p>
+                      <a:r>
+                        <a:rPr sz="1050" b="0">
+                          <a:solidFill>
+                            <a:srgbClr val="15201C"/>
+                          </a:solidFill>
+                          <a:latin typeface="Hanken Grotesk"/>
+                        </a:rPr>
+                        <a:t>$0</a:t>
+                      </a:r>
+                    </a:p>
+                  </a:txBody>
+                  <a:tcPr>
+                    <a:solidFill>
+                      <a:srgbClr val="FFFFFF"/>
+                    </a:solidFill>
+                  </a:tcPr>
+                </a:tc>
+                <a:tc>
+                  <a:txBody>
+                    <a:bodyPr/>
+                    <a:lstStyle/>
+                    <a:p>
+                      <a:r>
+                        <a:rPr sz="1050" b="0">
+                          <a:solidFill>
+                            <a:srgbClr val="15201C"/>
+                          </a:solidFill>
+                          <a:latin typeface="Hanken Grotesk"/>
+                        </a:rPr>
+                        <a:t>$0</a:t>
+                      </a:r>
+                    </a:p>
+                  </a:txBody>
+                  <a:tcPr>
+                    <a:solidFill>
+                      <a:srgbClr val="FFFFFF"/>
+                    </a:solidFill>
+                  </a:tcPr>
+                </a:tc>
+                <a:tc>
+                  <a:txBody>
+                    <a:bodyPr/>
+                    <a:lstStyle/>
+                    <a:p>
+                      <a:r>
+                        <a:rPr sz="1050" b="0">
+                          <a:solidFill>
+                            <a:srgbClr val="15201C"/>
+                          </a:solidFill>
+                          <a:latin typeface="Hanken Grotesk"/>
+                        </a:rPr>
+                        <a:t>$1,350</a:t>
+                      </a:r>
+                    </a:p>
+                  </a:txBody>
+                  <a:tcPr>
+                    <a:solidFill>
+                      <a:srgbClr val="FFFFFF"/>
+                    </a:solidFill>
+                  </a:tcPr>
+                </a:tc>
+              </a:tr>
+              <a:tr h="393192">
+                <a:tc>
+                  <a:txBody>
+                    <a:bodyPr/>
+                    <a:lstStyle/>
+                    <a:p>
+                      <a:r>
+                        <a:rPr sz="1050" b="1">
+                          <a:solidFill>
+                            <a:srgbClr val="15201C"/>
+                          </a:solidFill>
+                          <a:latin typeface="Hanken Grotesk"/>
+                        </a:rPr>
+                        <a:t>CloudFront + misc</a:t>
+                      </a:r>
+                    </a:p>
+                  </a:txBody>
+                  <a:tcPr>
+                    <a:solidFill>
+                      <a:srgbClr val="FFFFFF"/>
+                    </a:solidFill>
+                  </a:tcPr>
+                </a:tc>
+                <a:tc>
+                  <a:txBody>
+                    <a:bodyPr/>
+                    <a:lstStyle/>
+                    <a:p>
+                      <a:r>
+                        <a:rPr sz="1050" b="0">
+                          <a:solidFill>
+                            <a:srgbClr val="15201C"/>
+                          </a:solidFill>
+                          <a:latin typeface="Hanken Grotesk"/>
+                        </a:rPr>
+                        <a:t>~$3</a:t>
+                      </a:r>
+                    </a:p>
+                  </a:txBody>
+                  <a:tcPr>
+                    <a:solidFill>
+                      <a:srgbClr val="FFFFFF"/>
+                    </a:solidFill>
+                  </a:tcPr>
+                </a:tc>
+                <a:tc>
+                  <a:txBody>
+                    <a:bodyPr/>
+                    <a:lstStyle/>
+                    <a:p>
+                      <a:r>
+                        <a:rPr sz="1050" b="0">
+                          <a:solidFill>
+                            <a:srgbClr val="15201C"/>
+                          </a:solidFill>
+                          <a:latin typeface="Hanken Grotesk"/>
+                        </a:rPr>
+                        <a:t>~$3</a:t>
+                      </a:r>
+                    </a:p>
+                  </a:txBody>
+                  <a:tcPr>
+                    <a:solidFill>
+                      <a:srgbClr val="FFFFFF"/>
+                    </a:solidFill>
+                  </a:tcPr>
+                </a:tc>
+                <a:tc>
+                  <a:txBody>
+                    <a:bodyPr/>
+                    <a:lstStyle/>
+                    <a:p>
+                      <a:r>
+                        <a:rPr sz="1050" b="0">
+                          <a:solidFill>
+                            <a:srgbClr val="15201C"/>
+                          </a:solidFill>
+                          <a:latin typeface="Hanken Grotesk"/>
+                        </a:rPr>
+                        <a:t>~$5</a:t>
+                      </a:r>
+                    </a:p>
+                  </a:txBody>
+                  <a:tcPr>
+                    <a:solidFill>
+                      <a:srgbClr val="FFFFFF"/>
+                    </a:solidFill>
+                  </a:tcPr>
+                </a:tc>
+                <a:tc>
+                  <a:txBody>
+                    <a:bodyPr/>
+                    <a:lstStyle/>
+                    <a:p>
+                      <a:r>
+                        <a:rPr sz="1050" b="0">
+                          <a:solidFill>
+                            <a:srgbClr val="15201C"/>
+                          </a:solidFill>
+                          <a:latin typeface="Hanken Grotesk"/>
+                        </a:rPr>
+                        <a:t>~$12</a:t>
+                      </a:r>
+                    </a:p>
+                  </a:txBody>
+                  <a:tcPr>
+                    <a:solidFill>
+                      <a:srgbClr val="FFFFFF"/>
+                    </a:solidFill>
+                  </a:tcPr>
+                </a:tc>
+                <a:tc>
+                  <a:txBody>
+                    <a:bodyPr/>
+                    <a:lstStyle/>
+                    <a:p>
+                      <a:r>
+                        <a:rPr sz="1050" b="0">
+                          <a:solidFill>
+                            <a:srgbClr val="15201C"/>
+                          </a:solidFill>
+                          <a:latin typeface="Hanken Grotesk"/>
+                        </a:rPr>
+                        <a:t>~$42</a:t>
+                      </a:r>
+                    </a:p>
+                  </a:txBody>
+                  <a:tcPr>
+                    <a:solidFill>
+                      <a:srgbClr val="FFFFFF"/>
+                    </a:solidFill>
+                  </a:tcPr>
+                </a:tc>
+              </a:tr>
+              <a:tr h="393192">
+                <a:tc>
+                  <a:txBody>
+                    <a:bodyPr/>
+                    <a:lstStyle/>
+                    <a:p>
+                      <a:r>
+                        <a:rPr sz="1050" b="1">
+                          <a:solidFill>
+                            <a:srgbClr val="15201C"/>
+                          </a:solidFill>
+                          <a:latin typeface="Hanken Grotesk"/>
+                        </a:rPr>
+                        <a:t>Total</a:t>
+                      </a:r>
+                    </a:p>
+                  </a:txBody>
+                  <a:tcPr>
+                    <a:solidFill>
+                      <a:srgbClr val="EAF5EF"/>
                     </a:solidFill>
                   </a:tcPr>
                 </a:tc>
@@ -24073,7 +25214,7 @@
                   </a:txBody>
                   <a:tcPr>
                     <a:solidFill>
-                      <a:srgbClr val="FFFFFF"/>
+                      <a:srgbClr val="EAF5EF"/>
                     </a:solidFill>
                   </a:tcPr>
                 </a:tc>
@@ -24089,37 +25230,13 @@
                           </a:solidFill>
                           <a:latin typeface="Hanken Grotesk"/>
                         </a:rPr>
-                        <a:t>the fixed floor (WAF $14 + Aurora storage)</a:t>
+                        <a:t>~$25</a:t>
                       </a:r>
                     </a:p>
                   </a:txBody>
                   <a:tcPr>
                     <a:solidFill>
-                      <a:srgbClr val="FFFFFF"/>
-                    </a:solidFill>
-                  </a:tcPr>
-                </a:tc>
-              </a:tr>
-              <a:tr h="441960">
-                <a:tc>
-                  <a:txBody>
-                    <a:bodyPr/>
-                    <a:lstStyle/>
-                    <a:p>
-                      <a:r>
-                        <a:rPr sz="1050" b="1">
-                          <a:solidFill>
-                            <a:srgbClr val="15201C"/>
-                          </a:solidFill>
-                          <a:latin typeface="Hanken Grotesk"/>
-                        </a:rPr>
-                        <a:t>1,000</a:t>
-                      </a:r>
-                    </a:p>
-                  </a:txBody>
-                  <a:tcPr>
-                    <a:solidFill>
-                      <a:srgbClr val="FFFFFF"/>
+                      <a:srgbClr val="EAF5EF"/>
                     </a:solidFill>
                   </a:tcPr>
                 </a:tc>
@@ -24135,13 +25252,13 @@
                           </a:solidFill>
                           <a:latin typeface="Hanken Grotesk"/>
                         </a:rPr>
-                        <a:t>~$55-75</a:t>
+                        <a:t>~$65</a:t>
                       </a:r>
                     </a:p>
                   </a:txBody>
                   <a:tcPr>
                     <a:solidFill>
-                      <a:srgbClr val="FFFFFF"/>
+                      <a:srgbClr val="EAF5EF"/>
                     </a:solidFill>
                   </a:tcPr>
                 </a:tc>
@@ -24157,37 +25274,13 @@
                           </a:solidFill>
                           <a:latin typeface="Hanken Grotesk"/>
                         </a:rPr>
-                        <a:t>Aurora stops scaling to zero (~$35-55)</a:t>
+                        <a:t>~$215</a:t>
                       </a:r>
                     </a:p>
                   </a:txBody>
                   <a:tcPr>
                     <a:solidFill>
-                      <a:srgbClr val="FFFFFF"/>
-                    </a:solidFill>
-                  </a:tcPr>
-                </a:tc>
-              </a:tr>
-              <a:tr h="441960">
-                <a:tc>
-                  <a:txBody>
-                    <a:bodyPr/>
-                    <a:lstStyle/>
-                    <a:p>
-                      <a:r>
-                        <a:rPr sz="1050" b="1">
-                          <a:solidFill>
-                            <a:srgbClr val="15201C"/>
-                          </a:solidFill>
-                          <a:latin typeface="Hanken Grotesk"/>
-                        </a:rPr>
-                        <a:t>10,000</a:t>
-                      </a:r>
-                    </a:p>
-                  </a:txBody>
-                  <a:tcPr>
-                    <a:solidFill>
-                      <a:srgbClr val="FFFFFF"/>
+                      <a:srgbClr val="EAF5EF"/>
                     </a:solidFill>
                   </a:tcPr>
                 </a:tc>
@@ -24203,171 +25296,13 @@
                           </a:solidFill>
                           <a:latin typeface="Hanken Grotesk"/>
                         </a:rPr>
-                        <a:t>~$90-150</a:t>
+                        <a:t>~$1,835</a:t>
                       </a:r>
                     </a:p>
                   </a:txBody>
                   <a:tcPr>
                     <a:solidFill>
-                      <a:srgbClr val="FFFFFF"/>
-                    </a:solidFill>
-                  </a:tcPr>
-                </a:tc>
-                <a:tc>
-                  <a:txBody>
-                    <a:bodyPr/>
-                    <a:lstStyle/>
-                    <a:p>
-                      <a:r>
-                        <a:rPr sz="1050" b="1">
-                          <a:solidFill>
-                            <a:srgbClr val="15201C"/>
-                          </a:solidFill>
-                          <a:latin typeface="Hanken Grotesk"/>
-                        </a:rPr>
-                        <a:t>still inside the Cognito free tier (10k MAU)</a:t>
-                      </a:r>
-                    </a:p>
-                  </a:txBody>
-                  <a:tcPr>
-                    <a:solidFill>
-                      <a:srgbClr val="FFFFFF"/>
-                    </a:solidFill>
-                  </a:tcPr>
-                </a:tc>
-              </a:tr>
-              <a:tr h="441960">
-                <a:tc>
-                  <a:txBody>
-                    <a:bodyPr/>
-                    <a:lstStyle/>
-                    <a:p>
-                      <a:r>
-                        <a:rPr sz="1050" b="1">
-                          <a:solidFill>
-                            <a:srgbClr val="15201C"/>
-                          </a:solidFill>
-                          <a:latin typeface="Hanken Grotesk"/>
-                        </a:rPr>
-                        <a:t>10,000 + RDS Proxy</a:t>
-                      </a:r>
-                    </a:p>
-                  </a:txBody>
-                  <a:tcPr>
-                    <a:solidFill>
-                      <a:srgbClr val="FFFFFF"/>
-                    </a:solidFill>
-                  </a:tcPr>
-                </a:tc>
-                <a:tc>
-                  <a:txBody>
-                    <a:bodyPr/>
-                    <a:lstStyle/>
-                    <a:p>
-                      <a:r>
-                        <a:rPr sz="1050" b="1">
-                          <a:solidFill>
-                            <a:srgbClr val="15201C"/>
-                          </a:solidFill>
-                          <a:latin typeface="Hanken Grotesk"/>
-                        </a:rPr>
-                        <a:t>~$190-250</a:t>
-                      </a:r>
-                    </a:p>
-                  </a:txBody>
-                  <a:tcPr>
-                    <a:solidFill>
-                      <a:srgbClr val="FFFFFF"/>
-                    </a:solidFill>
-                  </a:tcPr>
-                </a:tc>
-                <a:tc>
-                  <a:txBody>
-                    <a:bodyPr/>
-                    <a:lstStyle/>
-                    <a:p>
-                      <a:r>
-                        <a:rPr sz="1050" b="1">
-                          <a:solidFill>
-                            <a:srgbClr val="15201C"/>
-                          </a:solidFill>
-                          <a:latin typeface="Hanken Grotesk"/>
-                        </a:rPr>
-                        <a:t>proxy 8-ACU minimum = ~$100/month FLAT</a:t>
-                      </a:r>
-                    </a:p>
-                  </a:txBody>
-                  <a:tcPr>
-                    <a:solidFill>
-                      <a:srgbClr val="FFFFFF"/>
-                    </a:solidFill>
-                  </a:tcPr>
-                </a:tc>
-              </a:tr>
-              <a:tr h="441960">
-                <a:tc>
-                  <a:txBody>
-                    <a:bodyPr/>
-                    <a:lstStyle/>
-                    <a:p>
-                      <a:r>
-                        <a:rPr sz="1050" b="1">
-                          <a:solidFill>
-                            <a:srgbClr val="15201C"/>
-                          </a:solidFill>
-                          <a:latin typeface="Hanken Grotesk"/>
-                        </a:rPr>
-                        <a:t>100,000</a:t>
-                      </a:r>
-                    </a:p>
-                  </a:txBody>
-                  <a:tcPr>
-                    <a:solidFill>
-                      <a:srgbClr val="FFFFFF"/>
-                    </a:solidFill>
-                  </a:tcPr>
-                </a:tc>
-                <a:tc>
-                  <a:txBody>
-                    <a:bodyPr/>
-                    <a:lstStyle/>
-                    <a:p>
-                      <a:r>
-                        <a:rPr sz="1050" b="1">
-                          <a:solidFill>
-                            <a:srgbClr val="15201C"/>
-                          </a:solidFill>
-                          <a:latin typeface="Hanken Grotesk"/>
-                        </a:rPr>
-                        <a:t>~$1,730</a:t>
-                      </a:r>
-                    </a:p>
-                  </a:txBody>
-                  <a:tcPr>
-                    <a:solidFill>
-                      <a:srgbClr val="FFFFFF"/>
-                    </a:solidFill>
-                  </a:tcPr>
-                </a:tc>
-                <a:tc>
-                  <a:txBody>
-                    <a:bodyPr/>
-                    <a:lstStyle/>
-                    <a:p>
-                      <a:r>
-                        <a:rPr sz="1050" b="1">
-                          <a:solidFill>
-                            <a:srgbClr val="15201C"/>
-                          </a:solidFill>
-                          <a:latin typeface="Hanken Grotesk"/>
-                        </a:rPr>
-                        <a:t>Cognito MAU $1,350 = 78% of the bill</a:t>
-                      </a:r>
-                    </a:p>
-                  </a:txBody>
-                  <a:tcPr>
-                    <a:solidFill>
-                      <a:srgbClr val="FFFFFF"/>
+                      <a:srgbClr val="EAF5EF"/>
                     </a:solidFill>
                   </a:tcPr>
                 </a:tc>
@@ -24384,8 +25319,8 @@
         </p:nvSpPr>
         <p:spPr>
           <a:xfrm>
-            <a:off x="658368" y="4572000"/>
-            <a:ext cx="10881360" cy="1737360"/>
+            <a:off x="658368" y="5623560"/>
+            <a:ext cx="10881360" cy="731520"/>
           </a:xfrm>
           <a:prstGeom prst="rect">
             <a:avLst/>
@@ -24399,35 +25334,24 @@
           <a:lstStyle/>
           <a:p>
             <a:r>
-              <a:rPr sz="1150" b="0">
+              <a:rPr sz="1100">
                 <a:solidFill>
                   <a:srgbClr val="6B7B73"/>
                 </a:solidFill>
                 <a:latin typeface="Hanken Grotesk"/>
               </a:rPr>
-              <a:t>Assumptions: 10 operations/user/day (wallet refresh, create recommendation), ~70/30 read-write, il-central-1 approximate prices, prod only; every active user = 1 Cognito MAU.</a:t>
-            </a:r>
-          </a:p>
-          <a:p>
-            <a:r>
-              <a:rPr sz="1150" b="0">
+              <a:t>Assumptions: 10 operations/user/day, ~70/30 read-write, il-central-1 approximate prices, prod only; every active user = 1 Cognito MAU; RDS Proxy included from 10k users.</a:t>
+            </a:r>
+          </a:p>
+          <a:p>
+            <a:r>
+              <a:rPr sz="1100">
                 <a:solidFill>
                   <a:srgbClr val="6B7B73"/>
                 </a:solidFill>
                 <a:latin typeface="Hanken Grotesk"/>
               </a:rPr>
-              <a:t>Two step functions, then linear: Aurora stops sleeping (~1k users); the Cognito free tier ends at exactly 10k MAU ($0.015/MAU after). Per-user at 100k: ~$0.017/month.</a:t>
-            </a:r>
-          </a:p>
-          <a:p>
-            <a:r>
-              <a:rPr sz="1150" b="0">
-                <a:solidFill>
-                  <a:srgbClr val="6B7B73"/>
-                </a:solidFill>
-                <a:latin typeface="Hanken Grotesk"/>
-              </a:rPr>
-              <a:t>Breaks BEFORE the bill: account concurrency 10 (~10k users, peaks) - AliExpress rate limits (ADR-0021) - Aurora 50 connections post-quota-raise (only THEN the proxy) - the 2-ACU max.</a:t>
+              <a:t>Two step functions, then linear: Aurora stops sleeping (~1k users); the Cognito free tier ends at exactly 10k MAU. Per-user at 100k: ~$0.018/month.</a:t>
             </a:r>
           </a:p>
         </p:txBody>

</xml_diff>

<commit_message>
slides: Security-by-design principle, cost projection into main deck, drop JWT-lag limit
- principles slide becomes a 3x2 six-card grid with the new Security by design card
- Cost projection by user count moves from backup B17 to main slide 18 (after cost,
  before Known limits); backup is B1-B16 again; numbering + footers updated
- Known limits: JWT-revocation-lag row removed (deck assumes the 15-minute
  access-token config; the CDK change itself is intentionally on hold)
- backup B1 trade-off line updated to the 15-minute wording

Co-Authored-By: Claude Fable 5 <noreply@anthropic.com>
Claude-Session: https://claude.ai/code/session_01FECrSGSMqWYxFMSwWq9E5s
</commit_message>
<xml_diff>
--- a/slides/wanthat-presentation.pptx
+++ b/slides/wanthat-presentation.pptx
@@ -22,6 +22,7 @@
     <p:sldId id="289" r:id="rId41"/>
     <p:sldId id="290" r:id="rId42"/>
     <p:sldId id="267" r:id="rId19"/>
+    <p:sldId id="291" r:id="rId43"/>
     <p:sldId id="268" r:id="rId20"/>
     <p:sldId id="269" r:id="rId21"/>
     <p:sldId id="264" r:id="rId16"/>
@@ -40,7 +41,6 @@
     <p:sldId id="275" r:id="rId27"/>
     <p:sldId id="276" r:id="rId28"/>
     <p:sldId id="277" r:id="rId29"/>
-    <p:sldId id="291" r:id="rId43"/>
   </p:sldIdLst>
   <p:sldSz cx="12191695" cy="6858000" type="screen4x3"/>
   <p:notesSz cx="6858000" cy="9144000"/>
@@ -9225,7 +9225,7 @@
                 </a:solidFill>
                 <a:latin typeface="Hanken Grotesk"/>
               </a:rPr>
-              <a:t>Scale projection (10 → 100k users): backup B17.</a:t>
+              <a:t>Scale projection (10 → 100k users): next slide.</a:t>
             </a:r>
           </a:p>
         </p:txBody>
@@ -9408,7 +9408,7 @@
                 </a:solidFill>
                 <a:latin typeface="Space Grotesk"/>
               </a:rPr>
-              <a:t>18</a:t>
+              <a:t>19</a:t>
             </a:r>
           </a:p>
         </p:txBody>
@@ -9771,89 +9771,6 @@
                           </a:solidFill>
                           <a:latin typeface="Hanken Grotesk"/>
                         </a:rPr>
-                        <a:t>JWT revocation lag &lt;= 1 h</a:t>
-                      </a:r>
-                    </a:p>
-                  </a:txBody>
-                  <a:tcPr marL="91440" marR="91440" marT="45720" marB="45720">
-                    <a:solidFill>
-                      <a:srgbClr val="FFFFFF"/>
-                    </a:solidFill>
-                  </a:tcPr>
-                </a:tc>
-                <a:tc>
-                  <a:txBody>
-                    <a:bodyPr/>
-                    <a:lstStyle/>
-                    <a:p>
-                      <a:pPr>
-                        <a:lnSpc>
-                          <a:spcPct val="108000"/>
-                        </a:lnSpc>
-                      </a:pPr>
-                      <a:r>
-                        <a:rPr sz="1050" b="0">
-                          <a:solidFill>
-                            <a:srgbClr val="6B7B73"/>
-                          </a:solidFill>
-                          <a:latin typeface="Hanken Grotesk"/>
-                        </a:rPr>
-                        <a:t>Only member surface is a read-only wallet</a:t>
-                      </a:r>
-                    </a:p>
-                  </a:txBody>
-                  <a:tcPr marL="91440" marR="91440" marT="45720" marB="45720">
-                    <a:solidFill>
-                      <a:srgbClr val="FFFFFF"/>
-                    </a:solidFill>
-                  </a:tcPr>
-                </a:tc>
-                <a:tc>
-                  <a:txBody>
-                    <a:bodyPr/>
-                    <a:lstStyle/>
-                    <a:p>
-                      <a:pPr>
-                        <a:lnSpc>
-                          <a:spcPct val="108000"/>
-                        </a:lnSpc>
-                      </a:pPr>
-                      <a:r>
-                        <a:rPr sz="1050" b="0">
-                          <a:solidFill>
-                            <a:srgbClr val="6B7B73"/>
-                          </a:solidFill>
-                          <a:latin typeface="Hanken Grotesk"/>
-                        </a:rPr>
-                        <a:t>Any sensitive member mutation → short tokens or in-handler check</a:t>
-                      </a:r>
-                    </a:p>
-                  </a:txBody>
-                  <a:tcPr marL="91440" marR="91440" marT="45720" marB="45720">
-                    <a:solidFill>
-                      <a:srgbClr val="FFFFFF"/>
-                    </a:solidFill>
-                  </a:tcPr>
-                </a:tc>
-              </a:tr>
-              <a:tr h="365760">
-                <a:tc>
-                  <a:txBody>
-                    <a:bodyPr/>
-                    <a:lstStyle/>
-                    <a:p>
-                      <a:pPr>
-                        <a:lnSpc>
-                          <a:spcPct val="108000"/>
-                        </a:lnSpc>
-                      </a:pPr>
-                      <a:r>
-                        <a:rPr sz="1050" b="1">
-                          <a:solidFill>
-                            <a:srgbClr val="15201C"/>
-                          </a:solidFill>
-                          <a:latin typeface="Hanken Grotesk"/>
-                        </a:rPr>
                         <a:t>Account concurrency = 10</a:t>
                       </a:r>
                     </a:p>
@@ -10249,7 +10166,7 @@
                 </a:solidFill>
                 <a:latin typeface="Space Mono"/>
               </a:rPr>
-              <a:t>18</a:t>
+              <a:t>19</a:t>
             </a:r>
           </a:p>
         </p:txBody>
@@ -12197,16 +12114,7 @@
                 </a:solidFill>
                 <a:latin typeface="Hanken Grotesk"/>
               </a:rPr>
-              <a:t>Trade-offs signed off with B: </a:t>
-            </a:r>
-            <a:r>
-              <a:rPr sz="1250" b="0">
-                <a:solidFill>
-                  <a:srgbClr val="6B7B73"/>
-                </a:solidFill>
-                <a:latin typeface="Hanken Grotesk"/>
-              </a:rPr>
-              <a:t>userless Face ID waived (remembered-phone one-prompt kept); phone enumeration accepted (preventUserExistenceErrors LEGACY) — mitigated by pool WAF rate rules; JWT revocation lags up to 1 h on our APIs (stateless authorizer) — acceptable while the only member surface is a read-only wallet.</a:t>
+              <a:t>Trade-offs signed off with B: userless Face ID waived (remembered-phone one-prompt kept); phone enumeration accepted (preventUserExistenceErrors LEGACY) — mitigated by pool WAF rate rules; JWT revocation lags up to 15 min on our APIs (stateless authorizer, 15-minute access tokens) — acceptable for the current member surface.</a:t>
             </a:r>
           </a:p>
           <a:p>
@@ -23746,7 +23654,7 @@
                 </a:solidFill>
                 <a:latin typeface="Space Grotesk"/>
               </a:rPr>
-              <a:t>B17</a:t>
+              <a:t>18</a:t>
             </a:r>
           </a:p>
         </p:txBody>
@@ -23780,7 +23688,7 @@
                 </a:solidFill>
                 <a:latin typeface="Space Mono"/>
               </a:rPr>
-              <a:t>BACKUP</a:t>
+              <a:t>DECISIONS</a:t>
             </a:r>
           </a:p>
         </p:txBody>
@@ -23814,7 +23722,7 @@
                 </a:solidFill>
                 <a:latin typeface="Space Grotesk"/>
               </a:rPr>
-              <a:t>Cost progression — 10 to 100k active users</a:t>
+              <a:t>Cost projection by user count</a:t>
             </a:r>
           </a:p>
         </p:txBody>
@@ -23936,7 +23844,7 @@
                 </a:solidFill>
                 <a:latin typeface="Space Mono"/>
               </a:rPr>
-              <a:t>B17</a:t>
+              <a:t>18</a:t>
             </a:r>
           </a:p>
         </p:txBody>
@@ -27277,8 +27185,8 @@
         </p:nvSpPr>
         <p:spPr>
           <a:xfrm>
-            <a:off x="658368" y="1874519"/>
-            <a:ext cx="2157984" cy="3794760"/>
+            <a:off x="658368" y="1691640"/>
+            <a:ext cx="3520440" cy="2240280"/>
           </a:xfrm>
           <a:prstGeom prst="roundRect">
             <a:avLst>
@@ -27325,7 +27233,7 @@
         </p:nvSpPr>
         <p:spPr>
           <a:xfrm>
-            <a:off x="841247" y="2075688"/>
+            <a:off x="841248" y="1874520"/>
             <a:ext cx="475488" cy="475488"/>
           </a:xfrm>
           <a:prstGeom prst="roundRect">
@@ -27381,7 +27289,7 @@
         </p:blipFill>
         <p:spPr>
           <a:xfrm>
-            <a:off x="909827" y="2144268"/>
+            <a:off x="905256" y="1943100"/>
             <a:ext cx="338328" cy="338328"/>
           </a:xfrm>
           <a:prstGeom prst="rect">
@@ -27397,8 +27305,8 @@
         </p:nvSpPr>
         <p:spPr>
           <a:xfrm>
-            <a:off x="841247" y="2697480"/>
-            <a:ext cx="1792224" cy="777240"/>
+            <a:off x="1435608" y="1929384"/>
+            <a:ext cx="2560320" cy="457200"/>
           </a:xfrm>
           <a:prstGeom prst="rect">
             <a:avLst/>
@@ -27436,8 +27344,8 @@
         </p:nvSpPr>
         <p:spPr>
           <a:xfrm>
-            <a:off x="841247" y="3520440"/>
-            <a:ext cx="1792224" cy="2011680"/>
+            <a:off x="841248" y="2468880"/>
+            <a:ext cx="3154680" cy="1371600"/>
           </a:xfrm>
           <a:prstGeom prst="rect">
             <a:avLst/>
@@ -27475,8 +27383,8 @@
         </p:nvSpPr>
         <p:spPr>
           <a:xfrm>
-            <a:off x="2962656" y="1874519"/>
-            <a:ext cx="2157984" cy="3794760"/>
+            <a:off x="4343400" y="1691640"/>
+            <a:ext cx="3520440" cy="2240280"/>
           </a:xfrm>
           <a:prstGeom prst="roundRect">
             <a:avLst>
@@ -27523,7 +27431,7 @@
         </p:nvSpPr>
         <p:spPr>
           <a:xfrm>
-            <a:off x="3145536" y="2075688"/>
+            <a:off x="4526280" y="1874520"/>
             <a:ext cx="475488" cy="475488"/>
           </a:xfrm>
           <a:prstGeom prst="roundRect">
@@ -27579,7 +27487,7 @@
         </p:blipFill>
         <p:spPr>
           <a:xfrm>
-            <a:off x="3214116" y="2144268"/>
+            <a:off x="4590288" y="1943100"/>
             <a:ext cx="338328" cy="338328"/>
           </a:xfrm>
           <a:prstGeom prst="rect">
@@ -27595,8 +27503,8 @@
         </p:nvSpPr>
         <p:spPr>
           <a:xfrm>
-            <a:off x="3145536" y="2697480"/>
-            <a:ext cx="1792224" cy="777240"/>
+            <a:off x="5120640" y="1929384"/>
+            <a:ext cx="2560320" cy="457200"/>
           </a:xfrm>
           <a:prstGeom prst="rect">
             <a:avLst/>
@@ -27634,8 +27542,8 @@
         </p:nvSpPr>
         <p:spPr>
           <a:xfrm>
-            <a:off x="3145536" y="3520440"/>
-            <a:ext cx="1792224" cy="2011680"/>
+            <a:off x="4526280" y="2468880"/>
+            <a:ext cx="3154680" cy="1371600"/>
           </a:xfrm>
           <a:prstGeom prst="rect">
             <a:avLst/>
@@ -27673,8 +27581,8 @@
         </p:nvSpPr>
         <p:spPr>
           <a:xfrm>
-            <a:off x="5266944" y="1874519"/>
-            <a:ext cx="2157984" cy="3794760"/>
+            <a:off x="8028432" y="1691640"/>
+            <a:ext cx="3520440" cy="2240280"/>
           </a:xfrm>
           <a:prstGeom prst="roundRect">
             <a:avLst>
@@ -27721,7 +27629,7 @@
         </p:nvSpPr>
         <p:spPr>
           <a:xfrm>
-            <a:off x="5449824" y="2075688"/>
+            <a:off x="8211312" y="1874520"/>
             <a:ext cx="475488" cy="475488"/>
           </a:xfrm>
           <a:prstGeom prst="roundRect">
@@ -27777,7 +27685,7 @@
         </p:blipFill>
         <p:spPr>
           <a:xfrm>
-            <a:off x="5518404" y="2144268"/>
+            <a:off x="8275320" y="1943100"/>
             <a:ext cx="338328" cy="338328"/>
           </a:xfrm>
           <a:prstGeom prst="rect">
@@ -27793,8 +27701,8 @@
         </p:nvSpPr>
         <p:spPr>
           <a:xfrm>
-            <a:off x="5449824" y="2697480"/>
-            <a:ext cx="1792224" cy="777240"/>
+            <a:off x="8805672" y="1929384"/>
+            <a:ext cx="2560320" cy="457200"/>
           </a:xfrm>
           <a:prstGeom prst="rect">
             <a:avLst/>
@@ -27832,8 +27740,8 @@
         </p:nvSpPr>
         <p:spPr>
           <a:xfrm>
-            <a:off x="5449824" y="3520440"/>
-            <a:ext cx="1792224" cy="2011680"/>
+            <a:off x="8211312" y="2468880"/>
+            <a:ext cx="3154680" cy="1371600"/>
           </a:xfrm>
           <a:prstGeom prst="rect">
             <a:avLst/>
@@ -27871,8 +27779,8 @@
         </p:nvSpPr>
         <p:spPr>
           <a:xfrm>
-            <a:off x="7571232" y="1874519"/>
-            <a:ext cx="2157984" cy="3794760"/>
+            <a:off x="658368" y="4050792"/>
+            <a:ext cx="3520440" cy="2240280"/>
           </a:xfrm>
           <a:prstGeom prst="roundRect">
             <a:avLst>
@@ -27919,7 +27827,7 @@
         </p:nvSpPr>
         <p:spPr>
           <a:xfrm>
-            <a:off x="7754112" y="2075688"/>
+            <a:off x="841248" y="4233672"/>
             <a:ext cx="475488" cy="475488"/>
           </a:xfrm>
           <a:prstGeom prst="roundRect">
@@ -27975,7 +27883,7 @@
         </p:blipFill>
         <p:spPr>
           <a:xfrm>
-            <a:off x="7822692" y="2144268"/>
+            <a:off x="905256" y="4302252"/>
             <a:ext cx="338328" cy="338328"/>
           </a:xfrm>
           <a:prstGeom prst="rect">
@@ -27991,8 +27899,8 @@
         </p:nvSpPr>
         <p:spPr>
           <a:xfrm>
-            <a:off x="7754112" y="2697480"/>
-            <a:ext cx="1792224" cy="777240"/>
+            <a:off x="1435608" y="4288536"/>
+            <a:ext cx="2560320" cy="457200"/>
           </a:xfrm>
           <a:prstGeom prst="rect">
             <a:avLst/>
@@ -28030,8 +27938,8 @@
         </p:nvSpPr>
         <p:spPr>
           <a:xfrm>
-            <a:off x="7754112" y="3520440"/>
-            <a:ext cx="1792224" cy="2011680"/>
+            <a:off x="841248" y="4828032"/>
+            <a:ext cx="3154680" cy="1371600"/>
           </a:xfrm>
           <a:prstGeom prst="rect">
             <a:avLst/>
@@ -28069,8 +27977,8 @@
         </p:nvSpPr>
         <p:spPr>
           <a:xfrm>
-            <a:off x="9875520" y="1874519"/>
-            <a:ext cx="2157984" cy="3794760"/>
+            <a:off x="4343400" y="4050792"/>
+            <a:ext cx="3520440" cy="2240280"/>
           </a:xfrm>
           <a:prstGeom prst="roundRect">
             <a:avLst>
@@ -28117,7 +28025,7 @@
         </p:nvSpPr>
         <p:spPr>
           <a:xfrm>
-            <a:off x="10058400" y="2075688"/>
+            <a:off x="4526280" y="4233672"/>
             <a:ext cx="475488" cy="475488"/>
           </a:xfrm>
           <a:prstGeom prst="roundRect">
@@ -28173,7 +28081,7 @@
         </p:blipFill>
         <p:spPr>
           <a:xfrm>
-            <a:off x="10126980" y="2144268"/>
+            <a:off x="4590288" y="4302252"/>
             <a:ext cx="338328" cy="338328"/>
           </a:xfrm>
           <a:prstGeom prst="rect">
@@ -28189,8 +28097,8 @@
         </p:nvSpPr>
         <p:spPr>
           <a:xfrm>
-            <a:off x="10058400" y="2697480"/>
-            <a:ext cx="1792224" cy="777240"/>
+            <a:off x="5120640" y="4288536"/>
+            <a:ext cx="2560320" cy="457200"/>
           </a:xfrm>
           <a:prstGeom prst="rect">
             <a:avLst/>
@@ -28228,8 +28136,8 @@
         </p:nvSpPr>
         <p:spPr>
           <a:xfrm>
-            <a:off x="10058400" y="3520440"/>
-            <a:ext cx="1792224" cy="2011680"/>
+            <a:off x="4526280" y="4828032"/>
+            <a:ext cx="3154680" cy="1371600"/>
           </a:xfrm>
           <a:prstGeom prst="rect">
             <a:avLst/>
@@ -28377,6 +28285,204 @@
                 <a:latin typeface="Space Mono"/>
               </a:rPr>
               <a:t>6</a:t>
+            </a:r>
+          </a:p>
+        </p:txBody>
+      </p:sp>
+      <p:sp>
+        <p:nvSpPr>
+          <p:cNvPr id="5" name="Rounded Rectangle 4"/>
+          <p:cNvSpPr/>
+          <p:nvPr/>
+        </p:nvSpPr>
+        <p:spPr>
+          <a:xfrm>
+            <a:off x="8028432" y="4050792"/>
+            <a:ext cx="3520440" cy="2240280"/>
+          </a:xfrm>
+          <a:prstGeom prst="roundRect">
+            <a:avLst>
+              <a:gd name="adj" fmla="val 5000"/>
+            </a:avLst>
+          </a:prstGeom>
+          <a:solidFill>
+            <a:srgbClr val="FFFFFF"/>
+          </a:solidFill>
+          <a:ln w="12700">
+            <a:solidFill>
+              <a:srgbClr val="E6EBE8"/>
+            </a:solidFill>
+          </a:ln>
+          <a:effectLst/>
+        </p:spPr>
+        <p:style>
+          <a:lnRef idx="1">
+            <a:schemeClr val="accent1"/>
+          </a:lnRef>
+          <a:fillRef idx="3">
+            <a:schemeClr val="accent1"/>
+          </a:fillRef>
+          <a:effectRef idx="2">
+            <a:schemeClr val="accent1"/>
+          </a:effectRef>
+          <a:fontRef idx="minor">
+            <a:schemeClr val="lt1"/>
+          </a:fontRef>
+        </p:style>
+        <p:txBody>
+          <a:bodyPr rtlCol="0" anchor="ctr"/>
+          <a:lstStyle/>
+          <a:p>
+            <a:pPr algn="ctr"/>
+          </a:p>
+        </p:txBody>
+      </p:sp>
+      <p:sp>
+        <p:nvSpPr>
+          <p:cNvPr id="6" name="Rounded Rectangle 5"/>
+          <p:cNvSpPr/>
+          <p:nvPr/>
+        </p:nvSpPr>
+        <p:spPr>
+          <a:xfrm>
+            <a:off x="8211312" y="4233672"/>
+            <a:ext cx="475488" cy="475488"/>
+          </a:xfrm>
+          <a:prstGeom prst="roundRect">
+            <a:avLst>
+              <a:gd name="adj" fmla="val 22000"/>
+            </a:avLst>
+          </a:prstGeom>
+          <a:solidFill>
+            <a:srgbClr val="E7F1EC"/>
+          </a:solidFill>
+          <a:ln w="12700">
+            <a:solidFill>
+              <a:srgbClr val="D2E3D9"/>
+            </a:solidFill>
+          </a:ln>
+          <a:effectLst/>
+        </p:spPr>
+        <p:style>
+          <a:lnRef idx="1">
+            <a:schemeClr val="accent1"/>
+          </a:lnRef>
+          <a:fillRef idx="3">
+            <a:schemeClr val="accent1"/>
+          </a:fillRef>
+          <a:effectRef idx="2">
+            <a:schemeClr val="accent1"/>
+          </a:effectRef>
+          <a:fontRef idx="minor">
+            <a:schemeClr val="lt1"/>
+          </a:fontRef>
+        </p:style>
+        <p:txBody>
+          <a:bodyPr rtlCol="0" anchor="ctr"/>
+          <a:lstStyle/>
+          <a:p>
+            <a:pPr algn="ctr"/>
+          </a:p>
+        </p:txBody>
+      </p:sp>
+      <p:pic>
+        <p:nvPicPr>
+          <p:cNvPr id="7" name="Picture 6" descr="s06_i1.png"/>
+          <p:cNvPicPr>
+            <a:picLocks noChangeAspect="1"/>
+          </p:cNvPicPr>
+          <p:nvPr/>
+        </p:nvPicPr>
+        <p:blipFill>
+          <a:blip r:embed="rId2"/>
+          <a:stretch>
+            <a:fillRect/>
+          </a:stretch>
+        </p:blipFill>
+        <p:spPr>
+          <a:xfrm>
+            <a:off x="8275320" y="4302252"/>
+            <a:ext cx="338328" cy="338328"/>
+          </a:xfrm>
+          <a:prstGeom prst="rect">
+            <a:avLst/>
+          </a:prstGeom>
+        </p:spPr>
+      </p:pic>
+      <p:sp>
+        <p:nvSpPr>
+          <p:cNvPr id="8" name="TextBox 7"/>
+          <p:cNvSpPr txBox="1"/>
+          <p:nvPr/>
+        </p:nvSpPr>
+        <p:spPr>
+          <a:xfrm>
+            <a:off x="8805672" y="4288536"/>
+            <a:ext cx="2560320" cy="457200"/>
+          </a:xfrm>
+          <a:prstGeom prst="rect">
+            <a:avLst/>
+          </a:prstGeom>
+          <a:noFill/>
+        </p:spPr>
+        <p:txBody>
+          <a:bodyPr wrap="square" anchor="t" lIns="0" rIns="0" tIns="0" bIns="0">
+            <a:spAutoFit/>
+          </a:bodyPr>
+          <a:lstStyle/>
+          <a:p>
+            <a:pPr>
+              <a:lnSpc>
+                <a:spcPct val="102000"/>
+              </a:lnSpc>
+            </a:pPr>
+            <a:r>
+              <a:rPr sz="1450" b="1">
+                <a:solidFill>
+                  <a:srgbClr val="15201C"/>
+                </a:solidFill>
+                <a:latin typeface="Space Grotesk"/>
+              </a:rPr>
+              <a:t>Security by design</a:t>
+            </a:r>
+          </a:p>
+        </p:txBody>
+      </p:sp>
+      <p:sp>
+        <p:nvSpPr>
+          <p:cNvPr id="9" name="TextBox 8"/>
+          <p:cNvSpPr txBox="1"/>
+          <p:nvPr/>
+        </p:nvSpPr>
+        <p:spPr>
+          <a:xfrm>
+            <a:off x="8211312" y="4828032"/>
+            <a:ext cx="3154680" cy="1371600"/>
+          </a:xfrm>
+          <a:prstGeom prst="rect">
+            <a:avLst/>
+          </a:prstGeom>
+          <a:noFill/>
+        </p:spPr>
+        <p:txBody>
+          <a:bodyPr wrap="square" anchor="t" lIns="0" rIns="0" tIns="0" bIns="0">
+            <a:spAutoFit/>
+          </a:bodyPr>
+          <a:lstStyle/>
+          <a:p>
+            <a:pPr>
+              <a:lnSpc>
+                <a:spcPct val="110000"/>
+              </a:lnSpc>
+            </a:pPr>
+            <a:r>
+              <a:rPr sz="1100" b="0">
+                <a:solidFill>
+                  <a:srgbClr val="6B7B73"/>
+                </a:solidFill>
+                <a:latin typeface="Hanken Grotesk"/>
+              </a:rPr>
+              <a:t>Least privilege per function — IAM + one Postgres role each; money is append-only + audited; PII isolated in Cognito; workers never HTTP-exposed.</a:t>
             </a:r>
           </a:p>
         </p:txBody>

</xml_diff>

<commit_message>
slides: Security-by-design principle, cost projection into main deck, drop JWT-lag limit (#208)
- principles slide becomes a 3x2 six-card grid with the new Security by design card
- Cost projection by user count moves from backup B17 to main slide 18 (after cost,
  before Known limits); backup is B1-B16 again; numbering + footers updated
- Known limits: JWT-revocation-lag row removed (deck assumes the 15-minute
  access-token config; the CDK change itself is intentionally on hold)
- backup B1 trade-off line updated to the 15-minute wording


Claude-Session: https://claude.ai/code/session_01FECrSGSMqWYxFMSwWq9E5s

Co-authored-by: Claude Fable 5 <noreply@anthropic.com>
</commit_message>
<xml_diff>
--- a/slides/wanthat-presentation.pptx
+++ b/slides/wanthat-presentation.pptx
@@ -22,6 +22,7 @@
     <p:sldId id="289" r:id="rId41"/>
     <p:sldId id="290" r:id="rId42"/>
     <p:sldId id="267" r:id="rId19"/>
+    <p:sldId id="291" r:id="rId43"/>
     <p:sldId id="268" r:id="rId20"/>
     <p:sldId id="269" r:id="rId21"/>
     <p:sldId id="264" r:id="rId16"/>
@@ -40,7 +41,6 @@
     <p:sldId id="275" r:id="rId27"/>
     <p:sldId id="276" r:id="rId28"/>
     <p:sldId id="277" r:id="rId29"/>
-    <p:sldId id="291" r:id="rId43"/>
   </p:sldIdLst>
   <p:sldSz cx="12191695" cy="6858000" type="screen4x3"/>
   <p:notesSz cx="6858000" cy="9144000"/>
@@ -9225,7 +9225,7 @@
                 </a:solidFill>
                 <a:latin typeface="Hanken Grotesk"/>
               </a:rPr>
-              <a:t>Scale projection (10 → 100k users): backup B17.</a:t>
+              <a:t>Scale projection (10 → 100k users): next slide.</a:t>
             </a:r>
           </a:p>
         </p:txBody>
@@ -9408,7 +9408,7 @@
                 </a:solidFill>
                 <a:latin typeface="Space Grotesk"/>
               </a:rPr>
-              <a:t>18</a:t>
+              <a:t>19</a:t>
             </a:r>
           </a:p>
         </p:txBody>
@@ -9771,89 +9771,6 @@
                           </a:solidFill>
                           <a:latin typeface="Hanken Grotesk"/>
                         </a:rPr>
-                        <a:t>JWT revocation lag &lt;= 1 h</a:t>
-                      </a:r>
-                    </a:p>
-                  </a:txBody>
-                  <a:tcPr marL="91440" marR="91440" marT="45720" marB="45720">
-                    <a:solidFill>
-                      <a:srgbClr val="FFFFFF"/>
-                    </a:solidFill>
-                  </a:tcPr>
-                </a:tc>
-                <a:tc>
-                  <a:txBody>
-                    <a:bodyPr/>
-                    <a:lstStyle/>
-                    <a:p>
-                      <a:pPr>
-                        <a:lnSpc>
-                          <a:spcPct val="108000"/>
-                        </a:lnSpc>
-                      </a:pPr>
-                      <a:r>
-                        <a:rPr sz="1050" b="0">
-                          <a:solidFill>
-                            <a:srgbClr val="6B7B73"/>
-                          </a:solidFill>
-                          <a:latin typeface="Hanken Grotesk"/>
-                        </a:rPr>
-                        <a:t>Only member surface is a read-only wallet</a:t>
-                      </a:r>
-                    </a:p>
-                  </a:txBody>
-                  <a:tcPr marL="91440" marR="91440" marT="45720" marB="45720">
-                    <a:solidFill>
-                      <a:srgbClr val="FFFFFF"/>
-                    </a:solidFill>
-                  </a:tcPr>
-                </a:tc>
-                <a:tc>
-                  <a:txBody>
-                    <a:bodyPr/>
-                    <a:lstStyle/>
-                    <a:p>
-                      <a:pPr>
-                        <a:lnSpc>
-                          <a:spcPct val="108000"/>
-                        </a:lnSpc>
-                      </a:pPr>
-                      <a:r>
-                        <a:rPr sz="1050" b="0">
-                          <a:solidFill>
-                            <a:srgbClr val="6B7B73"/>
-                          </a:solidFill>
-                          <a:latin typeface="Hanken Grotesk"/>
-                        </a:rPr>
-                        <a:t>Any sensitive member mutation → short tokens or in-handler check</a:t>
-                      </a:r>
-                    </a:p>
-                  </a:txBody>
-                  <a:tcPr marL="91440" marR="91440" marT="45720" marB="45720">
-                    <a:solidFill>
-                      <a:srgbClr val="FFFFFF"/>
-                    </a:solidFill>
-                  </a:tcPr>
-                </a:tc>
-              </a:tr>
-              <a:tr h="365760">
-                <a:tc>
-                  <a:txBody>
-                    <a:bodyPr/>
-                    <a:lstStyle/>
-                    <a:p>
-                      <a:pPr>
-                        <a:lnSpc>
-                          <a:spcPct val="108000"/>
-                        </a:lnSpc>
-                      </a:pPr>
-                      <a:r>
-                        <a:rPr sz="1050" b="1">
-                          <a:solidFill>
-                            <a:srgbClr val="15201C"/>
-                          </a:solidFill>
-                          <a:latin typeface="Hanken Grotesk"/>
-                        </a:rPr>
                         <a:t>Account concurrency = 10</a:t>
                       </a:r>
                     </a:p>
@@ -10249,7 +10166,7 @@
                 </a:solidFill>
                 <a:latin typeface="Space Mono"/>
               </a:rPr>
-              <a:t>18</a:t>
+              <a:t>19</a:t>
             </a:r>
           </a:p>
         </p:txBody>
@@ -12197,16 +12114,7 @@
                 </a:solidFill>
                 <a:latin typeface="Hanken Grotesk"/>
               </a:rPr>
-              <a:t>Trade-offs signed off with B: </a:t>
-            </a:r>
-            <a:r>
-              <a:rPr sz="1250" b="0">
-                <a:solidFill>
-                  <a:srgbClr val="6B7B73"/>
-                </a:solidFill>
-                <a:latin typeface="Hanken Grotesk"/>
-              </a:rPr>
-              <a:t>userless Face ID waived (remembered-phone one-prompt kept); phone enumeration accepted (preventUserExistenceErrors LEGACY) — mitigated by pool WAF rate rules; JWT revocation lags up to 1 h on our APIs (stateless authorizer) — acceptable while the only member surface is a read-only wallet.</a:t>
+              <a:t>Trade-offs signed off with B: userless Face ID waived (remembered-phone one-prompt kept); phone enumeration accepted (preventUserExistenceErrors LEGACY) — mitigated by pool WAF rate rules; JWT revocation lags up to 15 min on our APIs (stateless authorizer, 15-minute access tokens) — acceptable for the current member surface.</a:t>
             </a:r>
           </a:p>
           <a:p>
@@ -23746,7 +23654,7 @@
                 </a:solidFill>
                 <a:latin typeface="Space Grotesk"/>
               </a:rPr>
-              <a:t>B17</a:t>
+              <a:t>18</a:t>
             </a:r>
           </a:p>
         </p:txBody>
@@ -23780,7 +23688,7 @@
                 </a:solidFill>
                 <a:latin typeface="Space Mono"/>
               </a:rPr>
-              <a:t>BACKUP</a:t>
+              <a:t>DECISIONS</a:t>
             </a:r>
           </a:p>
         </p:txBody>
@@ -23814,7 +23722,7 @@
                 </a:solidFill>
                 <a:latin typeface="Space Grotesk"/>
               </a:rPr>
-              <a:t>Cost progression — 10 to 100k active users</a:t>
+              <a:t>Cost projection by user count</a:t>
             </a:r>
           </a:p>
         </p:txBody>
@@ -23936,7 +23844,7 @@
                 </a:solidFill>
                 <a:latin typeface="Space Mono"/>
               </a:rPr>
-              <a:t>B17</a:t>
+              <a:t>18</a:t>
             </a:r>
           </a:p>
         </p:txBody>
@@ -27277,8 +27185,8 @@
         </p:nvSpPr>
         <p:spPr>
           <a:xfrm>
-            <a:off x="658368" y="1874519"/>
-            <a:ext cx="2157984" cy="3794760"/>
+            <a:off x="658368" y="1691640"/>
+            <a:ext cx="3520440" cy="2240280"/>
           </a:xfrm>
           <a:prstGeom prst="roundRect">
             <a:avLst>
@@ -27325,7 +27233,7 @@
         </p:nvSpPr>
         <p:spPr>
           <a:xfrm>
-            <a:off x="841247" y="2075688"/>
+            <a:off x="841248" y="1874520"/>
             <a:ext cx="475488" cy="475488"/>
           </a:xfrm>
           <a:prstGeom prst="roundRect">
@@ -27381,7 +27289,7 @@
         </p:blipFill>
         <p:spPr>
           <a:xfrm>
-            <a:off x="909827" y="2144268"/>
+            <a:off x="905256" y="1943100"/>
             <a:ext cx="338328" cy="338328"/>
           </a:xfrm>
           <a:prstGeom prst="rect">
@@ -27397,8 +27305,8 @@
         </p:nvSpPr>
         <p:spPr>
           <a:xfrm>
-            <a:off x="841247" y="2697480"/>
-            <a:ext cx="1792224" cy="777240"/>
+            <a:off x="1435608" y="1929384"/>
+            <a:ext cx="2560320" cy="457200"/>
           </a:xfrm>
           <a:prstGeom prst="rect">
             <a:avLst/>
@@ -27436,8 +27344,8 @@
         </p:nvSpPr>
         <p:spPr>
           <a:xfrm>
-            <a:off x="841247" y="3520440"/>
-            <a:ext cx="1792224" cy="2011680"/>
+            <a:off x="841248" y="2468880"/>
+            <a:ext cx="3154680" cy="1371600"/>
           </a:xfrm>
           <a:prstGeom prst="rect">
             <a:avLst/>
@@ -27475,8 +27383,8 @@
         </p:nvSpPr>
         <p:spPr>
           <a:xfrm>
-            <a:off x="2962656" y="1874519"/>
-            <a:ext cx="2157984" cy="3794760"/>
+            <a:off x="4343400" y="1691640"/>
+            <a:ext cx="3520440" cy="2240280"/>
           </a:xfrm>
           <a:prstGeom prst="roundRect">
             <a:avLst>
@@ -27523,7 +27431,7 @@
         </p:nvSpPr>
         <p:spPr>
           <a:xfrm>
-            <a:off x="3145536" y="2075688"/>
+            <a:off x="4526280" y="1874520"/>
             <a:ext cx="475488" cy="475488"/>
           </a:xfrm>
           <a:prstGeom prst="roundRect">
@@ -27579,7 +27487,7 @@
         </p:blipFill>
         <p:spPr>
           <a:xfrm>
-            <a:off x="3214116" y="2144268"/>
+            <a:off x="4590288" y="1943100"/>
             <a:ext cx="338328" cy="338328"/>
           </a:xfrm>
           <a:prstGeom prst="rect">
@@ -27595,8 +27503,8 @@
         </p:nvSpPr>
         <p:spPr>
           <a:xfrm>
-            <a:off x="3145536" y="2697480"/>
-            <a:ext cx="1792224" cy="777240"/>
+            <a:off x="5120640" y="1929384"/>
+            <a:ext cx="2560320" cy="457200"/>
           </a:xfrm>
           <a:prstGeom prst="rect">
             <a:avLst/>
@@ -27634,8 +27542,8 @@
         </p:nvSpPr>
         <p:spPr>
           <a:xfrm>
-            <a:off x="3145536" y="3520440"/>
-            <a:ext cx="1792224" cy="2011680"/>
+            <a:off x="4526280" y="2468880"/>
+            <a:ext cx="3154680" cy="1371600"/>
           </a:xfrm>
           <a:prstGeom prst="rect">
             <a:avLst/>
@@ -27673,8 +27581,8 @@
         </p:nvSpPr>
         <p:spPr>
           <a:xfrm>
-            <a:off x="5266944" y="1874519"/>
-            <a:ext cx="2157984" cy="3794760"/>
+            <a:off x="8028432" y="1691640"/>
+            <a:ext cx="3520440" cy="2240280"/>
           </a:xfrm>
           <a:prstGeom prst="roundRect">
             <a:avLst>
@@ -27721,7 +27629,7 @@
         </p:nvSpPr>
         <p:spPr>
           <a:xfrm>
-            <a:off x="5449824" y="2075688"/>
+            <a:off x="8211312" y="1874520"/>
             <a:ext cx="475488" cy="475488"/>
           </a:xfrm>
           <a:prstGeom prst="roundRect">
@@ -27777,7 +27685,7 @@
         </p:blipFill>
         <p:spPr>
           <a:xfrm>
-            <a:off x="5518404" y="2144268"/>
+            <a:off x="8275320" y="1943100"/>
             <a:ext cx="338328" cy="338328"/>
           </a:xfrm>
           <a:prstGeom prst="rect">
@@ -27793,8 +27701,8 @@
         </p:nvSpPr>
         <p:spPr>
           <a:xfrm>
-            <a:off x="5449824" y="2697480"/>
-            <a:ext cx="1792224" cy="777240"/>
+            <a:off x="8805672" y="1929384"/>
+            <a:ext cx="2560320" cy="457200"/>
           </a:xfrm>
           <a:prstGeom prst="rect">
             <a:avLst/>
@@ -27832,8 +27740,8 @@
         </p:nvSpPr>
         <p:spPr>
           <a:xfrm>
-            <a:off x="5449824" y="3520440"/>
-            <a:ext cx="1792224" cy="2011680"/>
+            <a:off x="8211312" y="2468880"/>
+            <a:ext cx="3154680" cy="1371600"/>
           </a:xfrm>
           <a:prstGeom prst="rect">
             <a:avLst/>
@@ -27871,8 +27779,8 @@
         </p:nvSpPr>
         <p:spPr>
           <a:xfrm>
-            <a:off x="7571232" y="1874519"/>
-            <a:ext cx="2157984" cy="3794760"/>
+            <a:off x="658368" y="4050792"/>
+            <a:ext cx="3520440" cy="2240280"/>
           </a:xfrm>
           <a:prstGeom prst="roundRect">
             <a:avLst>
@@ -27919,7 +27827,7 @@
         </p:nvSpPr>
         <p:spPr>
           <a:xfrm>
-            <a:off x="7754112" y="2075688"/>
+            <a:off x="841248" y="4233672"/>
             <a:ext cx="475488" cy="475488"/>
           </a:xfrm>
           <a:prstGeom prst="roundRect">
@@ -27975,7 +27883,7 @@
         </p:blipFill>
         <p:spPr>
           <a:xfrm>
-            <a:off x="7822692" y="2144268"/>
+            <a:off x="905256" y="4302252"/>
             <a:ext cx="338328" cy="338328"/>
           </a:xfrm>
           <a:prstGeom prst="rect">
@@ -27991,8 +27899,8 @@
         </p:nvSpPr>
         <p:spPr>
           <a:xfrm>
-            <a:off x="7754112" y="2697480"/>
-            <a:ext cx="1792224" cy="777240"/>
+            <a:off x="1435608" y="4288536"/>
+            <a:ext cx="2560320" cy="457200"/>
           </a:xfrm>
           <a:prstGeom prst="rect">
             <a:avLst/>
@@ -28030,8 +27938,8 @@
         </p:nvSpPr>
         <p:spPr>
           <a:xfrm>
-            <a:off x="7754112" y="3520440"/>
-            <a:ext cx="1792224" cy="2011680"/>
+            <a:off x="841248" y="4828032"/>
+            <a:ext cx="3154680" cy="1371600"/>
           </a:xfrm>
           <a:prstGeom prst="rect">
             <a:avLst/>
@@ -28069,8 +27977,8 @@
         </p:nvSpPr>
         <p:spPr>
           <a:xfrm>
-            <a:off x="9875520" y="1874519"/>
-            <a:ext cx="2157984" cy="3794760"/>
+            <a:off x="4343400" y="4050792"/>
+            <a:ext cx="3520440" cy="2240280"/>
           </a:xfrm>
           <a:prstGeom prst="roundRect">
             <a:avLst>
@@ -28117,7 +28025,7 @@
         </p:nvSpPr>
         <p:spPr>
           <a:xfrm>
-            <a:off x="10058400" y="2075688"/>
+            <a:off x="4526280" y="4233672"/>
             <a:ext cx="475488" cy="475488"/>
           </a:xfrm>
           <a:prstGeom prst="roundRect">
@@ -28173,7 +28081,7 @@
         </p:blipFill>
         <p:spPr>
           <a:xfrm>
-            <a:off x="10126980" y="2144268"/>
+            <a:off x="4590288" y="4302252"/>
             <a:ext cx="338328" cy="338328"/>
           </a:xfrm>
           <a:prstGeom prst="rect">
@@ -28189,8 +28097,8 @@
         </p:nvSpPr>
         <p:spPr>
           <a:xfrm>
-            <a:off x="10058400" y="2697480"/>
-            <a:ext cx="1792224" cy="777240"/>
+            <a:off x="5120640" y="4288536"/>
+            <a:ext cx="2560320" cy="457200"/>
           </a:xfrm>
           <a:prstGeom prst="rect">
             <a:avLst/>
@@ -28228,8 +28136,8 @@
         </p:nvSpPr>
         <p:spPr>
           <a:xfrm>
-            <a:off x="10058400" y="3520440"/>
-            <a:ext cx="1792224" cy="2011680"/>
+            <a:off x="4526280" y="4828032"/>
+            <a:ext cx="3154680" cy="1371600"/>
           </a:xfrm>
           <a:prstGeom prst="rect">
             <a:avLst/>
@@ -28377,6 +28285,204 @@
                 <a:latin typeface="Space Mono"/>
               </a:rPr>
               <a:t>6</a:t>
+            </a:r>
+          </a:p>
+        </p:txBody>
+      </p:sp>
+      <p:sp>
+        <p:nvSpPr>
+          <p:cNvPr id="5" name="Rounded Rectangle 4"/>
+          <p:cNvSpPr/>
+          <p:nvPr/>
+        </p:nvSpPr>
+        <p:spPr>
+          <a:xfrm>
+            <a:off x="8028432" y="4050792"/>
+            <a:ext cx="3520440" cy="2240280"/>
+          </a:xfrm>
+          <a:prstGeom prst="roundRect">
+            <a:avLst>
+              <a:gd name="adj" fmla="val 5000"/>
+            </a:avLst>
+          </a:prstGeom>
+          <a:solidFill>
+            <a:srgbClr val="FFFFFF"/>
+          </a:solidFill>
+          <a:ln w="12700">
+            <a:solidFill>
+              <a:srgbClr val="E6EBE8"/>
+            </a:solidFill>
+          </a:ln>
+          <a:effectLst/>
+        </p:spPr>
+        <p:style>
+          <a:lnRef idx="1">
+            <a:schemeClr val="accent1"/>
+          </a:lnRef>
+          <a:fillRef idx="3">
+            <a:schemeClr val="accent1"/>
+          </a:fillRef>
+          <a:effectRef idx="2">
+            <a:schemeClr val="accent1"/>
+          </a:effectRef>
+          <a:fontRef idx="minor">
+            <a:schemeClr val="lt1"/>
+          </a:fontRef>
+        </p:style>
+        <p:txBody>
+          <a:bodyPr rtlCol="0" anchor="ctr"/>
+          <a:lstStyle/>
+          <a:p>
+            <a:pPr algn="ctr"/>
+          </a:p>
+        </p:txBody>
+      </p:sp>
+      <p:sp>
+        <p:nvSpPr>
+          <p:cNvPr id="6" name="Rounded Rectangle 5"/>
+          <p:cNvSpPr/>
+          <p:nvPr/>
+        </p:nvSpPr>
+        <p:spPr>
+          <a:xfrm>
+            <a:off x="8211312" y="4233672"/>
+            <a:ext cx="475488" cy="475488"/>
+          </a:xfrm>
+          <a:prstGeom prst="roundRect">
+            <a:avLst>
+              <a:gd name="adj" fmla="val 22000"/>
+            </a:avLst>
+          </a:prstGeom>
+          <a:solidFill>
+            <a:srgbClr val="E7F1EC"/>
+          </a:solidFill>
+          <a:ln w="12700">
+            <a:solidFill>
+              <a:srgbClr val="D2E3D9"/>
+            </a:solidFill>
+          </a:ln>
+          <a:effectLst/>
+        </p:spPr>
+        <p:style>
+          <a:lnRef idx="1">
+            <a:schemeClr val="accent1"/>
+          </a:lnRef>
+          <a:fillRef idx="3">
+            <a:schemeClr val="accent1"/>
+          </a:fillRef>
+          <a:effectRef idx="2">
+            <a:schemeClr val="accent1"/>
+          </a:effectRef>
+          <a:fontRef idx="minor">
+            <a:schemeClr val="lt1"/>
+          </a:fontRef>
+        </p:style>
+        <p:txBody>
+          <a:bodyPr rtlCol="0" anchor="ctr"/>
+          <a:lstStyle/>
+          <a:p>
+            <a:pPr algn="ctr"/>
+          </a:p>
+        </p:txBody>
+      </p:sp>
+      <p:pic>
+        <p:nvPicPr>
+          <p:cNvPr id="7" name="Picture 6" descr="s06_i1.png"/>
+          <p:cNvPicPr>
+            <a:picLocks noChangeAspect="1"/>
+          </p:cNvPicPr>
+          <p:nvPr/>
+        </p:nvPicPr>
+        <p:blipFill>
+          <a:blip r:embed="rId2"/>
+          <a:stretch>
+            <a:fillRect/>
+          </a:stretch>
+        </p:blipFill>
+        <p:spPr>
+          <a:xfrm>
+            <a:off x="8275320" y="4302252"/>
+            <a:ext cx="338328" cy="338328"/>
+          </a:xfrm>
+          <a:prstGeom prst="rect">
+            <a:avLst/>
+          </a:prstGeom>
+        </p:spPr>
+      </p:pic>
+      <p:sp>
+        <p:nvSpPr>
+          <p:cNvPr id="8" name="TextBox 7"/>
+          <p:cNvSpPr txBox="1"/>
+          <p:nvPr/>
+        </p:nvSpPr>
+        <p:spPr>
+          <a:xfrm>
+            <a:off x="8805672" y="4288536"/>
+            <a:ext cx="2560320" cy="457200"/>
+          </a:xfrm>
+          <a:prstGeom prst="rect">
+            <a:avLst/>
+          </a:prstGeom>
+          <a:noFill/>
+        </p:spPr>
+        <p:txBody>
+          <a:bodyPr wrap="square" anchor="t" lIns="0" rIns="0" tIns="0" bIns="0">
+            <a:spAutoFit/>
+          </a:bodyPr>
+          <a:lstStyle/>
+          <a:p>
+            <a:pPr>
+              <a:lnSpc>
+                <a:spcPct val="102000"/>
+              </a:lnSpc>
+            </a:pPr>
+            <a:r>
+              <a:rPr sz="1450" b="1">
+                <a:solidFill>
+                  <a:srgbClr val="15201C"/>
+                </a:solidFill>
+                <a:latin typeface="Space Grotesk"/>
+              </a:rPr>
+              <a:t>Security by design</a:t>
+            </a:r>
+          </a:p>
+        </p:txBody>
+      </p:sp>
+      <p:sp>
+        <p:nvSpPr>
+          <p:cNvPr id="9" name="TextBox 8"/>
+          <p:cNvSpPr txBox="1"/>
+          <p:nvPr/>
+        </p:nvSpPr>
+        <p:spPr>
+          <a:xfrm>
+            <a:off x="8211312" y="4828032"/>
+            <a:ext cx="3154680" cy="1371600"/>
+          </a:xfrm>
+          <a:prstGeom prst="rect">
+            <a:avLst/>
+          </a:prstGeom>
+          <a:noFill/>
+        </p:spPr>
+        <p:txBody>
+          <a:bodyPr wrap="square" anchor="t" lIns="0" rIns="0" tIns="0" bIns="0">
+            <a:spAutoFit/>
+          </a:bodyPr>
+          <a:lstStyle/>
+          <a:p>
+            <a:pPr>
+              <a:lnSpc>
+                <a:spcPct val="110000"/>
+              </a:lnSpc>
+            </a:pPr>
+            <a:r>
+              <a:rPr sz="1100" b="0">
+                <a:solidFill>
+                  <a:srgbClr val="6B7B73"/>
+                </a:solidFill>
+                <a:latin typeface="Hanken Grotesk"/>
+              </a:rPr>
+              <a:t>Least privilege per function — IAM + one Postgres role each; money is append-only + audited; PII isolated in Cognito; workers never HTTP-exposed.</a:t>
             </a:r>
           </a:p>
         </p:txBody>

</xml_diff>

<commit_message>
slides: sync with the Google Slides export (wanthat - technical.pdf)
- slides 7 (Domain Object Model) and 9-16 (architecture walkthrough) are now
  FULL-BLEED page images from Dennis's export - his diagrams, screenshots and
  captions, pixel-faithful; README documents the re-render path (pymupdf 180dpi)
- slide 6: Dennis's card order (cost / scale / security / monorepo / code /
  decisions) + his Security-by-design text + 'potential spike' wording
- slide 8: his table text (Money + Audit Log row, Cognito-backup phrasing);
  closing line keeps OUR post-#205 one-transaction wording (his export predates it)
- presentation.md updated to match throughout

Co-Authored-By: Claude Fable 5 <noreply@anthropic.com>
Claude-Session: https://claude.ai/code/session_01FECrSGSMqWYxFMSwWq9E5s
</commit_message>
<xml_diff>
--- a/slides/wanthat-presentation.pptx
+++ b/slides/wanthat-presentation.pptx
@@ -6086,335 +6086,30 @@
         <p:nvPr/>
       </p:nvGrpSpPr>
       <p:grpSpPr/>
-      <p:sp>
-        <p:nvSpPr>
-          <p:cNvPr id="2" name="TextBox 1"/>
-          <p:cNvSpPr txBox="1"/>
-          <p:nvPr/>
-        </p:nvSpPr>
-        <p:spPr>
-          <a:xfrm>
-            <a:off x="10195560" y="256032"/>
-            <a:ext cx="1371600" cy="1005840"/>
-          </a:xfrm>
-          <a:prstGeom prst="rect">
-            <a:avLst/>
-          </a:prstGeom>
-          <a:noFill/>
-        </p:spPr>
-        <p:txBody>
-          <a:bodyPr wrap="square" anchor="t" lIns="0" rIns="0" tIns="0" bIns="0">
-            <a:spAutoFit/>
-          </a:bodyPr>
-          <a:lstStyle/>
-          <a:p>
-            <a:pPr algn="r"/>
-            <a:r>
-              <a:rPr sz="4600" b="1">
-                <a:solidFill>
-                  <a:srgbClr val="DCE5E0"/>
-                </a:solidFill>
-                <a:latin typeface="Space Grotesk"/>
-              </a:rPr>
-              <a:t>10</a:t>
-            </a:r>
-          </a:p>
-        </p:txBody>
-      </p:sp>
-      <p:sp>
-        <p:nvSpPr>
-          <p:cNvPr id="3" name="TextBox 2"/>
-          <p:cNvSpPr txBox="1"/>
-          <p:nvPr/>
-        </p:nvSpPr>
-        <p:spPr>
-          <a:xfrm>
-            <a:off x="640080" y="420624"/>
-            <a:ext cx="9418320" cy="292608"/>
-          </a:xfrm>
-          <a:prstGeom prst="rect">
-            <a:avLst/>
-          </a:prstGeom>
-          <a:noFill/>
-        </p:spPr>
-        <p:txBody>
-          <a:bodyPr wrap="square" anchor="t" lIns="0" rIns="0" tIns="0" bIns="0">
-            <a:spAutoFit/>
-          </a:bodyPr>
-          <a:lstStyle/>
-          <a:p>
-            <a:r>
-              <a:rPr sz="1150" b="1">
-                <a:solidFill>
-                  <a:srgbClr val="1F7A57"/>
-                </a:solidFill>
-                <a:latin typeface="Space Mono"/>
-              </a:rPr>
-              <a:t>ENGINEERING</a:t>
-            </a:r>
-          </a:p>
-        </p:txBody>
-      </p:sp>
-      <p:sp>
-        <p:nvSpPr>
-          <p:cNvPr id="4" name="TextBox 3"/>
-          <p:cNvSpPr txBox="1"/>
-          <p:nvPr/>
-        </p:nvSpPr>
-        <p:spPr>
-          <a:xfrm>
-            <a:off x="621792" y="731520"/>
-            <a:ext cx="9509760" cy="868680"/>
-          </a:xfrm>
-          <a:prstGeom prst="rect">
-            <a:avLst/>
-          </a:prstGeom>
-          <a:noFill/>
-        </p:spPr>
-        <p:txBody>
-          <a:bodyPr wrap="square" anchor="t" lIns="0" rIns="0" tIns="0" bIns="0">
-            <a:spAutoFit/>
-          </a:bodyPr>
-          <a:lstStyle/>
-          <a:p>
-            <a:r>
-              <a:rPr sz="2700" b="1">
-                <a:solidFill>
-                  <a:srgbClr val="15201C"/>
-                </a:solidFill>
-                <a:latin typeface="Space Grotesk"/>
-              </a:rPr>
-              <a:t>Architecture UC1 — member creates a recommendation</a:t>
-            </a:r>
-          </a:p>
-        </p:txBody>
-      </p:sp>
-      <p:sp>
-        <p:nvSpPr>
-          <p:cNvPr id="5" name="Rounded Rectangle 4"/>
-          <p:cNvSpPr/>
-          <p:nvPr/>
-        </p:nvSpPr>
-        <p:spPr>
-          <a:xfrm>
-            <a:off x="3886200" y="1600200"/>
-            <a:ext cx="7653527" cy="4709160"/>
-          </a:xfrm>
-          <a:prstGeom prst="roundRect">
-            <a:avLst>
-              <a:gd name="adj" fmla="val 3000"/>
-            </a:avLst>
-          </a:prstGeom>
-          <a:solidFill>
-            <a:srgbClr val="FFFFFF"/>
-          </a:solidFill>
-          <a:ln w="12700">
-            <a:solidFill>
-              <a:srgbClr val="E6EBE8"/>
-            </a:solidFill>
-          </a:ln>
-          <a:effectLst/>
-        </p:spPr>
-        <p:style>
-          <a:lnRef idx="1">
-            <a:schemeClr val="accent1"/>
-          </a:lnRef>
-          <a:fillRef idx="3">
-            <a:schemeClr val="accent1"/>
-          </a:fillRef>
-          <a:effectRef idx="2">
-            <a:schemeClr val="accent1"/>
-          </a:effectRef>
-          <a:fontRef idx="minor">
-            <a:schemeClr val="lt1"/>
-          </a:fontRef>
-        </p:style>
-        <p:txBody>
-          <a:bodyPr rtlCol="0" anchor="ctr"/>
-          <a:lstStyle/>
-          <a:p>
-            <a:pPr algn="ctr"/>
-          </a:p>
-        </p:txBody>
-      </p:sp>
-      <p:sp>
-        <p:nvSpPr>
-          <p:cNvPr id="7" name="Rectangle 6"/>
-          <p:cNvSpPr/>
-          <p:nvPr/>
-        </p:nvSpPr>
-        <p:spPr>
-          <a:xfrm>
-            <a:off x="640080" y="6455664"/>
-            <a:ext cx="10908792" cy="9144"/>
-          </a:xfrm>
-          <a:prstGeom prst="rect">
-            <a:avLst/>
-          </a:prstGeom>
-          <a:solidFill>
-            <a:srgbClr val="E6EBE8"/>
-          </a:solidFill>
-          <a:ln>
-            <a:noFill/>
-          </a:ln>
-          <a:effectLst/>
-        </p:spPr>
-        <p:style>
-          <a:lnRef idx="1">
-            <a:schemeClr val="accent1"/>
-          </a:lnRef>
-          <a:fillRef idx="3">
-            <a:schemeClr val="accent1"/>
-          </a:fillRef>
-          <a:effectRef idx="2">
-            <a:schemeClr val="accent1"/>
-          </a:effectRef>
-          <a:fontRef idx="minor">
-            <a:schemeClr val="lt1"/>
-          </a:fontRef>
-        </p:style>
-        <p:txBody>
-          <a:bodyPr rtlCol="0" anchor="ctr"/>
-          <a:lstStyle/>
-          <a:p>
-            <a:pPr algn="ctr"/>
-          </a:p>
-        </p:txBody>
-      </p:sp>
-      <p:sp>
-        <p:nvSpPr>
-          <p:cNvPr id="8" name="TextBox 7"/>
-          <p:cNvSpPr txBox="1"/>
-          <p:nvPr/>
-        </p:nvSpPr>
-        <p:spPr>
-          <a:xfrm>
-            <a:off x="640080" y="6510528"/>
-            <a:ext cx="2743200" cy="274320"/>
-          </a:xfrm>
-          <a:prstGeom prst="rect">
-            <a:avLst/>
-          </a:prstGeom>
-          <a:noFill/>
-        </p:spPr>
-        <p:txBody>
-          <a:bodyPr wrap="square" anchor="t" lIns="0" rIns="0" tIns="0" bIns="0">
-            <a:spAutoFit/>
-          </a:bodyPr>
-          <a:lstStyle/>
-          <a:p>
-            <a:r>
-              <a:rPr sz="1100" b="1">
-                <a:solidFill>
-                  <a:srgbClr val="6B7B73"/>
-                </a:solidFill>
-                <a:latin typeface="Space Grotesk"/>
-              </a:rPr>
-              <a:t>want</a:t>
-            </a:r>
-            <a:r>
-              <a:rPr sz="1100" b="1">
-                <a:solidFill>
-                  <a:srgbClr val="1F7A57"/>
-                </a:solidFill>
-                <a:latin typeface="Space Grotesk"/>
-              </a:rPr>
-              <a:t>hat</a:t>
-            </a:r>
-          </a:p>
-        </p:txBody>
-      </p:sp>
-      <p:sp>
-        <p:nvSpPr>
-          <p:cNvPr id="9" name="TextBox 8"/>
-          <p:cNvSpPr txBox="1"/>
-          <p:nvPr/>
-        </p:nvSpPr>
-        <p:spPr>
-          <a:xfrm>
-            <a:off x="10607040" y="6510528"/>
-            <a:ext cx="941832" cy="274320"/>
-          </a:xfrm>
-          <a:prstGeom prst="rect">
-            <a:avLst/>
-          </a:prstGeom>
-          <a:noFill/>
-        </p:spPr>
-        <p:txBody>
-          <a:bodyPr wrap="square" anchor="t" lIns="0" rIns="0" tIns="0" bIns="0">
-            <a:spAutoFit/>
-          </a:bodyPr>
-          <a:lstStyle/>
-          <a:p>
-            <a:pPr algn="r"/>
-            <a:r>
-              <a:rPr sz="1000" b="0">
-                <a:solidFill>
-                  <a:srgbClr val="8A968F"/>
-                </a:solidFill>
-                <a:latin typeface="Space Mono"/>
-              </a:rPr>
-              <a:t>10</a:t>
-            </a:r>
-          </a:p>
-        </p:txBody>
-      </p:sp>
-      <p:sp>
-        <p:nvSpPr>
-          <p:cNvPr id="10" name="TextBox 9"/>
-          <p:cNvSpPr txBox="1"/>
-          <p:nvPr/>
-        </p:nvSpPr>
-        <p:spPr>
-          <a:xfrm>
-            <a:off x="658368" y="1783080"/>
-            <a:ext cx="3063240" cy="4480560"/>
-          </a:xfrm>
-          <a:prstGeom prst="rect">
-            <a:avLst/>
-          </a:prstGeom>
-          <a:noFill/>
-        </p:spPr>
-        <p:txBody>
-          <a:bodyPr wrap="square">
-            <a:spAutoFit/>
-          </a:bodyPr>
-          <a:lstStyle/>
-          <a:p>
-            <a:r>
-              <a:rPr sz="1200" b="0">
-                <a:solidFill>
-                  <a:srgbClr val="15201C"/>
-                </a:solidFill>
-                <a:latin typeface="Hanken Grotesk"/>
-              </a:rPr>
-              <a:t>-  SPA is served from S3 via CloudFront.</a:t>
-            </a:r>
-          </a:p>
-          <a:p>
-            <a:r>
-              <a:rPr sz="1200" b="0">
-                <a:solidFill>
-                  <a:srgbClr val="15201C"/>
-                </a:solidFill>
-                <a:latin typeface="Hanken Grotesk"/>
-              </a:rPr>
-              <a:t>-  Cognito-native authentication at the application level.</a:t>
-            </a:r>
-          </a:p>
-          <a:p>
-            <a:r>
-              <a:rPr sz="1200" b="0">
-                <a:solidFill>
-                  <a:srgbClr val="15201C"/>
-                </a:solidFill>
-                <a:latin typeface="Hanken Grotesk"/>
-              </a:rPr>
-              <a:t>-  The retailer link is created ONCE per product (cache; linkgen is the sole writer).</a:t>
-            </a:r>
-          </a:p>
-        </p:txBody>
-      </p:sp>
+      <p:pic>
+        <p:nvPicPr>
+          <p:cNvPr id="2" name="Picture 1" descr="page-10.png"/>
+          <p:cNvPicPr>
+            <a:picLocks noChangeAspect="1"/>
+          </p:cNvPicPr>
+          <p:nvPr/>
+        </p:nvPicPr>
+        <p:blipFill>
+          <a:blip r:embed="rId4"/>
+          <a:stretch>
+            <a:fillRect/>
+          </a:stretch>
+        </p:blipFill>
+        <p:spPr>
+          <a:xfrm>
+            <a:off x="0" y="0"/>
+            <a:ext cx="12191695" cy="6858000"/>
+          </a:xfrm>
+          <a:prstGeom prst="rect">
+            <a:avLst/>
+          </a:prstGeom>
+        </p:spPr>
+      </p:pic>
     </p:spTree>
   </p:cSld>
   <p:clrMapOvr>
@@ -6433,335 +6128,30 @@
         <p:nvPr/>
       </p:nvGrpSpPr>
       <p:grpSpPr/>
-      <p:sp>
-        <p:nvSpPr>
-          <p:cNvPr id="2" name="TextBox 1"/>
-          <p:cNvSpPr txBox="1"/>
-          <p:nvPr/>
-        </p:nvSpPr>
-        <p:spPr>
-          <a:xfrm>
-            <a:off x="10195560" y="256032"/>
-            <a:ext cx="1371600" cy="1005840"/>
-          </a:xfrm>
-          <a:prstGeom prst="rect">
-            <a:avLst/>
-          </a:prstGeom>
-          <a:noFill/>
-        </p:spPr>
-        <p:txBody>
-          <a:bodyPr wrap="square" anchor="t" lIns="0" rIns="0" tIns="0" bIns="0">
-            <a:spAutoFit/>
-          </a:bodyPr>
-          <a:lstStyle/>
-          <a:p>
-            <a:pPr algn="r"/>
-            <a:r>
-              <a:rPr sz="4600" b="1">
-                <a:solidFill>
-                  <a:srgbClr val="DCE5E0"/>
-                </a:solidFill>
-                <a:latin typeface="Space Grotesk"/>
-              </a:rPr>
-              <a:t>11</a:t>
-            </a:r>
-          </a:p>
-        </p:txBody>
-      </p:sp>
-      <p:sp>
-        <p:nvSpPr>
-          <p:cNvPr id="3" name="TextBox 2"/>
-          <p:cNvSpPr txBox="1"/>
-          <p:nvPr/>
-        </p:nvSpPr>
-        <p:spPr>
-          <a:xfrm>
-            <a:off x="640080" y="420624"/>
-            <a:ext cx="9418320" cy="292608"/>
-          </a:xfrm>
-          <a:prstGeom prst="rect">
-            <a:avLst/>
-          </a:prstGeom>
-          <a:noFill/>
-        </p:spPr>
-        <p:txBody>
-          <a:bodyPr wrap="square" anchor="t" lIns="0" rIns="0" tIns="0" bIns="0">
-            <a:spAutoFit/>
-          </a:bodyPr>
-          <a:lstStyle/>
-          <a:p>
-            <a:r>
-              <a:rPr sz="1150" b="1">
-                <a:solidFill>
-                  <a:srgbClr val="1F7A57"/>
-                </a:solidFill>
-                <a:latin typeface="Space Mono"/>
-              </a:rPr>
-              <a:t>ENGINEERING</a:t>
-            </a:r>
-          </a:p>
-        </p:txBody>
-      </p:sp>
-      <p:sp>
-        <p:nvSpPr>
-          <p:cNvPr id="4" name="TextBox 3"/>
-          <p:cNvSpPr txBox="1"/>
-          <p:nvPr/>
-        </p:nvSpPr>
-        <p:spPr>
-          <a:xfrm>
-            <a:off x="621792" y="731520"/>
-            <a:ext cx="9509760" cy="868680"/>
-          </a:xfrm>
-          <a:prstGeom prst="rect">
-            <a:avLst/>
-          </a:prstGeom>
-          <a:noFill/>
-        </p:spPr>
-        <p:txBody>
-          <a:bodyPr wrap="square" anchor="t" lIns="0" rIns="0" tIns="0" bIns="0">
-            <a:spAutoFit/>
-          </a:bodyPr>
-          <a:lstStyle/>
-          <a:p>
-            <a:r>
-              <a:rPr sz="2700" b="1">
-                <a:solidFill>
-                  <a:srgbClr val="15201C"/>
-                </a:solidFill>
-                <a:latin typeface="Space Grotesk"/>
-              </a:rPr>
-              <a:t>Architecture UC2 — the recommendation is shared</a:t>
-            </a:r>
-          </a:p>
-        </p:txBody>
-      </p:sp>
-      <p:sp>
-        <p:nvSpPr>
-          <p:cNvPr id="5" name="Rounded Rectangle 4"/>
-          <p:cNvSpPr/>
-          <p:nvPr/>
-        </p:nvSpPr>
-        <p:spPr>
-          <a:xfrm>
-            <a:off x="3886200" y="1600200"/>
-            <a:ext cx="7653527" cy="4709160"/>
-          </a:xfrm>
-          <a:prstGeom prst="roundRect">
-            <a:avLst>
-              <a:gd name="adj" fmla="val 3000"/>
-            </a:avLst>
-          </a:prstGeom>
-          <a:solidFill>
-            <a:srgbClr val="FFFFFF"/>
-          </a:solidFill>
-          <a:ln w="12700">
-            <a:solidFill>
-              <a:srgbClr val="E6EBE8"/>
-            </a:solidFill>
-          </a:ln>
-          <a:effectLst/>
-        </p:spPr>
-        <p:style>
-          <a:lnRef idx="1">
-            <a:schemeClr val="accent1"/>
-          </a:lnRef>
-          <a:fillRef idx="3">
-            <a:schemeClr val="accent1"/>
-          </a:fillRef>
-          <a:effectRef idx="2">
-            <a:schemeClr val="accent1"/>
-          </a:effectRef>
-          <a:fontRef idx="minor">
-            <a:schemeClr val="lt1"/>
-          </a:fontRef>
-        </p:style>
-        <p:txBody>
-          <a:bodyPr rtlCol="0" anchor="ctr"/>
-          <a:lstStyle/>
-          <a:p>
-            <a:pPr algn="ctr"/>
-          </a:p>
-        </p:txBody>
-      </p:sp>
-      <p:sp>
-        <p:nvSpPr>
-          <p:cNvPr id="7" name="Rectangle 6"/>
-          <p:cNvSpPr/>
-          <p:nvPr/>
-        </p:nvSpPr>
-        <p:spPr>
-          <a:xfrm>
-            <a:off x="640080" y="6455664"/>
-            <a:ext cx="10908792" cy="9144"/>
-          </a:xfrm>
-          <a:prstGeom prst="rect">
-            <a:avLst/>
-          </a:prstGeom>
-          <a:solidFill>
-            <a:srgbClr val="E6EBE8"/>
-          </a:solidFill>
-          <a:ln>
-            <a:noFill/>
-          </a:ln>
-          <a:effectLst/>
-        </p:spPr>
-        <p:style>
-          <a:lnRef idx="1">
-            <a:schemeClr val="accent1"/>
-          </a:lnRef>
-          <a:fillRef idx="3">
-            <a:schemeClr val="accent1"/>
-          </a:fillRef>
-          <a:effectRef idx="2">
-            <a:schemeClr val="accent1"/>
-          </a:effectRef>
-          <a:fontRef idx="minor">
-            <a:schemeClr val="lt1"/>
-          </a:fontRef>
-        </p:style>
-        <p:txBody>
-          <a:bodyPr rtlCol="0" anchor="ctr"/>
-          <a:lstStyle/>
-          <a:p>
-            <a:pPr algn="ctr"/>
-          </a:p>
-        </p:txBody>
-      </p:sp>
-      <p:sp>
-        <p:nvSpPr>
-          <p:cNvPr id="8" name="TextBox 7"/>
-          <p:cNvSpPr txBox="1"/>
-          <p:nvPr/>
-        </p:nvSpPr>
-        <p:spPr>
-          <a:xfrm>
-            <a:off x="640080" y="6510528"/>
-            <a:ext cx="2743200" cy="274320"/>
-          </a:xfrm>
-          <a:prstGeom prst="rect">
-            <a:avLst/>
-          </a:prstGeom>
-          <a:noFill/>
-        </p:spPr>
-        <p:txBody>
-          <a:bodyPr wrap="square" anchor="t" lIns="0" rIns="0" tIns="0" bIns="0">
-            <a:spAutoFit/>
-          </a:bodyPr>
-          <a:lstStyle/>
-          <a:p>
-            <a:r>
-              <a:rPr sz="1100" b="1">
-                <a:solidFill>
-                  <a:srgbClr val="6B7B73"/>
-                </a:solidFill>
-                <a:latin typeface="Space Grotesk"/>
-              </a:rPr>
-              <a:t>want</a:t>
-            </a:r>
-            <a:r>
-              <a:rPr sz="1100" b="1">
-                <a:solidFill>
-                  <a:srgbClr val="1F7A57"/>
-                </a:solidFill>
-                <a:latin typeface="Space Grotesk"/>
-              </a:rPr>
-              <a:t>hat</a:t>
-            </a:r>
-          </a:p>
-        </p:txBody>
-      </p:sp>
-      <p:sp>
-        <p:nvSpPr>
-          <p:cNvPr id="9" name="TextBox 8"/>
-          <p:cNvSpPr txBox="1"/>
-          <p:nvPr/>
-        </p:nvSpPr>
-        <p:spPr>
-          <a:xfrm>
-            <a:off x="10607040" y="6510528"/>
-            <a:ext cx="941832" cy="274320"/>
-          </a:xfrm>
-          <a:prstGeom prst="rect">
-            <a:avLst/>
-          </a:prstGeom>
-          <a:noFill/>
-        </p:spPr>
-        <p:txBody>
-          <a:bodyPr wrap="square" anchor="t" lIns="0" rIns="0" tIns="0" bIns="0">
-            <a:spAutoFit/>
-          </a:bodyPr>
-          <a:lstStyle/>
-          <a:p>
-            <a:pPr algn="r"/>
-            <a:r>
-              <a:rPr sz="1000" b="0">
-                <a:solidFill>
-                  <a:srgbClr val="8A968F"/>
-                </a:solidFill>
-                <a:latin typeface="Space Mono"/>
-              </a:rPr>
-              <a:t>11</a:t>
-            </a:r>
-          </a:p>
-        </p:txBody>
-      </p:sp>
-      <p:sp>
-        <p:nvSpPr>
-          <p:cNvPr id="10" name="TextBox 9"/>
-          <p:cNvSpPr txBox="1"/>
-          <p:nvPr/>
-        </p:nvSpPr>
-        <p:spPr>
-          <a:xfrm>
-            <a:off x="658368" y="1783080"/>
-            <a:ext cx="3063240" cy="4480560"/>
-          </a:xfrm>
-          <a:prstGeom prst="rect">
-            <a:avLst/>
-          </a:prstGeom>
-          <a:noFill/>
-        </p:spPr>
-        <p:txBody>
-          <a:bodyPr wrap="square">
-            <a:spAutoFit/>
-          </a:bodyPr>
-          <a:lstStyle/>
-          <a:p>
-            <a:r>
-              <a:rPr sz="1200" b="0">
-                <a:solidFill>
-                  <a:srgbClr val="15201C"/>
-                </a:solidFill>
-                <a:latin typeface="Hanken Grotesk"/>
-              </a:rPr>
-              <a:t>-  This is the hot path.</a:t>
-            </a:r>
-          </a:p>
-          <a:p>
-            <a:r>
-              <a:rPr sz="1200" b="0">
-                <a:solidFill>
-                  <a:srgbClr val="15201C"/>
-                </a:solidFill>
-                <a:latin typeface="Hanken Grotesk"/>
-              </a:rPr>
-              <a:t>-  The recommendation page is server-rendered and cached on CloudFront (60 s, origin-controlled).</a:t>
-            </a:r>
-          </a:p>
-          <a:p>
-            <a:r>
-              <a:rPr sz="1200" b="0">
-                <a:solidFill>
-                  <a:srgbClr val="15201C"/>
-                </a:solidFill>
-                <a:latin typeface="Hanken Grotesk"/>
-              </a:rPr>
-              <a:t>-  The TS landing app boots on the page for auth / registration and redirect-link generation.</a:t>
-            </a:r>
-          </a:p>
-        </p:txBody>
-      </p:sp>
+      <p:pic>
+        <p:nvPicPr>
+          <p:cNvPr id="2" name="Picture 1" descr="page-11.png"/>
+          <p:cNvPicPr>
+            <a:picLocks noChangeAspect="1"/>
+          </p:cNvPicPr>
+          <p:nvPr/>
+        </p:nvPicPr>
+        <p:blipFill>
+          <a:blip r:embed="rId4"/>
+          <a:stretch>
+            <a:fillRect/>
+          </a:stretch>
+        </p:blipFill>
+        <p:spPr>
+          <a:xfrm>
+            <a:off x="0" y="0"/>
+            <a:ext cx="12191695" cy="6858000"/>
+          </a:xfrm>
+          <a:prstGeom prst="rect">
+            <a:avLst/>
+          </a:prstGeom>
+        </p:spPr>
+      </p:pic>
     </p:spTree>
   </p:cSld>
   <p:clrMapOvr>
@@ -6780,335 +6170,30 @@
         <p:nvPr/>
       </p:nvGrpSpPr>
       <p:grpSpPr/>
-      <p:sp>
-        <p:nvSpPr>
-          <p:cNvPr id="2" name="TextBox 1"/>
-          <p:cNvSpPr txBox="1"/>
-          <p:nvPr/>
-        </p:nvSpPr>
-        <p:spPr>
-          <a:xfrm>
-            <a:off x="10195560" y="256032"/>
-            <a:ext cx="1371600" cy="1005840"/>
-          </a:xfrm>
-          <a:prstGeom prst="rect">
-            <a:avLst/>
-          </a:prstGeom>
-          <a:noFill/>
-        </p:spPr>
-        <p:txBody>
-          <a:bodyPr wrap="square" anchor="t" lIns="0" rIns="0" tIns="0" bIns="0">
-            <a:spAutoFit/>
-          </a:bodyPr>
-          <a:lstStyle/>
-          <a:p>
-            <a:pPr algn="r"/>
-            <a:r>
-              <a:rPr sz="4600" b="1">
-                <a:solidFill>
-                  <a:srgbClr val="DCE5E0"/>
-                </a:solidFill>
-                <a:latin typeface="Space Grotesk"/>
-              </a:rPr>
-              <a:t>12</a:t>
-            </a:r>
-          </a:p>
-        </p:txBody>
-      </p:sp>
-      <p:sp>
-        <p:nvSpPr>
-          <p:cNvPr id="3" name="TextBox 2"/>
-          <p:cNvSpPr txBox="1"/>
-          <p:nvPr/>
-        </p:nvSpPr>
-        <p:spPr>
-          <a:xfrm>
-            <a:off x="640080" y="420624"/>
-            <a:ext cx="9418320" cy="292608"/>
-          </a:xfrm>
-          <a:prstGeom prst="rect">
-            <a:avLst/>
-          </a:prstGeom>
-          <a:noFill/>
-        </p:spPr>
-        <p:txBody>
-          <a:bodyPr wrap="square" anchor="t" lIns="0" rIns="0" tIns="0" bIns="0">
-            <a:spAutoFit/>
-          </a:bodyPr>
-          <a:lstStyle/>
-          <a:p>
-            <a:r>
-              <a:rPr sz="1150" b="1">
-                <a:solidFill>
-                  <a:srgbClr val="1F7A57"/>
-                </a:solidFill>
-                <a:latin typeface="Space Mono"/>
-              </a:rPr>
-              <a:t>ENGINEERING</a:t>
-            </a:r>
-          </a:p>
-        </p:txBody>
-      </p:sp>
-      <p:sp>
-        <p:nvSpPr>
-          <p:cNvPr id="4" name="TextBox 3"/>
-          <p:cNvSpPr txBox="1"/>
-          <p:nvPr/>
-        </p:nvSpPr>
-        <p:spPr>
-          <a:xfrm>
-            <a:off x="621792" y="731520"/>
-            <a:ext cx="9509760" cy="868680"/>
-          </a:xfrm>
-          <a:prstGeom prst="rect">
-            <a:avLst/>
-          </a:prstGeom>
-          <a:noFill/>
-        </p:spPr>
-        <p:txBody>
-          <a:bodyPr wrap="square" anchor="t" lIns="0" rIns="0" tIns="0" bIns="0">
-            <a:spAutoFit/>
-          </a:bodyPr>
-          <a:lstStyle/>
-          <a:p>
-            <a:r>
-              <a:rPr sz="2700" b="1">
-                <a:solidFill>
-                  <a:srgbClr val="15201C"/>
-                </a:solidFill>
-                <a:latin typeface="Space Grotesk"/>
-              </a:rPr>
-              <a:t>Architecture UC3 — registration, login, guest + redirect</a:t>
-            </a:r>
-          </a:p>
-        </p:txBody>
-      </p:sp>
-      <p:sp>
-        <p:nvSpPr>
-          <p:cNvPr id="5" name="Rounded Rectangle 4"/>
-          <p:cNvSpPr/>
-          <p:nvPr/>
-        </p:nvSpPr>
-        <p:spPr>
-          <a:xfrm>
-            <a:off x="3886200" y="1600200"/>
-            <a:ext cx="7653527" cy="4709160"/>
-          </a:xfrm>
-          <a:prstGeom prst="roundRect">
-            <a:avLst>
-              <a:gd name="adj" fmla="val 3000"/>
-            </a:avLst>
-          </a:prstGeom>
-          <a:solidFill>
-            <a:srgbClr val="FFFFFF"/>
-          </a:solidFill>
-          <a:ln w="12700">
-            <a:solidFill>
-              <a:srgbClr val="E6EBE8"/>
-            </a:solidFill>
-          </a:ln>
-          <a:effectLst/>
-        </p:spPr>
-        <p:style>
-          <a:lnRef idx="1">
-            <a:schemeClr val="accent1"/>
-          </a:lnRef>
-          <a:fillRef idx="3">
-            <a:schemeClr val="accent1"/>
-          </a:fillRef>
-          <a:effectRef idx="2">
-            <a:schemeClr val="accent1"/>
-          </a:effectRef>
-          <a:fontRef idx="minor">
-            <a:schemeClr val="lt1"/>
-          </a:fontRef>
-        </p:style>
-        <p:txBody>
-          <a:bodyPr rtlCol="0" anchor="ctr"/>
-          <a:lstStyle/>
-          <a:p>
-            <a:pPr algn="ctr"/>
-          </a:p>
-        </p:txBody>
-      </p:sp>
-      <p:sp>
-        <p:nvSpPr>
-          <p:cNvPr id="7" name="Rectangle 6"/>
-          <p:cNvSpPr/>
-          <p:nvPr/>
-        </p:nvSpPr>
-        <p:spPr>
-          <a:xfrm>
-            <a:off x="640080" y="6455664"/>
-            <a:ext cx="10908792" cy="9144"/>
-          </a:xfrm>
-          <a:prstGeom prst="rect">
-            <a:avLst/>
-          </a:prstGeom>
-          <a:solidFill>
-            <a:srgbClr val="E6EBE8"/>
-          </a:solidFill>
-          <a:ln>
-            <a:noFill/>
-          </a:ln>
-          <a:effectLst/>
-        </p:spPr>
-        <p:style>
-          <a:lnRef idx="1">
-            <a:schemeClr val="accent1"/>
-          </a:lnRef>
-          <a:fillRef idx="3">
-            <a:schemeClr val="accent1"/>
-          </a:fillRef>
-          <a:effectRef idx="2">
-            <a:schemeClr val="accent1"/>
-          </a:effectRef>
-          <a:fontRef idx="minor">
-            <a:schemeClr val="lt1"/>
-          </a:fontRef>
-        </p:style>
-        <p:txBody>
-          <a:bodyPr rtlCol="0" anchor="ctr"/>
-          <a:lstStyle/>
-          <a:p>
-            <a:pPr algn="ctr"/>
-          </a:p>
-        </p:txBody>
-      </p:sp>
-      <p:sp>
-        <p:nvSpPr>
-          <p:cNvPr id="8" name="TextBox 7"/>
-          <p:cNvSpPr txBox="1"/>
-          <p:nvPr/>
-        </p:nvSpPr>
-        <p:spPr>
-          <a:xfrm>
-            <a:off x="640080" y="6510528"/>
-            <a:ext cx="2743200" cy="274320"/>
-          </a:xfrm>
-          <a:prstGeom prst="rect">
-            <a:avLst/>
-          </a:prstGeom>
-          <a:noFill/>
-        </p:spPr>
-        <p:txBody>
-          <a:bodyPr wrap="square" anchor="t" lIns="0" rIns="0" tIns="0" bIns="0">
-            <a:spAutoFit/>
-          </a:bodyPr>
-          <a:lstStyle/>
-          <a:p>
-            <a:r>
-              <a:rPr sz="1100" b="1">
-                <a:solidFill>
-                  <a:srgbClr val="6B7B73"/>
-                </a:solidFill>
-                <a:latin typeface="Space Grotesk"/>
-              </a:rPr>
-              <a:t>want</a:t>
-            </a:r>
-            <a:r>
-              <a:rPr sz="1100" b="1">
-                <a:solidFill>
-                  <a:srgbClr val="1F7A57"/>
-                </a:solidFill>
-                <a:latin typeface="Space Grotesk"/>
-              </a:rPr>
-              <a:t>hat</a:t>
-            </a:r>
-          </a:p>
-        </p:txBody>
-      </p:sp>
-      <p:sp>
-        <p:nvSpPr>
-          <p:cNvPr id="9" name="TextBox 8"/>
-          <p:cNvSpPr txBox="1"/>
-          <p:nvPr/>
-        </p:nvSpPr>
-        <p:spPr>
-          <a:xfrm>
-            <a:off x="10607040" y="6510528"/>
-            <a:ext cx="941832" cy="274320"/>
-          </a:xfrm>
-          <a:prstGeom prst="rect">
-            <a:avLst/>
-          </a:prstGeom>
-          <a:noFill/>
-        </p:spPr>
-        <p:txBody>
-          <a:bodyPr wrap="square" anchor="t" lIns="0" rIns="0" tIns="0" bIns="0">
-            <a:spAutoFit/>
-          </a:bodyPr>
-          <a:lstStyle/>
-          <a:p>
-            <a:pPr algn="r"/>
-            <a:r>
-              <a:rPr sz="1000" b="0">
-                <a:solidFill>
-                  <a:srgbClr val="8A968F"/>
-                </a:solidFill>
-                <a:latin typeface="Space Mono"/>
-              </a:rPr>
-              <a:t>12</a:t>
-            </a:r>
-          </a:p>
-        </p:txBody>
-      </p:sp>
-      <p:sp>
-        <p:nvSpPr>
-          <p:cNvPr id="10" name="TextBox 9"/>
-          <p:cNvSpPr txBox="1"/>
-          <p:nvPr/>
-        </p:nvSpPr>
-        <p:spPr>
-          <a:xfrm>
-            <a:off x="658368" y="1783080"/>
-            <a:ext cx="3063240" cy="4480560"/>
-          </a:xfrm>
-          <a:prstGeom prst="rect">
-            <a:avLst/>
-          </a:prstGeom>
-          <a:noFill/>
-        </p:spPr>
-        <p:txBody>
-          <a:bodyPr wrap="square">
-            <a:spAutoFit/>
-          </a:bodyPr>
-          <a:lstStyle/>
-          <a:p>
-            <a:r>
-              <a:rPr sz="1200" b="0">
-                <a:solidFill>
-                  <a:srgbClr val="15201C"/>
-                </a:solidFill>
-                <a:latin typeface="Hanken Grotesk"/>
-              </a:rPr>
-              <a:t>-  Every registration appends a hash-chained audit row — each row carries the previous row's hash.</a:t>
-            </a:r>
-          </a:p>
-          <a:p>
-            <a:r>
-              <a:rPr sz="1200" b="0">
-                <a:solidFill>
-                  <a:srgbClr val="15201C"/>
-                </a:solidFill>
-                <a:latin typeface="Hanken Grotesk"/>
-              </a:rPr>
-              <a:t>-  audit_writer is granted EXECUTE on the procedure ONLY.</a:t>
-            </a:r>
-          </a:p>
-          <a:p>
-            <a:r>
-              <a:rPr sz="1200" b="0">
-                <a:solidFill>
-                  <a:srgbClr val="15201C"/>
-                </a:solidFill>
-                <a:latin typeface="Hanken Grotesk"/>
-              </a:rPr>
-              <a:t>-  The stored procedure serializes concurrent appends (advisory lock).</a:t>
-            </a:r>
-          </a:p>
-        </p:txBody>
-      </p:sp>
+      <p:pic>
+        <p:nvPicPr>
+          <p:cNvPr id="2" name="Picture 1" descr="page-12.png"/>
+          <p:cNvPicPr>
+            <a:picLocks noChangeAspect="1"/>
+          </p:cNvPicPr>
+          <p:nvPr/>
+        </p:nvPicPr>
+        <p:blipFill>
+          <a:blip r:embed="rId4"/>
+          <a:stretch>
+            <a:fillRect/>
+          </a:stretch>
+        </p:blipFill>
+        <p:spPr>
+          <a:xfrm>
+            <a:off x="0" y="0"/>
+            <a:ext cx="12191695" cy="6858000"/>
+          </a:xfrm>
+          <a:prstGeom prst="rect">
+            <a:avLst/>
+          </a:prstGeom>
+        </p:spPr>
+      </p:pic>
     </p:spTree>
   </p:cSld>
   <p:clrMapOvr>
@@ -7127,324 +6212,30 @@
         <p:nvPr/>
       </p:nvGrpSpPr>
       <p:grpSpPr/>
-      <p:sp>
-        <p:nvSpPr>
-          <p:cNvPr id="2" name="TextBox 1"/>
-          <p:cNvSpPr txBox="1"/>
-          <p:nvPr/>
-        </p:nvSpPr>
-        <p:spPr>
-          <a:xfrm>
-            <a:off x="10195560" y="256032"/>
-            <a:ext cx="1371600" cy="1005840"/>
-          </a:xfrm>
-          <a:prstGeom prst="rect">
-            <a:avLst/>
-          </a:prstGeom>
-          <a:noFill/>
-        </p:spPr>
-        <p:txBody>
-          <a:bodyPr wrap="square" anchor="t" lIns="0" rIns="0" tIns="0" bIns="0">
-            <a:spAutoFit/>
-          </a:bodyPr>
-          <a:lstStyle/>
-          <a:p>
-            <a:pPr algn="r"/>
-            <a:r>
-              <a:rPr sz="4600" b="1">
-                <a:solidFill>
-                  <a:srgbClr val="DCE5E0"/>
-                </a:solidFill>
-                <a:latin typeface="Space Grotesk"/>
-              </a:rPr>
-              <a:t>13</a:t>
-            </a:r>
-          </a:p>
-        </p:txBody>
-      </p:sp>
-      <p:sp>
-        <p:nvSpPr>
-          <p:cNvPr id="3" name="TextBox 2"/>
-          <p:cNvSpPr txBox="1"/>
-          <p:nvPr/>
-        </p:nvSpPr>
-        <p:spPr>
-          <a:xfrm>
-            <a:off x="640080" y="420624"/>
-            <a:ext cx="9418320" cy="292608"/>
-          </a:xfrm>
-          <a:prstGeom prst="rect">
-            <a:avLst/>
-          </a:prstGeom>
-          <a:noFill/>
-        </p:spPr>
-        <p:txBody>
-          <a:bodyPr wrap="square" anchor="t" lIns="0" rIns="0" tIns="0" bIns="0">
-            <a:spAutoFit/>
-          </a:bodyPr>
-          <a:lstStyle/>
-          <a:p>
-            <a:r>
-              <a:rPr sz="1150" b="1">
-                <a:solidFill>
-                  <a:srgbClr val="1F7A57"/>
-                </a:solidFill>
-                <a:latin typeface="Space Mono"/>
-              </a:rPr>
-              <a:t>ENGINEERING</a:t>
-            </a:r>
-          </a:p>
-        </p:txBody>
-      </p:sp>
-      <p:sp>
-        <p:nvSpPr>
-          <p:cNvPr id="4" name="TextBox 3"/>
-          <p:cNvSpPr txBox="1"/>
-          <p:nvPr/>
-        </p:nvSpPr>
-        <p:spPr>
-          <a:xfrm>
-            <a:off x="621792" y="731520"/>
-            <a:ext cx="9509760" cy="868680"/>
-          </a:xfrm>
-          <a:prstGeom prst="rect">
-            <a:avLst/>
-          </a:prstGeom>
-          <a:noFill/>
-        </p:spPr>
-        <p:txBody>
-          <a:bodyPr wrap="square" anchor="t" lIns="0" rIns="0" tIns="0" bIns="0">
-            <a:spAutoFit/>
-          </a:bodyPr>
-          <a:lstStyle/>
-          <a:p>
-            <a:r>
-              <a:rPr sz="2700" b="1">
-                <a:solidFill>
-                  <a:srgbClr val="15201C"/>
-                </a:solidFill>
-                <a:latin typeface="Space Grotesk"/>
-              </a:rPr>
-              <a:t>Architecture UC4 — settlement pulled in the background</a:t>
-            </a:r>
-          </a:p>
-        </p:txBody>
-      </p:sp>
-      <p:sp>
-        <p:nvSpPr>
-          <p:cNvPr id="5" name="Rounded Rectangle 4"/>
-          <p:cNvSpPr/>
-          <p:nvPr/>
-        </p:nvSpPr>
-        <p:spPr>
-          <a:xfrm>
-            <a:off x="3886200" y="1600200"/>
-            <a:ext cx="7653527" cy="4709160"/>
-          </a:xfrm>
-          <a:prstGeom prst="roundRect">
-            <a:avLst>
-              <a:gd name="adj" fmla="val 3000"/>
-            </a:avLst>
-          </a:prstGeom>
-          <a:solidFill>
-            <a:srgbClr val="FFFFFF"/>
-          </a:solidFill>
-          <a:ln w="12700">
-            <a:solidFill>
-              <a:srgbClr val="E6EBE8"/>
-            </a:solidFill>
-          </a:ln>
-          <a:effectLst/>
-        </p:spPr>
-        <p:style>
-          <a:lnRef idx="1">
-            <a:schemeClr val="accent1"/>
-          </a:lnRef>
-          <a:fillRef idx="3">
-            <a:schemeClr val="accent1"/>
-          </a:fillRef>
-          <a:effectRef idx="2">
-            <a:schemeClr val="accent1"/>
-          </a:effectRef>
-          <a:fontRef idx="minor">
-            <a:schemeClr val="lt1"/>
-          </a:fontRef>
-        </p:style>
-        <p:txBody>
-          <a:bodyPr rtlCol="0" anchor="ctr"/>
-          <a:lstStyle/>
-          <a:p>
-            <a:pPr algn="ctr"/>
-          </a:p>
-        </p:txBody>
-      </p:sp>
-      <p:sp>
-        <p:nvSpPr>
-          <p:cNvPr id="7" name="Rectangle 6"/>
-          <p:cNvSpPr/>
-          <p:nvPr/>
-        </p:nvSpPr>
-        <p:spPr>
-          <a:xfrm>
-            <a:off x="640080" y="6455664"/>
-            <a:ext cx="10908792" cy="9144"/>
-          </a:xfrm>
-          <a:prstGeom prst="rect">
-            <a:avLst/>
-          </a:prstGeom>
-          <a:solidFill>
-            <a:srgbClr val="E6EBE8"/>
-          </a:solidFill>
-          <a:ln>
-            <a:noFill/>
-          </a:ln>
-          <a:effectLst/>
-        </p:spPr>
-        <p:style>
-          <a:lnRef idx="1">
-            <a:schemeClr val="accent1"/>
-          </a:lnRef>
-          <a:fillRef idx="3">
-            <a:schemeClr val="accent1"/>
-          </a:fillRef>
-          <a:effectRef idx="2">
-            <a:schemeClr val="accent1"/>
-          </a:effectRef>
-          <a:fontRef idx="minor">
-            <a:schemeClr val="lt1"/>
-          </a:fontRef>
-        </p:style>
-        <p:txBody>
-          <a:bodyPr rtlCol="0" anchor="ctr"/>
-          <a:lstStyle/>
-          <a:p>
-            <a:pPr algn="ctr"/>
-          </a:p>
-        </p:txBody>
-      </p:sp>
-      <p:sp>
-        <p:nvSpPr>
-          <p:cNvPr id="8" name="TextBox 7"/>
-          <p:cNvSpPr txBox="1"/>
-          <p:nvPr/>
-        </p:nvSpPr>
-        <p:spPr>
-          <a:xfrm>
-            <a:off x="640080" y="6510528"/>
-            <a:ext cx="2743200" cy="274320"/>
-          </a:xfrm>
-          <a:prstGeom prst="rect">
-            <a:avLst/>
-          </a:prstGeom>
-          <a:noFill/>
-        </p:spPr>
-        <p:txBody>
-          <a:bodyPr wrap="square" anchor="t" lIns="0" rIns="0" tIns="0" bIns="0">
-            <a:spAutoFit/>
-          </a:bodyPr>
-          <a:lstStyle/>
-          <a:p>
-            <a:r>
-              <a:rPr sz="1100" b="1">
-                <a:solidFill>
-                  <a:srgbClr val="6B7B73"/>
-                </a:solidFill>
-                <a:latin typeface="Space Grotesk"/>
-              </a:rPr>
-              <a:t>want</a:t>
-            </a:r>
-            <a:r>
-              <a:rPr sz="1100" b="1">
-                <a:solidFill>
-                  <a:srgbClr val="1F7A57"/>
-                </a:solidFill>
-                <a:latin typeface="Space Grotesk"/>
-              </a:rPr>
-              <a:t>hat</a:t>
-            </a:r>
-          </a:p>
-        </p:txBody>
-      </p:sp>
-      <p:sp>
-        <p:nvSpPr>
-          <p:cNvPr id="9" name="TextBox 8"/>
-          <p:cNvSpPr txBox="1"/>
-          <p:nvPr/>
-        </p:nvSpPr>
-        <p:spPr>
-          <a:xfrm>
-            <a:off x="10607040" y="6510528"/>
-            <a:ext cx="941832" cy="274320"/>
-          </a:xfrm>
-          <a:prstGeom prst="rect">
-            <a:avLst/>
-          </a:prstGeom>
-          <a:noFill/>
-        </p:spPr>
-        <p:txBody>
-          <a:bodyPr wrap="square" anchor="t" lIns="0" rIns="0" tIns="0" bIns="0">
-            <a:spAutoFit/>
-          </a:bodyPr>
-          <a:lstStyle/>
-          <a:p>
-            <a:pPr algn="r"/>
-            <a:r>
-              <a:rPr sz="1000" b="0">
-                <a:solidFill>
-                  <a:srgbClr val="8A968F"/>
-                </a:solidFill>
-                <a:latin typeface="Space Mono"/>
-              </a:rPr>
-              <a:t>13</a:t>
-            </a:r>
-          </a:p>
-        </p:txBody>
-      </p:sp>
-      <p:sp>
-        <p:nvSpPr>
-          <p:cNvPr id="10" name="TextBox 9"/>
-          <p:cNvSpPr txBox="1"/>
-          <p:nvPr/>
-        </p:nvSpPr>
-        <p:spPr>
-          <a:xfrm>
-            <a:off x="658368" y="1783080"/>
-            <a:ext cx="3063240" cy="4480560"/>
-          </a:xfrm>
-          <a:prstGeom prst="rect">
-            <a:avLst/>
-          </a:prstGeom>
-          <a:noFill/>
-        </p:spPr>
-        <p:txBody>
-          <a:bodyPr wrap="square">
-            <a:spAutoFit/>
-          </a:bodyPr>
-          <a:lstStyle/>
-          <a:p>
-            <a:r>
-              <a:rPr sz="1200" b="0">
-                <a:solidFill>
-                  <a:srgbClr val="15201C"/>
-                </a:solidFill>
-                <a:latin typeface="Hanken Grotesk"/>
-              </a:rPr>
-              <a:t>-  Internal-only flow — the ONLY path that can append wallet entries (GRANT-enforced).</a:t>
-            </a:r>
-          </a:p>
-          <a:p>
-            <a:r>
-              <a:rPr sz="1200" b="0">
-                <a:solidFill>
-                  <a:srgbClr val="15201C"/>
-                </a:solidFill>
-                <a:latin typeface="Hanken Grotesk"/>
-              </a:rPr>
-              <a:t>-  Side use case: FX rates pulled from the exchange-rate provider.</a:t>
-            </a:r>
-          </a:p>
-        </p:txBody>
-      </p:sp>
+      <p:pic>
+        <p:nvPicPr>
+          <p:cNvPr id="2" name="Picture 1" descr="page-13.jpg"/>
+          <p:cNvPicPr>
+            <a:picLocks noChangeAspect="1"/>
+          </p:cNvPicPr>
+          <p:nvPr/>
+        </p:nvPicPr>
+        <p:blipFill>
+          <a:blip r:embed="rId4"/>
+          <a:stretch>
+            <a:fillRect/>
+          </a:stretch>
+        </p:blipFill>
+        <p:spPr>
+          <a:xfrm>
+            <a:off x="0" y="0"/>
+            <a:ext cx="12191695" cy="6858000"/>
+          </a:xfrm>
+          <a:prstGeom prst="rect">
+            <a:avLst/>
+          </a:prstGeom>
+        </p:spPr>
+      </p:pic>
     </p:spTree>
   </p:cSld>
   <p:clrMapOvr>
@@ -7463,324 +6254,30 @@
         <p:nvPr/>
       </p:nvGrpSpPr>
       <p:grpSpPr/>
-      <p:sp>
-        <p:nvSpPr>
-          <p:cNvPr id="2" name="TextBox 1"/>
-          <p:cNvSpPr txBox="1"/>
-          <p:nvPr/>
-        </p:nvSpPr>
-        <p:spPr>
-          <a:xfrm>
-            <a:off x="10195560" y="256032"/>
-            <a:ext cx="1371600" cy="1005840"/>
-          </a:xfrm>
-          <a:prstGeom prst="rect">
-            <a:avLst/>
-          </a:prstGeom>
-          <a:noFill/>
-        </p:spPr>
-        <p:txBody>
-          <a:bodyPr wrap="square" anchor="t" lIns="0" rIns="0" tIns="0" bIns="0">
-            <a:spAutoFit/>
-          </a:bodyPr>
-          <a:lstStyle/>
-          <a:p>
-            <a:pPr algn="r"/>
-            <a:r>
-              <a:rPr sz="4600" b="1">
-                <a:solidFill>
-                  <a:srgbClr val="DCE5E0"/>
-                </a:solidFill>
-                <a:latin typeface="Space Grotesk"/>
-              </a:rPr>
-              <a:t>14</a:t>
-            </a:r>
-          </a:p>
-        </p:txBody>
-      </p:sp>
-      <p:sp>
-        <p:nvSpPr>
-          <p:cNvPr id="3" name="TextBox 2"/>
-          <p:cNvSpPr txBox="1"/>
-          <p:nvPr/>
-        </p:nvSpPr>
-        <p:spPr>
-          <a:xfrm>
-            <a:off x="640080" y="420624"/>
-            <a:ext cx="9418320" cy="292608"/>
-          </a:xfrm>
-          <a:prstGeom prst="rect">
-            <a:avLst/>
-          </a:prstGeom>
-          <a:noFill/>
-        </p:spPr>
-        <p:txBody>
-          <a:bodyPr wrap="square" anchor="t" lIns="0" rIns="0" tIns="0" bIns="0">
-            <a:spAutoFit/>
-          </a:bodyPr>
-          <a:lstStyle/>
-          <a:p>
-            <a:r>
-              <a:rPr sz="1150" b="1">
-                <a:solidFill>
-                  <a:srgbClr val="1F7A57"/>
-                </a:solidFill>
-                <a:latin typeface="Space Mono"/>
-              </a:rPr>
-              <a:t>ENGINEERING</a:t>
-            </a:r>
-          </a:p>
-        </p:txBody>
-      </p:sp>
-      <p:sp>
-        <p:nvSpPr>
-          <p:cNvPr id="4" name="TextBox 3"/>
-          <p:cNvSpPr txBox="1"/>
-          <p:nvPr/>
-        </p:nvSpPr>
-        <p:spPr>
-          <a:xfrm>
-            <a:off x="621792" y="731520"/>
-            <a:ext cx="9509760" cy="868680"/>
-          </a:xfrm>
-          <a:prstGeom prst="rect">
-            <a:avLst/>
-          </a:prstGeom>
-          <a:noFill/>
-        </p:spPr>
-        <p:txBody>
-          <a:bodyPr wrap="square" anchor="t" lIns="0" rIns="0" tIns="0" bIns="0">
-            <a:spAutoFit/>
-          </a:bodyPr>
-          <a:lstStyle/>
-          <a:p>
-            <a:r>
-              <a:rPr sz="2700" b="1">
-                <a:solidFill>
-                  <a:srgbClr val="15201C"/>
-                </a:solidFill>
-                <a:latin typeface="Space Grotesk"/>
-              </a:rPr>
-              <a:t>Architecture UC5 — the member home page</a:t>
-            </a:r>
-          </a:p>
-        </p:txBody>
-      </p:sp>
-      <p:sp>
-        <p:nvSpPr>
-          <p:cNvPr id="5" name="Rounded Rectangle 4"/>
-          <p:cNvSpPr/>
-          <p:nvPr/>
-        </p:nvSpPr>
-        <p:spPr>
-          <a:xfrm>
-            <a:off x="3886200" y="1600200"/>
-            <a:ext cx="7653527" cy="4709160"/>
-          </a:xfrm>
-          <a:prstGeom prst="roundRect">
-            <a:avLst>
-              <a:gd name="adj" fmla="val 3000"/>
-            </a:avLst>
-          </a:prstGeom>
-          <a:solidFill>
-            <a:srgbClr val="FFFFFF"/>
-          </a:solidFill>
-          <a:ln w="12700">
-            <a:solidFill>
-              <a:srgbClr val="E6EBE8"/>
-            </a:solidFill>
-          </a:ln>
-          <a:effectLst/>
-        </p:spPr>
-        <p:style>
-          <a:lnRef idx="1">
-            <a:schemeClr val="accent1"/>
-          </a:lnRef>
-          <a:fillRef idx="3">
-            <a:schemeClr val="accent1"/>
-          </a:fillRef>
-          <a:effectRef idx="2">
-            <a:schemeClr val="accent1"/>
-          </a:effectRef>
-          <a:fontRef idx="minor">
-            <a:schemeClr val="lt1"/>
-          </a:fontRef>
-        </p:style>
-        <p:txBody>
-          <a:bodyPr rtlCol="0" anchor="ctr"/>
-          <a:lstStyle/>
-          <a:p>
-            <a:pPr algn="ctr"/>
-          </a:p>
-        </p:txBody>
-      </p:sp>
-      <p:sp>
-        <p:nvSpPr>
-          <p:cNvPr id="7" name="Rectangle 6"/>
-          <p:cNvSpPr/>
-          <p:nvPr/>
-        </p:nvSpPr>
-        <p:spPr>
-          <a:xfrm>
-            <a:off x="640080" y="6455664"/>
-            <a:ext cx="10908792" cy="9144"/>
-          </a:xfrm>
-          <a:prstGeom prst="rect">
-            <a:avLst/>
-          </a:prstGeom>
-          <a:solidFill>
-            <a:srgbClr val="E6EBE8"/>
-          </a:solidFill>
-          <a:ln>
-            <a:noFill/>
-          </a:ln>
-          <a:effectLst/>
-        </p:spPr>
-        <p:style>
-          <a:lnRef idx="1">
-            <a:schemeClr val="accent1"/>
-          </a:lnRef>
-          <a:fillRef idx="3">
-            <a:schemeClr val="accent1"/>
-          </a:fillRef>
-          <a:effectRef idx="2">
-            <a:schemeClr val="accent1"/>
-          </a:effectRef>
-          <a:fontRef idx="minor">
-            <a:schemeClr val="lt1"/>
-          </a:fontRef>
-        </p:style>
-        <p:txBody>
-          <a:bodyPr rtlCol="0" anchor="ctr"/>
-          <a:lstStyle/>
-          <a:p>
-            <a:pPr algn="ctr"/>
-          </a:p>
-        </p:txBody>
-      </p:sp>
-      <p:sp>
-        <p:nvSpPr>
-          <p:cNvPr id="8" name="TextBox 7"/>
-          <p:cNvSpPr txBox="1"/>
-          <p:nvPr/>
-        </p:nvSpPr>
-        <p:spPr>
-          <a:xfrm>
-            <a:off x="640080" y="6510528"/>
-            <a:ext cx="2743200" cy="274320"/>
-          </a:xfrm>
-          <a:prstGeom prst="rect">
-            <a:avLst/>
-          </a:prstGeom>
-          <a:noFill/>
-        </p:spPr>
-        <p:txBody>
-          <a:bodyPr wrap="square" anchor="t" lIns="0" rIns="0" tIns="0" bIns="0">
-            <a:spAutoFit/>
-          </a:bodyPr>
-          <a:lstStyle/>
-          <a:p>
-            <a:r>
-              <a:rPr sz="1100" b="1">
-                <a:solidFill>
-                  <a:srgbClr val="6B7B73"/>
-                </a:solidFill>
-                <a:latin typeface="Space Grotesk"/>
-              </a:rPr>
-              <a:t>want</a:t>
-            </a:r>
-            <a:r>
-              <a:rPr sz="1100" b="1">
-                <a:solidFill>
-                  <a:srgbClr val="1F7A57"/>
-                </a:solidFill>
-                <a:latin typeface="Space Grotesk"/>
-              </a:rPr>
-              <a:t>hat</a:t>
-            </a:r>
-          </a:p>
-        </p:txBody>
-      </p:sp>
-      <p:sp>
-        <p:nvSpPr>
-          <p:cNvPr id="9" name="TextBox 8"/>
-          <p:cNvSpPr txBox="1"/>
-          <p:nvPr/>
-        </p:nvSpPr>
-        <p:spPr>
-          <a:xfrm>
-            <a:off x="10607040" y="6510528"/>
-            <a:ext cx="941832" cy="274320"/>
-          </a:xfrm>
-          <a:prstGeom prst="rect">
-            <a:avLst/>
-          </a:prstGeom>
-          <a:noFill/>
-        </p:spPr>
-        <p:txBody>
-          <a:bodyPr wrap="square" anchor="t" lIns="0" rIns="0" tIns="0" bIns="0">
-            <a:spAutoFit/>
-          </a:bodyPr>
-          <a:lstStyle/>
-          <a:p>
-            <a:pPr algn="r"/>
-            <a:r>
-              <a:rPr sz="1000" b="0">
-                <a:solidFill>
-                  <a:srgbClr val="8A968F"/>
-                </a:solidFill>
-                <a:latin typeface="Space Mono"/>
-              </a:rPr>
-              <a:t>14</a:t>
-            </a:r>
-          </a:p>
-        </p:txBody>
-      </p:sp>
-      <p:sp>
-        <p:nvSpPr>
-          <p:cNvPr id="10" name="TextBox 9"/>
-          <p:cNvSpPr txBox="1"/>
-          <p:nvPr/>
-        </p:nvSpPr>
-        <p:spPr>
-          <a:xfrm>
-            <a:off x="658368" y="1783080"/>
-            <a:ext cx="3063240" cy="4480560"/>
-          </a:xfrm>
-          <a:prstGeom prst="rect">
-            <a:avLst/>
-          </a:prstGeom>
-          <a:noFill/>
-        </p:spPr>
-        <p:txBody>
-          <a:bodyPr wrap="square">
-            <a:spAutoFit/>
-          </a:bodyPr>
-          <a:lstStyle/>
-          <a:p>
-            <a:r>
-              <a:rPr sz="1200" b="0">
-                <a:solidFill>
-                  <a:srgbClr val="15201C"/>
-                </a:solidFill>
-                <a:latin typeface="Hanken Grotesk"/>
-              </a:rPr>
-              <a:t>-  An Aurora cold resume may delay the wallet total + recent activity.</a:t>
-            </a:r>
-          </a:p>
-          <a:p>
-            <a:r>
-              <a:rPr sz="1200" b="0">
-                <a:solidFill>
-                  <a:srgbClr val="15201C"/>
-                </a:solidFill>
-                <a:latin typeface="Hanken Grotesk"/>
-              </a:rPr>
-              <a:t>-  Everything else is operational immediately.</a:t>
-            </a:r>
-          </a:p>
-        </p:txBody>
-      </p:sp>
+      <p:pic>
+        <p:nvPicPr>
+          <p:cNvPr id="2" name="Picture 1" descr="page-14.jpg"/>
+          <p:cNvPicPr>
+            <a:picLocks noChangeAspect="1"/>
+          </p:cNvPicPr>
+          <p:nvPr/>
+        </p:nvPicPr>
+        <p:blipFill>
+          <a:blip r:embed="rId4"/>
+          <a:stretch>
+            <a:fillRect/>
+          </a:stretch>
+        </p:blipFill>
+        <p:spPr>
+          <a:xfrm>
+            <a:off x="0" y="0"/>
+            <a:ext cx="12191695" cy="6858000"/>
+          </a:xfrm>
+          <a:prstGeom prst="rect">
+            <a:avLst/>
+          </a:prstGeom>
+        </p:spPr>
+      </p:pic>
     </p:spTree>
   </p:cSld>
   <p:clrMapOvr>
@@ -7799,324 +6296,30 @@
         <p:nvPr/>
       </p:nvGrpSpPr>
       <p:grpSpPr/>
-      <p:sp>
-        <p:nvSpPr>
-          <p:cNvPr id="2" name="TextBox 1"/>
-          <p:cNvSpPr txBox="1"/>
-          <p:nvPr/>
-        </p:nvSpPr>
-        <p:spPr>
-          <a:xfrm>
-            <a:off x="10195560" y="256032"/>
-            <a:ext cx="1371600" cy="1005840"/>
-          </a:xfrm>
-          <a:prstGeom prst="rect">
-            <a:avLst/>
-          </a:prstGeom>
-          <a:noFill/>
-        </p:spPr>
-        <p:txBody>
-          <a:bodyPr wrap="square" anchor="t" lIns="0" rIns="0" tIns="0" bIns="0">
-            <a:spAutoFit/>
-          </a:bodyPr>
-          <a:lstStyle/>
-          <a:p>
-            <a:pPr algn="r"/>
-            <a:r>
-              <a:rPr sz="4600" b="1">
-                <a:solidFill>
-                  <a:srgbClr val="DCE5E0"/>
-                </a:solidFill>
-                <a:latin typeface="Space Grotesk"/>
-              </a:rPr>
-              <a:t>15</a:t>
-            </a:r>
-          </a:p>
-        </p:txBody>
-      </p:sp>
-      <p:sp>
-        <p:nvSpPr>
-          <p:cNvPr id="3" name="TextBox 2"/>
-          <p:cNvSpPr txBox="1"/>
-          <p:nvPr/>
-        </p:nvSpPr>
-        <p:spPr>
-          <a:xfrm>
-            <a:off x="640080" y="420624"/>
-            <a:ext cx="9418320" cy="292608"/>
-          </a:xfrm>
-          <a:prstGeom prst="rect">
-            <a:avLst/>
-          </a:prstGeom>
-          <a:noFill/>
-        </p:spPr>
-        <p:txBody>
-          <a:bodyPr wrap="square" anchor="t" lIns="0" rIns="0" tIns="0" bIns="0">
-            <a:spAutoFit/>
-          </a:bodyPr>
-          <a:lstStyle/>
-          <a:p>
-            <a:r>
-              <a:rPr sz="1150" b="1">
-                <a:solidFill>
-                  <a:srgbClr val="1F7A57"/>
-                </a:solidFill>
-                <a:latin typeface="Space Mono"/>
-              </a:rPr>
-              <a:t>ENGINEERING</a:t>
-            </a:r>
-          </a:p>
-        </p:txBody>
-      </p:sp>
-      <p:sp>
-        <p:nvSpPr>
-          <p:cNvPr id="4" name="TextBox 3"/>
-          <p:cNvSpPr txBox="1"/>
-          <p:nvPr/>
-        </p:nvSpPr>
-        <p:spPr>
-          <a:xfrm>
-            <a:off x="621792" y="731520"/>
-            <a:ext cx="9509760" cy="868680"/>
-          </a:xfrm>
-          <a:prstGeom prst="rect">
-            <a:avLst/>
-          </a:prstGeom>
-          <a:noFill/>
-        </p:spPr>
-        <p:txBody>
-          <a:bodyPr wrap="square" anchor="t" lIns="0" rIns="0" tIns="0" bIns="0">
-            <a:spAutoFit/>
-          </a:bodyPr>
-          <a:lstStyle/>
-          <a:p>
-            <a:r>
-              <a:rPr sz="2700" b="1">
-                <a:solidFill>
-                  <a:srgbClr val="15201C"/>
-                </a:solidFill>
-                <a:latin typeface="Space Grotesk"/>
-              </a:rPr>
-              <a:t>Architecture UC6 — the admin console</a:t>
-            </a:r>
-          </a:p>
-        </p:txBody>
-      </p:sp>
-      <p:sp>
-        <p:nvSpPr>
-          <p:cNvPr id="5" name="Rounded Rectangle 4"/>
-          <p:cNvSpPr/>
-          <p:nvPr/>
-        </p:nvSpPr>
-        <p:spPr>
-          <a:xfrm>
-            <a:off x="3886200" y="1600200"/>
-            <a:ext cx="7653527" cy="4709160"/>
-          </a:xfrm>
-          <a:prstGeom prst="roundRect">
-            <a:avLst>
-              <a:gd name="adj" fmla="val 3000"/>
-            </a:avLst>
-          </a:prstGeom>
-          <a:solidFill>
-            <a:srgbClr val="FFFFFF"/>
-          </a:solidFill>
-          <a:ln w="12700">
-            <a:solidFill>
-              <a:srgbClr val="E6EBE8"/>
-            </a:solidFill>
-          </a:ln>
-          <a:effectLst/>
-        </p:spPr>
-        <p:style>
-          <a:lnRef idx="1">
-            <a:schemeClr val="accent1"/>
-          </a:lnRef>
-          <a:fillRef idx="3">
-            <a:schemeClr val="accent1"/>
-          </a:fillRef>
-          <a:effectRef idx="2">
-            <a:schemeClr val="accent1"/>
-          </a:effectRef>
-          <a:fontRef idx="minor">
-            <a:schemeClr val="lt1"/>
-          </a:fontRef>
-        </p:style>
-        <p:txBody>
-          <a:bodyPr rtlCol="0" anchor="ctr"/>
-          <a:lstStyle/>
-          <a:p>
-            <a:pPr algn="ctr"/>
-          </a:p>
-        </p:txBody>
-      </p:sp>
-      <p:sp>
-        <p:nvSpPr>
-          <p:cNvPr id="7" name="Rectangle 6"/>
-          <p:cNvSpPr/>
-          <p:nvPr/>
-        </p:nvSpPr>
-        <p:spPr>
-          <a:xfrm>
-            <a:off x="640080" y="6455664"/>
-            <a:ext cx="10908792" cy="9144"/>
-          </a:xfrm>
-          <a:prstGeom prst="rect">
-            <a:avLst/>
-          </a:prstGeom>
-          <a:solidFill>
-            <a:srgbClr val="E6EBE8"/>
-          </a:solidFill>
-          <a:ln>
-            <a:noFill/>
-          </a:ln>
-          <a:effectLst/>
-        </p:spPr>
-        <p:style>
-          <a:lnRef idx="1">
-            <a:schemeClr val="accent1"/>
-          </a:lnRef>
-          <a:fillRef idx="3">
-            <a:schemeClr val="accent1"/>
-          </a:fillRef>
-          <a:effectRef idx="2">
-            <a:schemeClr val="accent1"/>
-          </a:effectRef>
-          <a:fontRef idx="minor">
-            <a:schemeClr val="lt1"/>
-          </a:fontRef>
-        </p:style>
-        <p:txBody>
-          <a:bodyPr rtlCol="0" anchor="ctr"/>
-          <a:lstStyle/>
-          <a:p>
-            <a:pPr algn="ctr"/>
-          </a:p>
-        </p:txBody>
-      </p:sp>
-      <p:sp>
-        <p:nvSpPr>
-          <p:cNvPr id="8" name="TextBox 7"/>
-          <p:cNvSpPr txBox="1"/>
-          <p:nvPr/>
-        </p:nvSpPr>
-        <p:spPr>
-          <a:xfrm>
-            <a:off x="640080" y="6510528"/>
-            <a:ext cx="2743200" cy="274320"/>
-          </a:xfrm>
-          <a:prstGeom prst="rect">
-            <a:avLst/>
-          </a:prstGeom>
-          <a:noFill/>
-        </p:spPr>
-        <p:txBody>
-          <a:bodyPr wrap="square" anchor="t" lIns="0" rIns="0" tIns="0" bIns="0">
-            <a:spAutoFit/>
-          </a:bodyPr>
-          <a:lstStyle/>
-          <a:p>
-            <a:r>
-              <a:rPr sz="1100" b="1">
-                <a:solidFill>
-                  <a:srgbClr val="6B7B73"/>
-                </a:solidFill>
-                <a:latin typeface="Space Grotesk"/>
-              </a:rPr>
-              <a:t>want</a:t>
-            </a:r>
-            <a:r>
-              <a:rPr sz="1100" b="1">
-                <a:solidFill>
-                  <a:srgbClr val="1F7A57"/>
-                </a:solidFill>
-                <a:latin typeface="Space Grotesk"/>
-              </a:rPr>
-              <a:t>hat</a:t>
-            </a:r>
-          </a:p>
-        </p:txBody>
-      </p:sp>
-      <p:sp>
-        <p:nvSpPr>
-          <p:cNvPr id="9" name="TextBox 8"/>
-          <p:cNvSpPr txBox="1"/>
-          <p:nvPr/>
-        </p:nvSpPr>
-        <p:spPr>
-          <a:xfrm>
-            <a:off x="10607040" y="6510528"/>
-            <a:ext cx="941832" cy="274320"/>
-          </a:xfrm>
-          <a:prstGeom prst="rect">
-            <a:avLst/>
-          </a:prstGeom>
-          <a:noFill/>
-        </p:spPr>
-        <p:txBody>
-          <a:bodyPr wrap="square" anchor="t" lIns="0" rIns="0" tIns="0" bIns="0">
-            <a:spAutoFit/>
-          </a:bodyPr>
-          <a:lstStyle/>
-          <a:p>
-            <a:pPr algn="r"/>
-            <a:r>
-              <a:rPr sz="1000" b="0">
-                <a:solidFill>
-                  <a:srgbClr val="8A968F"/>
-                </a:solidFill>
-                <a:latin typeface="Space Mono"/>
-              </a:rPr>
-              <a:t>15</a:t>
-            </a:r>
-          </a:p>
-        </p:txBody>
-      </p:sp>
-      <p:sp>
-        <p:nvSpPr>
-          <p:cNvPr id="10" name="TextBox 9"/>
-          <p:cNvSpPr txBox="1"/>
-          <p:nvPr/>
-        </p:nvSpPr>
-        <p:spPr>
-          <a:xfrm>
-            <a:off x="658368" y="1783080"/>
-            <a:ext cx="3063240" cy="4480560"/>
-          </a:xfrm>
-          <a:prstGeom prst="rect">
-            <a:avLst/>
-          </a:prstGeom>
-          <a:noFill/>
-        </p:spPr>
-        <p:txBody>
-          <a:bodyPr wrap="square">
-            <a:spAutoFit/>
-          </a:bodyPr>
-          <a:lstStyle/>
-          <a:p>
-            <a:r>
-              <a:rPr sz="1200" b="0">
-                <a:solidFill>
-                  <a:srgbClr val="15201C"/>
-                </a:solidFill>
-                <a:latin typeface="Hanken Grotesk"/>
-              </a:rPr>
-              <a:t>-  Cognito Managed Login; a SEPARATE employee pool.</a:t>
-            </a:r>
-          </a:p>
-          <a:p>
-            <a:r>
-              <a:rPr sz="1200" b="0">
-                <a:solidFill>
-                  <a:srgbClr val="15201C"/>
-                </a:solidFill>
-                <a:latin typeface="Hanken Grotesk"/>
-              </a:rPr>
-              <a:t>-  Operational-data management; money views are read-only.</a:t>
-            </a:r>
-          </a:p>
-        </p:txBody>
-      </p:sp>
+      <p:pic>
+        <p:nvPicPr>
+          <p:cNvPr id="2" name="Picture 1" descr="page-15.jpg"/>
+          <p:cNvPicPr>
+            <a:picLocks noChangeAspect="1"/>
+          </p:cNvPicPr>
+          <p:nvPr/>
+        </p:nvPicPr>
+        <p:blipFill>
+          <a:blip r:embed="rId4"/>
+          <a:stretch>
+            <a:fillRect/>
+          </a:stretch>
+        </p:blipFill>
+        <p:spPr>
+          <a:xfrm>
+            <a:off x="0" y="0"/>
+            <a:ext cx="12191695" cy="6858000"/>
+          </a:xfrm>
+          <a:prstGeom prst="rect">
+            <a:avLst/>
+          </a:prstGeom>
+        </p:spPr>
+      </p:pic>
     </p:spTree>
   </p:cSld>
   <p:clrMapOvr>
@@ -8135,357 +6338,30 @@
         <p:nvPr/>
       </p:nvGrpSpPr>
       <p:grpSpPr/>
-      <p:sp>
-        <p:nvSpPr>
-          <p:cNvPr id="2" name="TextBox 1"/>
-          <p:cNvSpPr txBox="1"/>
-          <p:nvPr/>
-        </p:nvSpPr>
-        <p:spPr>
-          <a:xfrm>
-            <a:off x="10195560" y="256032"/>
-            <a:ext cx="1371600" cy="1005840"/>
-          </a:xfrm>
-          <a:prstGeom prst="rect">
-            <a:avLst/>
-          </a:prstGeom>
-          <a:noFill/>
-        </p:spPr>
-        <p:txBody>
-          <a:bodyPr wrap="square" anchor="t" lIns="0" rIns="0" tIns="0" bIns="0">
-            <a:spAutoFit/>
-          </a:bodyPr>
-          <a:lstStyle/>
-          <a:p>
-            <a:pPr algn="r"/>
-            <a:r>
-              <a:rPr sz="4600" b="1">
-                <a:solidFill>
-                  <a:srgbClr val="DCE5E0"/>
-                </a:solidFill>
-                <a:latin typeface="Space Grotesk"/>
-              </a:rPr>
-              <a:t>16</a:t>
-            </a:r>
-          </a:p>
-        </p:txBody>
-      </p:sp>
-      <p:sp>
-        <p:nvSpPr>
-          <p:cNvPr id="3" name="TextBox 2"/>
-          <p:cNvSpPr txBox="1"/>
-          <p:nvPr/>
-        </p:nvSpPr>
-        <p:spPr>
-          <a:xfrm>
-            <a:off x="640080" y="420624"/>
-            <a:ext cx="9418320" cy="292608"/>
-          </a:xfrm>
-          <a:prstGeom prst="rect">
-            <a:avLst/>
-          </a:prstGeom>
-          <a:noFill/>
-        </p:spPr>
-        <p:txBody>
-          <a:bodyPr wrap="square" anchor="t" lIns="0" rIns="0" tIns="0" bIns="0">
-            <a:spAutoFit/>
-          </a:bodyPr>
-          <a:lstStyle/>
-          <a:p>
-            <a:r>
-              <a:rPr sz="1150" b="1">
-                <a:solidFill>
-                  <a:srgbClr val="1F7A57"/>
-                </a:solidFill>
-                <a:latin typeface="Space Mono"/>
-              </a:rPr>
-              <a:t>ENGINEERING</a:t>
-            </a:r>
-          </a:p>
-        </p:txBody>
-      </p:sp>
-      <p:sp>
-        <p:nvSpPr>
-          <p:cNvPr id="4" name="TextBox 3"/>
-          <p:cNvSpPr txBox="1"/>
-          <p:nvPr/>
-        </p:nvSpPr>
-        <p:spPr>
-          <a:xfrm>
-            <a:off x="621792" y="731520"/>
-            <a:ext cx="9509760" cy="868680"/>
-          </a:xfrm>
-          <a:prstGeom prst="rect">
-            <a:avLst/>
-          </a:prstGeom>
-          <a:noFill/>
-        </p:spPr>
-        <p:txBody>
-          <a:bodyPr wrap="square" anchor="t" lIns="0" rIns="0" tIns="0" bIns="0">
-            <a:spAutoFit/>
-          </a:bodyPr>
-          <a:lstStyle/>
-          <a:p>
-            <a:r>
-              <a:rPr sz="2700" b="1">
-                <a:solidFill>
-                  <a:srgbClr val="15201C"/>
-                </a:solidFill>
-                <a:latin typeface="Space Grotesk"/>
-              </a:rPr>
-              <a:t>Architecture — additional use cases, same principles</a:t>
-            </a:r>
-          </a:p>
-        </p:txBody>
-      </p:sp>
-      <p:sp>
-        <p:nvSpPr>
-          <p:cNvPr id="5" name="Rounded Rectangle 4"/>
-          <p:cNvSpPr/>
-          <p:nvPr/>
-        </p:nvSpPr>
-        <p:spPr>
-          <a:xfrm>
-            <a:off x="3886200" y="1600200"/>
-            <a:ext cx="7653527" cy="4709160"/>
-          </a:xfrm>
-          <a:prstGeom prst="roundRect">
-            <a:avLst>
-              <a:gd name="adj" fmla="val 3000"/>
-            </a:avLst>
-          </a:prstGeom>
-          <a:solidFill>
-            <a:srgbClr val="FFFFFF"/>
-          </a:solidFill>
-          <a:ln w="12700">
-            <a:solidFill>
-              <a:srgbClr val="E6EBE8"/>
-            </a:solidFill>
-          </a:ln>
-          <a:effectLst/>
-        </p:spPr>
-        <p:style>
-          <a:lnRef idx="1">
-            <a:schemeClr val="accent1"/>
-          </a:lnRef>
-          <a:fillRef idx="3">
-            <a:schemeClr val="accent1"/>
-          </a:fillRef>
-          <a:effectRef idx="2">
-            <a:schemeClr val="accent1"/>
-          </a:effectRef>
-          <a:fontRef idx="minor">
-            <a:schemeClr val="lt1"/>
-          </a:fontRef>
-        </p:style>
-        <p:txBody>
-          <a:bodyPr rtlCol="0" anchor="ctr"/>
-          <a:lstStyle/>
-          <a:p>
-            <a:pPr algn="ctr"/>
-          </a:p>
-        </p:txBody>
-      </p:sp>
-      <p:sp>
-        <p:nvSpPr>
-          <p:cNvPr id="7" name="Rectangle 6"/>
-          <p:cNvSpPr/>
-          <p:nvPr/>
-        </p:nvSpPr>
-        <p:spPr>
-          <a:xfrm>
-            <a:off x="640080" y="6455664"/>
-            <a:ext cx="10908792" cy="9144"/>
-          </a:xfrm>
-          <a:prstGeom prst="rect">
-            <a:avLst/>
-          </a:prstGeom>
-          <a:solidFill>
-            <a:srgbClr val="E6EBE8"/>
-          </a:solidFill>
-          <a:ln>
-            <a:noFill/>
-          </a:ln>
-          <a:effectLst/>
-        </p:spPr>
-        <p:style>
-          <a:lnRef idx="1">
-            <a:schemeClr val="accent1"/>
-          </a:lnRef>
-          <a:fillRef idx="3">
-            <a:schemeClr val="accent1"/>
-          </a:fillRef>
-          <a:effectRef idx="2">
-            <a:schemeClr val="accent1"/>
-          </a:effectRef>
-          <a:fontRef idx="minor">
-            <a:schemeClr val="lt1"/>
-          </a:fontRef>
-        </p:style>
-        <p:txBody>
-          <a:bodyPr rtlCol="0" anchor="ctr"/>
-          <a:lstStyle/>
-          <a:p>
-            <a:pPr algn="ctr"/>
-          </a:p>
-        </p:txBody>
-      </p:sp>
-      <p:sp>
-        <p:nvSpPr>
-          <p:cNvPr id="8" name="TextBox 7"/>
-          <p:cNvSpPr txBox="1"/>
-          <p:nvPr/>
-        </p:nvSpPr>
-        <p:spPr>
-          <a:xfrm>
-            <a:off x="640080" y="6510528"/>
-            <a:ext cx="2743200" cy="274320"/>
-          </a:xfrm>
-          <a:prstGeom prst="rect">
-            <a:avLst/>
-          </a:prstGeom>
-          <a:noFill/>
-        </p:spPr>
-        <p:txBody>
-          <a:bodyPr wrap="square" anchor="t" lIns="0" rIns="0" tIns="0" bIns="0">
-            <a:spAutoFit/>
-          </a:bodyPr>
-          <a:lstStyle/>
-          <a:p>
-            <a:r>
-              <a:rPr sz="1100" b="1">
-                <a:solidFill>
-                  <a:srgbClr val="6B7B73"/>
-                </a:solidFill>
-                <a:latin typeface="Space Grotesk"/>
-              </a:rPr>
-              <a:t>want</a:t>
-            </a:r>
-            <a:r>
-              <a:rPr sz="1100" b="1">
-                <a:solidFill>
-                  <a:srgbClr val="1F7A57"/>
-                </a:solidFill>
-                <a:latin typeface="Space Grotesk"/>
-              </a:rPr>
-              <a:t>hat</a:t>
-            </a:r>
-          </a:p>
-        </p:txBody>
-      </p:sp>
-      <p:sp>
-        <p:nvSpPr>
-          <p:cNvPr id="9" name="TextBox 8"/>
-          <p:cNvSpPr txBox="1"/>
-          <p:nvPr/>
-        </p:nvSpPr>
-        <p:spPr>
-          <a:xfrm>
-            <a:off x="10607040" y="6510528"/>
-            <a:ext cx="941832" cy="274320"/>
-          </a:xfrm>
-          <a:prstGeom prst="rect">
-            <a:avLst/>
-          </a:prstGeom>
-          <a:noFill/>
-        </p:spPr>
-        <p:txBody>
-          <a:bodyPr wrap="square" anchor="t" lIns="0" rIns="0" tIns="0" bIns="0">
-            <a:spAutoFit/>
-          </a:bodyPr>
-          <a:lstStyle/>
-          <a:p>
-            <a:pPr algn="r"/>
-            <a:r>
-              <a:rPr sz="1000" b="0">
-                <a:solidFill>
-                  <a:srgbClr val="8A968F"/>
-                </a:solidFill>
-                <a:latin typeface="Space Mono"/>
-              </a:rPr>
-              <a:t>16</a:t>
-            </a:r>
-          </a:p>
-        </p:txBody>
-      </p:sp>
-      <p:sp>
-        <p:nvSpPr>
-          <p:cNvPr id="10" name="TextBox 9"/>
-          <p:cNvSpPr txBox="1"/>
-          <p:nvPr/>
-        </p:nvSpPr>
-        <p:spPr>
-          <a:xfrm>
-            <a:off x="658368" y="1783080"/>
-            <a:ext cx="3063240" cy="4480560"/>
-          </a:xfrm>
-          <a:prstGeom prst="rect">
-            <a:avLst/>
-          </a:prstGeom>
-          <a:noFill/>
-        </p:spPr>
-        <p:txBody>
-          <a:bodyPr wrap="square">
-            <a:spAutoFit/>
-          </a:bodyPr>
-          <a:lstStyle/>
-          <a:p>
-            <a:r>
-              <a:rPr sz="1200" b="0">
-                <a:solidFill>
-                  <a:srgbClr val="15201C"/>
-                </a:solidFill>
-                <a:latin typeface="Hanken Grotesk"/>
-              </a:rPr>
-              <a:t>-  Observability.</a:t>
-            </a:r>
-          </a:p>
-          <a:p>
-            <a:r>
-              <a:rPr sz="1200" b="0">
-                <a:solidFill>
-                  <a:srgbClr val="15201C"/>
-                </a:solidFill>
-                <a:latin typeface="Hanken Grotesk"/>
-              </a:rPr>
-              <a:t>-  Guest attribution within the affiliation window.</a:t>
-            </a:r>
-          </a:p>
-          <a:p>
-            <a:r>
-              <a:rPr sz="1200" b="0">
-                <a:solidFill>
-                  <a:srgbClr val="15201C"/>
-                </a:solidFill>
-                <a:latin typeface="Hanken Grotesk"/>
-              </a:rPr>
-              <a:t>-  Manual attribution of unattributed settlements.</a:t>
-            </a:r>
-          </a:p>
-          <a:p>
-            <a:r>
-              <a:rPr sz="1200" b="0">
-                <a:solidFill>
-                  <a:srgbClr val="15201C"/>
-                </a:solidFill>
-                <a:latin typeface="Hanken Grotesk"/>
-              </a:rPr>
-              <a:t>-  Ops counters for real-time admin stats.</a:t>
-            </a:r>
-          </a:p>
-          <a:p>
-            <a:r>
-              <a:rPr sz="1200" b="0">
-                <a:solidFill>
-                  <a:srgbClr val="15201C"/>
-                </a:solidFill>
-                <a:latin typeface="Hanken Grotesk"/>
-              </a:rPr>
-              <a:t>-  Offline analytics.</a:t>
-            </a:r>
-          </a:p>
-        </p:txBody>
-      </p:sp>
+      <p:pic>
+        <p:nvPicPr>
+          <p:cNvPr id="2" name="Picture 1" descr="page-16.jpg"/>
+          <p:cNvPicPr>
+            <a:picLocks noChangeAspect="1"/>
+          </p:cNvPicPr>
+          <p:nvPr/>
+        </p:nvPicPr>
+        <p:blipFill>
+          <a:blip r:embed="rId4"/>
+          <a:stretch>
+            <a:fillRect/>
+          </a:stretch>
+        </p:blipFill>
+        <p:spPr>
+          <a:xfrm>
+            <a:off x="0" y="0"/>
+            <a:ext cx="12191695" cy="6858000"/>
+          </a:xfrm>
+          <a:prstGeom prst="rect">
+            <a:avLst/>
+          </a:prstGeom>
+        </p:spPr>
+      </p:pic>
     </p:spTree>
   </p:cSld>
   <p:clrMapOvr>
@@ -27185,7 +25061,7 @@
         </p:nvSpPr>
         <p:spPr>
           <a:xfrm>
-            <a:off x="658368" y="1691640"/>
+            <a:off x="658368" y="4050792"/>
             <a:ext cx="3520440" cy="2240280"/>
           </a:xfrm>
           <a:prstGeom prst="roundRect">
@@ -27233,7 +25109,7 @@
         </p:nvSpPr>
         <p:spPr>
           <a:xfrm>
-            <a:off x="841248" y="1874520"/>
+            <a:off x="841248" y="4233672"/>
             <a:ext cx="475488" cy="475488"/>
           </a:xfrm>
           <a:prstGeom prst="roundRect">
@@ -27289,7 +25165,7 @@
         </p:blipFill>
         <p:spPr>
           <a:xfrm>
-            <a:off x="905256" y="1943100"/>
+            <a:off x="905256" y="4302252"/>
             <a:ext cx="338328" cy="338328"/>
           </a:xfrm>
           <a:prstGeom prst="rect">
@@ -27305,7 +25181,7 @@
         </p:nvSpPr>
         <p:spPr>
           <a:xfrm>
-            <a:off x="1435608" y="1929384"/>
+            <a:off x="1435608" y="4288536"/>
             <a:ext cx="2560320" cy="457200"/>
           </a:xfrm>
           <a:prstGeom prst="rect">
@@ -27344,7 +25220,7 @@
         </p:nvSpPr>
         <p:spPr>
           <a:xfrm>
-            <a:off x="841248" y="2468880"/>
+            <a:off x="841248" y="4828032"/>
             <a:ext cx="3154680" cy="1371600"/>
           </a:xfrm>
           <a:prstGeom prst="rect">
@@ -27383,7 +25259,7 @@
         </p:nvSpPr>
         <p:spPr>
           <a:xfrm>
-            <a:off x="4343400" y="1691640"/>
+            <a:off x="4343400" y="4050792"/>
             <a:ext cx="3520440" cy="2240280"/>
           </a:xfrm>
           <a:prstGeom prst="roundRect">
@@ -27431,7 +25307,7 @@
         </p:nvSpPr>
         <p:spPr>
           <a:xfrm>
-            <a:off x="4526280" y="1874520"/>
+            <a:off x="4526280" y="4233672"/>
             <a:ext cx="475488" cy="475488"/>
           </a:xfrm>
           <a:prstGeom prst="roundRect">
@@ -27487,7 +25363,7 @@
         </p:blipFill>
         <p:spPr>
           <a:xfrm>
-            <a:off x="4590288" y="1943100"/>
+            <a:off x="4590288" y="4302252"/>
             <a:ext cx="338328" cy="338328"/>
           </a:xfrm>
           <a:prstGeom prst="rect">
@@ -27503,7 +25379,7 @@
         </p:nvSpPr>
         <p:spPr>
           <a:xfrm>
-            <a:off x="5120640" y="1929384"/>
+            <a:off x="5120640" y="4288536"/>
             <a:ext cx="2560320" cy="457200"/>
           </a:xfrm>
           <a:prstGeom prst="rect">
@@ -27542,7 +25418,7 @@
         </p:nvSpPr>
         <p:spPr>
           <a:xfrm>
-            <a:off x="4526280" y="2468880"/>
+            <a:off x="4526280" y="4828032"/>
             <a:ext cx="3154680" cy="1371600"/>
           </a:xfrm>
           <a:prstGeom prst="rect">
@@ -27581,7 +25457,7 @@
         </p:nvSpPr>
         <p:spPr>
           <a:xfrm>
-            <a:off x="8028432" y="1691640"/>
+            <a:off x="8028432" y="4050792"/>
             <a:ext cx="3520440" cy="2240280"/>
           </a:xfrm>
           <a:prstGeom prst="roundRect">
@@ -27629,7 +25505,7 @@
         </p:nvSpPr>
         <p:spPr>
           <a:xfrm>
-            <a:off x="8211312" y="1874520"/>
+            <a:off x="8211312" y="4233672"/>
             <a:ext cx="475488" cy="475488"/>
           </a:xfrm>
           <a:prstGeom prst="roundRect">
@@ -27685,7 +25561,7 @@
         </p:blipFill>
         <p:spPr>
           <a:xfrm>
-            <a:off x="8275320" y="1943100"/>
+            <a:off x="8275320" y="4302252"/>
             <a:ext cx="338328" cy="338328"/>
           </a:xfrm>
           <a:prstGeom prst="rect">
@@ -27701,7 +25577,7 @@
         </p:nvSpPr>
         <p:spPr>
           <a:xfrm>
-            <a:off x="8805672" y="1929384"/>
+            <a:off x="8805672" y="4288536"/>
             <a:ext cx="2560320" cy="457200"/>
           </a:xfrm>
           <a:prstGeom prst="rect">
@@ -27740,7 +25616,7 @@
         </p:nvSpPr>
         <p:spPr>
           <a:xfrm>
-            <a:off x="8211312" y="2468880"/>
+            <a:off x="8211312" y="4828032"/>
             <a:ext cx="3154680" cy="1371600"/>
           </a:xfrm>
           <a:prstGeom prst="rect">
@@ -27779,7 +25655,7 @@
         </p:nvSpPr>
         <p:spPr>
           <a:xfrm>
-            <a:off x="658368" y="4050792"/>
+            <a:off x="658368" y="1691640"/>
             <a:ext cx="3520440" cy="2240280"/>
           </a:xfrm>
           <a:prstGeom prst="roundRect">
@@ -27827,7 +25703,7 @@
         </p:nvSpPr>
         <p:spPr>
           <a:xfrm>
-            <a:off x="841248" y="4233672"/>
+            <a:off x="841248" y="1874520"/>
             <a:ext cx="475488" cy="475488"/>
           </a:xfrm>
           <a:prstGeom prst="roundRect">
@@ -27883,7 +25759,7 @@
         </p:blipFill>
         <p:spPr>
           <a:xfrm>
-            <a:off x="905256" y="4302252"/>
+            <a:off x="905256" y="1943100"/>
             <a:ext cx="338328" cy="338328"/>
           </a:xfrm>
           <a:prstGeom prst="rect">
@@ -27899,7 +25775,7 @@
         </p:nvSpPr>
         <p:spPr>
           <a:xfrm>
-            <a:off x="1435608" y="4288536"/>
+            <a:off x="1435608" y="1929384"/>
             <a:ext cx="2560320" cy="457200"/>
           </a:xfrm>
           <a:prstGeom prst="rect">
@@ -27938,7 +25814,7 @@
         </p:nvSpPr>
         <p:spPr>
           <a:xfrm>
-            <a:off x="841248" y="4828032"/>
+            <a:off x="841248" y="2468880"/>
             <a:ext cx="3154680" cy="1371600"/>
           </a:xfrm>
           <a:prstGeom prst="rect">
@@ -27977,7 +25853,7 @@
         </p:nvSpPr>
         <p:spPr>
           <a:xfrm>
-            <a:off x="4343400" y="4050792"/>
+            <a:off x="4343400" y="1691640"/>
             <a:ext cx="3520440" cy="2240280"/>
           </a:xfrm>
           <a:prstGeom prst="roundRect">
@@ -28025,7 +25901,7 @@
         </p:nvSpPr>
         <p:spPr>
           <a:xfrm>
-            <a:off x="4526280" y="4233672"/>
+            <a:off x="4526280" y="1874520"/>
             <a:ext cx="475488" cy="475488"/>
           </a:xfrm>
           <a:prstGeom prst="roundRect">
@@ -28081,7 +25957,7 @@
         </p:blipFill>
         <p:spPr>
           <a:xfrm>
-            <a:off x="4590288" y="4302252"/>
+            <a:off x="4590288" y="1943100"/>
             <a:ext cx="338328" cy="338328"/>
           </a:xfrm>
           <a:prstGeom prst="rect">
@@ -28097,7 +25973,7 @@
         </p:nvSpPr>
         <p:spPr>
           <a:xfrm>
-            <a:off x="5120640" y="4288536"/>
+            <a:off x="5120640" y="1929384"/>
             <a:ext cx="2560320" cy="457200"/>
           </a:xfrm>
           <a:prstGeom prst="rect">
@@ -28136,7 +26012,7 @@
         </p:nvSpPr>
         <p:spPr>
           <a:xfrm>
-            <a:off x="4526280" y="4828032"/>
+            <a:off x="4526280" y="2468880"/>
             <a:ext cx="3154680" cy="1371600"/>
           </a:xfrm>
           <a:prstGeom prst="rect">
@@ -28162,7 +26038,7 @@
                 </a:solidFill>
                 <a:latin typeface="Hanken Grotesk"/>
               </a:rPr>
-              <a:t>A link going viral in a WhatsApp group is the design spike.</a:t>
+              <a:t>A link going viral in a WhatsApp group is the potential spike.</a:t>
             </a:r>
           </a:p>
         </p:txBody>
@@ -28297,7 +26173,7 @@
         </p:nvSpPr>
         <p:spPr>
           <a:xfrm>
-            <a:off x="8028432" y="4050792"/>
+            <a:off x="8028432" y="1691640"/>
             <a:ext cx="3520440" cy="2240280"/>
           </a:xfrm>
           <a:prstGeom prst="roundRect">
@@ -28345,7 +26221,7 @@
         </p:nvSpPr>
         <p:spPr>
           <a:xfrm>
-            <a:off x="8211312" y="4233672"/>
+            <a:off x="8211312" y="1874520"/>
             <a:ext cx="475488" cy="475488"/>
           </a:xfrm>
           <a:prstGeom prst="roundRect">
@@ -28393,7 +26269,7 @@
         </p:nvSpPr>
         <p:spPr>
           <a:xfrm>
-            <a:off x="8805672" y="4288536"/>
+            <a:off x="8805672" y="1929384"/>
             <a:ext cx="2560320" cy="457200"/>
           </a:xfrm>
           <a:prstGeom prst="rect">
@@ -28432,7 +26308,7 @@
         </p:nvSpPr>
         <p:spPr>
           <a:xfrm>
-            <a:off x="8211312" y="4828032"/>
+            <a:off x="8211312" y="2468880"/>
             <a:ext cx="3154680" cy="1371600"/>
           </a:xfrm>
           <a:prstGeom prst="rect">
@@ -28458,7 +26334,7 @@
                 </a:solidFill>
                 <a:latin typeface="Hanken Grotesk"/>
               </a:rPr>
-              <a:t>Least privilege per function — IAM + one Postgres role each; money is append-only + audited; PII isolated in Cognito; workers never HTTP-exposed.</a:t>
+              <a:t>The entire framework is about money movement. Apply least privilege access, MFA, data integrity provability, isolation of concerns, strict auditing and other security principles.</a:t>
             </a:r>
           </a:p>
         </p:txBody>
@@ -28479,7 +26355,7 @@
         </p:blipFill>
         <p:spPr>
           <a:xfrm>
-            <a:off x="8275320" y="4302252"/>
+            <a:off x="8275320" y="1943100"/>
             <a:ext cx="338328" cy="338328"/>
           </a:xfrm>
           <a:prstGeom prst="rect">
@@ -28505,337 +26381,30 @@
         <p:nvPr/>
       </p:nvGrpSpPr>
       <p:grpSpPr/>
-      <p:sp>
-        <p:nvSpPr>
-          <p:cNvPr id="2" name="TextBox 1"/>
-          <p:cNvSpPr txBox="1"/>
-          <p:nvPr/>
-        </p:nvSpPr>
-        <p:spPr>
-          <a:xfrm>
-            <a:off x="10195560" y="256032"/>
-            <a:ext cx="1371600" cy="1005840"/>
-          </a:xfrm>
-          <a:prstGeom prst="rect">
-            <a:avLst/>
-          </a:prstGeom>
-          <a:noFill/>
-        </p:spPr>
-        <p:txBody>
-          <a:bodyPr wrap="square" anchor="t" lIns="0" rIns="0" tIns="0" bIns="0">
-            <a:spAutoFit/>
-          </a:bodyPr>
-          <a:lstStyle/>
-          <a:p>
-            <a:pPr algn="r"/>
-            <a:r>
-              <a:rPr sz="4600" b="1">
-                <a:solidFill>
-                  <a:srgbClr val="DCE5E0"/>
-                </a:solidFill>
-                <a:latin typeface="Space Grotesk"/>
-              </a:rPr>
-              <a:t>07</a:t>
-            </a:r>
-          </a:p>
-        </p:txBody>
-      </p:sp>
-      <p:sp>
-        <p:nvSpPr>
-          <p:cNvPr id="3" name="TextBox 2"/>
-          <p:cNvSpPr txBox="1"/>
-          <p:nvPr/>
-        </p:nvSpPr>
-        <p:spPr>
-          <a:xfrm>
-            <a:off x="640080" y="420624"/>
-            <a:ext cx="9418320" cy="292608"/>
-          </a:xfrm>
-          <a:prstGeom prst="rect">
-            <a:avLst/>
-          </a:prstGeom>
-          <a:noFill/>
-        </p:spPr>
-        <p:txBody>
-          <a:bodyPr wrap="square" anchor="t" lIns="0" rIns="0" tIns="0" bIns="0">
-            <a:spAutoFit/>
-          </a:bodyPr>
-          <a:lstStyle/>
-          <a:p>
-            <a:r>
-              <a:rPr sz="1150" b="1">
-                <a:solidFill>
-                  <a:srgbClr val="1F7A57"/>
-                </a:solidFill>
-                <a:latin typeface="Space Mono"/>
-              </a:rPr>
-              <a:t>ENGINEERING</a:t>
-            </a:r>
-          </a:p>
-        </p:txBody>
-      </p:sp>
-      <p:sp>
-        <p:nvSpPr>
-          <p:cNvPr id="4" name="TextBox 3"/>
-          <p:cNvSpPr txBox="1"/>
-          <p:nvPr/>
-        </p:nvSpPr>
-        <p:spPr>
-          <a:xfrm>
-            <a:off x="621792" y="731520"/>
-            <a:ext cx="9509760" cy="868680"/>
-          </a:xfrm>
-          <a:prstGeom prst="rect">
-            <a:avLst/>
-          </a:prstGeom>
-          <a:noFill/>
-        </p:spPr>
-        <p:txBody>
-          <a:bodyPr wrap="square" anchor="t" lIns="0" rIns="0" tIns="0" bIns="0">
-            <a:spAutoFit/>
-          </a:bodyPr>
-          <a:lstStyle/>
-          <a:p>
-            <a:r>
-              <a:rPr sz="2500" b="1">
-                <a:solidFill>
-                  <a:srgbClr val="15201C"/>
-                </a:solidFill>
-                <a:latin typeface="Space Grotesk"/>
-              </a:rPr>
-              <a:t>Data model — three homes, one key</a:t>
-            </a:r>
-          </a:p>
-        </p:txBody>
-      </p:sp>
-      <p:sp>
-        <p:nvSpPr>
-          <p:cNvPr id="5" name="Rounded Rectangle 4"/>
-          <p:cNvSpPr/>
-          <p:nvPr/>
-        </p:nvSpPr>
-        <p:spPr>
-          <a:xfrm>
-            <a:off x="1344168" y="1481328"/>
-            <a:ext cx="9509760" cy="4206240"/>
-          </a:xfrm>
-          <a:prstGeom prst="roundRect">
-            <a:avLst>
-              <a:gd name="adj" fmla="val 3000"/>
-            </a:avLst>
-          </a:prstGeom>
-          <a:solidFill>
-            <a:srgbClr val="FFFFFF"/>
-          </a:solidFill>
-          <a:ln w="12700">
-            <a:solidFill>
-              <a:srgbClr val="E6EBE8"/>
-            </a:solidFill>
-          </a:ln>
-          <a:effectLst/>
-        </p:spPr>
-        <p:style>
-          <a:lnRef idx="1">
-            <a:schemeClr val="accent1"/>
-          </a:lnRef>
-          <a:fillRef idx="3">
-            <a:schemeClr val="accent1"/>
-          </a:fillRef>
-          <a:effectRef idx="2">
-            <a:schemeClr val="accent1"/>
-          </a:effectRef>
-          <a:fontRef idx="minor">
-            <a:schemeClr val="lt1"/>
-          </a:fontRef>
-        </p:style>
-        <p:txBody>
-          <a:bodyPr rtlCol="0" anchor="ctr"/>
-          <a:lstStyle/>
-          <a:p>
-            <a:pPr algn="ctr"/>
-          </a:p>
-        </p:txBody>
-      </p:sp>
-      <p:sp>
-        <p:nvSpPr>
-          <p:cNvPr id="7" name="Rectangle 6"/>
-          <p:cNvSpPr/>
-          <p:nvPr/>
-        </p:nvSpPr>
-        <p:spPr>
-          <a:xfrm>
-            <a:off x="640080" y="6455664"/>
-            <a:ext cx="10908792" cy="9144"/>
-          </a:xfrm>
-          <a:prstGeom prst="rect">
-            <a:avLst/>
-          </a:prstGeom>
-          <a:solidFill>
-            <a:srgbClr val="E6EBE8"/>
-          </a:solidFill>
-          <a:ln>
-            <a:noFill/>
-          </a:ln>
-          <a:effectLst/>
-        </p:spPr>
-        <p:style>
-          <a:lnRef idx="1">
-            <a:schemeClr val="accent1"/>
-          </a:lnRef>
-          <a:fillRef idx="3">
-            <a:schemeClr val="accent1"/>
-          </a:fillRef>
-          <a:effectRef idx="2">
-            <a:schemeClr val="accent1"/>
-          </a:effectRef>
-          <a:fontRef idx="minor">
-            <a:schemeClr val="lt1"/>
-          </a:fontRef>
-        </p:style>
-        <p:txBody>
-          <a:bodyPr rtlCol="0" anchor="ctr"/>
-          <a:lstStyle/>
-          <a:p>
-            <a:pPr algn="ctr"/>
-          </a:p>
-        </p:txBody>
-      </p:sp>
-      <p:sp>
-        <p:nvSpPr>
-          <p:cNvPr id="8" name="TextBox 7"/>
-          <p:cNvSpPr txBox="1"/>
-          <p:nvPr/>
-        </p:nvSpPr>
-        <p:spPr>
-          <a:xfrm>
-            <a:off x="640080" y="6510528"/>
-            <a:ext cx="2743200" cy="274320"/>
-          </a:xfrm>
-          <a:prstGeom prst="rect">
-            <a:avLst/>
-          </a:prstGeom>
-          <a:noFill/>
-        </p:spPr>
-        <p:txBody>
-          <a:bodyPr wrap="square" anchor="t" lIns="0" rIns="0" tIns="0" bIns="0">
-            <a:spAutoFit/>
-          </a:bodyPr>
-          <a:lstStyle/>
-          <a:p>
-            <a:r>
-              <a:rPr sz="1100" b="1">
-                <a:solidFill>
-                  <a:srgbClr val="6B7B73"/>
-                </a:solidFill>
-                <a:latin typeface="Space Grotesk"/>
-              </a:rPr>
-              <a:t>want</a:t>
-            </a:r>
-            <a:r>
-              <a:rPr sz="1100" b="1">
-                <a:solidFill>
-                  <a:srgbClr val="1F7A57"/>
-                </a:solidFill>
-                <a:latin typeface="Space Grotesk"/>
-              </a:rPr>
-              <a:t>hat</a:t>
-            </a:r>
-          </a:p>
-        </p:txBody>
-      </p:sp>
-      <p:sp>
-        <p:nvSpPr>
-          <p:cNvPr id="9" name="TextBox 8"/>
-          <p:cNvSpPr txBox="1"/>
-          <p:nvPr/>
-        </p:nvSpPr>
-        <p:spPr>
-          <a:xfrm>
-            <a:off x="10607040" y="6510528"/>
-            <a:ext cx="941832" cy="274320"/>
-          </a:xfrm>
-          <a:prstGeom prst="rect">
-            <a:avLst/>
-          </a:prstGeom>
-          <a:noFill/>
-        </p:spPr>
-        <p:txBody>
-          <a:bodyPr wrap="square" anchor="t" lIns="0" rIns="0" tIns="0" bIns="0">
-            <a:spAutoFit/>
-          </a:bodyPr>
-          <a:lstStyle/>
-          <a:p>
-            <a:pPr algn="r"/>
-            <a:r>
-              <a:rPr sz="1000" b="0">
-                <a:solidFill>
-                  <a:srgbClr val="8A968F"/>
-                </a:solidFill>
-                <a:latin typeface="Space Mono"/>
-              </a:rPr>
-              <a:t>7</a:t>
-            </a:r>
-          </a:p>
-        </p:txBody>
-      </p:sp>
       <p:pic>
         <p:nvPicPr>
-          <p:cNvPr id="10" name="Picture 9" descr="slide-7.png"/>
+          <p:cNvPr id="2" name="Picture 1" descr="page-07.png"/>
           <p:cNvPicPr>
             <a:picLocks noChangeAspect="1"/>
           </p:cNvPicPr>
           <p:nvPr/>
         </p:nvPicPr>
         <p:blipFill>
-          <a:blip r:embed="rId3"/>
+          <a:blip r:embed="rId5"/>
           <a:stretch>
             <a:fillRect/>
           </a:stretch>
         </p:blipFill>
         <p:spPr>
           <a:xfrm>
-            <a:off x="1527048" y="2221857"/>
-            <a:ext cx="9144000" cy="2725182"/>
+            <a:off x="0" y="0"/>
+            <a:ext cx="12191695" cy="6858000"/>
           </a:xfrm>
           <a:prstGeom prst="rect">
             <a:avLst/>
           </a:prstGeom>
         </p:spPr>
       </p:pic>
-      <p:sp>
-        <p:nvSpPr>
-          <p:cNvPr id="11" name="TextBox 10"/>
-          <p:cNvSpPr txBox="1"/>
-          <p:nvPr/>
-        </p:nvSpPr>
-        <p:spPr>
-          <a:xfrm>
-            <a:off x="658368" y="5760720"/>
-            <a:ext cx="10881360" cy="640080"/>
-          </a:xfrm>
-          <a:prstGeom prst="rect">
-            <a:avLst/>
-          </a:prstGeom>
-          <a:noFill/>
-        </p:spPr>
-        <p:txBody>
-          <a:bodyPr wrap="square">
-            <a:spAutoFit/>
-          </a:bodyPr>
-          <a:lstStyle/>
-          <a:p>
-            <a:r>
-              <a:rPr sz="1200">
-                <a:solidFill>
-                  <a:srgbClr val="6B7B73"/>
-                </a:solidFill>
-                <a:latin typeface="Hanken Grotesk"/>
-              </a:rPr>
-              <a:t>References across stores are soft — keys plus idempotency, never foreign keys or cross-store transactions. The Cognito sub ties PII, links and money together.</a:t>
-            </a:r>
-          </a:p>
-        </p:txBody>
-      </p:sp>
     </p:spTree>
   </p:cSld>
   <p:clrMapOvr>
@@ -28995,11 +26564,6 @@
                     <a:bodyPr/>
                     <a:lstStyle/>
                     <a:p>
-                      <a:pPr>
-                        <a:lnSpc>
-                          <a:spcPct val="108000"/>
-                        </a:lnSpc>
-                      </a:pPr>
                       <a:r>
                         <a:rPr sz="1100" b="1">
                           <a:solidFill>
@@ -29022,11 +26586,6 @@
                     <a:bodyPr/>
                     <a:lstStyle/>
                     <a:p>
-                      <a:pPr>
-                        <a:lnSpc>
-                          <a:spcPct val="108000"/>
-                        </a:lnSpc>
-                      </a:pPr>
                       <a:r>
                         <a:rPr sz="1100" b="1">
                           <a:solidFill>
@@ -29049,11 +26608,6 @@
                     <a:bodyPr/>
                     <a:lstStyle/>
                     <a:p>
-                      <a:pPr>
-                        <a:lnSpc>
-                          <a:spcPct val="108000"/>
-                        </a:lnSpc>
-                      </a:pPr>
                       <a:r>
                         <a:rPr sz="1100" b="1">
                           <a:solidFill>
@@ -29076,11 +26630,6 @@
                     <a:bodyPr/>
                     <a:lstStyle/>
                     <a:p>
-                      <a:pPr>
-                        <a:lnSpc>
-                          <a:spcPct val="108000"/>
-                        </a:lnSpc>
-                      </a:pPr>
                       <a:r>
                         <a:rPr sz="1100" b="1">
                           <a:solidFill>
@@ -29105,19 +26654,14 @@
                     <a:bodyPr/>
                     <a:lstStyle/>
                     <a:p>
-                      <a:pPr>
-                        <a:lnSpc>
-                          <a:spcPct val="108000"/>
-                        </a:lnSpc>
-                      </a:pPr>
                       <a:r>
-                        <a:rPr sz="1050" b="1">
+                        <a:rPr sz="1000" b="1">
                           <a:solidFill>
                             <a:srgbClr val="15201C"/>
                           </a:solidFill>
                           <a:latin typeface="Hanken Grotesk"/>
                         </a:rPr>
-                        <a:t>Money</a:t>
+                        <a:t>Money + Audit Log</a:t>
                       </a:r>
                     </a:p>
                   </a:txBody>
@@ -29132,15 +26676,10 @@
                     <a:bodyPr/>
                     <a:lstStyle/>
                     <a:p>
-                      <a:pPr>
-                        <a:lnSpc>
-                          <a:spcPct val="108000"/>
-                        </a:lnSpc>
-                      </a:pPr>
                       <a:r>
-                        <a:rPr sz="1050" b="0">
+                        <a:rPr sz="1000" b="0">
                           <a:solidFill>
-                            <a:srgbClr val="6B7B73"/>
+                            <a:srgbClr val="15201C"/>
                           </a:solidFill>
                           <a:latin typeface="Hanken Grotesk"/>
                         </a:rPr>
@@ -29159,19 +26698,14 @@
                     <a:bodyPr/>
                     <a:lstStyle/>
                     <a:p>
-                      <a:pPr>
-                        <a:lnSpc>
-                          <a:spcPct val="108000"/>
-                        </a:lnSpc>
-                      </a:pPr>
                       <a:r>
-                        <a:rPr sz="1050" b="0">
+                        <a:rPr sz="1000" b="0">
                           <a:solidFill>
-                            <a:srgbClr val="6B7B73"/>
+                            <a:srgbClr val="15201C"/>
                           </a:solidFill>
                           <a:latin typeface="Hanken Grotesk"/>
                         </a:rPr>
-                        <a:t>ACID + Postgres GRANTs as the money invariant (one role per function: wallet_reader / ledger_reader SELECT-only, ledger_writer INSERT-only, audit_writer = audit_append only); SQL for reconciliation</a:t>
+                        <a:t>ACID; permissions enforced on DB level (GRANTs); storing the audit log with hashed chains</a:t>
                       </a:r>
                     </a:p>
                   </a:txBody>
@@ -29186,19 +26720,14 @@
                     <a:bodyPr/>
                     <a:lstStyle/>
                     <a:p>
-                      <a:pPr>
-                        <a:lnSpc>
-                          <a:spcPct val="108000"/>
-                        </a:lnSpc>
-                      </a:pPr>
                       <a:r>
-                        <a:rPr sz="1050" b="0">
+                        <a:rPr sz="1000" b="0">
                           <a:solidFill>
-                            <a:srgbClr val="6B7B73"/>
+                            <a:srgbClr val="15201C"/>
                           </a:solidFill>
                           <a:latin typeface="Hanken Grotesk"/>
                         </a:rPr>
-                        <a:t>Scale-to-zero cold resume ~20 s (60 s connect timeout + SPA warm-up probe); 50-connection cap</a:t>
+                        <a:t>Scale-to-zero cold resume ~20 s (60 s connect timeout + SPA warm-up probe); 50-connection cap. Possible simple workaround — cached last known totals (display while reloading) per user on SPA or backend</a:t>
                       </a:r>
                     </a:p>
                   </a:txBody>
@@ -29215,13 +26744,8 @@
                     <a:bodyPr/>
                     <a:lstStyle/>
                     <a:p>
-                      <a:pPr>
-                        <a:lnSpc>
-                          <a:spcPct val="108000"/>
-                        </a:lnSpc>
-                      </a:pPr>
                       <a:r>
-                        <a:rPr sz="1050" b="1">
+                        <a:rPr sz="1000" b="1">
                           <a:solidFill>
                             <a:srgbClr val="15201C"/>
                           </a:solidFill>
@@ -29242,15 +26766,10 @@
                     <a:bodyPr/>
                     <a:lstStyle/>
                     <a:p>
-                      <a:pPr>
-                        <a:lnSpc>
-                          <a:spcPct val="108000"/>
-                        </a:lnSpc>
-                      </a:pPr>
                       <a:r>
-                        <a:rPr sz="1050" b="0">
+                        <a:rPr sz="1000" b="0">
                           <a:solidFill>
-                            <a:srgbClr val="6B7B73"/>
+                            <a:srgbClr val="15201C"/>
                           </a:solidFill>
                           <a:latin typeface="Hanken Grotesk"/>
                         </a:rPr>
@@ -29269,19 +26788,14 @@
                     <a:bodyPr/>
                     <a:lstStyle/>
                     <a:p>
-                      <a:pPr>
-                        <a:lnSpc>
-                          <a:spcPct val="108000"/>
-                        </a:lnSpc>
-                      </a:pPr>
                       <a:r>
-                        <a:rPr sz="1050" b="0">
+                        <a:rPr sz="1000" b="0">
                           <a:solidFill>
-                            <a:srgbClr val="6B7B73"/>
+                            <a:srgbClr val="15201C"/>
                           </a:solidFill>
                           <a:latin typeface="Hanken Grotesk"/>
                         </a:rPr>
-                        <a:t>Auth path touches zero databases; GDPR delete = one call; backups carry no PII</a:t>
+                        <a:t>Auth path touches zero databases; GDPR delete = one call; the only backup carrying PII is the Cognito backup</a:t>
                       </a:r>
                     </a:p>
                   </a:txBody>
@@ -29296,19 +26810,14 @@
                     <a:bodyPr/>
                     <a:lstStyle/>
                     <a:p>
-                      <a:pPr>
-                        <a:lnSpc>
-                          <a:spcPct val="108000"/>
-                        </a:lnSpc>
-                      </a:pPr>
                       <a:r>
-                        <a:rPr sz="1050" b="0">
+                        <a:rPr sz="1000" b="0">
                           <a:solidFill>
-                            <a:srgbClr val="6B7B73"/>
+                            <a:srgbClr val="15201C"/>
                           </a:solidFill>
                           <a:latin typeface="Hanken Grotesk"/>
                         </a:rPr>
-                        <a:t>ListUsers-only queries (no joins, one filter); no PITR; no attribute history. Escape hatch: dual-write projection</a:t>
+                        <a:t>ListUsers-only queries (no joins, one filter); no PITR; no attribute history</a:t>
                       </a:r>
                     </a:p>
                   </a:txBody>
@@ -29325,13 +26834,8 @@
                     <a:bodyPr/>
                     <a:lstStyle/>
                     <a:p>
-                      <a:pPr>
-                        <a:lnSpc>
-                          <a:spcPct val="108000"/>
-                        </a:lnSpc>
-                      </a:pPr>
                       <a:r>
-                        <a:rPr sz="1050" b="1">
+                        <a:rPr sz="1000" b="1">
                           <a:solidFill>
                             <a:srgbClr val="15201C"/>
                           </a:solidFill>
@@ -29352,15 +26856,10 @@
                     <a:bodyPr/>
                     <a:lstStyle/>
                     <a:p>
-                      <a:pPr>
-                        <a:lnSpc>
-                          <a:spcPct val="108000"/>
-                        </a:lnSpc>
-                      </a:pPr>
                       <a:r>
-                        <a:rPr sz="1050" b="0">
+                        <a:rPr sz="1000" b="0">
                           <a:solidFill>
-                            <a:srgbClr val="6B7B73"/>
+                            <a:srgbClr val="15201C"/>
                           </a:solidFill>
                           <a:latin typeface="Hanken Grotesk"/>
                         </a:rPr>
@@ -29379,15 +26878,10 @@
                     <a:bodyPr/>
                     <a:lstStyle/>
                     <a:p>
-                      <a:pPr>
-                        <a:lnSpc>
-                          <a:spcPct val="108000"/>
-                        </a:lnSpc>
-                      </a:pPr>
                       <a:r>
-                        <a:rPr sz="1050" b="0">
+                        <a:rPr sz="1000" b="0">
                           <a:solidFill>
-                            <a:srgbClr val="6B7B73"/>
+                            <a:srgbClr val="15201C"/>
                           </a:solidFill>
                           <a:latin typeface="Hanken Grotesk"/>
                         </a:rPr>
@@ -29406,15 +26900,10 @@
                     <a:bodyPr/>
                     <a:lstStyle/>
                     <a:p>
-                      <a:pPr>
-                        <a:lnSpc>
-                          <a:spcPct val="108000"/>
-                        </a:lnSpc>
-                      </a:pPr>
                       <a:r>
-                        <a:rPr sz="1050" b="0">
+                        <a:rPr sz="1000" b="0">
                           <a:solidFill>
-                            <a:srgbClr val="6B7B73"/>
+                            <a:srgbClr val="15201C"/>
                           </a:solidFill>
                           <a:latin typeface="Hanken Grotesk"/>
                         </a:rPr>
@@ -29629,313 +27118,30 @@
         <p:nvPr/>
       </p:nvGrpSpPr>
       <p:grpSpPr/>
-      <p:sp>
-        <p:nvSpPr>
-          <p:cNvPr id="2" name="TextBox 1"/>
-          <p:cNvSpPr txBox="1"/>
-          <p:nvPr/>
-        </p:nvSpPr>
-        <p:spPr>
-          <a:xfrm>
-            <a:off x="10195560" y="256032"/>
-            <a:ext cx="1371600" cy="1005840"/>
-          </a:xfrm>
-          <a:prstGeom prst="rect">
-            <a:avLst/>
-          </a:prstGeom>
-          <a:noFill/>
-        </p:spPr>
-        <p:txBody>
-          <a:bodyPr wrap="square" anchor="t" lIns="0" rIns="0" tIns="0" bIns="0">
-            <a:spAutoFit/>
-          </a:bodyPr>
-          <a:lstStyle/>
-          <a:p>
-            <a:pPr algn="r"/>
-            <a:r>
-              <a:rPr sz="4600" b="1">
-                <a:solidFill>
-                  <a:srgbClr val="DCE5E0"/>
-                </a:solidFill>
-                <a:latin typeface="Space Grotesk"/>
-              </a:rPr>
-              <a:t>09</a:t>
-            </a:r>
-          </a:p>
-        </p:txBody>
-      </p:sp>
-      <p:sp>
-        <p:nvSpPr>
-          <p:cNvPr id="3" name="TextBox 2"/>
-          <p:cNvSpPr txBox="1"/>
-          <p:nvPr/>
-        </p:nvSpPr>
-        <p:spPr>
-          <a:xfrm>
-            <a:off x="640080" y="420624"/>
-            <a:ext cx="9418320" cy="292608"/>
-          </a:xfrm>
-          <a:prstGeom prst="rect">
-            <a:avLst/>
-          </a:prstGeom>
-          <a:noFill/>
-        </p:spPr>
-        <p:txBody>
-          <a:bodyPr wrap="square" anchor="t" lIns="0" rIns="0" tIns="0" bIns="0">
-            <a:spAutoFit/>
-          </a:bodyPr>
-          <a:lstStyle/>
-          <a:p>
-            <a:r>
-              <a:rPr sz="1150" b="1">
-                <a:solidFill>
-                  <a:srgbClr val="1F7A57"/>
-                </a:solidFill>
-                <a:latin typeface="Space Mono"/>
-              </a:rPr>
-              <a:t>ENGINEERING</a:t>
-            </a:r>
-          </a:p>
-        </p:txBody>
-      </p:sp>
-      <p:sp>
-        <p:nvSpPr>
-          <p:cNvPr id="4" name="TextBox 3"/>
-          <p:cNvSpPr txBox="1"/>
-          <p:nvPr/>
-        </p:nvSpPr>
-        <p:spPr>
-          <a:xfrm>
-            <a:off x="621792" y="731520"/>
-            <a:ext cx="9509760" cy="868680"/>
-          </a:xfrm>
-          <a:prstGeom prst="rect">
-            <a:avLst/>
-          </a:prstGeom>
-          <a:noFill/>
-        </p:spPr>
-        <p:txBody>
-          <a:bodyPr wrap="square" anchor="t" lIns="0" rIns="0" tIns="0" bIns="0">
-            <a:spAutoFit/>
-          </a:bodyPr>
-          <a:lstStyle/>
-          <a:p>
-            <a:r>
-              <a:rPr sz="2700" b="1">
-                <a:solidFill>
-                  <a:srgbClr val="15201C"/>
-                </a:solidFill>
-                <a:latin typeface="Space Grotesk"/>
-              </a:rPr>
-              <a:t>Architecture — the starting point</a:t>
-            </a:r>
-          </a:p>
-        </p:txBody>
-      </p:sp>
-      <p:sp>
-        <p:nvSpPr>
-          <p:cNvPr id="5" name="Rounded Rectangle 4"/>
-          <p:cNvSpPr/>
-          <p:nvPr/>
-        </p:nvSpPr>
-        <p:spPr>
-          <a:xfrm>
-            <a:off x="658368" y="1600200"/>
-            <a:ext cx="10881360" cy="4114800"/>
-          </a:xfrm>
-          <a:prstGeom prst="roundRect">
-            <a:avLst>
-              <a:gd name="adj" fmla="val 3000"/>
-            </a:avLst>
-          </a:prstGeom>
-          <a:solidFill>
-            <a:srgbClr val="FFFFFF"/>
-          </a:solidFill>
-          <a:ln w="12700">
-            <a:solidFill>
-              <a:srgbClr val="E6EBE8"/>
-            </a:solidFill>
-          </a:ln>
-          <a:effectLst/>
-        </p:spPr>
-        <p:style>
-          <a:lnRef idx="1">
-            <a:schemeClr val="accent1"/>
-          </a:lnRef>
-          <a:fillRef idx="3">
-            <a:schemeClr val="accent1"/>
-          </a:fillRef>
-          <a:effectRef idx="2">
-            <a:schemeClr val="accent1"/>
-          </a:effectRef>
-          <a:fontRef idx="minor">
-            <a:schemeClr val="lt1"/>
-          </a:fontRef>
-        </p:style>
-        <p:txBody>
-          <a:bodyPr rtlCol="0" anchor="ctr"/>
-          <a:lstStyle/>
-          <a:p>
-            <a:pPr algn="ctr"/>
-          </a:p>
-        </p:txBody>
-      </p:sp>
-      <p:sp>
-        <p:nvSpPr>
-          <p:cNvPr id="7" name="Rectangle 6"/>
-          <p:cNvSpPr/>
-          <p:nvPr/>
-        </p:nvSpPr>
-        <p:spPr>
-          <a:xfrm>
-            <a:off x="640080" y="6455664"/>
-            <a:ext cx="10908792" cy="9144"/>
-          </a:xfrm>
-          <a:prstGeom prst="rect">
-            <a:avLst/>
-          </a:prstGeom>
-          <a:solidFill>
-            <a:srgbClr val="E6EBE8"/>
-          </a:solidFill>
-          <a:ln>
-            <a:noFill/>
-          </a:ln>
-          <a:effectLst/>
-        </p:spPr>
-        <p:style>
-          <a:lnRef idx="1">
-            <a:schemeClr val="accent1"/>
-          </a:lnRef>
-          <a:fillRef idx="3">
-            <a:schemeClr val="accent1"/>
-          </a:fillRef>
-          <a:effectRef idx="2">
-            <a:schemeClr val="accent1"/>
-          </a:effectRef>
-          <a:fontRef idx="minor">
-            <a:schemeClr val="lt1"/>
-          </a:fontRef>
-        </p:style>
-        <p:txBody>
-          <a:bodyPr rtlCol="0" anchor="ctr"/>
-          <a:lstStyle/>
-          <a:p>
-            <a:pPr algn="ctr"/>
-          </a:p>
-        </p:txBody>
-      </p:sp>
-      <p:sp>
-        <p:nvSpPr>
-          <p:cNvPr id="8" name="TextBox 7"/>
-          <p:cNvSpPr txBox="1"/>
-          <p:nvPr/>
-        </p:nvSpPr>
-        <p:spPr>
-          <a:xfrm>
-            <a:off x="640080" y="6510528"/>
-            <a:ext cx="2743200" cy="274320"/>
-          </a:xfrm>
-          <a:prstGeom prst="rect">
-            <a:avLst/>
-          </a:prstGeom>
-          <a:noFill/>
-        </p:spPr>
-        <p:txBody>
-          <a:bodyPr wrap="square" anchor="t" lIns="0" rIns="0" tIns="0" bIns="0">
-            <a:spAutoFit/>
-          </a:bodyPr>
-          <a:lstStyle/>
-          <a:p>
-            <a:r>
-              <a:rPr sz="1100" b="1">
-                <a:solidFill>
-                  <a:srgbClr val="6B7B73"/>
-                </a:solidFill>
-                <a:latin typeface="Space Grotesk"/>
-              </a:rPr>
-              <a:t>want</a:t>
-            </a:r>
-            <a:r>
-              <a:rPr sz="1100" b="1">
-                <a:solidFill>
-                  <a:srgbClr val="1F7A57"/>
-                </a:solidFill>
-                <a:latin typeface="Space Grotesk"/>
-              </a:rPr>
-              <a:t>hat</a:t>
-            </a:r>
-          </a:p>
-        </p:txBody>
-      </p:sp>
-      <p:sp>
-        <p:nvSpPr>
-          <p:cNvPr id="9" name="TextBox 8"/>
-          <p:cNvSpPr txBox="1"/>
-          <p:nvPr/>
-        </p:nvSpPr>
-        <p:spPr>
-          <a:xfrm>
-            <a:off x="10607040" y="6510528"/>
-            <a:ext cx="941832" cy="274320"/>
-          </a:xfrm>
-          <a:prstGeom prst="rect">
-            <a:avLst/>
-          </a:prstGeom>
-          <a:noFill/>
-        </p:spPr>
-        <p:txBody>
-          <a:bodyPr wrap="square" anchor="t" lIns="0" rIns="0" tIns="0" bIns="0">
-            <a:spAutoFit/>
-          </a:bodyPr>
-          <a:lstStyle/>
-          <a:p>
-            <a:pPr algn="r"/>
-            <a:r>
-              <a:rPr sz="1000" b="0">
-                <a:solidFill>
-                  <a:srgbClr val="8A968F"/>
-                </a:solidFill>
-                <a:latin typeface="Space Mono"/>
-              </a:rPr>
-              <a:t>9</a:t>
-            </a:r>
-          </a:p>
-        </p:txBody>
-      </p:sp>
-      <p:sp>
-        <p:nvSpPr>
-          <p:cNvPr id="10" name="TextBox 9"/>
-          <p:cNvSpPr txBox="1"/>
-          <p:nvPr/>
-        </p:nvSpPr>
-        <p:spPr>
-          <a:xfrm>
-            <a:off x="658368" y="5852160"/>
-            <a:ext cx="10881360" cy="457200"/>
-          </a:xfrm>
-          <a:prstGeom prst="rect">
-            <a:avLst/>
-          </a:prstGeom>
-          <a:noFill/>
-        </p:spPr>
-        <p:txBody>
-          <a:bodyPr wrap="square">
-            <a:spAutoFit/>
-          </a:bodyPr>
-          <a:lstStyle/>
-          <a:p>
-            <a:r>
-              <a:rPr sz="1400" b="1">
-                <a:solidFill>
-                  <a:srgbClr val="15201C"/>
-                </a:solidFill>
-                <a:latin typeface="Hanken Grotesk"/>
-              </a:rPr>
-              <a:t>Starting with:  in-VPC Aurora Serverless v2   and   DynamoDB on-demand.</a:t>
-            </a:r>
-          </a:p>
-        </p:txBody>
-      </p:sp>
+      <p:pic>
+        <p:nvPicPr>
+          <p:cNvPr id="2" name="Picture 1" descr="page-09.png"/>
+          <p:cNvPicPr>
+            <a:picLocks noChangeAspect="1"/>
+          </p:cNvPicPr>
+          <p:nvPr/>
+        </p:nvPicPr>
+        <p:blipFill>
+          <a:blip r:embed="rId4"/>
+          <a:stretch>
+            <a:fillRect/>
+          </a:stretch>
+        </p:blipFill>
+        <p:spPr>
+          <a:xfrm>
+            <a:off x="0" y="0"/>
+            <a:ext cx="12191695" cy="6858000"/>
+          </a:xfrm>
+          <a:prstGeom prst="rect">
+            <a:avLst/>
+          </a:prstGeom>
+        </p:spPr>
+      </p:pic>
     </p:spTree>
   </p:cSld>
   <p:clrMapOvr>

</xml_diff>

<commit_message>
slides: sync with the Google Slides export (wanthat - technical.pdf) (#210)
- slides 7 (Domain Object Model) and 9-16 (architecture walkthrough) are now
  FULL-BLEED page images from Dennis's export - his diagrams, screenshots and
  captions, pixel-faithful; README documents the re-render path (pymupdf 180dpi)
- slide 6: Dennis's card order (cost / scale / security / monorepo / code /
  decisions) + his Security-by-design text + 'potential spike' wording
- slide 8: his table text (Money + Audit Log row, Cognito-backup phrasing);
  closing line keeps OUR post-#205 one-transaction wording (his export predates it)
- presentation.md updated to match throughout


Claude-Session: https://claude.ai/code/session_01FECrSGSMqWYxFMSwWq9E5s

Co-authored-by: Claude Fable 5 <noreply@anthropic.com>
</commit_message>
<xml_diff>
--- a/slides/wanthat-presentation.pptx
+++ b/slides/wanthat-presentation.pptx
@@ -6086,335 +6086,30 @@
         <p:nvPr/>
       </p:nvGrpSpPr>
       <p:grpSpPr/>
-      <p:sp>
-        <p:nvSpPr>
-          <p:cNvPr id="2" name="TextBox 1"/>
-          <p:cNvSpPr txBox="1"/>
-          <p:nvPr/>
-        </p:nvSpPr>
-        <p:spPr>
-          <a:xfrm>
-            <a:off x="10195560" y="256032"/>
-            <a:ext cx="1371600" cy="1005840"/>
-          </a:xfrm>
-          <a:prstGeom prst="rect">
-            <a:avLst/>
-          </a:prstGeom>
-          <a:noFill/>
-        </p:spPr>
-        <p:txBody>
-          <a:bodyPr wrap="square" anchor="t" lIns="0" rIns="0" tIns="0" bIns="0">
-            <a:spAutoFit/>
-          </a:bodyPr>
-          <a:lstStyle/>
-          <a:p>
-            <a:pPr algn="r"/>
-            <a:r>
-              <a:rPr sz="4600" b="1">
-                <a:solidFill>
-                  <a:srgbClr val="DCE5E0"/>
-                </a:solidFill>
-                <a:latin typeface="Space Grotesk"/>
-              </a:rPr>
-              <a:t>10</a:t>
-            </a:r>
-          </a:p>
-        </p:txBody>
-      </p:sp>
-      <p:sp>
-        <p:nvSpPr>
-          <p:cNvPr id="3" name="TextBox 2"/>
-          <p:cNvSpPr txBox="1"/>
-          <p:nvPr/>
-        </p:nvSpPr>
-        <p:spPr>
-          <a:xfrm>
-            <a:off x="640080" y="420624"/>
-            <a:ext cx="9418320" cy="292608"/>
-          </a:xfrm>
-          <a:prstGeom prst="rect">
-            <a:avLst/>
-          </a:prstGeom>
-          <a:noFill/>
-        </p:spPr>
-        <p:txBody>
-          <a:bodyPr wrap="square" anchor="t" lIns="0" rIns="0" tIns="0" bIns="0">
-            <a:spAutoFit/>
-          </a:bodyPr>
-          <a:lstStyle/>
-          <a:p>
-            <a:r>
-              <a:rPr sz="1150" b="1">
-                <a:solidFill>
-                  <a:srgbClr val="1F7A57"/>
-                </a:solidFill>
-                <a:latin typeface="Space Mono"/>
-              </a:rPr>
-              <a:t>ENGINEERING</a:t>
-            </a:r>
-          </a:p>
-        </p:txBody>
-      </p:sp>
-      <p:sp>
-        <p:nvSpPr>
-          <p:cNvPr id="4" name="TextBox 3"/>
-          <p:cNvSpPr txBox="1"/>
-          <p:nvPr/>
-        </p:nvSpPr>
-        <p:spPr>
-          <a:xfrm>
-            <a:off x="621792" y="731520"/>
-            <a:ext cx="9509760" cy="868680"/>
-          </a:xfrm>
-          <a:prstGeom prst="rect">
-            <a:avLst/>
-          </a:prstGeom>
-          <a:noFill/>
-        </p:spPr>
-        <p:txBody>
-          <a:bodyPr wrap="square" anchor="t" lIns="0" rIns="0" tIns="0" bIns="0">
-            <a:spAutoFit/>
-          </a:bodyPr>
-          <a:lstStyle/>
-          <a:p>
-            <a:r>
-              <a:rPr sz="2700" b="1">
-                <a:solidFill>
-                  <a:srgbClr val="15201C"/>
-                </a:solidFill>
-                <a:latin typeface="Space Grotesk"/>
-              </a:rPr>
-              <a:t>Architecture UC1 — member creates a recommendation</a:t>
-            </a:r>
-          </a:p>
-        </p:txBody>
-      </p:sp>
-      <p:sp>
-        <p:nvSpPr>
-          <p:cNvPr id="5" name="Rounded Rectangle 4"/>
-          <p:cNvSpPr/>
-          <p:nvPr/>
-        </p:nvSpPr>
-        <p:spPr>
-          <a:xfrm>
-            <a:off x="3886200" y="1600200"/>
-            <a:ext cx="7653527" cy="4709160"/>
-          </a:xfrm>
-          <a:prstGeom prst="roundRect">
-            <a:avLst>
-              <a:gd name="adj" fmla="val 3000"/>
-            </a:avLst>
-          </a:prstGeom>
-          <a:solidFill>
-            <a:srgbClr val="FFFFFF"/>
-          </a:solidFill>
-          <a:ln w="12700">
-            <a:solidFill>
-              <a:srgbClr val="E6EBE8"/>
-            </a:solidFill>
-          </a:ln>
-          <a:effectLst/>
-        </p:spPr>
-        <p:style>
-          <a:lnRef idx="1">
-            <a:schemeClr val="accent1"/>
-          </a:lnRef>
-          <a:fillRef idx="3">
-            <a:schemeClr val="accent1"/>
-          </a:fillRef>
-          <a:effectRef idx="2">
-            <a:schemeClr val="accent1"/>
-          </a:effectRef>
-          <a:fontRef idx="minor">
-            <a:schemeClr val="lt1"/>
-          </a:fontRef>
-        </p:style>
-        <p:txBody>
-          <a:bodyPr rtlCol="0" anchor="ctr"/>
-          <a:lstStyle/>
-          <a:p>
-            <a:pPr algn="ctr"/>
-          </a:p>
-        </p:txBody>
-      </p:sp>
-      <p:sp>
-        <p:nvSpPr>
-          <p:cNvPr id="7" name="Rectangle 6"/>
-          <p:cNvSpPr/>
-          <p:nvPr/>
-        </p:nvSpPr>
-        <p:spPr>
-          <a:xfrm>
-            <a:off x="640080" y="6455664"/>
-            <a:ext cx="10908792" cy="9144"/>
-          </a:xfrm>
-          <a:prstGeom prst="rect">
-            <a:avLst/>
-          </a:prstGeom>
-          <a:solidFill>
-            <a:srgbClr val="E6EBE8"/>
-          </a:solidFill>
-          <a:ln>
-            <a:noFill/>
-          </a:ln>
-          <a:effectLst/>
-        </p:spPr>
-        <p:style>
-          <a:lnRef idx="1">
-            <a:schemeClr val="accent1"/>
-          </a:lnRef>
-          <a:fillRef idx="3">
-            <a:schemeClr val="accent1"/>
-          </a:fillRef>
-          <a:effectRef idx="2">
-            <a:schemeClr val="accent1"/>
-          </a:effectRef>
-          <a:fontRef idx="minor">
-            <a:schemeClr val="lt1"/>
-          </a:fontRef>
-        </p:style>
-        <p:txBody>
-          <a:bodyPr rtlCol="0" anchor="ctr"/>
-          <a:lstStyle/>
-          <a:p>
-            <a:pPr algn="ctr"/>
-          </a:p>
-        </p:txBody>
-      </p:sp>
-      <p:sp>
-        <p:nvSpPr>
-          <p:cNvPr id="8" name="TextBox 7"/>
-          <p:cNvSpPr txBox="1"/>
-          <p:nvPr/>
-        </p:nvSpPr>
-        <p:spPr>
-          <a:xfrm>
-            <a:off x="640080" y="6510528"/>
-            <a:ext cx="2743200" cy="274320"/>
-          </a:xfrm>
-          <a:prstGeom prst="rect">
-            <a:avLst/>
-          </a:prstGeom>
-          <a:noFill/>
-        </p:spPr>
-        <p:txBody>
-          <a:bodyPr wrap="square" anchor="t" lIns="0" rIns="0" tIns="0" bIns="0">
-            <a:spAutoFit/>
-          </a:bodyPr>
-          <a:lstStyle/>
-          <a:p>
-            <a:r>
-              <a:rPr sz="1100" b="1">
-                <a:solidFill>
-                  <a:srgbClr val="6B7B73"/>
-                </a:solidFill>
-                <a:latin typeface="Space Grotesk"/>
-              </a:rPr>
-              <a:t>want</a:t>
-            </a:r>
-            <a:r>
-              <a:rPr sz="1100" b="1">
-                <a:solidFill>
-                  <a:srgbClr val="1F7A57"/>
-                </a:solidFill>
-                <a:latin typeface="Space Grotesk"/>
-              </a:rPr>
-              <a:t>hat</a:t>
-            </a:r>
-          </a:p>
-        </p:txBody>
-      </p:sp>
-      <p:sp>
-        <p:nvSpPr>
-          <p:cNvPr id="9" name="TextBox 8"/>
-          <p:cNvSpPr txBox="1"/>
-          <p:nvPr/>
-        </p:nvSpPr>
-        <p:spPr>
-          <a:xfrm>
-            <a:off x="10607040" y="6510528"/>
-            <a:ext cx="941832" cy="274320"/>
-          </a:xfrm>
-          <a:prstGeom prst="rect">
-            <a:avLst/>
-          </a:prstGeom>
-          <a:noFill/>
-        </p:spPr>
-        <p:txBody>
-          <a:bodyPr wrap="square" anchor="t" lIns="0" rIns="0" tIns="0" bIns="0">
-            <a:spAutoFit/>
-          </a:bodyPr>
-          <a:lstStyle/>
-          <a:p>
-            <a:pPr algn="r"/>
-            <a:r>
-              <a:rPr sz="1000" b="0">
-                <a:solidFill>
-                  <a:srgbClr val="8A968F"/>
-                </a:solidFill>
-                <a:latin typeface="Space Mono"/>
-              </a:rPr>
-              <a:t>10</a:t>
-            </a:r>
-          </a:p>
-        </p:txBody>
-      </p:sp>
-      <p:sp>
-        <p:nvSpPr>
-          <p:cNvPr id="10" name="TextBox 9"/>
-          <p:cNvSpPr txBox="1"/>
-          <p:nvPr/>
-        </p:nvSpPr>
-        <p:spPr>
-          <a:xfrm>
-            <a:off x="658368" y="1783080"/>
-            <a:ext cx="3063240" cy="4480560"/>
-          </a:xfrm>
-          <a:prstGeom prst="rect">
-            <a:avLst/>
-          </a:prstGeom>
-          <a:noFill/>
-        </p:spPr>
-        <p:txBody>
-          <a:bodyPr wrap="square">
-            <a:spAutoFit/>
-          </a:bodyPr>
-          <a:lstStyle/>
-          <a:p>
-            <a:r>
-              <a:rPr sz="1200" b="0">
-                <a:solidFill>
-                  <a:srgbClr val="15201C"/>
-                </a:solidFill>
-                <a:latin typeface="Hanken Grotesk"/>
-              </a:rPr>
-              <a:t>-  SPA is served from S3 via CloudFront.</a:t>
-            </a:r>
-          </a:p>
-          <a:p>
-            <a:r>
-              <a:rPr sz="1200" b="0">
-                <a:solidFill>
-                  <a:srgbClr val="15201C"/>
-                </a:solidFill>
-                <a:latin typeface="Hanken Grotesk"/>
-              </a:rPr>
-              <a:t>-  Cognito-native authentication at the application level.</a:t>
-            </a:r>
-          </a:p>
-          <a:p>
-            <a:r>
-              <a:rPr sz="1200" b="0">
-                <a:solidFill>
-                  <a:srgbClr val="15201C"/>
-                </a:solidFill>
-                <a:latin typeface="Hanken Grotesk"/>
-              </a:rPr>
-              <a:t>-  The retailer link is created ONCE per product (cache; linkgen is the sole writer).</a:t>
-            </a:r>
-          </a:p>
-        </p:txBody>
-      </p:sp>
+      <p:pic>
+        <p:nvPicPr>
+          <p:cNvPr id="2" name="Picture 1" descr="page-10.png"/>
+          <p:cNvPicPr>
+            <a:picLocks noChangeAspect="1"/>
+          </p:cNvPicPr>
+          <p:nvPr/>
+        </p:nvPicPr>
+        <p:blipFill>
+          <a:blip r:embed="rId4"/>
+          <a:stretch>
+            <a:fillRect/>
+          </a:stretch>
+        </p:blipFill>
+        <p:spPr>
+          <a:xfrm>
+            <a:off x="0" y="0"/>
+            <a:ext cx="12191695" cy="6858000"/>
+          </a:xfrm>
+          <a:prstGeom prst="rect">
+            <a:avLst/>
+          </a:prstGeom>
+        </p:spPr>
+      </p:pic>
     </p:spTree>
   </p:cSld>
   <p:clrMapOvr>
@@ -6433,335 +6128,30 @@
         <p:nvPr/>
       </p:nvGrpSpPr>
       <p:grpSpPr/>
-      <p:sp>
-        <p:nvSpPr>
-          <p:cNvPr id="2" name="TextBox 1"/>
-          <p:cNvSpPr txBox="1"/>
-          <p:nvPr/>
-        </p:nvSpPr>
-        <p:spPr>
-          <a:xfrm>
-            <a:off x="10195560" y="256032"/>
-            <a:ext cx="1371600" cy="1005840"/>
-          </a:xfrm>
-          <a:prstGeom prst="rect">
-            <a:avLst/>
-          </a:prstGeom>
-          <a:noFill/>
-        </p:spPr>
-        <p:txBody>
-          <a:bodyPr wrap="square" anchor="t" lIns="0" rIns="0" tIns="0" bIns="0">
-            <a:spAutoFit/>
-          </a:bodyPr>
-          <a:lstStyle/>
-          <a:p>
-            <a:pPr algn="r"/>
-            <a:r>
-              <a:rPr sz="4600" b="1">
-                <a:solidFill>
-                  <a:srgbClr val="DCE5E0"/>
-                </a:solidFill>
-                <a:latin typeface="Space Grotesk"/>
-              </a:rPr>
-              <a:t>11</a:t>
-            </a:r>
-          </a:p>
-        </p:txBody>
-      </p:sp>
-      <p:sp>
-        <p:nvSpPr>
-          <p:cNvPr id="3" name="TextBox 2"/>
-          <p:cNvSpPr txBox="1"/>
-          <p:nvPr/>
-        </p:nvSpPr>
-        <p:spPr>
-          <a:xfrm>
-            <a:off x="640080" y="420624"/>
-            <a:ext cx="9418320" cy="292608"/>
-          </a:xfrm>
-          <a:prstGeom prst="rect">
-            <a:avLst/>
-          </a:prstGeom>
-          <a:noFill/>
-        </p:spPr>
-        <p:txBody>
-          <a:bodyPr wrap="square" anchor="t" lIns="0" rIns="0" tIns="0" bIns="0">
-            <a:spAutoFit/>
-          </a:bodyPr>
-          <a:lstStyle/>
-          <a:p>
-            <a:r>
-              <a:rPr sz="1150" b="1">
-                <a:solidFill>
-                  <a:srgbClr val="1F7A57"/>
-                </a:solidFill>
-                <a:latin typeface="Space Mono"/>
-              </a:rPr>
-              <a:t>ENGINEERING</a:t>
-            </a:r>
-          </a:p>
-        </p:txBody>
-      </p:sp>
-      <p:sp>
-        <p:nvSpPr>
-          <p:cNvPr id="4" name="TextBox 3"/>
-          <p:cNvSpPr txBox="1"/>
-          <p:nvPr/>
-        </p:nvSpPr>
-        <p:spPr>
-          <a:xfrm>
-            <a:off x="621792" y="731520"/>
-            <a:ext cx="9509760" cy="868680"/>
-          </a:xfrm>
-          <a:prstGeom prst="rect">
-            <a:avLst/>
-          </a:prstGeom>
-          <a:noFill/>
-        </p:spPr>
-        <p:txBody>
-          <a:bodyPr wrap="square" anchor="t" lIns="0" rIns="0" tIns="0" bIns="0">
-            <a:spAutoFit/>
-          </a:bodyPr>
-          <a:lstStyle/>
-          <a:p>
-            <a:r>
-              <a:rPr sz="2700" b="1">
-                <a:solidFill>
-                  <a:srgbClr val="15201C"/>
-                </a:solidFill>
-                <a:latin typeface="Space Grotesk"/>
-              </a:rPr>
-              <a:t>Architecture UC2 — the recommendation is shared</a:t>
-            </a:r>
-          </a:p>
-        </p:txBody>
-      </p:sp>
-      <p:sp>
-        <p:nvSpPr>
-          <p:cNvPr id="5" name="Rounded Rectangle 4"/>
-          <p:cNvSpPr/>
-          <p:nvPr/>
-        </p:nvSpPr>
-        <p:spPr>
-          <a:xfrm>
-            <a:off x="3886200" y="1600200"/>
-            <a:ext cx="7653527" cy="4709160"/>
-          </a:xfrm>
-          <a:prstGeom prst="roundRect">
-            <a:avLst>
-              <a:gd name="adj" fmla="val 3000"/>
-            </a:avLst>
-          </a:prstGeom>
-          <a:solidFill>
-            <a:srgbClr val="FFFFFF"/>
-          </a:solidFill>
-          <a:ln w="12700">
-            <a:solidFill>
-              <a:srgbClr val="E6EBE8"/>
-            </a:solidFill>
-          </a:ln>
-          <a:effectLst/>
-        </p:spPr>
-        <p:style>
-          <a:lnRef idx="1">
-            <a:schemeClr val="accent1"/>
-          </a:lnRef>
-          <a:fillRef idx="3">
-            <a:schemeClr val="accent1"/>
-          </a:fillRef>
-          <a:effectRef idx="2">
-            <a:schemeClr val="accent1"/>
-          </a:effectRef>
-          <a:fontRef idx="minor">
-            <a:schemeClr val="lt1"/>
-          </a:fontRef>
-        </p:style>
-        <p:txBody>
-          <a:bodyPr rtlCol="0" anchor="ctr"/>
-          <a:lstStyle/>
-          <a:p>
-            <a:pPr algn="ctr"/>
-          </a:p>
-        </p:txBody>
-      </p:sp>
-      <p:sp>
-        <p:nvSpPr>
-          <p:cNvPr id="7" name="Rectangle 6"/>
-          <p:cNvSpPr/>
-          <p:nvPr/>
-        </p:nvSpPr>
-        <p:spPr>
-          <a:xfrm>
-            <a:off x="640080" y="6455664"/>
-            <a:ext cx="10908792" cy="9144"/>
-          </a:xfrm>
-          <a:prstGeom prst="rect">
-            <a:avLst/>
-          </a:prstGeom>
-          <a:solidFill>
-            <a:srgbClr val="E6EBE8"/>
-          </a:solidFill>
-          <a:ln>
-            <a:noFill/>
-          </a:ln>
-          <a:effectLst/>
-        </p:spPr>
-        <p:style>
-          <a:lnRef idx="1">
-            <a:schemeClr val="accent1"/>
-          </a:lnRef>
-          <a:fillRef idx="3">
-            <a:schemeClr val="accent1"/>
-          </a:fillRef>
-          <a:effectRef idx="2">
-            <a:schemeClr val="accent1"/>
-          </a:effectRef>
-          <a:fontRef idx="minor">
-            <a:schemeClr val="lt1"/>
-          </a:fontRef>
-        </p:style>
-        <p:txBody>
-          <a:bodyPr rtlCol="0" anchor="ctr"/>
-          <a:lstStyle/>
-          <a:p>
-            <a:pPr algn="ctr"/>
-          </a:p>
-        </p:txBody>
-      </p:sp>
-      <p:sp>
-        <p:nvSpPr>
-          <p:cNvPr id="8" name="TextBox 7"/>
-          <p:cNvSpPr txBox="1"/>
-          <p:nvPr/>
-        </p:nvSpPr>
-        <p:spPr>
-          <a:xfrm>
-            <a:off x="640080" y="6510528"/>
-            <a:ext cx="2743200" cy="274320"/>
-          </a:xfrm>
-          <a:prstGeom prst="rect">
-            <a:avLst/>
-          </a:prstGeom>
-          <a:noFill/>
-        </p:spPr>
-        <p:txBody>
-          <a:bodyPr wrap="square" anchor="t" lIns="0" rIns="0" tIns="0" bIns="0">
-            <a:spAutoFit/>
-          </a:bodyPr>
-          <a:lstStyle/>
-          <a:p>
-            <a:r>
-              <a:rPr sz="1100" b="1">
-                <a:solidFill>
-                  <a:srgbClr val="6B7B73"/>
-                </a:solidFill>
-                <a:latin typeface="Space Grotesk"/>
-              </a:rPr>
-              <a:t>want</a:t>
-            </a:r>
-            <a:r>
-              <a:rPr sz="1100" b="1">
-                <a:solidFill>
-                  <a:srgbClr val="1F7A57"/>
-                </a:solidFill>
-                <a:latin typeface="Space Grotesk"/>
-              </a:rPr>
-              <a:t>hat</a:t>
-            </a:r>
-          </a:p>
-        </p:txBody>
-      </p:sp>
-      <p:sp>
-        <p:nvSpPr>
-          <p:cNvPr id="9" name="TextBox 8"/>
-          <p:cNvSpPr txBox="1"/>
-          <p:nvPr/>
-        </p:nvSpPr>
-        <p:spPr>
-          <a:xfrm>
-            <a:off x="10607040" y="6510528"/>
-            <a:ext cx="941832" cy="274320"/>
-          </a:xfrm>
-          <a:prstGeom prst="rect">
-            <a:avLst/>
-          </a:prstGeom>
-          <a:noFill/>
-        </p:spPr>
-        <p:txBody>
-          <a:bodyPr wrap="square" anchor="t" lIns="0" rIns="0" tIns="0" bIns="0">
-            <a:spAutoFit/>
-          </a:bodyPr>
-          <a:lstStyle/>
-          <a:p>
-            <a:pPr algn="r"/>
-            <a:r>
-              <a:rPr sz="1000" b="0">
-                <a:solidFill>
-                  <a:srgbClr val="8A968F"/>
-                </a:solidFill>
-                <a:latin typeface="Space Mono"/>
-              </a:rPr>
-              <a:t>11</a:t>
-            </a:r>
-          </a:p>
-        </p:txBody>
-      </p:sp>
-      <p:sp>
-        <p:nvSpPr>
-          <p:cNvPr id="10" name="TextBox 9"/>
-          <p:cNvSpPr txBox="1"/>
-          <p:nvPr/>
-        </p:nvSpPr>
-        <p:spPr>
-          <a:xfrm>
-            <a:off x="658368" y="1783080"/>
-            <a:ext cx="3063240" cy="4480560"/>
-          </a:xfrm>
-          <a:prstGeom prst="rect">
-            <a:avLst/>
-          </a:prstGeom>
-          <a:noFill/>
-        </p:spPr>
-        <p:txBody>
-          <a:bodyPr wrap="square">
-            <a:spAutoFit/>
-          </a:bodyPr>
-          <a:lstStyle/>
-          <a:p>
-            <a:r>
-              <a:rPr sz="1200" b="0">
-                <a:solidFill>
-                  <a:srgbClr val="15201C"/>
-                </a:solidFill>
-                <a:latin typeface="Hanken Grotesk"/>
-              </a:rPr>
-              <a:t>-  This is the hot path.</a:t>
-            </a:r>
-          </a:p>
-          <a:p>
-            <a:r>
-              <a:rPr sz="1200" b="0">
-                <a:solidFill>
-                  <a:srgbClr val="15201C"/>
-                </a:solidFill>
-                <a:latin typeface="Hanken Grotesk"/>
-              </a:rPr>
-              <a:t>-  The recommendation page is server-rendered and cached on CloudFront (60 s, origin-controlled).</a:t>
-            </a:r>
-          </a:p>
-          <a:p>
-            <a:r>
-              <a:rPr sz="1200" b="0">
-                <a:solidFill>
-                  <a:srgbClr val="15201C"/>
-                </a:solidFill>
-                <a:latin typeface="Hanken Grotesk"/>
-              </a:rPr>
-              <a:t>-  The TS landing app boots on the page for auth / registration and redirect-link generation.</a:t>
-            </a:r>
-          </a:p>
-        </p:txBody>
-      </p:sp>
+      <p:pic>
+        <p:nvPicPr>
+          <p:cNvPr id="2" name="Picture 1" descr="page-11.png"/>
+          <p:cNvPicPr>
+            <a:picLocks noChangeAspect="1"/>
+          </p:cNvPicPr>
+          <p:nvPr/>
+        </p:nvPicPr>
+        <p:blipFill>
+          <a:blip r:embed="rId4"/>
+          <a:stretch>
+            <a:fillRect/>
+          </a:stretch>
+        </p:blipFill>
+        <p:spPr>
+          <a:xfrm>
+            <a:off x="0" y="0"/>
+            <a:ext cx="12191695" cy="6858000"/>
+          </a:xfrm>
+          <a:prstGeom prst="rect">
+            <a:avLst/>
+          </a:prstGeom>
+        </p:spPr>
+      </p:pic>
     </p:spTree>
   </p:cSld>
   <p:clrMapOvr>
@@ -6780,335 +6170,30 @@
         <p:nvPr/>
       </p:nvGrpSpPr>
       <p:grpSpPr/>
-      <p:sp>
-        <p:nvSpPr>
-          <p:cNvPr id="2" name="TextBox 1"/>
-          <p:cNvSpPr txBox="1"/>
-          <p:nvPr/>
-        </p:nvSpPr>
-        <p:spPr>
-          <a:xfrm>
-            <a:off x="10195560" y="256032"/>
-            <a:ext cx="1371600" cy="1005840"/>
-          </a:xfrm>
-          <a:prstGeom prst="rect">
-            <a:avLst/>
-          </a:prstGeom>
-          <a:noFill/>
-        </p:spPr>
-        <p:txBody>
-          <a:bodyPr wrap="square" anchor="t" lIns="0" rIns="0" tIns="0" bIns="0">
-            <a:spAutoFit/>
-          </a:bodyPr>
-          <a:lstStyle/>
-          <a:p>
-            <a:pPr algn="r"/>
-            <a:r>
-              <a:rPr sz="4600" b="1">
-                <a:solidFill>
-                  <a:srgbClr val="DCE5E0"/>
-                </a:solidFill>
-                <a:latin typeface="Space Grotesk"/>
-              </a:rPr>
-              <a:t>12</a:t>
-            </a:r>
-          </a:p>
-        </p:txBody>
-      </p:sp>
-      <p:sp>
-        <p:nvSpPr>
-          <p:cNvPr id="3" name="TextBox 2"/>
-          <p:cNvSpPr txBox="1"/>
-          <p:nvPr/>
-        </p:nvSpPr>
-        <p:spPr>
-          <a:xfrm>
-            <a:off x="640080" y="420624"/>
-            <a:ext cx="9418320" cy="292608"/>
-          </a:xfrm>
-          <a:prstGeom prst="rect">
-            <a:avLst/>
-          </a:prstGeom>
-          <a:noFill/>
-        </p:spPr>
-        <p:txBody>
-          <a:bodyPr wrap="square" anchor="t" lIns="0" rIns="0" tIns="0" bIns="0">
-            <a:spAutoFit/>
-          </a:bodyPr>
-          <a:lstStyle/>
-          <a:p>
-            <a:r>
-              <a:rPr sz="1150" b="1">
-                <a:solidFill>
-                  <a:srgbClr val="1F7A57"/>
-                </a:solidFill>
-                <a:latin typeface="Space Mono"/>
-              </a:rPr>
-              <a:t>ENGINEERING</a:t>
-            </a:r>
-          </a:p>
-        </p:txBody>
-      </p:sp>
-      <p:sp>
-        <p:nvSpPr>
-          <p:cNvPr id="4" name="TextBox 3"/>
-          <p:cNvSpPr txBox="1"/>
-          <p:nvPr/>
-        </p:nvSpPr>
-        <p:spPr>
-          <a:xfrm>
-            <a:off x="621792" y="731520"/>
-            <a:ext cx="9509760" cy="868680"/>
-          </a:xfrm>
-          <a:prstGeom prst="rect">
-            <a:avLst/>
-          </a:prstGeom>
-          <a:noFill/>
-        </p:spPr>
-        <p:txBody>
-          <a:bodyPr wrap="square" anchor="t" lIns="0" rIns="0" tIns="0" bIns="0">
-            <a:spAutoFit/>
-          </a:bodyPr>
-          <a:lstStyle/>
-          <a:p>
-            <a:r>
-              <a:rPr sz="2700" b="1">
-                <a:solidFill>
-                  <a:srgbClr val="15201C"/>
-                </a:solidFill>
-                <a:latin typeface="Space Grotesk"/>
-              </a:rPr>
-              <a:t>Architecture UC3 — registration, login, guest + redirect</a:t>
-            </a:r>
-          </a:p>
-        </p:txBody>
-      </p:sp>
-      <p:sp>
-        <p:nvSpPr>
-          <p:cNvPr id="5" name="Rounded Rectangle 4"/>
-          <p:cNvSpPr/>
-          <p:nvPr/>
-        </p:nvSpPr>
-        <p:spPr>
-          <a:xfrm>
-            <a:off x="3886200" y="1600200"/>
-            <a:ext cx="7653527" cy="4709160"/>
-          </a:xfrm>
-          <a:prstGeom prst="roundRect">
-            <a:avLst>
-              <a:gd name="adj" fmla="val 3000"/>
-            </a:avLst>
-          </a:prstGeom>
-          <a:solidFill>
-            <a:srgbClr val="FFFFFF"/>
-          </a:solidFill>
-          <a:ln w="12700">
-            <a:solidFill>
-              <a:srgbClr val="E6EBE8"/>
-            </a:solidFill>
-          </a:ln>
-          <a:effectLst/>
-        </p:spPr>
-        <p:style>
-          <a:lnRef idx="1">
-            <a:schemeClr val="accent1"/>
-          </a:lnRef>
-          <a:fillRef idx="3">
-            <a:schemeClr val="accent1"/>
-          </a:fillRef>
-          <a:effectRef idx="2">
-            <a:schemeClr val="accent1"/>
-          </a:effectRef>
-          <a:fontRef idx="minor">
-            <a:schemeClr val="lt1"/>
-          </a:fontRef>
-        </p:style>
-        <p:txBody>
-          <a:bodyPr rtlCol="0" anchor="ctr"/>
-          <a:lstStyle/>
-          <a:p>
-            <a:pPr algn="ctr"/>
-          </a:p>
-        </p:txBody>
-      </p:sp>
-      <p:sp>
-        <p:nvSpPr>
-          <p:cNvPr id="7" name="Rectangle 6"/>
-          <p:cNvSpPr/>
-          <p:nvPr/>
-        </p:nvSpPr>
-        <p:spPr>
-          <a:xfrm>
-            <a:off x="640080" y="6455664"/>
-            <a:ext cx="10908792" cy="9144"/>
-          </a:xfrm>
-          <a:prstGeom prst="rect">
-            <a:avLst/>
-          </a:prstGeom>
-          <a:solidFill>
-            <a:srgbClr val="E6EBE8"/>
-          </a:solidFill>
-          <a:ln>
-            <a:noFill/>
-          </a:ln>
-          <a:effectLst/>
-        </p:spPr>
-        <p:style>
-          <a:lnRef idx="1">
-            <a:schemeClr val="accent1"/>
-          </a:lnRef>
-          <a:fillRef idx="3">
-            <a:schemeClr val="accent1"/>
-          </a:fillRef>
-          <a:effectRef idx="2">
-            <a:schemeClr val="accent1"/>
-          </a:effectRef>
-          <a:fontRef idx="minor">
-            <a:schemeClr val="lt1"/>
-          </a:fontRef>
-        </p:style>
-        <p:txBody>
-          <a:bodyPr rtlCol="0" anchor="ctr"/>
-          <a:lstStyle/>
-          <a:p>
-            <a:pPr algn="ctr"/>
-          </a:p>
-        </p:txBody>
-      </p:sp>
-      <p:sp>
-        <p:nvSpPr>
-          <p:cNvPr id="8" name="TextBox 7"/>
-          <p:cNvSpPr txBox="1"/>
-          <p:nvPr/>
-        </p:nvSpPr>
-        <p:spPr>
-          <a:xfrm>
-            <a:off x="640080" y="6510528"/>
-            <a:ext cx="2743200" cy="274320"/>
-          </a:xfrm>
-          <a:prstGeom prst="rect">
-            <a:avLst/>
-          </a:prstGeom>
-          <a:noFill/>
-        </p:spPr>
-        <p:txBody>
-          <a:bodyPr wrap="square" anchor="t" lIns="0" rIns="0" tIns="0" bIns="0">
-            <a:spAutoFit/>
-          </a:bodyPr>
-          <a:lstStyle/>
-          <a:p>
-            <a:r>
-              <a:rPr sz="1100" b="1">
-                <a:solidFill>
-                  <a:srgbClr val="6B7B73"/>
-                </a:solidFill>
-                <a:latin typeface="Space Grotesk"/>
-              </a:rPr>
-              <a:t>want</a:t>
-            </a:r>
-            <a:r>
-              <a:rPr sz="1100" b="1">
-                <a:solidFill>
-                  <a:srgbClr val="1F7A57"/>
-                </a:solidFill>
-                <a:latin typeface="Space Grotesk"/>
-              </a:rPr>
-              <a:t>hat</a:t>
-            </a:r>
-          </a:p>
-        </p:txBody>
-      </p:sp>
-      <p:sp>
-        <p:nvSpPr>
-          <p:cNvPr id="9" name="TextBox 8"/>
-          <p:cNvSpPr txBox="1"/>
-          <p:nvPr/>
-        </p:nvSpPr>
-        <p:spPr>
-          <a:xfrm>
-            <a:off x="10607040" y="6510528"/>
-            <a:ext cx="941832" cy="274320"/>
-          </a:xfrm>
-          <a:prstGeom prst="rect">
-            <a:avLst/>
-          </a:prstGeom>
-          <a:noFill/>
-        </p:spPr>
-        <p:txBody>
-          <a:bodyPr wrap="square" anchor="t" lIns="0" rIns="0" tIns="0" bIns="0">
-            <a:spAutoFit/>
-          </a:bodyPr>
-          <a:lstStyle/>
-          <a:p>
-            <a:pPr algn="r"/>
-            <a:r>
-              <a:rPr sz="1000" b="0">
-                <a:solidFill>
-                  <a:srgbClr val="8A968F"/>
-                </a:solidFill>
-                <a:latin typeface="Space Mono"/>
-              </a:rPr>
-              <a:t>12</a:t>
-            </a:r>
-          </a:p>
-        </p:txBody>
-      </p:sp>
-      <p:sp>
-        <p:nvSpPr>
-          <p:cNvPr id="10" name="TextBox 9"/>
-          <p:cNvSpPr txBox="1"/>
-          <p:nvPr/>
-        </p:nvSpPr>
-        <p:spPr>
-          <a:xfrm>
-            <a:off x="658368" y="1783080"/>
-            <a:ext cx="3063240" cy="4480560"/>
-          </a:xfrm>
-          <a:prstGeom prst="rect">
-            <a:avLst/>
-          </a:prstGeom>
-          <a:noFill/>
-        </p:spPr>
-        <p:txBody>
-          <a:bodyPr wrap="square">
-            <a:spAutoFit/>
-          </a:bodyPr>
-          <a:lstStyle/>
-          <a:p>
-            <a:r>
-              <a:rPr sz="1200" b="0">
-                <a:solidFill>
-                  <a:srgbClr val="15201C"/>
-                </a:solidFill>
-                <a:latin typeface="Hanken Grotesk"/>
-              </a:rPr>
-              <a:t>-  Every registration appends a hash-chained audit row — each row carries the previous row's hash.</a:t>
-            </a:r>
-          </a:p>
-          <a:p>
-            <a:r>
-              <a:rPr sz="1200" b="0">
-                <a:solidFill>
-                  <a:srgbClr val="15201C"/>
-                </a:solidFill>
-                <a:latin typeface="Hanken Grotesk"/>
-              </a:rPr>
-              <a:t>-  audit_writer is granted EXECUTE on the procedure ONLY.</a:t>
-            </a:r>
-          </a:p>
-          <a:p>
-            <a:r>
-              <a:rPr sz="1200" b="0">
-                <a:solidFill>
-                  <a:srgbClr val="15201C"/>
-                </a:solidFill>
-                <a:latin typeface="Hanken Grotesk"/>
-              </a:rPr>
-              <a:t>-  The stored procedure serializes concurrent appends (advisory lock).</a:t>
-            </a:r>
-          </a:p>
-        </p:txBody>
-      </p:sp>
+      <p:pic>
+        <p:nvPicPr>
+          <p:cNvPr id="2" name="Picture 1" descr="page-12.png"/>
+          <p:cNvPicPr>
+            <a:picLocks noChangeAspect="1"/>
+          </p:cNvPicPr>
+          <p:nvPr/>
+        </p:nvPicPr>
+        <p:blipFill>
+          <a:blip r:embed="rId4"/>
+          <a:stretch>
+            <a:fillRect/>
+          </a:stretch>
+        </p:blipFill>
+        <p:spPr>
+          <a:xfrm>
+            <a:off x="0" y="0"/>
+            <a:ext cx="12191695" cy="6858000"/>
+          </a:xfrm>
+          <a:prstGeom prst="rect">
+            <a:avLst/>
+          </a:prstGeom>
+        </p:spPr>
+      </p:pic>
     </p:spTree>
   </p:cSld>
   <p:clrMapOvr>
@@ -7127,324 +6212,30 @@
         <p:nvPr/>
       </p:nvGrpSpPr>
       <p:grpSpPr/>
-      <p:sp>
-        <p:nvSpPr>
-          <p:cNvPr id="2" name="TextBox 1"/>
-          <p:cNvSpPr txBox="1"/>
-          <p:nvPr/>
-        </p:nvSpPr>
-        <p:spPr>
-          <a:xfrm>
-            <a:off x="10195560" y="256032"/>
-            <a:ext cx="1371600" cy="1005840"/>
-          </a:xfrm>
-          <a:prstGeom prst="rect">
-            <a:avLst/>
-          </a:prstGeom>
-          <a:noFill/>
-        </p:spPr>
-        <p:txBody>
-          <a:bodyPr wrap="square" anchor="t" lIns="0" rIns="0" tIns="0" bIns="0">
-            <a:spAutoFit/>
-          </a:bodyPr>
-          <a:lstStyle/>
-          <a:p>
-            <a:pPr algn="r"/>
-            <a:r>
-              <a:rPr sz="4600" b="1">
-                <a:solidFill>
-                  <a:srgbClr val="DCE5E0"/>
-                </a:solidFill>
-                <a:latin typeface="Space Grotesk"/>
-              </a:rPr>
-              <a:t>13</a:t>
-            </a:r>
-          </a:p>
-        </p:txBody>
-      </p:sp>
-      <p:sp>
-        <p:nvSpPr>
-          <p:cNvPr id="3" name="TextBox 2"/>
-          <p:cNvSpPr txBox="1"/>
-          <p:nvPr/>
-        </p:nvSpPr>
-        <p:spPr>
-          <a:xfrm>
-            <a:off x="640080" y="420624"/>
-            <a:ext cx="9418320" cy="292608"/>
-          </a:xfrm>
-          <a:prstGeom prst="rect">
-            <a:avLst/>
-          </a:prstGeom>
-          <a:noFill/>
-        </p:spPr>
-        <p:txBody>
-          <a:bodyPr wrap="square" anchor="t" lIns="0" rIns="0" tIns="0" bIns="0">
-            <a:spAutoFit/>
-          </a:bodyPr>
-          <a:lstStyle/>
-          <a:p>
-            <a:r>
-              <a:rPr sz="1150" b="1">
-                <a:solidFill>
-                  <a:srgbClr val="1F7A57"/>
-                </a:solidFill>
-                <a:latin typeface="Space Mono"/>
-              </a:rPr>
-              <a:t>ENGINEERING</a:t>
-            </a:r>
-          </a:p>
-        </p:txBody>
-      </p:sp>
-      <p:sp>
-        <p:nvSpPr>
-          <p:cNvPr id="4" name="TextBox 3"/>
-          <p:cNvSpPr txBox="1"/>
-          <p:nvPr/>
-        </p:nvSpPr>
-        <p:spPr>
-          <a:xfrm>
-            <a:off x="621792" y="731520"/>
-            <a:ext cx="9509760" cy="868680"/>
-          </a:xfrm>
-          <a:prstGeom prst="rect">
-            <a:avLst/>
-          </a:prstGeom>
-          <a:noFill/>
-        </p:spPr>
-        <p:txBody>
-          <a:bodyPr wrap="square" anchor="t" lIns="0" rIns="0" tIns="0" bIns="0">
-            <a:spAutoFit/>
-          </a:bodyPr>
-          <a:lstStyle/>
-          <a:p>
-            <a:r>
-              <a:rPr sz="2700" b="1">
-                <a:solidFill>
-                  <a:srgbClr val="15201C"/>
-                </a:solidFill>
-                <a:latin typeface="Space Grotesk"/>
-              </a:rPr>
-              <a:t>Architecture UC4 — settlement pulled in the background</a:t>
-            </a:r>
-          </a:p>
-        </p:txBody>
-      </p:sp>
-      <p:sp>
-        <p:nvSpPr>
-          <p:cNvPr id="5" name="Rounded Rectangle 4"/>
-          <p:cNvSpPr/>
-          <p:nvPr/>
-        </p:nvSpPr>
-        <p:spPr>
-          <a:xfrm>
-            <a:off x="3886200" y="1600200"/>
-            <a:ext cx="7653527" cy="4709160"/>
-          </a:xfrm>
-          <a:prstGeom prst="roundRect">
-            <a:avLst>
-              <a:gd name="adj" fmla="val 3000"/>
-            </a:avLst>
-          </a:prstGeom>
-          <a:solidFill>
-            <a:srgbClr val="FFFFFF"/>
-          </a:solidFill>
-          <a:ln w="12700">
-            <a:solidFill>
-              <a:srgbClr val="E6EBE8"/>
-            </a:solidFill>
-          </a:ln>
-          <a:effectLst/>
-        </p:spPr>
-        <p:style>
-          <a:lnRef idx="1">
-            <a:schemeClr val="accent1"/>
-          </a:lnRef>
-          <a:fillRef idx="3">
-            <a:schemeClr val="accent1"/>
-          </a:fillRef>
-          <a:effectRef idx="2">
-            <a:schemeClr val="accent1"/>
-          </a:effectRef>
-          <a:fontRef idx="minor">
-            <a:schemeClr val="lt1"/>
-          </a:fontRef>
-        </p:style>
-        <p:txBody>
-          <a:bodyPr rtlCol="0" anchor="ctr"/>
-          <a:lstStyle/>
-          <a:p>
-            <a:pPr algn="ctr"/>
-          </a:p>
-        </p:txBody>
-      </p:sp>
-      <p:sp>
-        <p:nvSpPr>
-          <p:cNvPr id="7" name="Rectangle 6"/>
-          <p:cNvSpPr/>
-          <p:nvPr/>
-        </p:nvSpPr>
-        <p:spPr>
-          <a:xfrm>
-            <a:off x="640080" y="6455664"/>
-            <a:ext cx="10908792" cy="9144"/>
-          </a:xfrm>
-          <a:prstGeom prst="rect">
-            <a:avLst/>
-          </a:prstGeom>
-          <a:solidFill>
-            <a:srgbClr val="E6EBE8"/>
-          </a:solidFill>
-          <a:ln>
-            <a:noFill/>
-          </a:ln>
-          <a:effectLst/>
-        </p:spPr>
-        <p:style>
-          <a:lnRef idx="1">
-            <a:schemeClr val="accent1"/>
-          </a:lnRef>
-          <a:fillRef idx="3">
-            <a:schemeClr val="accent1"/>
-          </a:fillRef>
-          <a:effectRef idx="2">
-            <a:schemeClr val="accent1"/>
-          </a:effectRef>
-          <a:fontRef idx="minor">
-            <a:schemeClr val="lt1"/>
-          </a:fontRef>
-        </p:style>
-        <p:txBody>
-          <a:bodyPr rtlCol="0" anchor="ctr"/>
-          <a:lstStyle/>
-          <a:p>
-            <a:pPr algn="ctr"/>
-          </a:p>
-        </p:txBody>
-      </p:sp>
-      <p:sp>
-        <p:nvSpPr>
-          <p:cNvPr id="8" name="TextBox 7"/>
-          <p:cNvSpPr txBox="1"/>
-          <p:nvPr/>
-        </p:nvSpPr>
-        <p:spPr>
-          <a:xfrm>
-            <a:off x="640080" y="6510528"/>
-            <a:ext cx="2743200" cy="274320"/>
-          </a:xfrm>
-          <a:prstGeom prst="rect">
-            <a:avLst/>
-          </a:prstGeom>
-          <a:noFill/>
-        </p:spPr>
-        <p:txBody>
-          <a:bodyPr wrap="square" anchor="t" lIns="0" rIns="0" tIns="0" bIns="0">
-            <a:spAutoFit/>
-          </a:bodyPr>
-          <a:lstStyle/>
-          <a:p>
-            <a:r>
-              <a:rPr sz="1100" b="1">
-                <a:solidFill>
-                  <a:srgbClr val="6B7B73"/>
-                </a:solidFill>
-                <a:latin typeface="Space Grotesk"/>
-              </a:rPr>
-              <a:t>want</a:t>
-            </a:r>
-            <a:r>
-              <a:rPr sz="1100" b="1">
-                <a:solidFill>
-                  <a:srgbClr val="1F7A57"/>
-                </a:solidFill>
-                <a:latin typeface="Space Grotesk"/>
-              </a:rPr>
-              <a:t>hat</a:t>
-            </a:r>
-          </a:p>
-        </p:txBody>
-      </p:sp>
-      <p:sp>
-        <p:nvSpPr>
-          <p:cNvPr id="9" name="TextBox 8"/>
-          <p:cNvSpPr txBox="1"/>
-          <p:nvPr/>
-        </p:nvSpPr>
-        <p:spPr>
-          <a:xfrm>
-            <a:off x="10607040" y="6510528"/>
-            <a:ext cx="941832" cy="274320"/>
-          </a:xfrm>
-          <a:prstGeom prst="rect">
-            <a:avLst/>
-          </a:prstGeom>
-          <a:noFill/>
-        </p:spPr>
-        <p:txBody>
-          <a:bodyPr wrap="square" anchor="t" lIns="0" rIns="0" tIns="0" bIns="0">
-            <a:spAutoFit/>
-          </a:bodyPr>
-          <a:lstStyle/>
-          <a:p>
-            <a:pPr algn="r"/>
-            <a:r>
-              <a:rPr sz="1000" b="0">
-                <a:solidFill>
-                  <a:srgbClr val="8A968F"/>
-                </a:solidFill>
-                <a:latin typeface="Space Mono"/>
-              </a:rPr>
-              <a:t>13</a:t>
-            </a:r>
-          </a:p>
-        </p:txBody>
-      </p:sp>
-      <p:sp>
-        <p:nvSpPr>
-          <p:cNvPr id="10" name="TextBox 9"/>
-          <p:cNvSpPr txBox="1"/>
-          <p:nvPr/>
-        </p:nvSpPr>
-        <p:spPr>
-          <a:xfrm>
-            <a:off x="658368" y="1783080"/>
-            <a:ext cx="3063240" cy="4480560"/>
-          </a:xfrm>
-          <a:prstGeom prst="rect">
-            <a:avLst/>
-          </a:prstGeom>
-          <a:noFill/>
-        </p:spPr>
-        <p:txBody>
-          <a:bodyPr wrap="square">
-            <a:spAutoFit/>
-          </a:bodyPr>
-          <a:lstStyle/>
-          <a:p>
-            <a:r>
-              <a:rPr sz="1200" b="0">
-                <a:solidFill>
-                  <a:srgbClr val="15201C"/>
-                </a:solidFill>
-                <a:latin typeface="Hanken Grotesk"/>
-              </a:rPr>
-              <a:t>-  Internal-only flow — the ONLY path that can append wallet entries (GRANT-enforced).</a:t>
-            </a:r>
-          </a:p>
-          <a:p>
-            <a:r>
-              <a:rPr sz="1200" b="0">
-                <a:solidFill>
-                  <a:srgbClr val="15201C"/>
-                </a:solidFill>
-                <a:latin typeface="Hanken Grotesk"/>
-              </a:rPr>
-              <a:t>-  Side use case: FX rates pulled from the exchange-rate provider.</a:t>
-            </a:r>
-          </a:p>
-        </p:txBody>
-      </p:sp>
+      <p:pic>
+        <p:nvPicPr>
+          <p:cNvPr id="2" name="Picture 1" descr="page-13.jpg"/>
+          <p:cNvPicPr>
+            <a:picLocks noChangeAspect="1"/>
+          </p:cNvPicPr>
+          <p:nvPr/>
+        </p:nvPicPr>
+        <p:blipFill>
+          <a:blip r:embed="rId4"/>
+          <a:stretch>
+            <a:fillRect/>
+          </a:stretch>
+        </p:blipFill>
+        <p:spPr>
+          <a:xfrm>
+            <a:off x="0" y="0"/>
+            <a:ext cx="12191695" cy="6858000"/>
+          </a:xfrm>
+          <a:prstGeom prst="rect">
+            <a:avLst/>
+          </a:prstGeom>
+        </p:spPr>
+      </p:pic>
     </p:spTree>
   </p:cSld>
   <p:clrMapOvr>
@@ -7463,324 +6254,30 @@
         <p:nvPr/>
       </p:nvGrpSpPr>
       <p:grpSpPr/>
-      <p:sp>
-        <p:nvSpPr>
-          <p:cNvPr id="2" name="TextBox 1"/>
-          <p:cNvSpPr txBox="1"/>
-          <p:nvPr/>
-        </p:nvSpPr>
-        <p:spPr>
-          <a:xfrm>
-            <a:off x="10195560" y="256032"/>
-            <a:ext cx="1371600" cy="1005840"/>
-          </a:xfrm>
-          <a:prstGeom prst="rect">
-            <a:avLst/>
-          </a:prstGeom>
-          <a:noFill/>
-        </p:spPr>
-        <p:txBody>
-          <a:bodyPr wrap="square" anchor="t" lIns="0" rIns="0" tIns="0" bIns="0">
-            <a:spAutoFit/>
-          </a:bodyPr>
-          <a:lstStyle/>
-          <a:p>
-            <a:pPr algn="r"/>
-            <a:r>
-              <a:rPr sz="4600" b="1">
-                <a:solidFill>
-                  <a:srgbClr val="DCE5E0"/>
-                </a:solidFill>
-                <a:latin typeface="Space Grotesk"/>
-              </a:rPr>
-              <a:t>14</a:t>
-            </a:r>
-          </a:p>
-        </p:txBody>
-      </p:sp>
-      <p:sp>
-        <p:nvSpPr>
-          <p:cNvPr id="3" name="TextBox 2"/>
-          <p:cNvSpPr txBox="1"/>
-          <p:nvPr/>
-        </p:nvSpPr>
-        <p:spPr>
-          <a:xfrm>
-            <a:off x="640080" y="420624"/>
-            <a:ext cx="9418320" cy="292608"/>
-          </a:xfrm>
-          <a:prstGeom prst="rect">
-            <a:avLst/>
-          </a:prstGeom>
-          <a:noFill/>
-        </p:spPr>
-        <p:txBody>
-          <a:bodyPr wrap="square" anchor="t" lIns="0" rIns="0" tIns="0" bIns="0">
-            <a:spAutoFit/>
-          </a:bodyPr>
-          <a:lstStyle/>
-          <a:p>
-            <a:r>
-              <a:rPr sz="1150" b="1">
-                <a:solidFill>
-                  <a:srgbClr val="1F7A57"/>
-                </a:solidFill>
-                <a:latin typeface="Space Mono"/>
-              </a:rPr>
-              <a:t>ENGINEERING</a:t>
-            </a:r>
-          </a:p>
-        </p:txBody>
-      </p:sp>
-      <p:sp>
-        <p:nvSpPr>
-          <p:cNvPr id="4" name="TextBox 3"/>
-          <p:cNvSpPr txBox="1"/>
-          <p:nvPr/>
-        </p:nvSpPr>
-        <p:spPr>
-          <a:xfrm>
-            <a:off x="621792" y="731520"/>
-            <a:ext cx="9509760" cy="868680"/>
-          </a:xfrm>
-          <a:prstGeom prst="rect">
-            <a:avLst/>
-          </a:prstGeom>
-          <a:noFill/>
-        </p:spPr>
-        <p:txBody>
-          <a:bodyPr wrap="square" anchor="t" lIns="0" rIns="0" tIns="0" bIns="0">
-            <a:spAutoFit/>
-          </a:bodyPr>
-          <a:lstStyle/>
-          <a:p>
-            <a:r>
-              <a:rPr sz="2700" b="1">
-                <a:solidFill>
-                  <a:srgbClr val="15201C"/>
-                </a:solidFill>
-                <a:latin typeface="Space Grotesk"/>
-              </a:rPr>
-              <a:t>Architecture UC5 — the member home page</a:t>
-            </a:r>
-          </a:p>
-        </p:txBody>
-      </p:sp>
-      <p:sp>
-        <p:nvSpPr>
-          <p:cNvPr id="5" name="Rounded Rectangle 4"/>
-          <p:cNvSpPr/>
-          <p:nvPr/>
-        </p:nvSpPr>
-        <p:spPr>
-          <a:xfrm>
-            <a:off x="3886200" y="1600200"/>
-            <a:ext cx="7653527" cy="4709160"/>
-          </a:xfrm>
-          <a:prstGeom prst="roundRect">
-            <a:avLst>
-              <a:gd name="adj" fmla="val 3000"/>
-            </a:avLst>
-          </a:prstGeom>
-          <a:solidFill>
-            <a:srgbClr val="FFFFFF"/>
-          </a:solidFill>
-          <a:ln w="12700">
-            <a:solidFill>
-              <a:srgbClr val="E6EBE8"/>
-            </a:solidFill>
-          </a:ln>
-          <a:effectLst/>
-        </p:spPr>
-        <p:style>
-          <a:lnRef idx="1">
-            <a:schemeClr val="accent1"/>
-          </a:lnRef>
-          <a:fillRef idx="3">
-            <a:schemeClr val="accent1"/>
-          </a:fillRef>
-          <a:effectRef idx="2">
-            <a:schemeClr val="accent1"/>
-          </a:effectRef>
-          <a:fontRef idx="minor">
-            <a:schemeClr val="lt1"/>
-          </a:fontRef>
-        </p:style>
-        <p:txBody>
-          <a:bodyPr rtlCol="0" anchor="ctr"/>
-          <a:lstStyle/>
-          <a:p>
-            <a:pPr algn="ctr"/>
-          </a:p>
-        </p:txBody>
-      </p:sp>
-      <p:sp>
-        <p:nvSpPr>
-          <p:cNvPr id="7" name="Rectangle 6"/>
-          <p:cNvSpPr/>
-          <p:nvPr/>
-        </p:nvSpPr>
-        <p:spPr>
-          <a:xfrm>
-            <a:off x="640080" y="6455664"/>
-            <a:ext cx="10908792" cy="9144"/>
-          </a:xfrm>
-          <a:prstGeom prst="rect">
-            <a:avLst/>
-          </a:prstGeom>
-          <a:solidFill>
-            <a:srgbClr val="E6EBE8"/>
-          </a:solidFill>
-          <a:ln>
-            <a:noFill/>
-          </a:ln>
-          <a:effectLst/>
-        </p:spPr>
-        <p:style>
-          <a:lnRef idx="1">
-            <a:schemeClr val="accent1"/>
-          </a:lnRef>
-          <a:fillRef idx="3">
-            <a:schemeClr val="accent1"/>
-          </a:fillRef>
-          <a:effectRef idx="2">
-            <a:schemeClr val="accent1"/>
-          </a:effectRef>
-          <a:fontRef idx="minor">
-            <a:schemeClr val="lt1"/>
-          </a:fontRef>
-        </p:style>
-        <p:txBody>
-          <a:bodyPr rtlCol="0" anchor="ctr"/>
-          <a:lstStyle/>
-          <a:p>
-            <a:pPr algn="ctr"/>
-          </a:p>
-        </p:txBody>
-      </p:sp>
-      <p:sp>
-        <p:nvSpPr>
-          <p:cNvPr id="8" name="TextBox 7"/>
-          <p:cNvSpPr txBox="1"/>
-          <p:nvPr/>
-        </p:nvSpPr>
-        <p:spPr>
-          <a:xfrm>
-            <a:off x="640080" y="6510528"/>
-            <a:ext cx="2743200" cy="274320"/>
-          </a:xfrm>
-          <a:prstGeom prst="rect">
-            <a:avLst/>
-          </a:prstGeom>
-          <a:noFill/>
-        </p:spPr>
-        <p:txBody>
-          <a:bodyPr wrap="square" anchor="t" lIns="0" rIns="0" tIns="0" bIns="0">
-            <a:spAutoFit/>
-          </a:bodyPr>
-          <a:lstStyle/>
-          <a:p>
-            <a:r>
-              <a:rPr sz="1100" b="1">
-                <a:solidFill>
-                  <a:srgbClr val="6B7B73"/>
-                </a:solidFill>
-                <a:latin typeface="Space Grotesk"/>
-              </a:rPr>
-              <a:t>want</a:t>
-            </a:r>
-            <a:r>
-              <a:rPr sz="1100" b="1">
-                <a:solidFill>
-                  <a:srgbClr val="1F7A57"/>
-                </a:solidFill>
-                <a:latin typeface="Space Grotesk"/>
-              </a:rPr>
-              <a:t>hat</a:t>
-            </a:r>
-          </a:p>
-        </p:txBody>
-      </p:sp>
-      <p:sp>
-        <p:nvSpPr>
-          <p:cNvPr id="9" name="TextBox 8"/>
-          <p:cNvSpPr txBox="1"/>
-          <p:nvPr/>
-        </p:nvSpPr>
-        <p:spPr>
-          <a:xfrm>
-            <a:off x="10607040" y="6510528"/>
-            <a:ext cx="941832" cy="274320"/>
-          </a:xfrm>
-          <a:prstGeom prst="rect">
-            <a:avLst/>
-          </a:prstGeom>
-          <a:noFill/>
-        </p:spPr>
-        <p:txBody>
-          <a:bodyPr wrap="square" anchor="t" lIns="0" rIns="0" tIns="0" bIns="0">
-            <a:spAutoFit/>
-          </a:bodyPr>
-          <a:lstStyle/>
-          <a:p>
-            <a:pPr algn="r"/>
-            <a:r>
-              <a:rPr sz="1000" b="0">
-                <a:solidFill>
-                  <a:srgbClr val="8A968F"/>
-                </a:solidFill>
-                <a:latin typeface="Space Mono"/>
-              </a:rPr>
-              <a:t>14</a:t>
-            </a:r>
-          </a:p>
-        </p:txBody>
-      </p:sp>
-      <p:sp>
-        <p:nvSpPr>
-          <p:cNvPr id="10" name="TextBox 9"/>
-          <p:cNvSpPr txBox="1"/>
-          <p:nvPr/>
-        </p:nvSpPr>
-        <p:spPr>
-          <a:xfrm>
-            <a:off x="658368" y="1783080"/>
-            <a:ext cx="3063240" cy="4480560"/>
-          </a:xfrm>
-          <a:prstGeom prst="rect">
-            <a:avLst/>
-          </a:prstGeom>
-          <a:noFill/>
-        </p:spPr>
-        <p:txBody>
-          <a:bodyPr wrap="square">
-            <a:spAutoFit/>
-          </a:bodyPr>
-          <a:lstStyle/>
-          <a:p>
-            <a:r>
-              <a:rPr sz="1200" b="0">
-                <a:solidFill>
-                  <a:srgbClr val="15201C"/>
-                </a:solidFill>
-                <a:latin typeface="Hanken Grotesk"/>
-              </a:rPr>
-              <a:t>-  An Aurora cold resume may delay the wallet total + recent activity.</a:t>
-            </a:r>
-          </a:p>
-          <a:p>
-            <a:r>
-              <a:rPr sz="1200" b="0">
-                <a:solidFill>
-                  <a:srgbClr val="15201C"/>
-                </a:solidFill>
-                <a:latin typeface="Hanken Grotesk"/>
-              </a:rPr>
-              <a:t>-  Everything else is operational immediately.</a:t>
-            </a:r>
-          </a:p>
-        </p:txBody>
-      </p:sp>
+      <p:pic>
+        <p:nvPicPr>
+          <p:cNvPr id="2" name="Picture 1" descr="page-14.jpg"/>
+          <p:cNvPicPr>
+            <a:picLocks noChangeAspect="1"/>
+          </p:cNvPicPr>
+          <p:nvPr/>
+        </p:nvPicPr>
+        <p:blipFill>
+          <a:blip r:embed="rId4"/>
+          <a:stretch>
+            <a:fillRect/>
+          </a:stretch>
+        </p:blipFill>
+        <p:spPr>
+          <a:xfrm>
+            <a:off x="0" y="0"/>
+            <a:ext cx="12191695" cy="6858000"/>
+          </a:xfrm>
+          <a:prstGeom prst="rect">
+            <a:avLst/>
+          </a:prstGeom>
+        </p:spPr>
+      </p:pic>
     </p:spTree>
   </p:cSld>
   <p:clrMapOvr>
@@ -7799,324 +6296,30 @@
         <p:nvPr/>
       </p:nvGrpSpPr>
       <p:grpSpPr/>
-      <p:sp>
-        <p:nvSpPr>
-          <p:cNvPr id="2" name="TextBox 1"/>
-          <p:cNvSpPr txBox="1"/>
-          <p:nvPr/>
-        </p:nvSpPr>
-        <p:spPr>
-          <a:xfrm>
-            <a:off x="10195560" y="256032"/>
-            <a:ext cx="1371600" cy="1005840"/>
-          </a:xfrm>
-          <a:prstGeom prst="rect">
-            <a:avLst/>
-          </a:prstGeom>
-          <a:noFill/>
-        </p:spPr>
-        <p:txBody>
-          <a:bodyPr wrap="square" anchor="t" lIns="0" rIns="0" tIns="0" bIns="0">
-            <a:spAutoFit/>
-          </a:bodyPr>
-          <a:lstStyle/>
-          <a:p>
-            <a:pPr algn="r"/>
-            <a:r>
-              <a:rPr sz="4600" b="1">
-                <a:solidFill>
-                  <a:srgbClr val="DCE5E0"/>
-                </a:solidFill>
-                <a:latin typeface="Space Grotesk"/>
-              </a:rPr>
-              <a:t>15</a:t>
-            </a:r>
-          </a:p>
-        </p:txBody>
-      </p:sp>
-      <p:sp>
-        <p:nvSpPr>
-          <p:cNvPr id="3" name="TextBox 2"/>
-          <p:cNvSpPr txBox="1"/>
-          <p:nvPr/>
-        </p:nvSpPr>
-        <p:spPr>
-          <a:xfrm>
-            <a:off x="640080" y="420624"/>
-            <a:ext cx="9418320" cy="292608"/>
-          </a:xfrm>
-          <a:prstGeom prst="rect">
-            <a:avLst/>
-          </a:prstGeom>
-          <a:noFill/>
-        </p:spPr>
-        <p:txBody>
-          <a:bodyPr wrap="square" anchor="t" lIns="0" rIns="0" tIns="0" bIns="0">
-            <a:spAutoFit/>
-          </a:bodyPr>
-          <a:lstStyle/>
-          <a:p>
-            <a:r>
-              <a:rPr sz="1150" b="1">
-                <a:solidFill>
-                  <a:srgbClr val="1F7A57"/>
-                </a:solidFill>
-                <a:latin typeface="Space Mono"/>
-              </a:rPr>
-              <a:t>ENGINEERING</a:t>
-            </a:r>
-          </a:p>
-        </p:txBody>
-      </p:sp>
-      <p:sp>
-        <p:nvSpPr>
-          <p:cNvPr id="4" name="TextBox 3"/>
-          <p:cNvSpPr txBox="1"/>
-          <p:nvPr/>
-        </p:nvSpPr>
-        <p:spPr>
-          <a:xfrm>
-            <a:off x="621792" y="731520"/>
-            <a:ext cx="9509760" cy="868680"/>
-          </a:xfrm>
-          <a:prstGeom prst="rect">
-            <a:avLst/>
-          </a:prstGeom>
-          <a:noFill/>
-        </p:spPr>
-        <p:txBody>
-          <a:bodyPr wrap="square" anchor="t" lIns="0" rIns="0" tIns="0" bIns="0">
-            <a:spAutoFit/>
-          </a:bodyPr>
-          <a:lstStyle/>
-          <a:p>
-            <a:r>
-              <a:rPr sz="2700" b="1">
-                <a:solidFill>
-                  <a:srgbClr val="15201C"/>
-                </a:solidFill>
-                <a:latin typeface="Space Grotesk"/>
-              </a:rPr>
-              <a:t>Architecture UC6 — the admin console</a:t>
-            </a:r>
-          </a:p>
-        </p:txBody>
-      </p:sp>
-      <p:sp>
-        <p:nvSpPr>
-          <p:cNvPr id="5" name="Rounded Rectangle 4"/>
-          <p:cNvSpPr/>
-          <p:nvPr/>
-        </p:nvSpPr>
-        <p:spPr>
-          <a:xfrm>
-            <a:off x="3886200" y="1600200"/>
-            <a:ext cx="7653527" cy="4709160"/>
-          </a:xfrm>
-          <a:prstGeom prst="roundRect">
-            <a:avLst>
-              <a:gd name="adj" fmla="val 3000"/>
-            </a:avLst>
-          </a:prstGeom>
-          <a:solidFill>
-            <a:srgbClr val="FFFFFF"/>
-          </a:solidFill>
-          <a:ln w="12700">
-            <a:solidFill>
-              <a:srgbClr val="E6EBE8"/>
-            </a:solidFill>
-          </a:ln>
-          <a:effectLst/>
-        </p:spPr>
-        <p:style>
-          <a:lnRef idx="1">
-            <a:schemeClr val="accent1"/>
-          </a:lnRef>
-          <a:fillRef idx="3">
-            <a:schemeClr val="accent1"/>
-          </a:fillRef>
-          <a:effectRef idx="2">
-            <a:schemeClr val="accent1"/>
-          </a:effectRef>
-          <a:fontRef idx="minor">
-            <a:schemeClr val="lt1"/>
-          </a:fontRef>
-        </p:style>
-        <p:txBody>
-          <a:bodyPr rtlCol="0" anchor="ctr"/>
-          <a:lstStyle/>
-          <a:p>
-            <a:pPr algn="ctr"/>
-          </a:p>
-        </p:txBody>
-      </p:sp>
-      <p:sp>
-        <p:nvSpPr>
-          <p:cNvPr id="7" name="Rectangle 6"/>
-          <p:cNvSpPr/>
-          <p:nvPr/>
-        </p:nvSpPr>
-        <p:spPr>
-          <a:xfrm>
-            <a:off x="640080" y="6455664"/>
-            <a:ext cx="10908792" cy="9144"/>
-          </a:xfrm>
-          <a:prstGeom prst="rect">
-            <a:avLst/>
-          </a:prstGeom>
-          <a:solidFill>
-            <a:srgbClr val="E6EBE8"/>
-          </a:solidFill>
-          <a:ln>
-            <a:noFill/>
-          </a:ln>
-          <a:effectLst/>
-        </p:spPr>
-        <p:style>
-          <a:lnRef idx="1">
-            <a:schemeClr val="accent1"/>
-          </a:lnRef>
-          <a:fillRef idx="3">
-            <a:schemeClr val="accent1"/>
-          </a:fillRef>
-          <a:effectRef idx="2">
-            <a:schemeClr val="accent1"/>
-          </a:effectRef>
-          <a:fontRef idx="minor">
-            <a:schemeClr val="lt1"/>
-          </a:fontRef>
-        </p:style>
-        <p:txBody>
-          <a:bodyPr rtlCol="0" anchor="ctr"/>
-          <a:lstStyle/>
-          <a:p>
-            <a:pPr algn="ctr"/>
-          </a:p>
-        </p:txBody>
-      </p:sp>
-      <p:sp>
-        <p:nvSpPr>
-          <p:cNvPr id="8" name="TextBox 7"/>
-          <p:cNvSpPr txBox="1"/>
-          <p:nvPr/>
-        </p:nvSpPr>
-        <p:spPr>
-          <a:xfrm>
-            <a:off x="640080" y="6510528"/>
-            <a:ext cx="2743200" cy="274320"/>
-          </a:xfrm>
-          <a:prstGeom prst="rect">
-            <a:avLst/>
-          </a:prstGeom>
-          <a:noFill/>
-        </p:spPr>
-        <p:txBody>
-          <a:bodyPr wrap="square" anchor="t" lIns="0" rIns="0" tIns="0" bIns="0">
-            <a:spAutoFit/>
-          </a:bodyPr>
-          <a:lstStyle/>
-          <a:p>
-            <a:r>
-              <a:rPr sz="1100" b="1">
-                <a:solidFill>
-                  <a:srgbClr val="6B7B73"/>
-                </a:solidFill>
-                <a:latin typeface="Space Grotesk"/>
-              </a:rPr>
-              <a:t>want</a:t>
-            </a:r>
-            <a:r>
-              <a:rPr sz="1100" b="1">
-                <a:solidFill>
-                  <a:srgbClr val="1F7A57"/>
-                </a:solidFill>
-                <a:latin typeface="Space Grotesk"/>
-              </a:rPr>
-              <a:t>hat</a:t>
-            </a:r>
-          </a:p>
-        </p:txBody>
-      </p:sp>
-      <p:sp>
-        <p:nvSpPr>
-          <p:cNvPr id="9" name="TextBox 8"/>
-          <p:cNvSpPr txBox="1"/>
-          <p:nvPr/>
-        </p:nvSpPr>
-        <p:spPr>
-          <a:xfrm>
-            <a:off x="10607040" y="6510528"/>
-            <a:ext cx="941832" cy="274320"/>
-          </a:xfrm>
-          <a:prstGeom prst="rect">
-            <a:avLst/>
-          </a:prstGeom>
-          <a:noFill/>
-        </p:spPr>
-        <p:txBody>
-          <a:bodyPr wrap="square" anchor="t" lIns="0" rIns="0" tIns="0" bIns="0">
-            <a:spAutoFit/>
-          </a:bodyPr>
-          <a:lstStyle/>
-          <a:p>
-            <a:pPr algn="r"/>
-            <a:r>
-              <a:rPr sz="1000" b="0">
-                <a:solidFill>
-                  <a:srgbClr val="8A968F"/>
-                </a:solidFill>
-                <a:latin typeface="Space Mono"/>
-              </a:rPr>
-              <a:t>15</a:t>
-            </a:r>
-          </a:p>
-        </p:txBody>
-      </p:sp>
-      <p:sp>
-        <p:nvSpPr>
-          <p:cNvPr id="10" name="TextBox 9"/>
-          <p:cNvSpPr txBox="1"/>
-          <p:nvPr/>
-        </p:nvSpPr>
-        <p:spPr>
-          <a:xfrm>
-            <a:off x="658368" y="1783080"/>
-            <a:ext cx="3063240" cy="4480560"/>
-          </a:xfrm>
-          <a:prstGeom prst="rect">
-            <a:avLst/>
-          </a:prstGeom>
-          <a:noFill/>
-        </p:spPr>
-        <p:txBody>
-          <a:bodyPr wrap="square">
-            <a:spAutoFit/>
-          </a:bodyPr>
-          <a:lstStyle/>
-          <a:p>
-            <a:r>
-              <a:rPr sz="1200" b="0">
-                <a:solidFill>
-                  <a:srgbClr val="15201C"/>
-                </a:solidFill>
-                <a:latin typeface="Hanken Grotesk"/>
-              </a:rPr>
-              <a:t>-  Cognito Managed Login; a SEPARATE employee pool.</a:t>
-            </a:r>
-          </a:p>
-          <a:p>
-            <a:r>
-              <a:rPr sz="1200" b="0">
-                <a:solidFill>
-                  <a:srgbClr val="15201C"/>
-                </a:solidFill>
-                <a:latin typeface="Hanken Grotesk"/>
-              </a:rPr>
-              <a:t>-  Operational-data management; money views are read-only.</a:t>
-            </a:r>
-          </a:p>
-        </p:txBody>
-      </p:sp>
+      <p:pic>
+        <p:nvPicPr>
+          <p:cNvPr id="2" name="Picture 1" descr="page-15.jpg"/>
+          <p:cNvPicPr>
+            <a:picLocks noChangeAspect="1"/>
+          </p:cNvPicPr>
+          <p:nvPr/>
+        </p:nvPicPr>
+        <p:blipFill>
+          <a:blip r:embed="rId4"/>
+          <a:stretch>
+            <a:fillRect/>
+          </a:stretch>
+        </p:blipFill>
+        <p:spPr>
+          <a:xfrm>
+            <a:off x="0" y="0"/>
+            <a:ext cx="12191695" cy="6858000"/>
+          </a:xfrm>
+          <a:prstGeom prst="rect">
+            <a:avLst/>
+          </a:prstGeom>
+        </p:spPr>
+      </p:pic>
     </p:spTree>
   </p:cSld>
   <p:clrMapOvr>
@@ -8135,357 +6338,30 @@
         <p:nvPr/>
       </p:nvGrpSpPr>
       <p:grpSpPr/>
-      <p:sp>
-        <p:nvSpPr>
-          <p:cNvPr id="2" name="TextBox 1"/>
-          <p:cNvSpPr txBox="1"/>
-          <p:nvPr/>
-        </p:nvSpPr>
-        <p:spPr>
-          <a:xfrm>
-            <a:off x="10195560" y="256032"/>
-            <a:ext cx="1371600" cy="1005840"/>
-          </a:xfrm>
-          <a:prstGeom prst="rect">
-            <a:avLst/>
-          </a:prstGeom>
-          <a:noFill/>
-        </p:spPr>
-        <p:txBody>
-          <a:bodyPr wrap="square" anchor="t" lIns="0" rIns="0" tIns="0" bIns="0">
-            <a:spAutoFit/>
-          </a:bodyPr>
-          <a:lstStyle/>
-          <a:p>
-            <a:pPr algn="r"/>
-            <a:r>
-              <a:rPr sz="4600" b="1">
-                <a:solidFill>
-                  <a:srgbClr val="DCE5E0"/>
-                </a:solidFill>
-                <a:latin typeface="Space Grotesk"/>
-              </a:rPr>
-              <a:t>16</a:t>
-            </a:r>
-          </a:p>
-        </p:txBody>
-      </p:sp>
-      <p:sp>
-        <p:nvSpPr>
-          <p:cNvPr id="3" name="TextBox 2"/>
-          <p:cNvSpPr txBox="1"/>
-          <p:nvPr/>
-        </p:nvSpPr>
-        <p:spPr>
-          <a:xfrm>
-            <a:off x="640080" y="420624"/>
-            <a:ext cx="9418320" cy="292608"/>
-          </a:xfrm>
-          <a:prstGeom prst="rect">
-            <a:avLst/>
-          </a:prstGeom>
-          <a:noFill/>
-        </p:spPr>
-        <p:txBody>
-          <a:bodyPr wrap="square" anchor="t" lIns="0" rIns="0" tIns="0" bIns="0">
-            <a:spAutoFit/>
-          </a:bodyPr>
-          <a:lstStyle/>
-          <a:p>
-            <a:r>
-              <a:rPr sz="1150" b="1">
-                <a:solidFill>
-                  <a:srgbClr val="1F7A57"/>
-                </a:solidFill>
-                <a:latin typeface="Space Mono"/>
-              </a:rPr>
-              <a:t>ENGINEERING</a:t>
-            </a:r>
-          </a:p>
-        </p:txBody>
-      </p:sp>
-      <p:sp>
-        <p:nvSpPr>
-          <p:cNvPr id="4" name="TextBox 3"/>
-          <p:cNvSpPr txBox="1"/>
-          <p:nvPr/>
-        </p:nvSpPr>
-        <p:spPr>
-          <a:xfrm>
-            <a:off x="621792" y="731520"/>
-            <a:ext cx="9509760" cy="868680"/>
-          </a:xfrm>
-          <a:prstGeom prst="rect">
-            <a:avLst/>
-          </a:prstGeom>
-          <a:noFill/>
-        </p:spPr>
-        <p:txBody>
-          <a:bodyPr wrap="square" anchor="t" lIns="0" rIns="0" tIns="0" bIns="0">
-            <a:spAutoFit/>
-          </a:bodyPr>
-          <a:lstStyle/>
-          <a:p>
-            <a:r>
-              <a:rPr sz="2700" b="1">
-                <a:solidFill>
-                  <a:srgbClr val="15201C"/>
-                </a:solidFill>
-                <a:latin typeface="Space Grotesk"/>
-              </a:rPr>
-              <a:t>Architecture — additional use cases, same principles</a:t>
-            </a:r>
-          </a:p>
-        </p:txBody>
-      </p:sp>
-      <p:sp>
-        <p:nvSpPr>
-          <p:cNvPr id="5" name="Rounded Rectangle 4"/>
-          <p:cNvSpPr/>
-          <p:nvPr/>
-        </p:nvSpPr>
-        <p:spPr>
-          <a:xfrm>
-            <a:off x="3886200" y="1600200"/>
-            <a:ext cx="7653527" cy="4709160"/>
-          </a:xfrm>
-          <a:prstGeom prst="roundRect">
-            <a:avLst>
-              <a:gd name="adj" fmla="val 3000"/>
-            </a:avLst>
-          </a:prstGeom>
-          <a:solidFill>
-            <a:srgbClr val="FFFFFF"/>
-          </a:solidFill>
-          <a:ln w="12700">
-            <a:solidFill>
-              <a:srgbClr val="E6EBE8"/>
-            </a:solidFill>
-          </a:ln>
-          <a:effectLst/>
-        </p:spPr>
-        <p:style>
-          <a:lnRef idx="1">
-            <a:schemeClr val="accent1"/>
-          </a:lnRef>
-          <a:fillRef idx="3">
-            <a:schemeClr val="accent1"/>
-          </a:fillRef>
-          <a:effectRef idx="2">
-            <a:schemeClr val="accent1"/>
-          </a:effectRef>
-          <a:fontRef idx="minor">
-            <a:schemeClr val="lt1"/>
-          </a:fontRef>
-        </p:style>
-        <p:txBody>
-          <a:bodyPr rtlCol="0" anchor="ctr"/>
-          <a:lstStyle/>
-          <a:p>
-            <a:pPr algn="ctr"/>
-          </a:p>
-        </p:txBody>
-      </p:sp>
-      <p:sp>
-        <p:nvSpPr>
-          <p:cNvPr id="7" name="Rectangle 6"/>
-          <p:cNvSpPr/>
-          <p:nvPr/>
-        </p:nvSpPr>
-        <p:spPr>
-          <a:xfrm>
-            <a:off x="640080" y="6455664"/>
-            <a:ext cx="10908792" cy="9144"/>
-          </a:xfrm>
-          <a:prstGeom prst="rect">
-            <a:avLst/>
-          </a:prstGeom>
-          <a:solidFill>
-            <a:srgbClr val="E6EBE8"/>
-          </a:solidFill>
-          <a:ln>
-            <a:noFill/>
-          </a:ln>
-          <a:effectLst/>
-        </p:spPr>
-        <p:style>
-          <a:lnRef idx="1">
-            <a:schemeClr val="accent1"/>
-          </a:lnRef>
-          <a:fillRef idx="3">
-            <a:schemeClr val="accent1"/>
-          </a:fillRef>
-          <a:effectRef idx="2">
-            <a:schemeClr val="accent1"/>
-          </a:effectRef>
-          <a:fontRef idx="minor">
-            <a:schemeClr val="lt1"/>
-          </a:fontRef>
-        </p:style>
-        <p:txBody>
-          <a:bodyPr rtlCol="0" anchor="ctr"/>
-          <a:lstStyle/>
-          <a:p>
-            <a:pPr algn="ctr"/>
-          </a:p>
-        </p:txBody>
-      </p:sp>
-      <p:sp>
-        <p:nvSpPr>
-          <p:cNvPr id="8" name="TextBox 7"/>
-          <p:cNvSpPr txBox="1"/>
-          <p:nvPr/>
-        </p:nvSpPr>
-        <p:spPr>
-          <a:xfrm>
-            <a:off x="640080" y="6510528"/>
-            <a:ext cx="2743200" cy="274320"/>
-          </a:xfrm>
-          <a:prstGeom prst="rect">
-            <a:avLst/>
-          </a:prstGeom>
-          <a:noFill/>
-        </p:spPr>
-        <p:txBody>
-          <a:bodyPr wrap="square" anchor="t" lIns="0" rIns="0" tIns="0" bIns="0">
-            <a:spAutoFit/>
-          </a:bodyPr>
-          <a:lstStyle/>
-          <a:p>
-            <a:r>
-              <a:rPr sz="1100" b="1">
-                <a:solidFill>
-                  <a:srgbClr val="6B7B73"/>
-                </a:solidFill>
-                <a:latin typeface="Space Grotesk"/>
-              </a:rPr>
-              <a:t>want</a:t>
-            </a:r>
-            <a:r>
-              <a:rPr sz="1100" b="1">
-                <a:solidFill>
-                  <a:srgbClr val="1F7A57"/>
-                </a:solidFill>
-                <a:latin typeface="Space Grotesk"/>
-              </a:rPr>
-              <a:t>hat</a:t>
-            </a:r>
-          </a:p>
-        </p:txBody>
-      </p:sp>
-      <p:sp>
-        <p:nvSpPr>
-          <p:cNvPr id="9" name="TextBox 8"/>
-          <p:cNvSpPr txBox="1"/>
-          <p:nvPr/>
-        </p:nvSpPr>
-        <p:spPr>
-          <a:xfrm>
-            <a:off x="10607040" y="6510528"/>
-            <a:ext cx="941832" cy="274320"/>
-          </a:xfrm>
-          <a:prstGeom prst="rect">
-            <a:avLst/>
-          </a:prstGeom>
-          <a:noFill/>
-        </p:spPr>
-        <p:txBody>
-          <a:bodyPr wrap="square" anchor="t" lIns="0" rIns="0" tIns="0" bIns="0">
-            <a:spAutoFit/>
-          </a:bodyPr>
-          <a:lstStyle/>
-          <a:p>
-            <a:pPr algn="r"/>
-            <a:r>
-              <a:rPr sz="1000" b="0">
-                <a:solidFill>
-                  <a:srgbClr val="8A968F"/>
-                </a:solidFill>
-                <a:latin typeface="Space Mono"/>
-              </a:rPr>
-              <a:t>16</a:t>
-            </a:r>
-          </a:p>
-        </p:txBody>
-      </p:sp>
-      <p:sp>
-        <p:nvSpPr>
-          <p:cNvPr id="10" name="TextBox 9"/>
-          <p:cNvSpPr txBox="1"/>
-          <p:nvPr/>
-        </p:nvSpPr>
-        <p:spPr>
-          <a:xfrm>
-            <a:off x="658368" y="1783080"/>
-            <a:ext cx="3063240" cy="4480560"/>
-          </a:xfrm>
-          <a:prstGeom prst="rect">
-            <a:avLst/>
-          </a:prstGeom>
-          <a:noFill/>
-        </p:spPr>
-        <p:txBody>
-          <a:bodyPr wrap="square">
-            <a:spAutoFit/>
-          </a:bodyPr>
-          <a:lstStyle/>
-          <a:p>
-            <a:r>
-              <a:rPr sz="1200" b="0">
-                <a:solidFill>
-                  <a:srgbClr val="15201C"/>
-                </a:solidFill>
-                <a:latin typeface="Hanken Grotesk"/>
-              </a:rPr>
-              <a:t>-  Observability.</a:t>
-            </a:r>
-          </a:p>
-          <a:p>
-            <a:r>
-              <a:rPr sz="1200" b="0">
-                <a:solidFill>
-                  <a:srgbClr val="15201C"/>
-                </a:solidFill>
-                <a:latin typeface="Hanken Grotesk"/>
-              </a:rPr>
-              <a:t>-  Guest attribution within the affiliation window.</a:t>
-            </a:r>
-          </a:p>
-          <a:p>
-            <a:r>
-              <a:rPr sz="1200" b="0">
-                <a:solidFill>
-                  <a:srgbClr val="15201C"/>
-                </a:solidFill>
-                <a:latin typeface="Hanken Grotesk"/>
-              </a:rPr>
-              <a:t>-  Manual attribution of unattributed settlements.</a:t>
-            </a:r>
-          </a:p>
-          <a:p>
-            <a:r>
-              <a:rPr sz="1200" b="0">
-                <a:solidFill>
-                  <a:srgbClr val="15201C"/>
-                </a:solidFill>
-                <a:latin typeface="Hanken Grotesk"/>
-              </a:rPr>
-              <a:t>-  Ops counters for real-time admin stats.</a:t>
-            </a:r>
-          </a:p>
-          <a:p>
-            <a:r>
-              <a:rPr sz="1200" b="0">
-                <a:solidFill>
-                  <a:srgbClr val="15201C"/>
-                </a:solidFill>
-                <a:latin typeface="Hanken Grotesk"/>
-              </a:rPr>
-              <a:t>-  Offline analytics.</a:t>
-            </a:r>
-          </a:p>
-        </p:txBody>
-      </p:sp>
+      <p:pic>
+        <p:nvPicPr>
+          <p:cNvPr id="2" name="Picture 1" descr="page-16.jpg"/>
+          <p:cNvPicPr>
+            <a:picLocks noChangeAspect="1"/>
+          </p:cNvPicPr>
+          <p:nvPr/>
+        </p:nvPicPr>
+        <p:blipFill>
+          <a:blip r:embed="rId4"/>
+          <a:stretch>
+            <a:fillRect/>
+          </a:stretch>
+        </p:blipFill>
+        <p:spPr>
+          <a:xfrm>
+            <a:off x="0" y="0"/>
+            <a:ext cx="12191695" cy="6858000"/>
+          </a:xfrm>
+          <a:prstGeom prst="rect">
+            <a:avLst/>
+          </a:prstGeom>
+        </p:spPr>
+      </p:pic>
     </p:spTree>
   </p:cSld>
   <p:clrMapOvr>
@@ -27185,7 +25061,7 @@
         </p:nvSpPr>
         <p:spPr>
           <a:xfrm>
-            <a:off x="658368" y="1691640"/>
+            <a:off x="658368" y="4050792"/>
             <a:ext cx="3520440" cy="2240280"/>
           </a:xfrm>
           <a:prstGeom prst="roundRect">
@@ -27233,7 +25109,7 @@
         </p:nvSpPr>
         <p:spPr>
           <a:xfrm>
-            <a:off x="841248" y="1874520"/>
+            <a:off x="841248" y="4233672"/>
             <a:ext cx="475488" cy="475488"/>
           </a:xfrm>
           <a:prstGeom prst="roundRect">
@@ -27289,7 +25165,7 @@
         </p:blipFill>
         <p:spPr>
           <a:xfrm>
-            <a:off x="905256" y="1943100"/>
+            <a:off x="905256" y="4302252"/>
             <a:ext cx="338328" cy="338328"/>
           </a:xfrm>
           <a:prstGeom prst="rect">
@@ -27305,7 +25181,7 @@
         </p:nvSpPr>
         <p:spPr>
           <a:xfrm>
-            <a:off x="1435608" y="1929384"/>
+            <a:off x="1435608" y="4288536"/>
             <a:ext cx="2560320" cy="457200"/>
           </a:xfrm>
           <a:prstGeom prst="rect">
@@ -27344,7 +25220,7 @@
         </p:nvSpPr>
         <p:spPr>
           <a:xfrm>
-            <a:off x="841248" y="2468880"/>
+            <a:off x="841248" y="4828032"/>
             <a:ext cx="3154680" cy="1371600"/>
           </a:xfrm>
           <a:prstGeom prst="rect">
@@ -27383,7 +25259,7 @@
         </p:nvSpPr>
         <p:spPr>
           <a:xfrm>
-            <a:off x="4343400" y="1691640"/>
+            <a:off x="4343400" y="4050792"/>
             <a:ext cx="3520440" cy="2240280"/>
           </a:xfrm>
           <a:prstGeom prst="roundRect">
@@ -27431,7 +25307,7 @@
         </p:nvSpPr>
         <p:spPr>
           <a:xfrm>
-            <a:off x="4526280" y="1874520"/>
+            <a:off x="4526280" y="4233672"/>
             <a:ext cx="475488" cy="475488"/>
           </a:xfrm>
           <a:prstGeom prst="roundRect">
@@ -27487,7 +25363,7 @@
         </p:blipFill>
         <p:spPr>
           <a:xfrm>
-            <a:off x="4590288" y="1943100"/>
+            <a:off x="4590288" y="4302252"/>
             <a:ext cx="338328" cy="338328"/>
           </a:xfrm>
           <a:prstGeom prst="rect">
@@ -27503,7 +25379,7 @@
         </p:nvSpPr>
         <p:spPr>
           <a:xfrm>
-            <a:off x="5120640" y="1929384"/>
+            <a:off x="5120640" y="4288536"/>
             <a:ext cx="2560320" cy="457200"/>
           </a:xfrm>
           <a:prstGeom prst="rect">
@@ -27542,7 +25418,7 @@
         </p:nvSpPr>
         <p:spPr>
           <a:xfrm>
-            <a:off x="4526280" y="2468880"/>
+            <a:off x="4526280" y="4828032"/>
             <a:ext cx="3154680" cy="1371600"/>
           </a:xfrm>
           <a:prstGeom prst="rect">
@@ -27581,7 +25457,7 @@
         </p:nvSpPr>
         <p:spPr>
           <a:xfrm>
-            <a:off x="8028432" y="1691640"/>
+            <a:off x="8028432" y="4050792"/>
             <a:ext cx="3520440" cy="2240280"/>
           </a:xfrm>
           <a:prstGeom prst="roundRect">
@@ -27629,7 +25505,7 @@
         </p:nvSpPr>
         <p:spPr>
           <a:xfrm>
-            <a:off x="8211312" y="1874520"/>
+            <a:off x="8211312" y="4233672"/>
             <a:ext cx="475488" cy="475488"/>
           </a:xfrm>
           <a:prstGeom prst="roundRect">
@@ -27685,7 +25561,7 @@
         </p:blipFill>
         <p:spPr>
           <a:xfrm>
-            <a:off x="8275320" y="1943100"/>
+            <a:off x="8275320" y="4302252"/>
             <a:ext cx="338328" cy="338328"/>
           </a:xfrm>
           <a:prstGeom prst="rect">
@@ -27701,7 +25577,7 @@
         </p:nvSpPr>
         <p:spPr>
           <a:xfrm>
-            <a:off x="8805672" y="1929384"/>
+            <a:off x="8805672" y="4288536"/>
             <a:ext cx="2560320" cy="457200"/>
           </a:xfrm>
           <a:prstGeom prst="rect">
@@ -27740,7 +25616,7 @@
         </p:nvSpPr>
         <p:spPr>
           <a:xfrm>
-            <a:off x="8211312" y="2468880"/>
+            <a:off x="8211312" y="4828032"/>
             <a:ext cx="3154680" cy="1371600"/>
           </a:xfrm>
           <a:prstGeom prst="rect">
@@ -27779,7 +25655,7 @@
         </p:nvSpPr>
         <p:spPr>
           <a:xfrm>
-            <a:off x="658368" y="4050792"/>
+            <a:off x="658368" y="1691640"/>
             <a:ext cx="3520440" cy="2240280"/>
           </a:xfrm>
           <a:prstGeom prst="roundRect">
@@ -27827,7 +25703,7 @@
         </p:nvSpPr>
         <p:spPr>
           <a:xfrm>
-            <a:off x="841248" y="4233672"/>
+            <a:off x="841248" y="1874520"/>
             <a:ext cx="475488" cy="475488"/>
           </a:xfrm>
           <a:prstGeom prst="roundRect">
@@ -27883,7 +25759,7 @@
         </p:blipFill>
         <p:spPr>
           <a:xfrm>
-            <a:off x="905256" y="4302252"/>
+            <a:off x="905256" y="1943100"/>
             <a:ext cx="338328" cy="338328"/>
           </a:xfrm>
           <a:prstGeom prst="rect">
@@ -27899,7 +25775,7 @@
         </p:nvSpPr>
         <p:spPr>
           <a:xfrm>
-            <a:off x="1435608" y="4288536"/>
+            <a:off x="1435608" y="1929384"/>
             <a:ext cx="2560320" cy="457200"/>
           </a:xfrm>
           <a:prstGeom prst="rect">
@@ -27938,7 +25814,7 @@
         </p:nvSpPr>
         <p:spPr>
           <a:xfrm>
-            <a:off x="841248" y="4828032"/>
+            <a:off x="841248" y="2468880"/>
             <a:ext cx="3154680" cy="1371600"/>
           </a:xfrm>
           <a:prstGeom prst="rect">
@@ -27977,7 +25853,7 @@
         </p:nvSpPr>
         <p:spPr>
           <a:xfrm>
-            <a:off x="4343400" y="4050792"/>
+            <a:off x="4343400" y="1691640"/>
             <a:ext cx="3520440" cy="2240280"/>
           </a:xfrm>
           <a:prstGeom prst="roundRect">
@@ -28025,7 +25901,7 @@
         </p:nvSpPr>
         <p:spPr>
           <a:xfrm>
-            <a:off x="4526280" y="4233672"/>
+            <a:off x="4526280" y="1874520"/>
             <a:ext cx="475488" cy="475488"/>
           </a:xfrm>
           <a:prstGeom prst="roundRect">
@@ -28081,7 +25957,7 @@
         </p:blipFill>
         <p:spPr>
           <a:xfrm>
-            <a:off x="4590288" y="4302252"/>
+            <a:off x="4590288" y="1943100"/>
             <a:ext cx="338328" cy="338328"/>
           </a:xfrm>
           <a:prstGeom prst="rect">
@@ -28097,7 +25973,7 @@
         </p:nvSpPr>
         <p:spPr>
           <a:xfrm>
-            <a:off x="5120640" y="4288536"/>
+            <a:off x="5120640" y="1929384"/>
             <a:ext cx="2560320" cy="457200"/>
           </a:xfrm>
           <a:prstGeom prst="rect">
@@ -28136,7 +26012,7 @@
         </p:nvSpPr>
         <p:spPr>
           <a:xfrm>
-            <a:off x="4526280" y="4828032"/>
+            <a:off x="4526280" y="2468880"/>
             <a:ext cx="3154680" cy="1371600"/>
           </a:xfrm>
           <a:prstGeom prst="rect">
@@ -28162,7 +26038,7 @@
                 </a:solidFill>
                 <a:latin typeface="Hanken Grotesk"/>
               </a:rPr>
-              <a:t>A link going viral in a WhatsApp group is the design spike.</a:t>
+              <a:t>A link going viral in a WhatsApp group is the potential spike.</a:t>
             </a:r>
           </a:p>
         </p:txBody>
@@ -28297,7 +26173,7 @@
         </p:nvSpPr>
         <p:spPr>
           <a:xfrm>
-            <a:off x="8028432" y="4050792"/>
+            <a:off x="8028432" y="1691640"/>
             <a:ext cx="3520440" cy="2240280"/>
           </a:xfrm>
           <a:prstGeom prst="roundRect">
@@ -28345,7 +26221,7 @@
         </p:nvSpPr>
         <p:spPr>
           <a:xfrm>
-            <a:off x="8211312" y="4233672"/>
+            <a:off x="8211312" y="1874520"/>
             <a:ext cx="475488" cy="475488"/>
           </a:xfrm>
           <a:prstGeom prst="roundRect">
@@ -28393,7 +26269,7 @@
         </p:nvSpPr>
         <p:spPr>
           <a:xfrm>
-            <a:off x="8805672" y="4288536"/>
+            <a:off x="8805672" y="1929384"/>
             <a:ext cx="2560320" cy="457200"/>
           </a:xfrm>
           <a:prstGeom prst="rect">
@@ -28432,7 +26308,7 @@
         </p:nvSpPr>
         <p:spPr>
           <a:xfrm>
-            <a:off x="8211312" y="4828032"/>
+            <a:off x="8211312" y="2468880"/>
             <a:ext cx="3154680" cy="1371600"/>
           </a:xfrm>
           <a:prstGeom prst="rect">
@@ -28458,7 +26334,7 @@
                 </a:solidFill>
                 <a:latin typeface="Hanken Grotesk"/>
               </a:rPr>
-              <a:t>Least privilege per function — IAM + one Postgres role each; money is append-only + audited; PII isolated in Cognito; workers never HTTP-exposed.</a:t>
+              <a:t>The entire framework is about money movement. Apply least privilege access, MFA, data integrity provability, isolation of concerns, strict auditing and other security principles.</a:t>
             </a:r>
           </a:p>
         </p:txBody>
@@ -28479,7 +26355,7 @@
         </p:blipFill>
         <p:spPr>
           <a:xfrm>
-            <a:off x="8275320" y="4302252"/>
+            <a:off x="8275320" y="1943100"/>
             <a:ext cx="338328" cy="338328"/>
           </a:xfrm>
           <a:prstGeom prst="rect">
@@ -28505,337 +26381,30 @@
         <p:nvPr/>
       </p:nvGrpSpPr>
       <p:grpSpPr/>
-      <p:sp>
-        <p:nvSpPr>
-          <p:cNvPr id="2" name="TextBox 1"/>
-          <p:cNvSpPr txBox="1"/>
-          <p:nvPr/>
-        </p:nvSpPr>
-        <p:spPr>
-          <a:xfrm>
-            <a:off x="10195560" y="256032"/>
-            <a:ext cx="1371600" cy="1005840"/>
-          </a:xfrm>
-          <a:prstGeom prst="rect">
-            <a:avLst/>
-          </a:prstGeom>
-          <a:noFill/>
-        </p:spPr>
-        <p:txBody>
-          <a:bodyPr wrap="square" anchor="t" lIns="0" rIns="0" tIns="0" bIns="0">
-            <a:spAutoFit/>
-          </a:bodyPr>
-          <a:lstStyle/>
-          <a:p>
-            <a:pPr algn="r"/>
-            <a:r>
-              <a:rPr sz="4600" b="1">
-                <a:solidFill>
-                  <a:srgbClr val="DCE5E0"/>
-                </a:solidFill>
-                <a:latin typeface="Space Grotesk"/>
-              </a:rPr>
-              <a:t>07</a:t>
-            </a:r>
-          </a:p>
-        </p:txBody>
-      </p:sp>
-      <p:sp>
-        <p:nvSpPr>
-          <p:cNvPr id="3" name="TextBox 2"/>
-          <p:cNvSpPr txBox="1"/>
-          <p:nvPr/>
-        </p:nvSpPr>
-        <p:spPr>
-          <a:xfrm>
-            <a:off x="640080" y="420624"/>
-            <a:ext cx="9418320" cy="292608"/>
-          </a:xfrm>
-          <a:prstGeom prst="rect">
-            <a:avLst/>
-          </a:prstGeom>
-          <a:noFill/>
-        </p:spPr>
-        <p:txBody>
-          <a:bodyPr wrap="square" anchor="t" lIns="0" rIns="0" tIns="0" bIns="0">
-            <a:spAutoFit/>
-          </a:bodyPr>
-          <a:lstStyle/>
-          <a:p>
-            <a:r>
-              <a:rPr sz="1150" b="1">
-                <a:solidFill>
-                  <a:srgbClr val="1F7A57"/>
-                </a:solidFill>
-                <a:latin typeface="Space Mono"/>
-              </a:rPr>
-              <a:t>ENGINEERING</a:t>
-            </a:r>
-          </a:p>
-        </p:txBody>
-      </p:sp>
-      <p:sp>
-        <p:nvSpPr>
-          <p:cNvPr id="4" name="TextBox 3"/>
-          <p:cNvSpPr txBox="1"/>
-          <p:nvPr/>
-        </p:nvSpPr>
-        <p:spPr>
-          <a:xfrm>
-            <a:off x="621792" y="731520"/>
-            <a:ext cx="9509760" cy="868680"/>
-          </a:xfrm>
-          <a:prstGeom prst="rect">
-            <a:avLst/>
-          </a:prstGeom>
-          <a:noFill/>
-        </p:spPr>
-        <p:txBody>
-          <a:bodyPr wrap="square" anchor="t" lIns="0" rIns="0" tIns="0" bIns="0">
-            <a:spAutoFit/>
-          </a:bodyPr>
-          <a:lstStyle/>
-          <a:p>
-            <a:r>
-              <a:rPr sz="2500" b="1">
-                <a:solidFill>
-                  <a:srgbClr val="15201C"/>
-                </a:solidFill>
-                <a:latin typeface="Space Grotesk"/>
-              </a:rPr>
-              <a:t>Data model — three homes, one key</a:t>
-            </a:r>
-          </a:p>
-        </p:txBody>
-      </p:sp>
-      <p:sp>
-        <p:nvSpPr>
-          <p:cNvPr id="5" name="Rounded Rectangle 4"/>
-          <p:cNvSpPr/>
-          <p:nvPr/>
-        </p:nvSpPr>
-        <p:spPr>
-          <a:xfrm>
-            <a:off x="1344168" y="1481328"/>
-            <a:ext cx="9509760" cy="4206240"/>
-          </a:xfrm>
-          <a:prstGeom prst="roundRect">
-            <a:avLst>
-              <a:gd name="adj" fmla="val 3000"/>
-            </a:avLst>
-          </a:prstGeom>
-          <a:solidFill>
-            <a:srgbClr val="FFFFFF"/>
-          </a:solidFill>
-          <a:ln w="12700">
-            <a:solidFill>
-              <a:srgbClr val="E6EBE8"/>
-            </a:solidFill>
-          </a:ln>
-          <a:effectLst/>
-        </p:spPr>
-        <p:style>
-          <a:lnRef idx="1">
-            <a:schemeClr val="accent1"/>
-          </a:lnRef>
-          <a:fillRef idx="3">
-            <a:schemeClr val="accent1"/>
-          </a:fillRef>
-          <a:effectRef idx="2">
-            <a:schemeClr val="accent1"/>
-          </a:effectRef>
-          <a:fontRef idx="minor">
-            <a:schemeClr val="lt1"/>
-          </a:fontRef>
-        </p:style>
-        <p:txBody>
-          <a:bodyPr rtlCol="0" anchor="ctr"/>
-          <a:lstStyle/>
-          <a:p>
-            <a:pPr algn="ctr"/>
-          </a:p>
-        </p:txBody>
-      </p:sp>
-      <p:sp>
-        <p:nvSpPr>
-          <p:cNvPr id="7" name="Rectangle 6"/>
-          <p:cNvSpPr/>
-          <p:nvPr/>
-        </p:nvSpPr>
-        <p:spPr>
-          <a:xfrm>
-            <a:off x="640080" y="6455664"/>
-            <a:ext cx="10908792" cy="9144"/>
-          </a:xfrm>
-          <a:prstGeom prst="rect">
-            <a:avLst/>
-          </a:prstGeom>
-          <a:solidFill>
-            <a:srgbClr val="E6EBE8"/>
-          </a:solidFill>
-          <a:ln>
-            <a:noFill/>
-          </a:ln>
-          <a:effectLst/>
-        </p:spPr>
-        <p:style>
-          <a:lnRef idx="1">
-            <a:schemeClr val="accent1"/>
-          </a:lnRef>
-          <a:fillRef idx="3">
-            <a:schemeClr val="accent1"/>
-          </a:fillRef>
-          <a:effectRef idx="2">
-            <a:schemeClr val="accent1"/>
-          </a:effectRef>
-          <a:fontRef idx="minor">
-            <a:schemeClr val="lt1"/>
-          </a:fontRef>
-        </p:style>
-        <p:txBody>
-          <a:bodyPr rtlCol="0" anchor="ctr"/>
-          <a:lstStyle/>
-          <a:p>
-            <a:pPr algn="ctr"/>
-          </a:p>
-        </p:txBody>
-      </p:sp>
-      <p:sp>
-        <p:nvSpPr>
-          <p:cNvPr id="8" name="TextBox 7"/>
-          <p:cNvSpPr txBox="1"/>
-          <p:nvPr/>
-        </p:nvSpPr>
-        <p:spPr>
-          <a:xfrm>
-            <a:off x="640080" y="6510528"/>
-            <a:ext cx="2743200" cy="274320"/>
-          </a:xfrm>
-          <a:prstGeom prst="rect">
-            <a:avLst/>
-          </a:prstGeom>
-          <a:noFill/>
-        </p:spPr>
-        <p:txBody>
-          <a:bodyPr wrap="square" anchor="t" lIns="0" rIns="0" tIns="0" bIns="0">
-            <a:spAutoFit/>
-          </a:bodyPr>
-          <a:lstStyle/>
-          <a:p>
-            <a:r>
-              <a:rPr sz="1100" b="1">
-                <a:solidFill>
-                  <a:srgbClr val="6B7B73"/>
-                </a:solidFill>
-                <a:latin typeface="Space Grotesk"/>
-              </a:rPr>
-              <a:t>want</a:t>
-            </a:r>
-            <a:r>
-              <a:rPr sz="1100" b="1">
-                <a:solidFill>
-                  <a:srgbClr val="1F7A57"/>
-                </a:solidFill>
-                <a:latin typeface="Space Grotesk"/>
-              </a:rPr>
-              <a:t>hat</a:t>
-            </a:r>
-          </a:p>
-        </p:txBody>
-      </p:sp>
-      <p:sp>
-        <p:nvSpPr>
-          <p:cNvPr id="9" name="TextBox 8"/>
-          <p:cNvSpPr txBox="1"/>
-          <p:nvPr/>
-        </p:nvSpPr>
-        <p:spPr>
-          <a:xfrm>
-            <a:off x="10607040" y="6510528"/>
-            <a:ext cx="941832" cy="274320"/>
-          </a:xfrm>
-          <a:prstGeom prst="rect">
-            <a:avLst/>
-          </a:prstGeom>
-          <a:noFill/>
-        </p:spPr>
-        <p:txBody>
-          <a:bodyPr wrap="square" anchor="t" lIns="0" rIns="0" tIns="0" bIns="0">
-            <a:spAutoFit/>
-          </a:bodyPr>
-          <a:lstStyle/>
-          <a:p>
-            <a:pPr algn="r"/>
-            <a:r>
-              <a:rPr sz="1000" b="0">
-                <a:solidFill>
-                  <a:srgbClr val="8A968F"/>
-                </a:solidFill>
-                <a:latin typeface="Space Mono"/>
-              </a:rPr>
-              <a:t>7</a:t>
-            </a:r>
-          </a:p>
-        </p:txBody>
-      </p:sp>
       <p:pic>
         <p:nvPicPr>
-          <p:cNvPr id="10" name="Picture 9" descr="slide-7.png"/>
+          <p:cNvPr id="2" name="Picture 1" descr="page-07.png"/>
           <p:cNvPicPr>
             <a:picLocks noChangeAspect="1"/>
           </p:cNvPicPr>
           <p:nvPr/>
         </p:nvPicPr>
         <p:blipFill>
-          <a:blip r:embed="rId3"/>
+          <a:blip r:embed="rId5"/>
           <a:stretch>
             <a:fillRect/>
           </a:stretch>
         </p:blipFill>
         <p:spPr>
           <a:xfrm>
-            <a:off x="1527048" y="2221857"/>
-            <a:ext cx="9144000" cy="2725182"/>
+            <a:off x="0" y="0"/>
+            <a:ext cx="12191695" cy="6858000"/>
           </a:xfrm>
           <a:prstGeom prst="rect">
             <a:avLst/>
           </a:prstGeom>
         </p:spPr>
       </p:pic>
-      <p:sp>
-        <p:nvSpPr>
-          <p:cNvPr id="11" name="TextBox 10"/>
-          <p:cNvSpPr txBox="1"/>
-          <p:nvPr/>
-        </p:nvSpPr>
-        <p:spPr>
-          <a:xfrm>
-            <a:off x="658368" y="5760720"/>
-            <a:ext cx="10881360" cy="640080"/>
-          </a:xfrm>
-          <a:prstGeom prst="rect">
-            <a:avLst/>
-          </a:prstGeom>
-          <a:noFill/>
-        </p:spPr>
-        <p:txBody>
-          <a:bodyPr wrap="square">
-            <a:spAutoFit/>
-          </a:bodyPr>
-          <a:lstStyle/>
-          <a:p>
-            <a:r>
-              <a:rPr sz="1200">
-                <a:solidFill>
-                  <a:srgbClr val="6B7B73"/>
-                </a:solidFill>
-                <a:latin typeface="Hanken Grotesk"/>
-              </a:rPr>
-              <a:t>References across stores are soft — keys plus idempotency, never foreign keys or cross-store transactions. The Cognito sub ties PII, links and money together.</a:t>
-            </a:r>
-          </a:p>
-        </p:txBody>
-      </p:sp>
     </p:spTree>
   </p:cSld>
   <p:clrMapOvr>
@@ -28995,11 +26564,6 @@
                     <a:bodyPr/>
                     <a:lstStyle/>
                     <a:p>
-                      <a:pPr>
-                        <a:lnSpc>
-                          <a:spcPct val="108000"/>
-                        </a:lnSpc>
-                      </a:pPr>
                       <a:r>
                         <a:rPr sz="1100" b="1">
                           <a:solidFill>
@@ -29022,11 +26586,6 @@
                     <a:bodyPr/>
                     <a:lstStyle/>
                     <a:p>
-                      <a:pPr>
-                        <a:lnSpc>
-                          <a:spcPct val="108000"/>
-                        </a:lnSpc>
-                      </a:pPr>
                       <a:r>
                         <a:rPr sz="1100" b="1">
                           <a:solidFill>
@@ -29049,11 +26608,6 @@
                     <a:bodyPr/>
                     <a:lstStyle/>
                     <a:p>
-                      <a:pPr>
-                        <a:lnSpc>
-                          <a:spcPct val="108000"/>
-                        </a:lnSpc>
-                      </a:pPr>
                       <a:r>
                         <a:rPr sz="1100" b="1">
                           <a:solidFill>
@@ -29076,11 +26630,6 @@
                     <a:bodyPr/>
                     <a:lstStyle/>
                     <a:p>
-                      <a:pPr>
-                        <a:lnSpc>
-                          <a:spcPct val="108000"/>
-                        </a:lnSpc>
-                      </a:pPr>
                       <a:r>
                         <a:rPr sz="1100" b="1">
                           <a:solidFill>
@@ -29105,19 +26654,14 @@
                     <a:bodyPr/>
                     <a:lstStyle/>
                     <a:p>
-                      <a:pPr>
-                        <a:lnSpc>
-                          <a:spcPct val="108000"/>
-                        </a:lnSpc>
-                      </a:pPr>
                       <a:r>
-                        <a:rPr sz="1050" b="1">
+                        <a:rPr sz="1000" b="1">
                           <a:solidFill>
                             <a:srgbClr val="15201C"/>
                           </a:solidFill>
                           <a:latin typeface="Hanken Grotesk"/>
                         </a:rPr>
-                        <a:t>Money</a:t>
+                        <a:t>Money + Audit Log</a:t>
                       </a:r>
                     </a:p>
                   </a:txBody>
@@ -29132,15 +26676,10 @@
                     <a:bodyPr/>
                     <a:lstStyle/>
                     <a:p>
-                      <a:pPr>
-                        <a:lnSpc>
-                          <a:spcPct val="108000"/>
-                        </a:lnSpc>
-                      </a:pPr>
                       <a:r>
-                        <a:rPr sz="1050" b="0">
+                        <a:rPr sz="1000" b="0">
                           <a:solidFill>
-                            <a:srgbClr val="6B7B73"/>
+                            <a:srgbClr val="15201C"/>
                           </a:solidFill>
                           <a:latin typeface="Hanken Grotesk"/>
                         </a:rPr>
@@ -29159,19 +26698,14 @@
                     <a:bodyPr/>
                     <a:lstStyle/>
                     <a:p>
-                      <a:pPr>
-                        <a:lnSpc>
-                          <a:spcPct val="108000"/>
-                        </a:lnSpc>
-                      </a:pPr>
                       <a:r>
-                        <a:rPr sz="1050" b="0">
+                        <a:rPr sz="1000" b="0">
                           <a:solidFill>
-                            <a:srgbClr val="6B7B73"/>
+                            <a:srgbClr val="15201C"/>
                           </a:solidFill>
                           <a:latin typeface="Hanken Grotesk"/>
                         </a:rPr>
-                        <a:t>ACID + Postgres GRANTs as the money invariant (one role per function: wallet_reader / ledger_reader SELECT-only, ledger_writer INSERT-only, audit_writer = audit_append only); SQL for reconciliation</a:t>
+                        <a:t>ACID; permissions enforced on DB level (GRANTs); storing the audit log with hashed chains</a:t>
                       </a:r>
                     </a:p>
                   </a:txBody>
@@ -29186,19 +26720,14 @@
                     <a:bodyPr/>
                     <a:lstStyle/>
                     <a:p>
-                      <a:pPr>
-                        <a:lnSpc>
-                          <a:spcPct val="108000"/>
-                        </a:lnSpc>
-                      </a:pPr>
                       <a:r>
-                        <a:rPr sz="1050" b="0">
+                        <a:rPr sz="1000" b="0">
                           <a:solidFill>
-                            <a:srgbClr val="6B7B73"/>
+                            <a:srgbClr val="15201C"/>
                           </a:solidFill>
                           <a:latin typeface="Hanken Grotesk"/>
                         </a:rPr>
-                        <a:t>Scale-to-zero cold resume ~20 s (60 s connect timeout + SPA warm-up probe); 50-connection cap</a:t>
+                        <a:t>Scale-to-zero cold resume ~20 s (60 s connect timeout + SPA warm-up probe); 50-connection cap. Possible simple workaround — cached last known totals (display while reloading) per user on SPA or backend</a:t>
                       </a:r>
                     </a:p>
                   </a:txBody>
@@ -29215,13 +26744,8 @@
                     <a:bodyPr/>
                     <a:lstStyle/>
                     <a:p>
-                      <a:pPr>
-                        <a:lnSpc>
-                          <a:spcPct val="108000"/>
-                        </a:lnSpc>
-                      </a:pPr>
                       <a:r>
-                        <a:rPr sz="1050" b="1">
+                        <a:rPr sz="1000" b="1">
                           <a:solidFill>
                             <a:srgbClr val="15201C"/>
                           </a:solidFill>
@@ -29242,15 +26766,10 @@
                     <a:bodyPr/>
                     <a:lstStyle/>
                     <a:p>
-                      <a:pPr>
-                        <a:lnSpc>
-                          <a:spcPct val="108000"/>
-                        </a:lnSpc>
-                      </a:pPr>
                       <a:r>
-                        <a:rPr sz="1050" b="0">
+                        <a:rPr sz="1000" b="0">
                           <a:solidFill>
-                            <a:srgbClr val="6B7B73"/>
+                            <a:srgbClr val="15201C"/>
                           </a:solidFill>
                           <a:latin typeface="Hanken Grotesk"/>
                         </a:rPr>
@@ -29269,19 +26788,14 @@
                     <a:bodyPr/>
                     <a:lstStyle/>
                     <a:p>
-                      <a:pPr>
-                        <a:lnSpc>
-                          <a:spcPct val="108000"/>
-                        </a:lnSpc>
-                      </a:pPr>
                       <a:r>
-                        <a:rPr sz="1050" b="0">
+                        <a:rPr sz="1000" b="0">
                           <a:solidFill>
-                            <a:srgbClr val="6B7B73"/>
+                            <a:srgbClr val="15201C"/>
                           </a:solidFill>
                           <a:latin typeface="Hanken Grotesk"/>
                         </a:rPr>
-                        <a:t>Auth path touches zero databases; GDPR delete = one call; backups carry no PII</a:t>
+                        <a:t>Auth path touches zero databases; GDPR delete = one call; the only backup carrying PII is the Cognito backup</a:t>
                       </a:r>
                     </a:p>
                   </a:txBody>
@@ -29296,19 +26810,14 @@
                     <a:bodyPr/>
                     <a:lstStyle/>
                     <a:p>
-                      <a:pPr>
-                        <a:lnSpc>
-                          <a:spcPct val="108000"/>
-                        </a:lnSpc>
-                      </a:pPr>
                       <a:r>
-                        <a:rPr sz="1050" b="0">
+                        <a:rPr sz="1000" b="0">
                           <a:solidFill>
-                            <a:srgbClr val="6B7B73"/>
+                            <a:srgbClr val="15201C"/>
                           </a:solidFill>
                           <a:latin typeface="Hanken Grotesk"/>
                         </a:rPr>
-                        <a:t>ListUsers-only queries (no joins, one filter); no PITR; no attribute history. Escape hatch: dual-write projection</a:t>
+                        <a:t>ListUsers-only queries (no joins, one filter); no PITR; no attribute history</a:t>
                       </a:r>
                     </a:p>
                   </a:txBody>
@@ -29325,13 +26834,8 @@
                     <a:bodyPr/>
                     <a:lstStyle/>
                     <a:p>
-                      <a:pPr>
-                        <a:lnSpc>
-                          <a:spcPct val="108000"/>
-                        </a:lnSpc>
-                      </a:pPr>
                       <a:r>
-                        <a:rPr sz="1050" b="1">
+                        <a:rPr sz="1000" b="1">
                           <a:solidFill>
                             <a:srgbClr val="15201C"/>
                           </a:solidFill>
@@ -29352,15 +26856,10 @@
                     <a:bodyPr/>
                     <a:lstStyle/>
                     <a:p>
-                      <a:pPr>
-                        <a:lnSpc>
-                          <a:spcPct val="108000"/>
-                        </a:lnSpc>
-                      </a:pPr>
                       <a:r>
-                        <a:rPr sz="1050" b="0">
+                        <a:rPr sz="1000" b="0">
                           <a:solidFill>
-                            <a:srgbClr val="6B7B73"/>
+                            <a:srgbClr val="15201C"/>
                           </a:solidFill>
                           <a:latin typeface="Hanken Grotesk"/>
                         </a:rPr>
@@ -29379,15 +26878,10 @@
                     <a:bodyPr/>
                     <a:lstStyle/>
                     <a:p>
-                      <a:pPr>
-                        <a:lnSpc>
-                          <a:spcPct val="108000"/>
-                        </a:lnSpc>
-                      </a:pPr>
                       <a:r>
-                        <a:rPr sz="1050" b="0">
+                        <a:rPr sz="1000" b="0">
                           <a:solidFill>
-                            <a:srgbClr val="6B7B73"/>
+                            <a:srgbClr val="15201C"/>
                           </a:solidFill>
                           <a:latin typeface="Hanken Grotesk"/>
                         </a:rPr>
@@ -29406,15 +26900,10 @@
                     <a:bodyPr/>
                     <a:lstStyle/>
                     <a:p>
-                      <a:pPr>
-                        <a:lnSpc>
-                          <a:spcPct val="108000"/>
-                        </a:lnSpc>
-                      </a:pPr>
                       <a:r>
-                        <a:rPr sz="1050" b="0">
+                        <a:rPr sz="1000" b="0">
                           <a:solidFill>
-                            <a:srgbClr val="6B7B73"/>
+                            <a:srgbClr val="15201C"/>
                           </a:solidFill>
                           <a:latin typeface="Hanken Grotesk"/>
                         </a:rPr>
@@ -29629,313 +27118,30 @@
         <p:nvPr/>
       </p:nvGrpSpPr>
       <p:grpSpPr/>
-      <p:sp>
-        <p:nvSpPr>
-          <p:cNvPr id="2" name="TextBox 1"/>
-          <p:cNvSpPr txBox="1"/>
-          <p:nvPr/>
-        </p:nvSpPr>
-        <p:spPr>
-          <a:xfrm>
-            <a:off x="10195560" y="256032"/>
-            <a:ext cx="1371600" cy="1005840"/>
-          </a:xfrm>
-          <a:prstGeom prst="rect">
-            <a:avLst/>
-          </a:prstGeom>
-          <a:noFill/>
-        </p:spPr>
-        <p:txBody>
-          <a:bodyPr wrap="square" anchor="t" lIns="0" rIns="0" tIns="0" bIns="0">
-            <a:spAutoFit/>
-          </a:bodyPr>
-          <a:lstStyle/>
-          <a:p>
-            <a:pPr algn="r"/>
-            <a:r>
-              <a:rPr sz="4600" b="1">
-                <a:solidFill>
-                  <a:srgbClr val="DCE5E0"/>
-                </a:solidFill>
-                <a:latin typeface="Space Grotesk"/>
-              </a:rPr>
-              <a:t>09</a:t>
-            </a:r>
-          </a:p>
-        </p:txBody>
-      </p:sp>
-      <p:sp>
-        <p:nvSpPr>
-          <p:cNvPr id="3" name="TextBox 2"/>
-          <p:cNvSpPr txBox="1"/>
-          <p:nvPr/>
-        </p:nvSpPr>
-        <p:spPr>
-          <a:xfrm>
-            <a:off x="640080" y="420624"/>
-            <a:ext cx="9418320" cy="292608"/>
-          </a:xfrm>
-          <a:prstGeom prst="rect">
-            <a:avLst/>
-          </a:prstGeom>
-          <a:noFill/>
-        </p:spPr>
-        <p:txBody>
-          <a:bodyPr wrap="square" anchor="t" lIns="0" rIns="0" tIns="0" bIns="0">
-            <a:spAutoFit/>
-          </a:bodyPr>
-          <a:lstStyle/>
-          <a:p>
-            <a:r>
-              <a:rPr sz="1150" b="1">
-                <a:solidFill>
-                  <a:srgbClr val="1F7A57"/>
-                </a:solidFill>
-                <a:latin typeface="Space Mono"/>
-              </a:rPr>
-              <a:t>ENGINEERING</a:t>
-            </a:r>
-          </a:p>
-        </p:txBody>
-      </p:sp>
-      <p:sp>
-        <p:nvSpPr>
-          <p:cNvPr id="4" name="TextBox 3"/>
-          <p:cNvSpPr txBox="1"/>
-          <p:nvPr/>
-        </p:nvSpPr>
-        <p:spPr>
-          <a:xfrm>
-            <a:off x="621792" y="731520"/>
-            <a:ext cx="9509760" cy="868680"/>
-          </a:xfrm>
-          <a:prstGeom prst="rect">
-            <a:avLst/>
-          </a:prstGeom>
-          <a:noFill/>
-        </p:spPr>
-        <p:txBody>
-          <a:bodyPr wrap="square" anchor="t" lIns="0" rIns="0" tIns="0" bIns="0">
-            <a:spAutoFit/>
-          </a:bodyPr>
-          <a:lstStyle/>
-          <a:p>
-            <a:r>
-              <a:rPr sz="2700" b="1">
-                <a:solidFill>
-                  <a:srgbClr val="15201C"/>
-                </a:solidFill>
-                <a:latin typeface="Space Grotesk"/>
-              </a:rPr>
-              <a:t>Architecture — the starting point</a:t>
-            </a:r>
-          </a:p>
-        </p:txBody>
-      </p:sp>
-      <p:sp>
-        <p:nvSpPr>
-          <p:cNvPr id="5" name="Rounded Rectangle 4"/>
-          <p:cNvSpPr/>
-          <p:nvPr/>
-        </p:nvSpPr>
-        <p:spPr>
-          <a:xfrm>
-            <a:off x="658368" y="1600200"/>
-            <a:ext cx="10881360" cy="4114800"/>
-          </a:xfrm>
-          <a:prstGeom prst="roundRect">
-            <a:avLst>
-              <a:gd name="adj" fmla="val 3000"/>
-            </a:avLst>
-          </a:prstGeom>
-          <a:solidFill>
-            <a:srgbClr val="FFFFFF"/>
-          </a:solidFill>
-          <a:ln w="12700">
-            <a:solidFill>
-              <a:srgbClr val="E6EBE8"/>
-            </a:solidFill>
-          </a:ln>
-          <a:effectLst/>
-        </p:spPr>
-        <p:style>
-          <a:lnRef idx="1">
-            <a:schemeClr val="accent1"/>
-          </a:lnRef>
-          <a:fillRef idx="3">
-            <a:schemeClr val="accent1"/>
-          </a:fillRef>
-          <a:effectRef idx="2">
-            <a:schemeClr val="accent1"/>
-          </a:effectRef>
-          <a:fontRef idx="minor">
-            <a:schemeClr val="lt1"/>
-          </a:fontRef>
-        </p:style>
-        <p:txBody>
-          <a:bodyPr rtlCol="0" anchor="ctr"/>
-          <a:lstStyle/>
-          <a:p>
-            <a:pPr algn="ctr"/>
-          </a:p>
-        </p:txBody>
-      </p:sp>
-      <p:sp>
-        <p:nvSpPr>
-          <p:cNvPr id="7" name="Rectangle 6"/>
-          <p:cNvSpPr/>
-          <p:nvPr/>
-        </p:nvSpPr>
-        <p:spPr>
-          <a:xfrm>
-            <a:off x="640080" y="6455664"/>
-            <a:ext cx="10908792" cy="9144"/>
-          </a:xfrm>
-          <a:prstGeom prst="rect">
-            <a:avLst/>
-          </a:prstGeom>
-          <a:solidFill>
-            <a:srgbClr val="E6EBE8"/>
-          </a:solidFill>
-          <a:ln>
-            <a:noFill/>
-          </a:ln>
-          <a:effectLst/>
-        </p:spPr>
-        <p:style>
-          <a:lnRef idx="1">
-            <a:schemeClr val="accent1"/>
-          </a:lnRef>
-          <a:fillRef idx="3">
-            <a:schemeClr val="accent1"/>
-          </a:fillRef>
-          <a:effectRef idx="2">
-            <a:schemeClr val="accent1"/>
-          </a:effectRef>
-          <a:fontRef idx="minor">
-            <a:schemeClr val="lt1"/>
-          </a:fontRef>
-        </p:style>
-        <p:txBody>
-          <a:bodyPr rtlCol="0" anchor="ctr"/>
-          <a:lstStyle/>
-          <a:p>
-            <a:pPr algn="ctr"/>
-          </a:p>
-        </p:txBody>
-      </p:sp>
-      <p:sp>
-        <p:nvSpPr>
-          <p:cNvPr id="8" name="TextBox 7"/>
-          <p:cNvSpPr txBox="1"/>
-          <p:nvPr/>
-        </p:nvSpPr>
-        <p:spPr>
-          <a:xfrm>
-            <a:off x="640080" y="6510528"/>
-            <a:ext cx="2743200" cy="274320"/>
-          </a:xfrm>
-          <a:prstGeom prst="rect">
-            <a:avLst/>
-          </a:prstGeom>
-          <a:noFill/>
-        </p:spPr>
-        <p:txBody>
-          <a:bodyPr wrap="square" anchor="t" lIns="0" rIns="0" tIns="0" bIns="0">
-            <a:spAutoFit/>
-          </a:bodyPr>
-          <a:lstStyle/>
-          <a:p>
-            <a:r>
-              <a:rPr sz="1100" b="1">
-                <a:solidFill>
-                  <a:srgbClr val="6B7B73"/>
-                </a:solidFill>
-                <a:latin typeface="Space Grotesk"/>
-              </a:rPr>
-              <a:t>want</a:t>
-            </a:r>
-            <a:r>
-              <a:rPr sz="1100" b="1">
-                <a:solidFill>
-                  <a:srgbClr val="1F7A57"/>
-                </a:solidFill>
-                <a:latin typeface="Space Grotesk"/>
-              </a:rPr>
-              <a:t>hat</a:t>
-            </a:r>
-          </a:p>
-        </p:txBody>
-      </p:sp>
-      <p:sp>
-        <p:nvSpPr>
-          <p:cNvPr id="9" name="TextBox 8"/>
-          <p:cNvSpPr txBox="1"/>
-          <p:nvPr/>
-        </p:nvSpPr>
-        <p:spPr>
-          <a:xfrm>
-            <a:off x="10607040" y="6510528"/>
-            <a:ext cx="941832" cy="274320"/>
-          </a:xfrm>
-          <a:prstGeom prst="rect">
-            <a:avLst/>
-          </a:prstGeom>
-          <a:noFill/>
-        </p:spPr>
-        <p:txBody>
-          <a:bodyPr wrap="square" anchor="t" lIns="0" rIns="0" tIns="0" bIns="0">
-            <a:spAutoFit/>
-          </a:bodyPr>
-          <a:lstStyle/>
-          <a:p>
-            <a:pPr algn="r"/>
-            <a:r>
-              <a:rPr sz="1000" b="0">
-                <a:solidFill>
-                  <a:srgbClr val="8A968F"/>
-                </a:solidFill>
-                <a:latin typeface="Space Mono"/>
-              </a:rPr>
-              <a:t>9</a:t>
-            </a:r>
-          </a:p>
-        </p:txBody>
-      </p:sp>
-      <p:sp>
-        <p:nvSpPr>
-          <p:cNvPr id="10" name="TextBox 9"/>
-          <p:cNvSpPr txBox="1"/>
-          <p:nvPr/>
-        </p:nvSpPr>
-        <p:spPr>
-          <a:xfrm>
-            <a:off x="658368" y="5852160"/>
-            <a:ext cx="10881360" cy="457200"/>
-          </a:xfrm>
-          <a:prstGeom prst="rect">
-            <a:avLst/>
-          </a:prstGeom>
-          <a:noFill/>
-        </p:spPr>
-        <p:txBody>
-          <a:bodyPr wrap="square">
-            <a:spAutoFit/>
-          </a:bodyPr>
-          <a:lstStyle/>
-          <a:p>
-            <a:r>
-              <a:rPr sz="1400" b="1">
-                <a:solidFill>
-                  <a:srgbClr val="15201C"/>
-                </a:solidFill>
-                <a:latin typeface="Hanken Grotesk"/>
-              </a:rPr>
-              <a:t>Starting with:  in-VPC Aurora Serverless v2   and   DynamoDB on-demand.</a:t>
-            </a:r>
-          </a:p>
-        </p:txBody>
-      </p:sp>
+      <p:pic>
+        <p:nvPicPr>
+          <p:cNvPr id="2" name="Picture 1" descr="page-09.png"/>
+          <p:cNvPicPr>
+            <a:picLocks noChangeAspect="1"/>
+          </p:cNvPicPr>
+          <p:nvPr/>
+        </p:nvPicPr>
+        <p:blipFill>
+          <a:blip r:embed="rId4"/>
+          <a:stretch>
+            <a:fillRect/>
+          </a:stretch>
+        </p:blipFill>
+        <p:spPr>
+          <a:xfrm>
+            <a:off x="0" y="0"/>
+            <a:ext cx="12191695" cy="6858000"/>
+          </a:xfrm>
+          <a:prstGeom prst="rect">
+            <a:avLst/>
+          </a:prstGeom>
+        </p:spPr>
+      </p:pic>
     </p:spTree>
   </p:cSld>
   <p:clrMapOvr>

</xml_diff>